<commit_message>
Add slide 7: worked example building the graph component-by-component
4-stage walkthrough on one 5-block example: Start(=VainF) → +S_min (remove
B2) → +theta (color into importance groups) → +alpha (add functional edges).
Shows the graph is built up, not rebuilt. Speaker notes updated.

Co-Authored-By: Claude Sonnet 4.6 <noreply@anthropic.com>
</commit_message>
<xml_diff>
--- a/hypergraph_slides.pptx
+++ b/hypergraph_slides.pptx
@@ -11,6 +11,7 @@
     <p:sldId id="259" r:id="rId10"/>
     <p:sldId id="260" r:id="rId11"/>
     <p:sldId id="261" r:id="rId12"/>
+    <p:sldId id="262" r:id="rId13"/>
   </p:sldIdLst>
   <p:sldSz cx="12192000" cy="6858000" type="screen4x3"/>
   <p:notesSz cx="6858000" cy="9144000"/>
@@ -14364,6 +14365,2917 @@
                 <a:latin typeface="Calibri"/>
               </a:rPr>
               <a:t>VainF is one corner of our space; the three knobs let us search for a better point.</a:t>
+            </a:r>
+          </a:p>
+        </p:txBody>
+      </p:sp>
+    </p:spTree>
+  </p:cSld>
+  <p:clrMapOvr>
+    <a:masterClrMapping/>
+  </p:clrMapOvr>
+</p:sld>
+</file>
+
+<file path=ppt/slides/slide7.xml><?xml version="1.0" encoding="utf-8"?>
+<p:sld xmlns:a="http://schemas.openxmlformats.org/drawingml/2006/main" xmlns:p="http://schemas.openxmlformats.org/presentationml/2006/main" xmlns:r="http://schemas.openxmlformats.org/officeDocument/2006/relationships">
+  <p:cSld>
+    <p:spTree>
+      <p:nvGrpSpPr>
+        <p:cNvPr id="1" name=""/>
+        <p:cNvGrpSpPr/>
+        <p:nvPr/>
+      </p:nvGrpSpPr>
+      <p:grpSpPr/>
+      <p:sp>
+        <p:nvSpPr>
+          <p:cNvPr id="2" name="TextBox 1"/>
+          <p:cNvSpPr txBox="1"/>
+          <p:nvPr/>
+        </p:nvSpPr>
+        <p:spPr>
+          <a:xfrm>
+            <a:off x="365760" y="228600"/>
+            <a:ext cx="11430000" cy="548640"/>
+          </a:xfrm>
+          <a:prstGeom prst="rect">
+            <a:avLst/>
+          </a:prstGeom>
+          <a:noFill/>
+        </p:spPr>
+        <p:txBody>
+          <a:bodyPr wrap="square">
+            <a:spAutoFit/>
+          </a:bodyPr>
+          <a:lstStyle/>
+          <a:p>
+            <a:pPr algn="l"/>
+            <a:r>
+              <a:rPr sz="2800" b="1" i="0">
+                <a:solidFill>
+                  <a:srgbClr val="1A1A1A"/>
+                </a:solidFill>
+                <a:latin typeface="Calibri"/>
+              </a:rPr>
+              <a:t>Worked Example: Building the Graph, One Component at a Time</a:t>
+            </a:r>
+          </a:p>
+        </p:txBody>
+      </p:sp>
+      <p:sp>
+        <p:nvSpPr>
+          <p:cNvPr id="3" name="Rectangle 2"/>
+          <p:cNvSpPr/>
+          <p:nvPr/>
+        </p:nvSpPr>
+        <p:spPr>
+          <a:xfrm>
+            <a:off x="365760" y="795528"/>
+            <a:ext cx="11457432" cy="31750"/>
+          </a:xfrm>
+          <a:prstGeom prst="rect">
+            <a:avLst/>
+          </a:prstGeom>
+          <a:solidFill>
+            <a:srgbClr val="0068B5"/>
+          </a:solidFill>
+          <a:ln>
+            <a:noFill/>
+          </a:ln>
+          <a:effectLst/>
+        </p:spPr>
+        <p:style>
+          <a:lnRef idx="1">
+            <a:schemeClr val="accent1"/>
+          </a:lnRef>
+          <a:fillRef idx="3">
+            <a:schemeClr val="accent1"/>
+          </a:fillRef>
+          <a:effectRef idx="2">
+            <a:schemeClr val="accent1"/>
+          </a:effectRef>
+          <a:fontRef idx="minor">
+            <a:schemeClr val="lt1"/>
+          </a:fontRef>
+        </p:style>
+        <p:txBody>
+          <a:bodyPr rtlCol="0" anchor="ctr"/>
+          <a:lstStyle/>
+          <a:p>
+            <a:pPr algn="ctr"/>
+          </a:p>
+        </p:txBody>
+      </p:sp>
+      <p:sp>
+        <p:nvSpPr>
+          <p:cNvPr id="4" name="TextBox 3"/>
+          <p:cNvSpPr txBox="1"/>
+          <p:nvPr/>
+        </p:nvSpPr>
+        <p:spPr>
+          <a:xfrm>
+            <a:off x="11430000" y="6492240"/>
+            <a:ext cx="640080" cy="274320"/>
+          </a:xfrm>
+          <a:prstGeom prst="rect">
+            <a:avLst/>
+          </a:prstGeom>
+          <a:noFill/>
+        </p:spPr>
+        <p:txBody>
+          <a:bodyPr wrap="square">
+            <a:spAutoFit/>
+          </a:bodyPr>
+          <a:lstStyle/>
+          <a:p>
+            <a:pPr algn="r"/>
+            <a:r>
+              <a:rPr sz="1000" b="0" i="0">
+                <a:solidFill>
+                  <a:srgbClr val="AAAAAA"/>
+                </a:solidFill>
+                <a:latin typeface="Calibri"/>
+              </a:rPr>
+              <a:t>6</a:t>
+            </a:r>
+          </a:p>
+        </p:txBody>
+      </p:sp>
+      <p:sp>
+        <p:nvSpPr>
+          <p:cNvPr id="5" name="Rectangle 4"/>
+          <p:cNvSpPr/>
+          <p:nvPr/>
+        </p:nvSpPr>
+        <p:spPr>
+          <a:xfrm>
+            <a:off x="365760" y="1020000"/>
+            <a:ext cx="11430000" cy="1120000"/>
+          </a:xfrm>
+          <a:prstGeom prst="rect">
+            <a:avLst/>
+          </a:prstGeom>
+          <a:solidFill>
+            <a:srgbClr val="F7F9FC"/>
+          </a:solidFill>
+          <a:ln>
+            <a:noFill/>
+          </a:ln>
+          <a:effectLst/>
+        </p:spPr>
+        <p:style>
+          <a:lnRef idx="1">
+            <a:schemeClr val="accent1"/>
+          </a:lnRef>
+          <a:fillRef idx="3">
+            <a:schemeClr val="accent1"/>
+          </a:fillRef>
+          <a:effectRef idx="2">
+            <a:schemeClr val="accent1"/>
+          </a:effectRef>
+          <a:fontRef idx="minor">
+            <a:schemeClr val="lt1"/>
+          </a:fontRef>
+        </p:style>
+        <p:txBody>
+          <a:bodyPr rtlCol="0" anchor="ctr"/>
+          <a:lstStyle/>
+          <a:p>
+            <a:pPr algn="ctr"/>
+          </a:p>
+        </p:txBody>
+      </p:sp>
+      <p:sp>
+        <p:nvSpPr>
+          <p:cNvPr id="6" name="Rectangle 5"/>
+          <p:cNvSpPr/>
+          <p:nvPr/>
+        </p:nvSpPr>
+        <p:spPr>
+          <a:xfrm>
+            <a:off x="365760" y="1140000"/>
+            <a:ext cx="110000" cy="860000"/>
+          </a:xfrm>
+          <a:prstGeom prst="rect">
+            <a:avLst/>
+          </a:prstGeom>
+          <a:solidFill>
+            <a:srgbClr val="BFBFBF"/>
+          </a:solidFill>
+          <a:ln>
+            <a:noFill/>
+          </a:ln>
+          <a:effectLst/>
+        </p:spPr>
+        <p:style>
+          <a:lnRef idx="1">
+            <a:schemeClr val="accent1"/>
+          </a:lnRef>
+          <a:fillRef idx="3">
+            <a:schemeClr val="accent1"/>
+          </a:fillRef>
+          <a:effectRef idx="2">
+            <a:schemeClr val="accent1"/>
+          </a:effectRef>
+          <a:fontRef idx="minor">
+            <a:schemeClr val="lt1"/>
+          </a:fontRef>
+        </p:style>
+        <p:txBody>
+          <a:bodyPr rtlCol="0" anchor="ctr"/>
+          <a:lstStyle/>
+          <a:p>
+            <a:pPr algn="ctr"/>
+          </a:p>
+        </p:txBody>
+      </p:sp>
+      <p:sp>
+        <p:nvSpPr>
+          <p:cNvPr id="7" name="TextBox 6"/>
+          <p:cNvSpPr txBox="1"/>
+          <p:nvPr/>
+        </p:nvSpPr>
+        <p:spPr>
+          <a:xfrm>
+            <a:off x="565760" y="1150000"/>
+            <a:ext cx="3000000" cy="920000"/>
+          </a:xfrm>
+          <a:prstGeom prst="rect">
+            <a:avLst/>
+          </a:prstGeom>
+          <a:noFill/>
+        </p:spPr>
+        <p:txBody>
+          <a:bodyPr wrap="square">
+            <a:spAutoFit/>
+          </a:bodyPr>
+          <a:lstStyle/>
+          <a:p>
+            <a:pPr algn="l"/>
+            <a:r>
+              <a:rPr sz="1600" b="1" i="0">
+                <a:solidFill>
+                  <a:srgbClr val="BFBFBF"/>
+                </a:solidFill>
+                <a:latin typeface="Calibri"/>
+              </a:rPr>
+              <a:t>0   Start  =  VainF</a:t>
+            </a:r>
+          </a:p>
+          <a:p>
+            <a:pPr algn="l">
+              <a:spcBef>
+                <a:spcPts val="600"/>
+              </a:spcBef>
+            </a:pPr>
+            <a:r>
+              <a:rPr sz="1200" b="0" i="0">
+                <a:solidFill>
+                  <a:srgbClr val="525252"/>
+                </a:solidFill>
+                <a:latin typeface="Calibri"/>
+              </a:rPr>
+              <a:t>All 5 blocks kept · one uniform ratio · no inter-block edges</a:t>
+            </a:r>
+          </a:p>
+        </p:txBody>
+      </p:sp>
+      <p:cxnSp>
+        <p:nvCxnSpPr>
+          <p:cNvPr id="8" name="Connector 7"/>
+          <p:cNvCxnSpPr/>
+          <p:nvPr/>
+        </p:nvCxnSpPr>
+        <p:spPr>
+          <a:xfrm>
+            <a:off x="4335760" y="1650000"/>
+            <a:ext cx="1402620" cy="0"/>
+          </a:xfrm>
+          <a:prstGeom prst="bentConnector3">
+            <a:avLst/>
+          </a:prstGeom>
+          <a:ln w="17780">
+            <a:solidFill>
+              <a:srgbClr val="808080"/>
+            </a:solidFill>
+          </a:ln>
+          <a:effectLst/>
+        </p:spPr>
+        <p:style>
+          <a:lnRef idx="2">
+            <a:schemeClr val="accent1"/>
+          </a:lnRef>
+          <a:fillRef idx="0">
+            <a:schemeClr val="accent1"/>
+          </a:fillRef>
+          <a:effectRef idx="1">
+            <a:schemeClr val="accent1"/>
+          </a:effectRef>
+          <a:fontRef idx="minor">
+            <a:schemeClr val="tx1"/>
+          </a:fontRef>
+        </p:style>
+      </p:cxnSp>
+      <p:cxnSp>
+        <p:nvCxnSpPr>
+          <p:cNvPr id="9" name="Connector 8"/>
+          <p:cNvCxnSpPr/>
+          <p:nvPr/>
+        </p:nvCxnSpPr>
+        <p:spPr>
+          <a:xfrm>
+            <a:off x="6208380" y="1650000"/>
+            <a:ext cx="1402620" cy="0"/>
+          </a:xfrm>
+          <a:prstGeom prst="bentConnector3">
+            <a:avLst/>
+          </a:prstGeom>
+          <a:ln w="17780">
+            <a:solidFill>
+              <a:srgbClr val="808080"/>
+            </a:solidFill>
+          </a:ln>
+          <a:effectLst/>
+        </p:spPr>
+        <p:style>
+          <a:lnRef idx="2">
+            <a:schemeClr val="accent1"/>
+          </a:lnRef>
+          <a:fillRef idx="0">
+            <a:schemeClr val="accent1"/>
+          </a:fillRef>
+          <a:effectRef idx="1">
+            <a:schemeClr val="accent1"/>
+          </a:effectRef>
+          <a:fontRef idx="minor">
+            <a:schemeClr val="tx1"/>
+          </a:fontRef>
+        </p:style>
+      </p:cxnSp>
+      <p:cxnSp>
+        <p:nvCxnSpPr>
+          <p:cNvPr id="10" name="Connector 9"/>
+          <p:cNvCxnSpPr/>
+          <p:nvPr/>
+        </p:nvCxnSpPr>
+        <p:spPr>
+          <a:xfrm>
+            <a:off x="8081000" y="1650000"/>
+            <a:ext cx="1402620" cy="0"/>
+          </a:xfrm>
+          <a:prstGeom prst="bentConnector3">
+            <a:avLst/>
+          </a:prstGeom>
+          <a:ln w="17780">
+            <a:solidFill>
+              <a:srgbClr val="808080"/>
+            </a:solidFill>
+          </a:ln>
+          <a:effectLst/>
+        </p:spPr>
+        <p:style>
+          <a:lnRef idx="2">
+            <a:schemeClr val="accent1"/>
+          </a:lnRef>
+          <a:fillRef idx="0">
+            <a:schemeClr val="accent1"/>
+          </a:fillRef>
+          <a:effectRef idx="1">
+            <a:schemeClr val="accent1"/>
+          </a:effectRef>
+          <a:fontRef idx="minor">
+            <a:schemeClr val="tx1"/>
+          </a:fontRef>
+        </p:style>
+      </p:cxnSp>
+      <p:cxnSp>
+        <p:nvCxnSpPr>
+          <p:cNvPr id="11" name="Connector 10"/>
+          <p:cNvCxnSpPr/>
+          <p:nvPr/>
+        </p:nvCxnSpPr>
+        <p:spPr>
+          <a:xfrm>
+            <a:off x="9953620" y="1650000"/>
+            <a:ext cx="1402620" cy="0"/>
+          </a:xfrm>
+          <a:prstGeom prst="bentConnector3">
+            <a:avLst/>
+          </a:prstGeom>
+          <a:ln w="17780">
+            <a:solidFill>
+              <a:srgbClr val="808080"/>
+            </a:solidFill>
+          </a:ln>
+          <a:effectLst/>
+        </p:spPr>
+        <p:style>
+          <a:lnRef idx="2">
+            <a:schemeClr val="accent1"/>
+          </a:lnRef>
+          <a:fillRef idx="0">
+            <a:schemeClr val="accent1"/>
+          </a:fillRef>
+          <a:effectRef idx="1">
+            <a:schemeClr val="accent1"/>
+          </a:effectRef>
+          <a:fontRef idx="minor">
+            <a:schemeClr val="tx1"/>
+          </a:fontRef>
+        </p:style>
+      </p:cxnSp>
+      <p:sp>
+        <p:nvSpPr>
+          <p:cNvPr id="12" name="Oval 11"/>
+          <p:cNvSpPr/>
+          <p:nvPr/>
+        </p:nvSpPr>
+        <p:spPr>
+          <a:xfrm>
+            <a:off x="3865760" y="1415000"/>
+            <a:ext cx="470000" cy="470000"/>
+          </a:xfrm>
+          <a:prstGeom prst="ellipse">
+            <a:avLst/>
+          </a:prstGeom>
+          <a:solidFill>
+            <a:srgbClr val="0068B5"/>
+          </a:solidFill>
+          <a:ln>
+            <a:noFill/>
+          </a:ln>
+          <a:effectLst/>
+        </p:spPr>
+        <p:style>
+          <a:lnRef idx="1">
+            <a:schemeClr val="accent1"/>
+          </a:lnRef>
+          <a:fillRef idx="3">
+            <a:schemeClr val="accent1"/>
+          </a:fillRef>
+          <a:effectRef idx="2">
+            <a:schemeClr val="accent1"/>
+          </a:effectRef>
+          <a:fontRef idx="minor">
+            <a:schemeClr val="lt1"/>
+          </a:fontRef>
+        </p:style>
+        <p:txBody>
+          <a:bodyPr rtlCol="0" anchor="ctr"/>
+          <a:lstStyle/>
+          <a:p>
+            <a:pPr algn="ctr"/>
+          </a:p>
+        </p:txBody>
+      </p:sp>
+      <p:sp>
+        <p:nvSpPr>
+          <p:cNvPr id="13" name="TextBox 12"/>
+          <p:cNvSpPr txBox="1"/>
+          <p:nvPr/>
+        </p:nvSpPr>
+        <p:spPr>
+          <a:xfrm>
+            <a:off x="3865760" y="1530000"/>
+            <a:ext cx="470000" cy="240000"/>
+          </a:xfrm>
+          <a:prstGeom prst="rect">
+            <a:avLst/>
+          </a:prstGeom>
+          <a:noFill/>
+        </p:spPr>
+        <p:txBody>
+          <a:bodyPr wrap="square">
+            <a:spAutoFit/>
+          </a:bodyPr>
+          <a:lstStyle/>
+          <a:p>
+            <a:pPr algn="ctr"/>
+            <a:r>
+              <a:rPr sz="1100" b="1" i="0">
+                <a:solidFill>
+                  <a:srgbClr val="FFFFFF"/>
+                </a:solidFill>
+                <a:latin typeface="Calibri"/>
+              </a:rPr>
+              <a:t>B0</a:t>
+            </a:r>
+          </a:p>
+        </p:txBody>
+      </p:sp>
+      <p:sp>
+        <p:nvSpPr>
+          <p:cNvPr id="14" name="Oval 13"/>
+          <p:cNvSpPr/>
+          <p:nvPr/>
+        </p:nvSpPr>
+        <p:spPr>
+          <a:xfrm>
+            <a:off x="5738380" y="1415000"/>
+            <a:ext cx="470000" cy="470000"/>
+          </a:xfrm>
+          <a:prstGeom prst="ellipse">
+            <a:avLst/>
+          </a:prstGeom>
+          <a:solidFill>
+            <a:srgbClr val="0068B5"/>
+          </a:solidFill>
+          <a:ln>
+            <a:noFill/>
+          </a:ln>
+          <a:effectLst/>
+        </p:spPr>
+        <p:style>
+          <a:lnRef idx="1">
+            <a:schemeClr val="accent1"/>
+          </a:lnRef>
+          <a:fillRef idx="3">
+            <a:schemeClr val="accent1"/>
+          </a:fillRef>
+          <a:effectRef idx="2">
+            <a:schemeClr val="accent1"/>
+          </a:effectRef>
+          <a:fontRef idx="minor">
+            <a:schemeClr val="lt1"/>
+          </a:fontRef>
+        </p:style>
+        <p:txBody>
+          <a:bodyPr rtlCol="0" anchor="ctr"/>
+          <a:lstStyle/>
+          <a:p>
+            <a:pPr algn="ctr"/>
+          </a:p>
+        </p:txBody>
+      </p:sp>
+      <p:sp>
+        <p:nvSpPr>
+          <p:cNvPr id="15" name="TextBox 14"/>
+          <p:cNvSpPr txBox="1"/>
+          <p:nvPr/>
+        </p:nvSpPr>
+        <p:spPr>
+          <a:xfrm>
+            <a:off x="5738380" y="1530000"/>
+            <a:ext cx="470000" cy="240000"/>
+          </a:xfrm>
+          <a:prstGeom prst="rect">
+            <a:avLst/>
+          </a:prstGeom>
+          <a:noFill/>
+        </p:spPr>
+        <p:txBody>
+          <a:bodyPr wrap="square">
+            <a:spAutoFit/>
+          </a:bodyPr>
+          <a:lstStyle/>
+          <a:p>
+            <a:pPr algn="ctr"/>
+            <a:r>
+              <a:rPr sz="1100" b="1" i="0">
+                <a:solidFill>
+                  <a:srgbClr val="FFFFFF"/>
+                </a:solidFill>
+                <a:latin typeface="Calibri"/>
+              </a:rPr>
+              <a:t>B1</a:t>
+            </a:r>
+          </a:p>
+        </p:txBody>
+      </p:sp>
+      <p:sp>
+        <p:nvSpPr>
+          <p:cNvPr id="16" name="Oval 15"/>
+          <p:cNvSpPr/>
+          <p:nvPr/>
+        </p:nvSpPr>
+        <p:spPr>
+          <a:xfrm>
+            <a:off x="7611000" y="1415000"/>
+            <a:ext cx="470000" cy="470000"/>
+          </a:xfrm>
+          <a:prstGeom prst="ellipse">
+            <a:avLst/>
+          </a:prstGeom>
+          <a:solidFill>
+            <a:srgbClr val="0068B5"/>
+          </a:solidFill>
+          <a:ln>
+            <a:noFill/>
+          </a:ln>
+          <a:effectLst/>
+        </p:spPr>
+        <p:style>
+          <a:lnRef idx="1">
+            <a:schemeClr val="accent1"/>
+          </a:lnRef>
+          <a:fillRef idx="3">
+            <a:schemeClr val="accent1"/>
+          </a:fillRef>
+          <a:effectRef idx="2">
+            <a:schemeClr val="accent1"/>
+          </a:effectRef>
+          <a:fontRef idx="minor">
+            <a:schemeClr val="lt1"/>
+          </a:fontRef>
+        </p:style>
+        <p:txBody>
+          <a:bodyPr rtlCol="0" anchor="ctr"/>
+          <a:lstStyle/>
+          <a:p>
+            <a:pPr algn="ctr"/>
+          </a:p>
+        </p:txBody>
+      </p:sp>
+      <p:sp>
+        <p:nvSpPr>
+          <p:cNvPr id="17" name="TextBox 16"/>
+          <p:cNvSpPr txBox="1"/>
+          <p:nvPr/>
+        </p:nvSpPr>
+        <p:spPr>
+          <a:xfrm>
+            <a:off x="7611000" y="1530000"/>
+            <a:ext cx="470000" cy="240000"/>
+          </a:xfrm>
+          <a:prstGeom prst="rect">
+            <a:avLst/>
+          </a:prstGeom>
+          <a:noFill/>
+        </p:spPr>
+        <p:txBody>
+          <a:bodyPr wrap="square">
+            <a:spAutoFit/>
+          </a:bodyPr>
+          <a:lstStyle/>
+          <a:p>
+            <a:pPr algn="ctr"/>
+            <a:r>
+              <a:rPr sz="1100" b="1" i="0">
+                <a:solidFill>
+                  <a:srgbClr val="FFFFFF"/>
+                </a:solidFill>
+                <a:latin typeface="Calibri"/>
+              </a:rPr>
+              <a:t>B2</a:t>
+            </a:r>
+          </a:p>
+        </p:txBody>
+      </p:sp>
+      <p:sp>
+        <p:nvSpPr>
+          <p:cNvPr id="18" name="Oval 17"/>
+          <p:cNvSpPr/>
+          <p:nvPr/>
+        </p:nvSpPr>
+        <p:spPr>
+          <a:xfrm>
+            <a:off x="9483620" y="1415000"/>
+            <a:ext cx="470000" cy="470000"/>
+          </a:xfrm>
+          <a:prstGeom prst="ellipse">
+            <a:avLst/>
+          </a:prstGeom>
+          <a:solidFill>
+            <a:srgbClr val="0068B5"/>
+          </a:solidFill>
+          <a:ln>
+            <a:noFill/>
+          </a:ln>
+          <a:effectLst/>
+        </p:spPr>
+        <p:style>
+          <a:lnRef idx="1">
+            <a:schemeClr val="accent1"/>
+          </a:lnRef>
+          <a:fillRef idx="3">
+            <a:schemeClr val="accent1"/>
+          </a:fillRef>
+          <a:effectRef idx="2">
+            <a:schemeClr val="accent1"/>
+          </a:effectRef>
+          <a:fontRef idx="minor">
+            <a:schemeClr val="lt1"/>
+          </a:fontRef>
+        </p:style>
+        <p:txBody>
+          <a:bodyPr rtlCol="0" anchor="ctr"/>
+          <a:lstStyle/>
+          <a:p>
+            <a:pPr algn="ctr"/>
+          </a:p>
+        </p:txBody>
+      </p:sp>
+      <p:sp>
+        <p:nvSpPr>
+          <p:cNvPr id="19" name="TextBox 18"/>
+          <p:cNvSpPr txBox="1"/>
+          <p:nvPr/>
+        </p:nvSpPr>
+        <p:spPr>
+          <a:xfrm>
+            <a:off x="9483620" y="1530000"/>
+            <a:ext cx="470000" cy="240000"/>
+          </a:xfrm>
+          <a:prstGeom prst="rect">
+            <a:avLst/>
+          </a:prstGeom>
+          <a:noFill/>
+        </p:spPr>
+        <p:txBody>
+          <a:bodyPr wrap="square">
+            <a:spAutoFit/>
+          </a:bodyPr>
+          <a:lstStyle/>
+          <a:p>
+            <a:pPr algn="ctr"/>
+            <a:r>
+              <a:rPr sz="1100" b="1" i="0">
+                <a:solidFill>
+                  <a:srgbClr val="FFFFFF"/>
+                </a:solidFill>
+                <a:latin typeface="Calibri"/>
+              </a:rPr>
+              <a:t>B3</a:t>
+            </a:r>
+          </a:p>
+        </p:txBody>
+      </p:sp>
+      <p:sp>
+        <p:nvSpPr>
+          <p:cNvPr id="20" name="Oval 19"/>
+          <p:cNvSpPr/>
+          <p:nvPr/>
+        </p:nvSpPr>
+        <p:spPr>
+          <a:xfrm>
+            <a:off x="11356240" y="1415000"/>
+            <a:ext cx="470000" cy="470000"/>
+          </a:xfrm>
+          <a:prstGeom prst="ellipse">
+            <a:avLst/>
+          </a:prstGeom>
+          <a:solidFill>
+            <a:srgbClr val="0068B5"/>
+          </a:solidFill>
+          <a:ln>
+            <a:noFill/>
+          </a:ln>
+          <a:effectLst/>
+        </p:spPr>
+        <p:style>
+          <a:lnRef idx="1">
+            <a:schemeClr val="accent1"/>
+          </a:lnRef>
+          <a:fillRef idx="3">
+            <a:schemeClr val="accent1"/>
+          </a:fillRef>
+          <a:effectRef idx="2">
+            <a:schemeClr val="accent1"/>
+          </a:effectRef>
+          <a:fontRef idx="minor">
+            <a:schemeClr val="lt1"/>
+          </a:fontRef>
+        </p:style>
+        <p:txBody>
+          <a:bodyPr rtlCol="0" anchor="ctr"/>
+          <a:lstStyle/>
+          <a:p>
+            <a:pPr algn="ctr"/>
+          </a:p>
+        </p:txBody>
+      </p:sp>
+      <p:sp>
+        <p:nvSpPr>
+          <p:cNvPr id="21" name="TextBox 20"/>
+          <p:cNvSpPr txBox="1"/>
+          <p:nvPr/>
+        </p:nvSpPr>
+        <p:spPr>
+          <a:xfrm>
+            <a:off x="11356240" y="1530000"/>
+            <a:ext cx="470000" cy="240000"/>
+          </a:xfrm>
+          <a:prstGeom prst="rect">
+            <a:avLst/>
+          </a:prstGeom>
+          <a:noFill/>
+        </p:spPr>
+        <p:txBody>
+          <a:bodyPr wrap="square">
+            <a:spAutoFit/>
+          </a:bodyPr>
+          <a:lstStyle/>
+          <a:p>
+            <a:pPr algn="ctr"/>
+            <a:r>
+              <a:rPr sz="1100" b="1" i="0">
+                <a:solidFill>
+                  <a:srgbClr val="FFFFFF"/>
+                </a:solidFill>
+                <a:latin typeface="Calibri"/>
+              </a:rPr>
+              <a:t>B4</a:t>
+            </a:r>
+          </a:p>
+        </p:txBody>
+      </p:sp>
+      <p:sp>
+        <p:nvSpPr>
+          <p:cNvPr id="22" name="Rectangle 21"/>
+          <p:cNvSpPr/>
+          <p:nvPr/>
+        </p:nvSpPr>
+        <p:spPr>
+          <a:xfrm>
+            <a:off x="365760" y="2320000"/>
+            <a:ext cx="110000" cy="860000"/>
+          </a:xfrm>
+          <a:prstGeom prst="rect">
+            <a:avLst/>
+          </a:prstGeom>
+          <a:solidFill>
+            <a:srgbClr val="C0504D"/>
+          </a:solidFill>
+          <a:ln>
+            <a:noFill/>
+          </a:ln>
+          <a:effectLst/>
+        </p:spPr>
+        <p:style>
+          <a:lnRef idx="1">
+            <a:schemeClr val="accent1"/>
+          </a:lnRef>
+          <a:fillRef idx="3">
+            <a:schemeClr val="accent1"/>
+          </a:fillRef>
+          <a:effectRef idx="2">
+            <a:schemeClr val="accent1"/>
+          </a:effectRef>
+          <a:fontRef idx="minor">
+            <a:schemeClr val="lt1"/>
+          </a:fontRef>
+        </p:style>
+        <p:txBody>
+          <a:bodyPr rtlCol="0" anchor="ctr"/>
+          <a:lstStyle/>
+          <a:p>
+            <a:pPr algn="ctr"/>
+          </a:p>
+        </p:txBody>
+      </p:sp>
+      <p:sp>
+        <p:nvSpPr>
+          <p:cNvPr id="23" name="TextBox 22"/>
+          <p:cNvSpPr txBox="1"/>
+          <p:nvPr/>
+        </p:nvSpPr>
+        <p:spPr>
+          <a:xfrm>
+            <a:off x="565760" y="2330000"/>
+            <a:ext cx="3000000" cy="920000"/>
+          </a:xfrm>
+          <a:prstGeom prst="rect">
+            <a:avLst/>
+          </a:prstGeom>
+          <a:noFill/>
+        </p:spPr>
+        <p:txBody>
+          <a:bodyPr wrap="square">
+            <a:spAutoFit/>
+          </a:bodyPr>
+          <a:lstStyle/>
+          <a:p>
+            <a:pPr algn="l"/>
+            <a:r>
+              <a:rPr sz="1600" b="1" i="0">
+                <a:solidFill>
+                  <a:srgbClr val="C0504D"/>
+                </a:solidFill>
+                <a:latin typeface="Calibri"/>
+              </a:rPr>
+              <a:t>+  S_min = 0.40</a:t>
+            </a:r>
+          </a:p>
+          <a:p>
+            <a:pPr algn="l">
+              <a:spcBef>
+                <a:spcPts val="600"/>
+              </a:spcBef>
+            </a:pPr>
+            <a:r>
+              <a:rPr sz="1200" b="0" i="0">
+                <a:solidFill>
+                  <a:srgbClr val="525252"/>
+                </a:solidFill>
+                <a:latin typeface="Calibri"/>
+              </a:rPr>
+              <a:t>B2 has S = 0.35 &lt; 0.40  →  removed entirely  (node set V′ shrinks)</a:t>
+            </a:r>
+          </a:p>
+        </p:txBody>
+      </p:sp>
+      <p:cxnSp>
+        <p:nvCxnSpPr>
+          <p:cNvPr id="24" name="Connector 23"/>
+          <p:cNvCxnSpPr/>
+          <p:nvPr/>
+        </p:nvCxnSpPr>
+        <p:spPr>
+          <a:xfrm>
+            <a:off x="4335760" y="2830000"/>
+            <a:ext cx="1402620" cy="0"/>
+          </a:xfrm>
+          <a:prstGeom prst="bentConnector3">
+            <a:avLst/>
+          </a:prstGeom>
+          <a:ln w="17780">
+            <a:solidFill>
+              <a:srgbClr val="808080"/>
+            </a:solidFill>
+          </a:ln>
+          <a:effectLst/>
+        </p:spPr>
+        <p:style>
+          <a:lnRef idx="2">
+            <a:schemeClr val="accent1"/>
+          </a:lnRef>
+          <a:fillRef idx="0">
+            <a:schemeClr val="accent1"/>
+          </a:fillRef>
+          <a:effectRef idx="1">
+            <a:schemeClr val="accent1"/>
+          </a:effectRef>
+          <a:fontRef idx="minor">
+            <a:schemeClr val="tx1"/>
+          </a:fontRef>
+        </p:style>
+      </p:cxnSp>
+      <p:cxnSp>
+        <p:nvCxnSpPr>
+          <p:cNvPr id="25" name="Connector 24"/>
+          <p:cNvCxnSpPr/>
+          <p:nvPr/>
+        </p:nvCxnSpPr>
+        <p:spPr>
+          <a:xfrm>
+            <a:off x="6208380" y="2830000"/>
+            <a:ext cx="3275240" cy="0"/>
+          </a:xfrm>
+          <a:prstGeom prst="bentConnector3">
+            <a:avLst/>
+          </a:prstGeom>
+          <a:ln w="17780">
+            <a:solidFill>
+              <a:srgbClr val="808080"/>
+            </a:solidFill>
+          </a:ln>
+          <a:effectLst/>
+        </p:spPr>
+        <p:style>
+          <a:lnRef idx="2">
+            <a:schemeClr val="accent1"/>
+          </a:lnRef>
+          <a:fillRef idx="0">
+            <a:schemeClr val="accent1"/>
+          </a:fillRef>
+          <a:effectRef idx="1">
+            <a:schemeClr val="accent1"/>
+          </a:effectRef>
+          <a:fontRef idx="minor">
+            <a:schemeClr val="tx1"/>
+          </a:fontRef>
+        </p:style>
+      </p:cxnSp>
+      <p:cxnSp>
+        <p:nvCxnSpPr>
+          <p:cNvPr id="26" name="Connector 25"/>
+          <p:cNvCxnSpPr/>
+          <p:nvPr/>
+        </p:nvCxnSpPr>
+        <p:spPr>
+          <a:xfrm>
+            <a:off x="9953620" y="2830000"/>
+            <a:ext cx="1402620" cy="0"/>
+          </a:xfrm>
+          <a:prstGeom prst="bentConnector3">
+            <a:avLst/>
+          </a:prstGeom>
+          <a:ln w="17780">
+            <a:solidFill>
+              <a:srgbClr val="808080"/>
+            </a:solidFill>
+          </a:ln>
+          <a:effectLst/>
+        </p:spPr>
+        <p:style>
+          <a:lnRef idx="2">
+            <a:schemeClr val="accent1"/>
+          </a:lnRef>
+          <a:fillRef idx="0">
+            <a:schemeClr val="accent1"/>
+          </a:fillRef>
+          <a:effectRef idx="1">
+            <a:schemeClr val="accent1"/>
+          </a:effectRef>
+          <a:fontRef idx="minor">
+            <a:schemeClr val="tx1"/>
+          </a:fontRef>
+        </p:style>
+      </p:cxnSp>
+      <p:sp>
+        <p:nvSpPr>
+          <p:cNvPr id="27" name="Oval 26"/>
+          <p:cNvSpPr/>
+          <p:nvPr/>
+        </p:nvSpPr>
+        <p:spPr>
+          <a:xfrm>
+            <a:off x="3865760" y="2595000"/>
+            <a:ext cx="470000" cy="470000"/>
+          </a:xfrm>
+          <a:prstGeom prst="ellipse">
+            <a:avLst/>
+          </a:prstGeom>
+          <a:solidFill>
+            <a:srgbClr val="0068B5"/>
+          </a:solidFill>
+          <a:ln>
+            <a:noFill/>
+          </a:ln>
+          <a:effectLst/>
+        </p:spPr>
+        <p:style>
+          <a:lnRef idx="1">
+            <a:schemeClr val="accent1"/>
+          </a:lnRef>
+          <a:fillRef idx="3">
+            <a:schemeClr val="accent1"/>
+          </a:fillRef>
+          <a:effectRef idx="2">
+            <a:schemeClr val="accent1"/>
+          </a:effectRef>
+          <a:fontRef idx="minor">
+            <a:schemeClr val="lt1"/>
+          </a:fontRef>
+        </p:style>
+        <p:txBody>
+          <a:bodyPr rtlCol="0" anchor="ctr"/>
+          <a:lstStyle/>
+          <a:p>
+            <a:pPr algn="ctr"/>
+          </a:p>
+        </p:txBody>
+      </p:sp>
+      <p:sp>
+        <p:nvSpPr>
+          <p:cNvPr id="28" name="TextBox 27"/>
+          <p:cNvSpPr txBox="1"/>
+          <p:nvPr/>
+        </p:nvSpPr>
+        <p:spPr>
+          <a:xfrm>
+            <a:off x="3865760" y="2710000"/>
+            <a:ext cx="470000" cy="240000"/>
+          </a:xfrm>
+          <a:prstGeom prst="rect">
+            <a:avLst/>
+          </a:prstGeom>
+          <a:noFill/>
+        </p:spPr>
+        <p:txBody>
+          <a:bodyPr wrap="square">
+            <a:spAutoFit/>
+          </a:bodyPr>
+          <a:lstStyle/>
+          <a:p>
+            <a:pPr algn="ctr"/>
+            <a:r>
+              <a:rPr sz="1100" b="1" i="0">
+                <a:solidFill>
+                  <a:srgbClr val="FFFFFF"/>
+                </a:solidFill>
+                <a:latin typeface="Calibri"/>
+              </a:rPr>
+              <a:t>B0</a:t>
+            </a:r>
+          </a:p>
+        </p:txBody>
+      </p:sp>
+      <p:sp>
+        <p:nvSpPr>
+          <p:cNvPr id="29" name="Oval 28"/>
+          <p:cNvSpPr/>
+          <p:nvPr/>
+        </p:nvSpPr>
+        <p:spPr>
+          <a:xfrm>
+            <a:off x="5738380" y="2595000"/>
+            <a:ext cx="470000" cy="470000"/>
+          </a:xfrm>
+          <a:prstGeom prst="ellipse">
+            <a:avLst/>
+          </a:prstGeom>
+          <a:solidFill>
+            <a:srgbClr val="0068B5"/>
+          </a:solidFill>
+          <a:ln>
+            <a:noFill/>
+          </a:ln>
+          <a:effectLst/>
+        </p:spPr>
+        <p:style>
+          <a:lnRef idx="1">
+            <a:schemeClr val="accent1"/>
+          </a:lnRef>
+          <a:fillRef idx="3">
+            <a:schemeClr val="accent1"/>
+          </a:fillRef>
+          <a:effectRef idx="2">
+            <a:schemeClr val="accent1"/>
+          </a:effectRef>
+          <a:fontRef idx="minor">
+            <a:schemeClr val="lt1"/>
+          </a:fontRef>
+        </p:style>
+        <p:txBody>
+          <a:bodyPr rtlCol="0" anchor="ctr"/>
+          <a:lstStyle/>
+          <a:p>
+            <a:pPr algn="ctr"/>
+          </a:p>
+        </p:txBody>
+      </p:sp>
+      <p:sp>
+        <p:nvSpPr>
+          <p:cNvPr id="30" name="TextBox 29"/>
+          <p:cNvSpPr txBox="1"/>
+          <p:nvPr/>
+        </p:nvSpPr>
+        <p:spPr>
+          <a:xfrm>
+            <a:off x="5738380" y="2710000"/>
+            <a:ext cx="470000" cy="240000"/>
+          </a:xfrm>
+          <a:prstGeom prst="rect">
+            <a:avLst/>
+          </a:prstGeom>
+          <a:noFill/>
+        </p:spPr>
+        <p:txBody>
+          <a:bodyPr wrap="square">
+            <a:spAutoFit/>
+          </a:bodyPr>
+          <a:lstStyle/>
+          <a:p>
+            <a:pPr algn="ctr"/>
+            <a:r>
+              <a:rPr sz="1100" b="1" i="0">
+                <a:solidFill>
+                  <a:srgbClr val="FFFFFF"/>
+                </a:solidFill>
+                <a:latin typeface="Calibri"/>
+              </a:rPr>
+              <a:t>B1</a:t>
+            </a:r>
+          </a:p>
+        </p:txBody>
+      </p:sp>
+      <p:sp>
+        <p:nvSpPr>
+          <p:cNvPr id="31" name="Oval 30"/>
+          <p:cNvSpPr/>
+          <p:nvPr/>
+        </p:nvSpPr>
+        <p:spPr>
+          <a:xfrm>
+            <a:off x="7611000" y="2595000"/>
+            <a:ext cx="470000" cy="470000"/>
+          </a:xfrm>
+          <a:prstGeom prst="ellipse">
+            <a:avLst/>
+          </a:prstGeom>
+          <a:solidFill>
+            <a:srgbClr val="EDEDED"/>
+          </a:solidFill>
+          <a:ln w="9525">
+            <a:solidFill>
+              <a:srgbClr val="BFBFBF"/>
+            </a:solidFill>
+          </a:ln>
+          <a:effectLst/>
+        </p:spPr>
+        <p:style>
+          <a:lnRef idx="1">
+            <a:schemeClr val="accent1"/>
+          </a:lnRef>
+          <a:fillRef idx="3">
+            <a:schemeClr val="accent1"/>
+          </a:fillRef>
+          <a:effectRef idx="2">
+            <a:schemeClr val="accent1"/>
+          </a:effectRef>
+          <a:fontRef idx="minor">
+            <a:schemeClr val="lt1"/>
+          </a:fontRef>
+        </p:style>
+        <p:txBody>
+          <a:bodyPr rtlCol="0" anchor="ctr"/>
+          <a:lstStyle/>
+          <a:p>
+            <a:pPr algn="ctr"/>
+          </a:p>
+        </p:txBody>
+      </p:sp>
+      <p:sp>
+        <p:nvSpPr>
+          <p:cNvPr id="32" name="TextBox 31"/>
+          <p:cNvSpPr txBox="1"/>
+          <p:nvPr/>
+        </p:nvSpPr>
+        <p:spPr>
+          <a:xfrm>
+            <a:off x="7611000" y="2680000"/>
+            <a:ext cx="470000" cy="300000"/>
+          </a:xfrm>
+          <a:prstGeom prst="rect">
+            <a:avLst/>
+          </a:prstGeom>
+          <a:noFill/>
+        </p:spPr>
+        <p:txBody>
+          <a:bodyPr wrap="square">
+            <a:spAutoFit/>
+          </a:bodyPr>
+          <a:lstStyle/>
+          <a:p>
+            <a:pPr algn="ctr"/>
+            <a:r>
+              <a:rPr sz="2000" b="1" i="0">
+                <a:solidFill>
+                  <a:srgbClr val="C0504D"/>
+                </a:solidFill>
+                <a:latin typeface="Calibri"/>
+              </a:rPr>
+              <a:t>✕</a:t>
+            </a:r>
+          </a:p>
+        </p:txBody>
+      </p:sp>
+      <p:sp>
+        <p:nvSpPr>
+          <p:cNvPr id="33" name="Oval 32"/>
+          <p:cNvSpPr/>
+          <p:nvPr/>
+        </p:nvSpPr>
+        <p:spPr>
+          <a:xfrm>
+            <a:off x="9483620" y="2595000"/>
+            <a:ext cx="470000" cy="470000"/>
+          </a:xfrm>
+          <a:prstGeom prst="ellipse">
+            <a:avLst/>
+          </a:prstGeom>
+          <a:solidFill>
+            <a:srgbClr val="0068B5"/>
+          </a:solidFill>
+          <a:ln>
+            <a:noFill/>
+          </a:ln>
+          <a:effectLst/>
+        </p:spPr>
+        <p:style>
+          <a:lnRef idx="1">
+            <a:schemeClr val="accent1"/>
+          </a:lnRef>
+          <a:fillRef idx="3">
+            <a:schemeClr val="accent1"/>
+          </a:fillRef>
+          <a:effectRef idx="2">
+            <a:schemeClr val="accent1"/>
+          </a:effectRef>
+          <a:fontRef idx="minor">
+            <a:schemeClr val="lt1"/>
+          </a:fontRef>
+        </p:style>
+        <p:txBody>
+          <a:bodyPr rtlCol="0" anchor="ctr"/>
+          <a:lstStyle/>
+          <a:p>
+            <a:pPr algn="ctr"/>
+          </a:p>
+        </p:txBody>
+      </p:sp>
+      <p:sp>
+        <p:nvSpPr>
+          <p:cNvPr id="34" name="TextBox 33"/>
+          <p:cNvSpPr txBox="1"/>
+          <p:nvPr/>
+        </p:nvSpPr>
+        <p:spPr>
+          <a:xfrm>
+            <a:off x="9483620" y="2710000"/>
+            <a:ext cx="470000" cy="240000"/>
+          </a:xfrm>
+          <a:prstGeom prst="rect">
+            <a:avLst/>
+          </a:prstGeom>
+          <a:noFill/>
+        </p:spPr>
+        <p:txBody>
+          <a:bodyPr wrap="square">
+            <a:spAutoFit/>
+          </a:bodyPr>
+          <a:lstStyle/>
+          <a:p>
+            <a:pPr algn="ctr"/>
+            <a:r>
+              <a:rPr sz="1100" b="1" i="0">
+                <a:solidFill>
+                  <a:srgbClr val="FFFFFF"/>
+                </a:solidFill>
+                <a:latin typeface="Calibri"/>
+              </a:rPr>
+              <a:t>B3</a:t>
+            </a:r>
+          </a:p>
+        </p:txBody>
+      </p:sp>
+      <p:sp>
+        <p:nvSpPr>
+          <p:cNvPr id="35" name="Oval 34"/>
+          <p:cNvSpPr/>
+          <p:nvPr/>
+        </p:nvSpPr>
+        <p:spPr>
+          <a:xfrm>
+            <a:off x="11356240" y="2595000"/>
+            <a:ext cx="470000" cy="470000"/>
+          </a:xfrm>
+          <a:prstGeom prst="ellipse">
+            <a:avLst/>
+          </a:prstGeom>
+          <a:solidFill>
+            <a:srgbClr val="0068B5"/>
+          </a:solidFill>
+          <a:ln>
+            <a:noFill/>
+          </a:ln>
+          <a:effectLst/>
+        </p:spPr>
+        <p:style>
+          <a:lnRef idx="1">
+            <a:schemeClr val="accent1"/>
+          </a:lnRef>
+          <a:fillRef idx="3">
+            <a:schemeClr val="accent1"/>
+          </a:fillRef>
+          <a:effectRef idx="2">
+            <a:schemeClr val="accent1"/>
+          </a:effectRef>
+          <a:fontRef idx="minor">
+            <a:schemeClr val="lt1"/>
+          </a:fontRef>
+        </p:style>
+        <p:txBody>
+          <a:bodyPr rtlCol="0" anchor="ctr"/>
+          <a:lstStyle/>
+          <a:p>
+            <a:pPr algn="ctr"/>
+          </a:p>
+        </p:txBody>
+      </p:sp>
+      <p:sp>
+        <p:nvSpPr>
+          <p:cNvPr id="36" name="TextBox 35"/>
+          <p:cNvSpPr txBox="1"/>
+          <p:nvPr/>
+        </p:nvSpPr>
+        <p:spPr>
+          <a:xfrm>
+            <a:off x="11356240" y="2710000"/>
+            <a:ext cx="470000" cy="240000"/>
+          </a:xfrm>
+          <a:prstGeom prst="rect">
+            <a:avLst/>
+          </a:prstGeom>
+          <a:noFill/>
+        </p:spPr>
+        <p:txBody>
+          <a:bodyPr wrap="square">
+            <a:spAutoFit/>
+          </a:bodyPr>
+          <a:lstStyle/>
+          <a:p>
+            <a:pPr algn="ctr"/>
+            <a:r>
+              <a:rPr sz="1100" b="1" i="0">
+                <a:solidFill>
+                  <a:srgbClr val="FFFFFF"/>
+                </a:solidFill>
+                <a:latin typeface="Calibri"/>
+              </a:rPr>
+              <a:t>B4</a:t>
+            </a:r>
+          </a:p>
+        </p:txBody>
+      </p:sp>
+      <p:sp>
+        <p:nvSpPr>
+          <p:cNvPr id="37" name="Rectangle 36"/>
+          <p:cNvSpPr/>
+          <p:nvPr/>
+        </p:nvSpPr>
+        <p:spPr>
+          <a:xfrm>
+            <a:off x="365760" y="3380000"/>
+            <a:ext cx="11430000" cy="1120000"/>
+          </a:xfrm>
+          <a:prstGeom prst="rect">
+            <a:avLst/>
+          </a:prstGeom>
+          <a:solidFill>
+            <a:srgbClr val="F7F9FC"/>
+          </a:solidFill>
+          <a:ln>
+            <a:noFill/>
+          </a:ln>
+          <a:effectLst/>
+        </p:spPr>
+        <p:style>
+          <a:lnRef idx="1">
+            <a:schemeClr val="accent1"/>
+          </a:lnRef>
+          <a:fillRef idx="3">
+            <a:schemeClr val="accent1"/>
+          </a:fillRef>
+          <a:effectRef idx="2">
+            <a:schemeClr val="accent1"/>
+          </a:effectRef>
+          <a:fontRef idx="minor">
+            <a:schemeClr val="lt1"/>
+          </a:fontRef>
+        </p:style>
+        <p:txBody>
+          <a:bodyPr rtlCol="0" anchor="ctr"/>
+          <a:lstStyle/>
+          <a:p>
+            <a:pPr algn="ctr"/>
+          </a:p>
+        </p:txBody>
+      </p:sp>
+      <p:sp>
+        <p:nvSpPr>
+          <p:cNvPr id="38" name="Rectangle 37"/>
+          <p:cNvSpPr/>
+          <p:nvPr/>
+        </p:nvSpPr>
+        <p:spPr>
+          <a:xfrm>
+            <a:off x="365760" y="3500000"/>
+            <a:ext cx="110000" cy="860000"/>
+          </a:xfrm>
+          <a:prstGeom prst="rect">
+            <a:avLst/>
+          </a:prstGeom>
+          <a:solidFill>
+            <a:srgbClr val="0068B5"/>
+          </a:solidFill>
+          <a:ln>
+            <a:noFill/>
+          </a:ln>
+          <a:effectLst/>
+        </p:spPr>
+        <p:style>
+          <a:lnRef idx="1">
+            <a:schemeClr val="accent1"/>
+          </a:lnRef>
+          <a:fillRef idx="3">
+            <a:schemeClr val="accent1"/>
+          </a:fillRef>
+          <a:effectRef idx="2">
+            <a:schemeClr val="accent1"/>
+          </a:effectRef>
+          <a:fontRef idx="minor">
+            <a:schemeClr val="lt1"/>
+          </a:fontRef>
+        </p:style>
+        <p:txBody>
+          <a:bodyPr rtlCol="0" anchor="ctr"/>
+          <a:lstStyle/>
+          <a:p>
+            <a:pPr algn="ctr"/>
+          </a:p>
+        </p:txBody>
+      </p:sp>
+      <p:sp>
+        <p:nvSpPr>
+          <p:cNvPr id="39" name="TextBox 38"/>
+          <p:cNvSpPr txBox="1"/>
+          <p:nvPr/>
+        </p:nvSpPr>
+        <p:spPr>
+          <a:xfrm>
+            <a:off x="565760" y="3510000"/>
+            <a:ext cx="3000000" cy="920000"/>
+          </a:xfrm>
+          <a:prstGeom prst="rect">
+            <a:avLst/>
+          </a:prstGeom>
+          <a:noFill/>
+        </p:spPr>
+        <p:txBody>
+          <a:bodyPr wrap="square">
+            <a:spAutoFit/>
+          </a:bodyPr>
+          <a:lstStyle/>
+          <a:p>
+            <a:pPr algn="l"/>
+            <a:r>
+              <a:rPr sz="1600" b="1" i="0">
+                <a:solidFill>
+                  <a:srgbClr val="0068B5"/>
+                </a:solidFill>
+                <a:latin typeface="Calibri"/>
+              </a:rPr>
+              <a:t>+  θ  (grouping)</a:t>
+            </a:r>
+          </a:p>
+          <a:p>
+            <a:pPr algn="l">
+              <a:spcBef>
+                <a:spcPts val="600"/>
+              </a:spcBef>
+            </a:pPr>
+            <a:r>
+              <a:rPr sz="1200" b="0" i="0">
+                <a:solidFill>
+                  <a:srgbClr val="525252"/>
+                </a:solidFill>
+                <a:latin typeface="Calibri"/>
+              </a:rPr>
+              <a:t>Group by importance: {B0,B4} high → pruned less,  {B1,B3} low → pruned more</a:t>
+            </a:r>
+          </a:p>
+        </p:txBody>
+      </p:sp>
+      <p:cxnSp>
+        <p:nvCxnSpPr>
+          <p:cNvPr id="40" name="Connector 39"/>
+          <p:cNvCxnSpPr/>
+          <p:nvPr/>
+        </p:nvCxnSpPr>
+        <p:spPr>
+          <a:xfrm>
+            <a:off x="4335760" y="4010000"/>
+            <a:ext cx="1402620" cy="0"/>
+          </a:xfrm>
+          <a:prstGeom prst="bentConnector3">
+            <a:avLst/>
+          </a:prstGeom>
+          <a:ln w="17780">
+            <a:solidFill>
+              <a:srgbClr val="808080"/>
+            </a:solidFill>
+          </a:ln>
+          <a:effectLst/>
+        </p:spPr>
+        <p:style>
+          <a:lnRef idx="2">
+            <a:schemeClr val="accent1"/>
+          </a:lnRef>
+          <a:fillRef idx="0">
+            <a:schemeClr val="accent1"/>
+          </a:fillRef>
+          <a:effectRef idx="1">
+            <a:schemeClr val="accent1"/>
+          </a:effectRef>
+          <a:fontRef idx="minor">
+            <a:schemeClr val="tx1"/>
+          </a:fontRef>
+        </p:style>
+      </p:cxnSp>
+      <p:cxnSp>
+        <p:nvCxnSpPr>
+          <p:cNvPr id="41" name="Connector 40"/>
+          <p:cNvCxnSpPr/>
+          <p:nvPr/>
+        </p:nvCxnSpPr>
+        <p:spPr>
+          <a:xfrm>
+            <a:off x="6208380" y="4010000"/>
+            <a:ext cx="3275240" cy="0"/>
+          </a:xfrm>
+          <a:prstGeom prst="bentConnector3">
+            <a:avLst/>
+          </a:prstGeom>
+          <a:ln w="17780">
+            <a:solidFill>
+              <a:srgbClr val="808080"/>
+            </a:solidFill>
+          </a:ln>
+          <a:effectLst/>
+        </p:spPr>
+        <p:style>
+          <a:lnRef idx="2">
+            <a:schemeClr val="accent1"/>
+          </a:lnRef>
+          <a:fillRef idx="0">
+            <a:schemeClr val="accent1"/>
+          </a:fillRef>
+          <a:effectRef idx="1">
+            <a:schemeClr val="accent1"/>
+          </a:effectRef>
+          <a:fontRef idx="minor">
+            <a:schemeClr val="tx1"/>
+          </a:fontRef>
+        </p:style>
+      </p:cxnSp>
+      <p:cxnSp>
+        <p:nvCxnSpPr>
+          <p:cNvPr id="42" name="Connector 41"/>
+          <p:cNvCxnSpPr/>
+          <p:nvPr/>
+        </p:nvCxnSpPr>
+        <p:spPr>
+          <a:xfrm>
+            <a:off x="9953620" y="4010000"/>
+            <a:ext cx="1402620" cy="0"/>
+          </a:xfrm>
+          <a:prstGeom prst="bentConnector3">
+            <a:avLst/>
+          </a:prstGeom>
+          <a:ln w="17780">
+            <a:solidFill>
+              <a:srgbClr val="808080"/>
+            </a:solidFill>
+          </a:ln>
+          <a:effectLst/>
+        </p:spPr>
+        <p:style>
+          <a:lnRef idx="2">
+            <a:schemeClr val="accent1"/>
+          </a:lnRef>
+          <a:fillRef idx="0">
+            <a:schemeClr val="accent1"/>
+          </a:fillRef>
+          <a:effectRef idx="1">
+            <a:schemeClr val="accent1"/>
+          </a:effectRef>
+          <a:fontRef idx="minor">
+            <a:schemeClr val="tx1"/>
+          </a:fontRef>
+        </p:style>
+      </p:cxnSp>
+      <p:sp>
+        <p:nvSpPr>
+          <p:cNvPr id="43" name="Oval 42"/>
+          <p:cNvSpPr/>
+          <p:nvPr/>
+        </p:nvSpPr>
+        <p:spPr>
+          <a:xfrm>
+            <a:off x="3865760" y="3775000"/>
+            <a:ext cx="470000" cy="470000"/>
+          </a:xfrm>
+          <a:prstGeom prst="ellipse">
+            <a:avLst/>
+          </a:prstGeom>
+          <a:solidFill>
+            <a:srgbClr val="70AD47"/>
+          </a:solidFill>
+          <a:ln>
+            <a:noFill/>
+          </a:ln>
+          <a:effectLst/>
+        </p:spPr>
+        <p:style>
+          <a:lnRef idx="1">
+            <a:schemeClr val="accent1"/>
+          </a:lnRef>
+          <a:fillRef idx="3">
+            <a:schemeClr val="accent1"/>
+          </a:fillRef>
+          <a:effectRef idx="2">
+            <a:schemeClr val="accent1"/>
+          </a:effectRef>
+          <a:fontRef idx="minor">
+            <a:schemeClr val="lt1"/>
+          </a:fontRef>
+        </p:style>
+        <p:txBody>
+          <a:bodyPr rtlCol="0" anchor="ctr"/>
+          <a:lstStyle/>
+          <a:p>
+            <a:pPr algn="ctr"/>
+          </a:p>
+        </p:txBody>
+      </p:sp>
+      <p:sp>
+        <p:nvSpPr>
+          <p:cNvPr id="44" name="TextBox 43"/>
+          <p:cNvSpPr txBox="1"/>
+          <p:nvPr/>
+        </p:nvSpPr>
+        <p:spPr>
+          <a:xfrm>
+            <a:off x="3865760" y="3890000"/>
+            <a:ext cx="470000" cy="240000"/>
+          </a:xfrm>
+          <a:prstGeom prst="rect">
+            <a:avLst/>
+          </a:prstGeom>
+          <a:noFill/>
+        </p:spPr>
+        <p:txBody>
+          <a:bodyPr wrap="square">
+            <a:spAutoFit/>
+          </a:bodyPr>
+          <a:lstStyle/>
+          <a:p>
+            <a:pPr algn="ctr"/>
+            <a:r>
+              <a:rPr sz="1100" b="1" i="0">
+                <a:solidFill>
+                  <a:srgbClr val="FFFFFF"/>
+                </a:solidFill>
+                <a:latin typeface="Calibri"/>
+              </a:rPr>
+              <a:t>B0</a:t>
+            </a:r>
+          </a:p>
+        </p:txBody>
+      </p:sp>
+      <p:sp>
+        <p:nvSpPr>
+          <p:cNvPr id="45" name="Oval 44"/>
+          <p:cNvSpPr/>
+          <p:nvPr/>
+        </p:nvSpPr>
+        <p:spPr>
+          <a:xfrm>
+            <a:off x="5738380" y="3775000"/>
+            <a:ext cx="470000" cy="470000"/>
+          </a:xfrm>
+          <a:prstGeom prst="ellipse">
+            <a:avLst/>
+          </a:prstGeom>
+          <a:solidFill>
+            <a:srgbClr val="C0504D"/>
+          </a:solidFill>
+          <a:ln>
+            <a:noFill/>
+          </a:ln>
+          <a:effectLst/>
+        </p:spPr>
+        <p:style>
+          <a:lnRef idx="1">
+            <a:schemeClr val="accent1"/>
+          </a:lnRef>
+          <a:fillRef idx="3">
+            <a:schemeClr val="accent1"/>
+          </a:fillRef>
+          <a:effectRef idx="2">
+            <a:schemeClr val="accent1"/>
+          </a:effectRef>
+          <a:fontRef idx="minor">
+            <a:schemeClr val="lt1"/>
+          </a:fontRef>
+        </p:style>
+        <p:txBody>
+          <a:bodyPr rtlCol="0" anchor="ctr"/>
+          <a:lstStyle/>
+          <a:p>
+            <a:pPr algn="ctr"/>
+          </a:p>
+        </p:txBody>
+      </p:sp>
+      <p:sp>
+        <p:nvSpPr>
+          <p:cNvPr id="46" name="TextBox 45"/>
+          <p:cNvSpPr txBox="1"/>
+          <p:nvPr/>
+        </p:nvSpPr>
+        <p:spPr>
+          <a:xfrm>
+            <a:off x="5738380" y="3890000"/>
+            <a:ext cx="470000" cy="240000"/>
+          </a:xfrm>
+          <a:prstGeom prst="rect">
+            <a:avLst/>
+          </a:prstGeom>
+          <a:noFill/>
+        </p:spPr>
+        <p:txBody>
+          <a:bodyPr wrap="square">
+            <a:spAutoFit/>
+          </a:bodyPr>
+          <a:lstStyle/>
+          <a:p>
+            <a:pPr algn="ctr"/>
+            <a:r>
+              <a:rPr sz="1100" b="1" i="0">
+                <a:solidFill>
+                  <a:srgbClr val="FFFFFF"/>
+                </a:solidFill>
+                <a:latin typeface="Calibri"/>
+              </a:rPr>
+              <a:t>B1</a:t>
+            </a:r>
+          </a:p>
+        </p:txBody>
+      </p:sp>
+      <p:sp>
+        <p:nvSpPr>
+          <p:cNvPr id="47" name="Oval 46"/>
+          <p:cNvSpPr/>
+          <p:nvPr/>
+        </p:nvSpPr>
+        <p:spPr>
+          <a:xfrm>
+            <a:off x="7611000" y="3775000"/>
+            <a:ext cx="470000" cy="470000"/>
+          </a:xfrm>
+          <a:prstGeom prst="ellipse">
+            <a:avLst/>
+          </a:prstGeom>
+          <a:solidFill>
+            <a:srgbClr val="EDEDED"/>
+          </a:solidFill>
+          <a:ln w="9525">
+            <a:solidFill>
+              <a:srgbClr val="BFBFBF"/>
+            </a:solidFill>
+          </a:ln>
+          <a:effectLst/>
+        </p:spPr>
+        <p:style>
+          <a:lnRef idx="1">
+            <a:schemeClr val="accent1"/>
+          </a:lnRef>
+          <a:fillRef idx="3">
+            <a:schemeClr val="accent1"/>
+          </a:fillRef>
+          <a:effectRef idx="2">
+            <a:schemeClr val="accent1"/>
+          </a:effectRef>
+          <a:fontRef idx="minor">
+            <a:schemeClr val="lt1"/>
+          </a:fontRef>
+        </p:style>
+        <p:txBody>
+          <a:bodyPr rtlCol="0" anchor="ctr"/>
+          <a:lstStyle/>
+          <a:p>
+            <a:pPr algn="ctr"/>
+          </a:p>
+        </p:txBody>
+      </p:sp>
+      <p:sp>
+        <p:nvSpPr>
+          <p:cNvPr id="48" name="TextBox 47"/>
+          <p:cNvSpPr txBox="1"/>
+          <p:nvPr/>
+        </p:nvSpPr>
+        <p:spPr>
+          <a:xfrm>
+            <a:off x="7611000" y="3860000"/>
+            <a:ext cx="470000" cy="300000"/>
+          </a:xfrm>
+          <a:prstGeom prst="rect">
+            <a:avLst/>
+          </a:prstGeom>
+          <a:noFill/>
+        </p:spPr>
+        <p:txBody>
+          <a:bodyPr wrap="square">
+            <a:spAutoFit/>
+          </a:bodyPr>
+          <a:lstStyle/>
+          <a:p>
+            <a:pPr algn="ctr"/>
+            <a:r>
+              <a:rPr sz="2000" b="1" i="0">
+                <a:solidFill>
+                  <a:srgbClr val="C0504D"/>
+                </a:solidFill>
+                <a:latin typeface="Calibri"/>
+              </a:rPr>
+              <a:t>✕</a:t>
+            </a:r>
+          </a:p>
+        </p:txBody>
+      </p:sp>
+      <p:sp>
+        <p:nvSpPr>
+          <p:cNvPr id="49" name="Oval 48"/>
+          <p:cNvSpPr/>
+          <p:nvPr/>
+        </p:nvSpPr>
+        <p:spPr>
+          <a:xfrm>
+            <a:off x="9483620" y="3775000"/>
+            <a:ext cx="470000" cy="470000"/>
+          </a:xfrm>
+          <a:prstGeom prst="ellipse">
+            <a:avLst/>
+          </a:prstGeom>
+          <a:solidFill>
+            <a:srgbClr val="C0504D"/>
+          </a:solidFill>
+          <a:ln>
+            <a:noFill/>
+          </a:ln>
+          <a:effectLst/>
+        </p:spPr>
+        <p:style>
+          <a:lnRef idx="1">
+            <a:schemeClr val="accent1"/>
+          </a:lnRef>
+          <a:fillRef idx="3">
+            <a:schemeClr val="accent1"/>
+          </a:fillRef>
+          <a:effectRef idx="2">
+            <a:schemeClr val="accent1"/>
+          </a:effectRef>
+          <a:fontRef idx="minor">
+            <a:schemeClr val="lt1"/>
+          </a:fontRef>
+        </p:style>
+        <p:txBody>
+          <a:bodyPr rtlCol="0" anchor="ctr"/>
+          <a:lstStyle/>
+          <a:p>
+            <a:pPr algn="ctr"/>
+          </a:p>
+        </p:txBody>
+      </p:sp>
+      <p:sp>
+        <p:nvSpPr>
+          <p:cNvPr id="50" name="TextBox 49"/>
+          <p:cNvSpPr txBox="1"/>
+          <p:nvPr/>
+        </p:nvSpPr>
+        <p:spPr>
+          <a:xfrm>
+            <a:off x="9483620" y="3890000"/>
+            <a:ext cx="470000" cy="240000"/>
+          </a:xfrm>
+          <a:prstGeom prst="rect">
+            <a:avLst/>
+          </a:prstGeom>
+          <a:noFill/>
+        </p:spPr>
+        <p:txBody>
+          <a:bodyPr wrap="square">
+            <a:spAutoFit/>
+          </a:bodyPr>
+          <a:lstStyle/>
+          <a:p>
+            <a:pPr algn="ctr"/>
+            <a:r>
+              <a:rPr sz="1100" b="1" i="0">
+                <a:solidFill>
+                  <a:srgbClr val="FFFFFF"/>
+                </a:solidFill>
+                <a:latin typeface="Calibri"/>
+              </a:rPr>
+              <a:t>B3</a:t>
+            </a:r>
+          </a:p>
+        </p:txBody>
+      </p:sp>
+      <p:sp>
+        <p:nvSpPr>
+          <p:cNvPr id="51" name="Oval 50"/>
+          <p:cNvSpPr/>
+          <p:nvPr/>
+        </p:nvSpPr>
+        <p:spPr>
+          <a:xfrm>
+            <a:off x="11356240" y="3775000"/>
+            <a:ext cx="470000" cy="470000"/>
+          </a:xfrm>
+          <a:prstGeom prst="ellipse">
+            <a:avLst/>
+          </a:prstGeom>
+          <a:solidFill>
+            <a:srgbClr val="70AD47"/>
+          </a:solidFill>
+          <a:ln>
+            <a:noFill/>
+          </a:ln>
+          <a:effectLst/>
+        </p:spPr>
+        <p:style>
+          <a:lnRef idx="1">
+            <a:schemeClr val="accent1"/>
+          </a:lnRef>
+          <a:fillRef idx="3">
+            <a:schemeClr val="accent1"/>
+          </a:fillRef>
+          <a:effectRef idx="2">
+            <a:schemeClr val="accent1"/>
+          </a:effectRef>
+          <a:fontRef idx="minor">
+            <a:schemeClr val="lt1"/>
+          </a:fontRef>
+        </p:style>
+        <p:txBody>
+          <a:bodyPr rtlCol="0" anchor="ctr"/>
+          <a:lstStyle/>
+          <a:p>
+            <a:pPr algn="ctr"/>
+          </a:p>
+        </p:txBody>
+      </p:sp>
+      <p:sp>
+        <p:nvSpPr>
+          <p:cNvPr id="52" name="TextBox 51"/>
+          <p:cNvSpPr txBox="1"/>
+          <p:nvPr/>
+        </p:nvSpPr>
+        <p:spPr>
+          <a:xfrm>
+            <a:off x="11356240" y="3890000"/>
+            <a:ext cx="470000" cy="240000"/>
+          </a:xfrm>
+          <a:prstGeom prst="rect">
+            <a:avLst/>
+          </a:prstGeom>
+          <a:noFill/>
+        </p:spPr>
+        <p:txBody>
+          <a:bodyPr wrap="square">
+            <a:spAutoFit/>
+          </a:bodyPr>
+          <a:lstStyle/>
+          <a:p>
+            <a:pPr algn="ctr"/>
+            <a:r>
+              <a:rPr sz="1100" b="1" i="0">
+                <a:solidFill>
+                  <a:srgbClr val="FFFFFF"/>
+                </a:solidFill>
+                <a:latin typeface="Calibri"/>
+              </a:rPr>
+              <a:t>B4</a:t>
+            </a:r>
+          </a:p>
+        </p:txBody>
+      </p:sp>
+      <p:sp>
+        <p:nvSpPr>
+          <p:cNvPr id="53" name="Rectangle 52"/>
+          <p:cNvSpPr/>
+          <p:nvPr/>
+        </p:nvSpPr>
+        <p:spPr>
+          <a:xfrm>
+            <a:off x="365760" y="4680000"/>
+            <a:ext cx="110000" cy="860000"/>
+          </a:xfrm>
+          <a:prstGeom prst="rect">
+            <a:avLst/>
+          </a:prstGeom>
+          <a:solidFill>
+            <a:srgbClr val="FFA300"/>
+          </a:solidFill>
+          <a:ln>
+            <a:noFill/>
+          </a:ln>
+          <a:effectLst/>
+        </p:spPr>
+        <p:style>
+          <a:lnRef idx="1">
+            <a:schemeClr val="accent1"/>
+          </a:lnRef>
+          <a:fillRef idx="3">
+            <a:schemeClr val="accent1"/>
+          </a:fillRef>
+          <a:effectRef idx="2">
+            <a:schemeClr val="accent1"/>
+          </a:effectRef>
+          <a:fontRef idx="minor">
+            <a:schemeClr val="lt1"/>
+          </a:fontRef>
+        </p:style>
+        <p:txBody>
+          <a:bodyPr rtlCol="0" anchor="ctr"/>
+          <a:lstStyle/>
+          <a:p>
+            <a:pPr algn="ctr"/>
+          </a:p>
+        </p:txBody>
+      </p:sp>
+      <p:sp>
+        <p:nvSpPr>
+          <p:cNvPr id="54" name="TextBox 53"/>
+          <p:cNvSpPr txBox="1"/>
+          <p:nvPr/>
+        </p:nvSpPr>
+        <p:spPr>
+          <a:xfrm>
+            <a:off x="565760" y="4690000"/>
+            <a:ext cx="3000000" cy="920000"/>
+          </a:xfrm>
+          <a:prstGeom prst="rect">
+            <a:avLst/>
+          </a:prstGeom>
+          <a:noFill/>
+        </p:spPr>
+        <p:txBody>
+          <a:bodyPr wrap="square">
+            <a:spAutoFit/>
+          </a:bodyPr>
+          <a:lstStyle/>
+          <a:p>
+            <a:pPr algn="l"/>
+            <a:r>
+              <a:rPr sz="1600" b="1" i="0">
+                <a:solidFill>
+                  <a:srgbClr val="FFA300"/>
+                </a:solidFill>
+                <a:latin typeface="Calibri"/>
+              </a:rPr>
+              <a:t>+  α  (coupling)</a:t>
+            </a:r>
+          </a:p>
+          <a:p>
+            <a:pPr algn="l">
+              <a:spcBef>
+                <a:spcPts val="600"/>
+              </a:spcBef>
+            </a:pPr>
+            <a:r>
+              <a:rPr sz="1200" b="0" i="0">
+                <a:solidFill>
+                  <a:srgbClr val="525252"/>
+                </a:solidFill>
+                <a:latin typeface="Calibri"/>
+              </a:rPr>
+              <a:t>Functional edges link similar blocks: B0–B4 and B1–B3 boost each other</a:t>
+            </a:r>
+          </a:p>
+        </p:txBody>
+      </p:sp>
+      <p:cxnSp>
+        <p:nvCxnSpPr>
+          <p:cNvPr id="55" name="Connector 54"/>
+          <p:cNvCxnSpPr/>
+          <p:nvPr/>
+        </p:nvCxnSpPr>
+        <p:spPr>
+          <a:xfrm>
+            <a:off x="4335760" y="5190000"/>
+            <a:ext cx="1402620" cy="0"/>
+          </a:xfrm>
+          <a:prstGeom prst="bentConnector3">
+            <a:avLst/>
+          </a:prstGeom>
+          <a:ln w="17780">
+            <a:solidFill>
+              <a:srgbClr val="808080"/>
+            </a:solidFill>
+          </a:ln>
+          <a:effectLst/>
+        </p:spPr>
+        <p:style>
+          <a:lnRef idx="2">
+            <a:schemeClr val="accent1"/>
+          </a:lnRef>
+          <a:fillRef idx="0">
+            <a:schemeClr val="accent1"/>
+          </a:fillRef>
+          <a:effectRef idx="1">
+            <a:schemeClr val="accent1"/>
+          </a:effectRef>
+          <a:fontRef idx="minor">
+            <a:schemeClr val="tx1"/>
+          </a:fontRef>
+        </p:style>
+      </p:cxnSp>
+      <p:cxnSp>
+        <p:nvCxnSpPr>
+          <p:cNvPr id="56" name="Connector 55"/>
+          <p:cNvCxnSpPr/>
+          <p:nvPr/>
+        </p:nvCxnSpPr>
+        <p:spPr>
+          <a:xfrm>
+            <a:off x="6208380" y="5190000"/>
+            <a:ext cx="3275240" cy="0"/>
+          </a:xfrm>
+          <a:prstGeom prst="bentConnector3">
+            <a:avLst/>
+          </a:prstGeom>
+          <a:ln w="17780">
+            <a:solidFill>
+              <a:srgbClr val="808080"/>
+            </a:solidFill>
+          </a:ln>
+          <a:effectLst/>
+        </p:spPr>
+        <p:style>
+          <a:lnRef idx="2">
+            <a:schemeClr val="accent1"/>
+          </a:lnRef>
+          <a:fillRef idx="0">
+            <a:schemeClr val="accent1"/>
+          </a:fillRef>
+          <a:effectRef idx="1">
+            <a:schemeClr val="accent1"/>
+          </a:effectRef>
+          <a:fontRef idx="minor">
+            <a:schemeClr val="tx1"/>
+          </a:fontRef>
+        </p:style>
+      </p:cxnSp>
+      <p:cxnSp>
+        <p:nvCxnSpPr>
+          <p:cNvPr id="57" name="Connector 56"/>
+          <p:cNvCxnSpPr/>
+          <p:nvPr/>
+        </p:nvCxnSpPr>
+        <p:spPr>
+          <a:xfrm>
+            <a:off x="9953620" y="5190000"/>
+            <a:ext cx="1402620" cy="0"/>
+          </a:xfrm>
+          <a:prstGeom prst="bentConnector3">
+            <a:avLst/>
+          </a:prstGeom>
+          <a:ln w="17780">
+            <a:solidFill>
+              <a:srgbClr val="808080"/>
+            </a:solidFill>
+          </a:ln>
+          <a:effectLst/>
+        </p:spPr>
+        <p:style>
+          <a:lnRef idx="2">
+            <a:schemeClr val="accent1"/>
+          </a:lnRef>
+          <a:fillRef idx="0">
+            <a:schemeClr val="accent1"/>
+          </a:fillRef>
+          <a:effectRef idx="1">
+            <a:schemeClr val="accent1"/>
+          </a:effectRef>
+          <a:fontRef idx="minor">
+            <a:schemeClr val="tx1"/>
+          </a:fontRef>
+        </p:style>
+      </p:cxnSp>
+      <p:cxnSp>
+        <p:nvCxnSpPr>
+          <p:cNvPr id="58" name="Connector 57"/>
+          <p:cNvCxnSpPr/>
+          <p:nvPr/>
+        </p:nvCxnSpPr>
+        <p:spPr>
+          <a:xfrm flipV="1">
+            <a:off x="4100760" y="4725000"/>
+            <a:ext cx="0" cy="230000"/>
+          </a:xfrm>
+          <a:prstGeom prst="bentConnector3">
+            <a:avLst/>
+          </a:prstGeom>
+          <a:ln w="15875">
+            <a:solidFill>
+              <a:srgbClr val="FFA300"/>
+            </a:solidFill>
+            <a:prstDash val="dash"/>
+          </a:ln>
+          <a:effectLst/>
+        </p:spPr>
+        <p:style>
+          <a:lnRef idx="2">
+            <a:schemeClr val="accent1"/>
+          </a:lnRef>
+          <a:fillRef idx="0">
+            <a:schemeClr val="accent1"/>
+          </a:fillRef>
+          <a:effectRef idx="1">
+            <a:schemeClr val="accent1"/>
+          </a:effectRef>
+          <a:fontRef idx="minor">
+            <a:schemeClr val="tx1"/>
+          </a:fontRef>
+        </p:style>
+      </p:cxnSp>
+      <p:cxnSp>
+        <p:nvCxnSpPr>
+          <p:cNvPr id="59" name="Connector 58"/>
+          <p:cNvCxnSpPr/>
+          <p:nvPr/>
+        </p:nvCxnSpPr>
+        <p:spPr>
+          <a:xfrm>
+            <a:off x="4100760" y="4725000"/>
+            <a:ext cx="7490480" cy="0"/>
+          </a:xfrm>
+          <a:prstGeom prst="bentConnector3">
+            <a:avLst/>
+          </a:prstGeom>
+          <a:ln w="15875">
+            <a:solidFill>
+              <a:srgbClr val="FFA300"/>
+            </a:solidFill>
+            <a:prstDash val="dash"/>
+          </a:ln>
+          <a:effectLst/>
+        </p:spPr>
+        <p:style>
+          <a:lnRef idx="2">
+            <a:schemeClr val="accent1"/>
+          </a:lnRef>
+          <a:fillRef idx="0">
+            <a:schemeClr val="accent1"/>
+          </a:fillRef>
+          <a:effectRef idx="1">
+            <a:schemeClr val="accent1"/>
+          </a:effectRef>
+          <a:fontRef idx="minor">
+            <a:schemeClr val="tx1"/>
+          </a:fontRef>
+        </p:style>
+      </p:cxnSp>
+      <p:cxnSp>
+        <p:nvCxnSpPr>
+          <p:cNvPr id="60" name="Connector 59"/>
+          <p:cNvCxnSpPr/>
+          <p:nvPr/>
+        </p:nvCxnSpPr>
+        <p:spPr>
+          <a:xfrm>
+            <a:off x="11591240" y="4725000"/>
+            <a:ext cx="0" cy="230000"/>
+          </a:xfrm>
+          <a:prstGeom prst="bentConnector3">
+            <a:avLst/>
+          </a:prstGeom>
+          <a:ln w="15875">
+            <a:solidFill>
+              <a:srgbClr val="FFA300"/>
+            </a:solidFill>
+            <a:prstDash val="dash"/>
+          </a:ln>
+          <a:effectLst/>
+        </p:spPr>
+        <p:style>
+          <a:lnRef idx="2">
+            <a:schemeClr val="accent1"/>
+          </a:lnRef>
+          <a:fillRef idx="0">
+            <a:schemeClr val="accent1"/>
+          </a:fillRef>
+          <a:effectRef idx="1">
+            <a:schemeClr val="accent1"/>
+          </a:effectRef>
+          <a:fontRef idx="minor">
+            <a:schemeClr val="tx1"/>
+          </a:fontRef>
+        </p:style>
+      </p:cxnSp>
+      <p:cxnSp>
+        <p:nvCxnSpPr>
+          <p:cNvPr id="61" name="Connector 60"/>
+          <p:cNvCxnSpPr/>
+          <p:nvPr/>
+        </p:nvCxnSpPr>
+        <p:spPr>
+          <a:xfrm flipV="1">
+            <a:off x="5973380" y="4725000"/>
+            <a:ext cx="0" cy="230000"/>
+          </a:xfrm>
+          <a:prstGeom prst="bentConnector3">
+            <a:avLst/>
+          </a:prstGeom>
+          <a:ln w="15875">
+            <a:solidFill>
+              <a:srgbClr val="FFA300"/>
+            </a:solidFill>
+            <a:prstDash val="dash"/>
+          </a:ln>
+          <a:effectLst/>
+        </p:spPr>
+        <p:style>
+          <a:lnRef idx="2">
+            <a:schemeClr val="accent1"/>
+          </a:lnRef>
+          <a:fillRef idx="0">
+            <a:schemeClr val="accent1"/>
+          </a:fillRef>
+          <a:effectRef idx="1">
+            <a:schemeClr val="accent1"/>
+          </a:effectRef>
+          <a:fontRef idx="minor">
+            <a:schemeClr val="tx1"/>
+          </a:fontRef>
+        </p:style>
+      </p:cxnSp>
+      <p:cxnSp>
+        <p:nvCxnSpPr>
+          <p:cNvPr id="62" name="Connector 61"/>
+          <p:cNvCxnSpPr/>
+          <p:nvPr/>
+        </p:nvCxnSpPr>
+        <p:spPr>
+          <a:xfrm>
+            <a:off x="5973380" y="4725000"/>
+            <a:ext cx="3745240" cy="0"/>
+          </a:xfrm>
+          <a:prstGeom prst="bentConnector3">
+            <a:avLst/>
+          </a:prstGeom>
+          <a:ln w="15875">
+            <a:solidFill>
+              <a:srgbClr val="FFA300"/>
+            </a:solidFill>
+            <a:prstDash val="dash"/>
+          </a:ln>
+          <a:effectLst/>
+        </p:spPr>
+        <p:style>
+          <a:lnRef idx="2">
+            <a:schemeClr val="accent1"/>
+          </a:lnRef>
+          <a:fillRef idx="0">
+            <a:schemeClr val="accent1"/>
+          </a:fillRef>
+          <a:effectRef idx="1">
+            <a:schemeClr val="accent1"/>
+          </a:effectRef>
+          <a:fontRef idx="minor">
+            <a:schemeClr val="tx1"/>
+          </a:fontRef>
+        </p:style>
+      </p:cxnSp>
+      <p:cxnSp>
+        <p:nvCxnSpPr>
+          <p:cNvPr id="63" name="Connector 62"/>
+          <p:cNvCxnSpPr/>
+          <p:nvPr/>
+        </p:nvCxnSpPr>
+        <p:spPr>
+          <a:xfrm>
+            <a:off x="9718620" y="4725000"/>
+            <a:ext cx="0" cy="230000"/>
+          </a:xfrm>
+          <a:prstGeom prst="bentConnector3">
+            <a:avLst/>
+          </a:prstGeom>
+          <a:ln w="15875">
+            <a:solidFill>
+              <a:srgbClr val="FFA300"/>
+            </a:solidFill>
+            <a:prstDash val="dash"/>
+          </a:ln>
+          <a:effectLst/>
+        </p:spPr>
+        <p:style>
+          <a:lnRef idx="2">
+            <a:schemeClr val="accent1"/>
+          </a:lnRef>
+          <a:fillRef idx="0">
+            <a:schemeClr val="accent1"/>
+          </a:fillRef>
+          <a:effectRef idx="1">
+            <a:schemeClr val="accent1"/>
+          </a:effectRef>
+          <a:fontRef idx="minor">
+            <a:schemeClr val="tx1"/>
+          </a:fontRef>
+        </p:style>
+      </p:cxnSp>
+      <p:sp>
+        <p:nvSpPr>
+          <p:cNvPr id="64" name="Oval 63"/>
+          <p:cNvSpPr/>
+          <p:nvPr/>
+        </p:nvSpPr>
+        <p:spPr>
+          <a:xfrm>
+            <a:off x="3865760" y="4955000"/>
+            <a:ext cx="470000" cy="470000"/>
+          </a:xfrm>
+          <a:prstGeom prst="ellipse">
+            <a:avLst/>
+          </a:prstGeom>
+          <a:solidFill>
+            <a:srgbClr val="70AD47"/>
+          </a:solidFill>
+          <a:ln>
+            <a:noFill/>
+          </a:ln>
+          <a:effectLst/>
+        </p:spPr>
+        <p:style>
+          <a:lnRef idx="1">
+            <a:schemeClr val="accent1"/>
+          </a:lnRef>
+          <a:fillRef idx="3">
+            <a:schemeClr val="accent1"/>
+          </a:fillRef>
+          <a:effectRef idx="2">
+            <a:schemeClr val="accent1"/>
+          </a:effectRef>
+          <a:fontRef idx="minor">
+            <a:schemeClr val="lt1"/>
+          </a:fontRef>
+        </p:style>
+        <p:txBody>
+          <a:bodyPr rtlCol="0" anchor="ctr"/>
+          <a:lstStyle/>
+          <a:p>
+            <a:pPr algn="ctr"/>
+          </a:p>
+        </p:txBody>
+      </p:sp>
+      <p:sp>
+        <p:nvSpPr>
+          <p:cNvPr id="65" name="TextBox 64"/>
+          <p:cNvSpPr txBox="1"/>
+          <p:nvPr/>
+        </p:nvSpPr>
+        <p:spPr>
+          <a:xfrm>
+            <a:off x="3865760" y="5070000"/>
+            <a:ext cx="470000" cy="240000"/>
+          </a:xfrm>
+          <a:prstGeom prst="rect">
+            <a:avLst/>
+          </a:prstGeom>
+          <a:noFill/>
+        </p:spPr>
+        <p:txBody>
+          <a:bodyPr wrap="square">
+            <a:spAutoFit/>
+          </a:bodyPr>
+          <a:lstStyle/>
+          <a:p>
+            <a:pPr algn="ctr"/>
+            <a:r>
+              <a:rPr sz="1100" b="1" i="0">
+                <a:solidFill>
+                  <a:srgbClr val="FFFFFF"/>
+                </a:solidFill>
+                <a:latin typeface="Calibri"/>
+              </a:rPr>
+              <a:t>B0</a:t>
+            </a:r>
+          </a:p>
+        </p:txBody>
+      </p:sp>
+      <p:sp>
+        <p:nvSpPr>
+          <p:cNvPr id="66" name="Oval 65"/>
+          <p:cNvSpPr/>
+          <p:nvPr/>
+        </p:nvSpPr>
+        <p:spPr>
+          <a:xfrm>
+            <a:off x="5738380" y="4955000"/>
+            <a:ext cx="470000" cy="470000"/>
+          </a:xfrm>
+          <a:prstGeom prst="ellipse">
+            <a:avLst/>
+          </a:prstGeom>
+          <a:solidFill>
+            <a:srgbClr val="C0504D"/>
+          </a:solidFill>
+          <a:ln>
+            <a:noFill/>
+          </a:ln>
+          <a:effectLst/>
+        </p:spPr>
+        <p:style>
+          <a:lnRef idx="1">
+            <a:schemeClr val="accent1"/>
+          </a:lnRef>
+          <a:fillRef idx="3">
+            <a:schemeClr val="accent1"/>
+          </a:fillRef>
+          <a:effectRef idx="2">
+            <a:schemeClr val="accent1"/>
+          </a:effectRef>
+          <a:fontRef idx="minor">
+            <a:schemeClr val="lt1"/>
+          </a:fontRef>
+        </p:style>
+        <p:txBody>
+          <a:bodyPr rtlCol="0" anchor="ctr"/>
+          <a:lstStyle/>
+          <a:p>
+            <a:pPr algn="ctr"/>
+          </a:p>
+        </p:txBody>
+      </p:sp>
+      <p:sp>
+        <p:nvSpPr>
+          <p:cNvPr id="67" name="TextBox 66"/>
+          <p:cNvSpPr txBox="1"/>
+          <p:nvPr/>
+        </p:nvSpPr>
+        <p:spPr>
+          <a:xfrm>
+            <a:off x="5738380" y="5070000"/>
+            <a:ext cx="470000" cy="240000"/>
+          </a:xfrm>
+          <a:prstGeom prst="rect">
+            <a:avLst/>
+          </a:prstGeom>
+          <a:noFill/>
+        </p:spPr>
+        <p:txBody>
+          <a:bodyPr wrap="square">
+            <a:spAutoFit/>
+          </a:bodyPr>
+          <a:lstStyle/>
+          <a:p>
+            <a:pPr algn="ctr"/>
+            <a:r>
+              <a:rPr sz="1100" b="1" i="0">
+                <a:solidFill>
+                  <a:srgbClr val="FFFFFF"/>
+                </a:solidFill>
+                <a:latin typeface="Calibri"/>
+              </a:rPr>
+              <a:t>B1</a:t>
+            </a:r>
+          </a:p>
+        </p:txBody>
+      </p:sp>
+      <p:sp>
+        <p:nvSpPr>
+          <p:cNvPr id="68" name="Oval 67"/>
+          <p:cNvSpPr/>
+          <p:nvPr/>
+        </p:nvSpPr>
+        <p:spPr>
+          <a:xfrm>
+            <a:off x="7611000" y="4955000"/>
+            <a:ext cx="470000" cy="470000"/>
+          </a:xfrm>
+          <a:prstGeom prst="ellipse">
+            <a:avLst/>
+          </a:prstGeom>
+          <a:solidFill>
+            <a:srgbClr val="EDEDED"/>
+          </a:solidFill>
+          <a:ln w="9525">
+            <a:solidFill>
+              <a:srgbClr val="BFBFBF"/>
+            </a:solidFill>
+          </a:ln>
+          <a:effectLst/>
+        </p:spPr>
+        <p:style>
+          <a:lnRef idx="1">
+            <a:schemeClr val="accent1"/>
+          </a:lnRef>
+          <a:fillRef idx="3">
+            <a:schemeClr val="accent1"/>
+          </a:fillRef>
+          <a:effectRef idx="2">
+            <a:schemeClr val="accent1"/>
+          </a:effectRef>
+          <a:fontRef idx="minor">
+            <a:schemeClr val="lt1"/>
+          </a:fontRef>
+        </p:style>
+        <p:txBody>
+          <a:bodyPr rtlCol="0" anchor="ctr"/>
+          <a:lstStyle/>
+          <a:p>
+            <a:pPr algn="ctr"/>
+          </a:p>
+        </p:txBody>
+      </p:sp>
+      <p:sp>
+        <p:nvSpPr>
+          <p:cNvPr id="69" name="TextBox 68"/>
+          <p:cNvSpPr txBox="1"/>
+          <p:nvPr/>
+        </p:nvSpPr>
+        <p:spPr>
+          <a:xfrm>
+            <a:off x="7611000" y="5040000"/>
+            <a:ext cx="470000" cy="300000"/>
+          </a:xfrm>
+          <a:prstGeom prst="rect">
+            <a:avLst/>
+          </a:prstGeom>
+          <a:noFill/>
+        </p:spPr>
+        <p:txBody>
+          <a:bodyPr wrap="square">
+            <a:spAutoFit/>
+          </a:bodyPr>
+          <a:lstStyle/>
+          <a:p>
+            <a:pPr algn="ctr"/>
+            <a:r>
+              <a:rPr sz="2000" b="1" i="0">
+                <a:solidFill>
+                  <a:srgbClr val="C0504D"/>
+                </a:solidFill>
+                <a:latin typeface="Calibri"/>
+              </a:rPr>
+              <a:t>✕</a:t>
+            </a:r>
+          </a:p>
+        </p:txBody>
+      </p:sp>
+      <p:sp>
+        <p:nvSpPr>
+          <p:cNvPr id="70" name="Oval 69"/>
+          <p:cNvSpPr/>
+          <p:nvPr/>
+        </p:nvSpPr>
+        <p:spPr>
+          <a:xfrm>
+            <a:off x="9483620" y="4955000"/>
+            <a:ext cx="470000" cy="470000"/>
+          </a:xfrm>
+          <a:prstGeom prst="ellipse">
+            <a:avLst/>
+          </a:prstGeom>
+          <a:solidFill>
+            <a:srgbClr val="C0504D"/>
+          </a:solidFill>
+          <a:ln>
+            <a:noFill/>
+          </a:ln>
+          <a:effectLst/>
+        </p:spPr>
+        <p:style>
+          <a:lnRef idx="1">
+            <a:schemeClr val="accent1"/>
+          </a:lnRef>
+          <a:fillRef idx="3">
+            <a:schemeClr val="accent1"/>
+          </a:fillRef>
+          <a:effectRef idx="2">
+            <a:schemeClr val="accent1"/>
+          </a:effectRef>
+          <a:fontRef idx="minor">
+            <a:schemeClr val="lt1"/>
+          </a:fontRef>
+        </p:style>
+        <p:txBody>
+          <a:bodyPr rtlCol="0" anchor="ctr"/>
+          <a:lstStyle/>
+          <a:p>
+            <a:pPr algn="ctr"/>
+          </a:p>
+        </p:txBody>
+      </p:sp>
+      <p:sp>
+        <p:nvSpPr>
+          <p:cNvPr id="71" name="TextBox 70"/>
+          <p:cNvSpPr txBox="1"/>
+          <p:nvPr/>
+        </p:nvSpPr>
+        <p:spPr>
+          <a:xfrm>
+            <a:off x="9483620" y="5070000"/>
+            <a:ext cx="470000" cy="240000"/>
+          </a:xfrm>
+          <a:prstGeom prst="rect">
+            <a:avLst/>
+          </a:prstGeom>
+          <a:noFill/>
+        </p:spPr>
+        <p:txBody>
+          <a:bodyPr wrap="square">
+            <a:spAutoFit/>
+          </a:bodyPr>
+          <a:lstStyle/>
+          <a:p>
+            <a:pPr algn="ctr"/>
+            <a:r>
+              <a:rPr sz="1100" b="1" i="0">
+                <a:solidFill>
+                  <a:srgbClr val="FFFFFF"/>
+                </a:solidFill>
+                <a:latin typeface="Calibri"/>
+              </a:rPr>
+              <a:t>B3</a:t>
+            </a:r>
+          </a:p>
+        </p:txBody>
+      </p:sp>
+      <p:sp>
+        <p:nvSpPr>
+          <p:cNvPr id="72" name="Oval 71"/>
+          <p:cNvSpPr/>
+          <p:nvPr/>
+        </p:nvSpPr>
+        <p:spPr>
+          <a:xfrm>
+            <a:off x="11356240" y="4955000"/>
+            <a:ext cx="470000" cy="470000"/>
+          </a:xfrm>
+          <a:prstGeom prst="ellipse">
+            <a:avLst/>
+          </a:prstGeom>
+          <a:solidFill>
+            <a:srgbClr val="70AD47"/>
+          </a:solidFill>
+          <a:ln>
+            <a:noFill/>
+          </a:ln>
+          <a:effectLst/>
+        </p:spPr>
+        <p:style>
+          <a:lnRef idx="1">
+            <a:schemeClr val="accent1"/>
+          </a:lnRef>
+          <a:fillRef idx="3">
+            <a:schemeClr val="accent1"/>
+          </a:fillRef>
+          <a:effectRef idx="2">
+            <a:schemeClr val="accent1"/>
+          </a:effectRef>
+          <a:fontRef idx="minor">
+            <a:schemeClr val="lt1"/>
+          </a:fontRef>
+        </p:style>
+        <p:txBody>
+          <a:bodyPr rtlCol="0" anchor="ctr"/>
+          <a:lstStyle/>
+          <a:p>
+            <a:pPr algn="ctr"/>
+          </a:p>
+        </p:txBody>
+      </p:sp>
+      <p:sp>
+        <p:nvSpPr>
+          <p:cNvPr id="73" name="TextBox 72"/>
+          <p:cNvSpPr txBox="1"/>
+          <p:nvPr/>
+        </p:nvSpPr>
+        <p:spPr>
+          <a:xfrm>
+            <a:off x="11356240" y="5070000"/>
+            <a:ext cx="470000" cy="240000"/>
+          </a:xfrm>
+          <a:prstGeom prst="rect">
+            <a:avLst/>
+          </a:prstGeom>
+          <a:noFill/>
+        </p:spPr>
+        <p:txBody>
+          <a:bodyPr wrap="square">
+            <a:spAutoFit/>
+          </a:bodyPr>
+          <a:lstStyle/>
+          <a:p>
+            <a:pPr algn="ctr"/>
+            <a:r>
+              <a:rPr sz="1100" b="1" i="0">
+                <a:solidFill>
+                  <a:srgbClr val="FFFFFF"/>
+                </a:solidFill>
+                <a:latin typeface="Calibri"/>
+              </a:rPr>
+              <a:t>B4</a:t>
+            </a:r>
+          </a:p>
+        </p:txBody>
+      </p:sp>
+      <p:sp>
+        <p:nvSpPr>
+          <p:cNvPr id="74" name="TextBox 73"/>
+          <p:cNvSpPr txBox="1"/>
+          <p:nvPr/>
+        </p:nvSpPr>
+        <p:spPr>
+          <a:xfrm>
+            <a:off x="365760" y="6388000"/>
+            <a:ext cx="11430000" cy="320000"/>
+          </a:xfrm>
+          <a:prstGeom prst="rect">
+            <a:avLst/>
+          </a:prstGeom>
+          <a:noFill/>
+        </p:spPr>
+        <p:txBody>
+          <a:bodyPr wrap="square">
+            <a:spAutoFit/>
+          </a:bodyPr>
+          <a:lstStyle/>
+          <a:p>
+            <a:pPr algn="l"/>
+            <a:r>
+              <a:rPr sz="1200" b="0" i="1">
+                <a:solidFill>
+                  <a:srgbClr val="525252"/>
+                </a:solidFill>
+                <a:latin typeface="Calibri"/>
+              </a:rPr>
+              <a:t>Illustrative 5-block example (values chosen to show the mechanism). Each row adds one component to the row above — the graph is built up, not rebuilt.</a:t>
             </a:r>
           </a:p>
         </p:txBody>

</xml_diff>

<commit_message>
Improve gap slide with concrete detail + gap->fix mapping
Each of the three misses now states the specific metric isomorphic ignores
(sensitivity / Taylor importance / importance correlation), the concrete
consequence, and a right-hand chip mapping it to the parameter that fixes it
(S_min / theta / alpha). Speaker notes updated.

Co-Authored-By: Claude Sonnet 4.6 <noreply@anthropic.com>
</commit_message>
<xml_diff>
--- a/hypergraph_slides.pptx
+++ b/hypergraph_slides.pptx
@@ -15753,146 +15753,14 @@
       </p:sp>
       <p:sp>
         <p:nvSpPr>
-          <p:cNvPr id="5" name="Rectangle 4"/>
-          <p:cNvSpPr/>
-          <p:nvPr/>
-        </p:nvSpPr>
-        <p:spPr>
-          <a:xfrm>
-            <a:off x="365760" y="1100000"/>
-            <a:ext cx="11430000" cy="1180000"/>
-          </a:xfrm>
-          <a:prstGeom prst="rect">
-            <a:avLst/>
-          </a:prstGeom>
-          <a:solidFill>
-            <a:srgbClr val="FCE4D6"/>
-          </a:solidFill>
-          <a:ln>
-            <a:noFill/>
-          </a:ln>
-          <a:effectLst/>
-        </p:spPr>
-        <p:style>
-          <a:lnRef idx="1">
-            <a:schemeClr val="accent1"/>
-          </a:lnRef>
-          <a:fillRef idx="3">
-            <a:schemeClr val="accent1"/>
-          </a:fillRef>
-          <a:effectRef idx="2">
-            <a:schemeClr val="accent1"/>
-          </a:effectRef>
-          <a:fontRef idx="minor">
-            <a:schemeClr val="lt1"/>
-          </a:fontRef>
-        </p:style>
-        <p:txBody>
-          <a:bodyPr rtlCol="0" anchor="ctr"/>
-          <a:lstStyle/>
-          <a:p>
-            <a:pPr algn="ctr"/>
-          </a:p>
-        </p:txBody>
-      </p:sp>
-      <p:sp>
-        <p:nvSpPr>
-          <p:cNvPr id="6" name="Rectangle 5"/>
-          <p:cNvSpPr/>
-          <p:nvPr/>
-        </p:nvSpPr>
-        <p:spPr>
-          <a:xfrm>
-            <a:off x="365760" y="1100000"/>
-            <a:ext cx="150000" cy="1180000"/>
-          </a:xfrm>
-          <a:prstGeom prst="rect">
-            <a:avLst/>
-          </a:prstGeom>
-          <a:solidFill>
-            <a:srgbClr val="C0504D"/>
-          </a:solidFill>
-          <a:ln>
-            <a:noFill/>
-          </a:ln>
-          <a:effectLst/>
-        </p:spPr>
-        <p:style>
-          <a:lnRef idx="1">
-            <a:schemeClr val="accent1"/>
-          </a:lnRef>
-          <a:fillRef idx="3">
-            <a:schemeClr val="accent1"/>
-          </a:fillRef>
-          <a:effectRef idx="2">
-            <a:schemeClr val="accent1"/>
-          </a:effectRef>
-          <a:fontRef idx="minor">
-            <a:schemeClr val="lt1"/>
-          </a:fontRef>
-        </p:style>
-        <p:txBody>
-          <a:bodyPr rtlCol="0" anchor="ctr"/>
-          <a:lstStyle/>
-          <a:p>
-            <a:pPr algn="ctr"/>
-          </a:p>
-        </p:txBody>
-      </p:sp>
-      <p:sp>
-        <p:nvSpPr>
-          <p:cNvPr id="7" name="Oval 6"/>
-          <p:cNvSpPr/>
-          <p:nvPr/>
-        </p:nvSpPr>
-        <p:spPr>
-          <a:xfrm>
-            <a:off x="685760" y="1330000"/>
-            <a:ext cx="720000" cy="720000"/>
-          </a:xfrm>
-          <a:prstGeom prst="ellipse">
-            <a:avLst/>
-          </a:prstGeom>
-          <a:solidFill>
-            <a:srgbClr val="C0504D"/>
-          </a:solidFill>
-          <a:ln>
-            <a:noFill/>
-          </a:ln>
-          <a:effectLst/>
-        </p:spPr>
-        <p:style>
-          <a:lnRef idx="1">
-            <a:schemeClr val="accent1"/>
-          </a:lnRef>
-          <a:fillRef idx="3">
-            <a:schemeClr val="accent1"/>
-          </a:fillRef>
-          <a:effectRef idx="2">
-            <a:schemeClr val="accent1"/>
-          </a:effectRef>
-          <a:fontRef idx="minor">
-            <a:schemeClr val="lt1"/>
-          </a:fontRef>
-        </p:style>
-        <p:txBody>
-          <a:bodyPr rtlCol="0" anchor="ctr"/>
-          <a:lstStyle/>
-          <a:p>
-            <a:pPr algn="ctr"/>
-          </a:p>
-        </p:txBody>
-      </p:sp>
-      <p:sp>
-        <p:nvSpPr>
-          <p:cNvPr id="8" name="TextBox 7"/>
+          <p:cNvPr id="5" name="TextBox 4"/>
           <p:cNvSpPr txBox="1"/>
           <p:nvPr/>
         </p:nvSpPr>
         <p:spPr>
           <a:xfrm>
-            <a:off x="685760" y="1390000"/>
-            <a:ext cx="720000" cy="600000"/>
+            <a:off x="365760" y="980000"/>
+            <a:ext cx="11430000" cy="320000"/>
           </a:xfrm>
           <a:prstGeom prst="rect">
             <a:avLst/>
@@ -15905,16 +15773,148 @@
           </a:bodyPr>
           <a:lstStyle/>
           <a:p>
-            <a:pPr algn="ctr"/>
-            <a:r>
-              <a:rPr sz="3400" b="1" i="0">
-                <a:solidFill>
-                  <a:srgbClr val="FFFFFF"/>
-                </a:solidFill>
-                <a:latin typeface="Calibri"/>
-              </a:rPr>
-              <a:t>1</a:t>
-            </a:r>
+            <a:pPr algn="l"/>
+            <a:r>
+              <a:rPr sz="1500" b="1" i="0">
+                <a:solidFill>
+                  <a:srgbClr val="1A1A1A"/>
+                </a:solidFill>
+                <a:latin typeface="Calibri"/>
+              </a:rPr>
+              <a:t>One ratio for every block cannot express three real differences between blocks:</a:t>
+            </a:r>
+          </a:p>
+        </p:txBody>
+      </p:sp>
+      <p:sp>
+        <p:nvSpPr>
+          <p:cNvPr id="6" name="Rectangle 5"/>
+          <p:cNvSpPr/>
+          <p:nvPr/>
+        </p:nvSpPr>
+        <p:spPr>
+          <a:xfrm>
+            <a:off x="365760" y="1360000"/>
+            <a:ext cx="11430000" cy="1430000"/>
+          </a:xfrm>
+          <a:prstGeom prst="rect">
+            <a:avLst/>
+          </a:prstGeom>
+          <a:solidFill>
+            <a:srgbClr val="FCE4D6"/>
+          </a:solidFill>
+          <a:ln>
+            <a:noFill/>
+          </a:ln>
+          <a:effectLst/>
+        </p:spPr>
+        <p:style>
+          <a:lnRef idx="1">
+            <a:schemeClr val="accent1"/>
+          </a:lnRef>
+          <a:fillRef idx="3">
+            <a:schemeClr val="accent1"/>
+          </a:fillRef>
+          <a:effectRef idx="2">
+            <a:schemeClr val="accent1"/>
+          </a:effectRef>
+          <a:fontRef idx="minor">
+            <a:schemeClr val="lt1"/>
+          </a:fontRef>
+        </p:style>
+        <p:txBody>
+          <a:bodyPr rtlCol="0" anchor="ctr"/>
+          <a:lstStyle/>
+          <a:p>
+            <a:pPr algn="ctr"/>
+          </a:p>
+        </p:txBody>
+      </p:sp>
+      <p:sp>
+        <p:nvSpPr>
+          <p:cNvPr id="7" name="Rectangle 6"/>
+          <p:cNvSpPr/>
+          <p:nvPr/>
+        </p:nvSpPr>
+        <p:spPr>
+          <a:xfrm>
+            <a:off x="365760" y="1360000"/>
+            <a:ext cx="150000" cy="1430000"/>
+          </a:xfrm>
+          <a:prstGeom prst="rect">
+            <a:avLst/>
+          </a:prstGeom>
+          <a:solidFill>
+            <a:srgbClr val="C0504D"/>
+          </a:solidFill>
+          <a:ln>
+            <a:noFill/>
+          </a:ln>
+          <a:effectLst/>
+        </p:spPr>
+        <p:style>
+          <a:lnRef idx="1">
+            <a:schemeClr val="accent1"/>
+          </a:lnRef>
+          <a:fillRef idx="3">
+            <a:schemeClr val="accent1"/>
+          </a:fillRef>
+          <a:effectRef idx="2">
+            <a:schemeClr val="accent1"/>
+          </a:effectRef>
+          <a:fontRef idx="minor">
+            <a:schemeClr val="lt1"/>
+          </a:fontRef>
+        </p:style>
+        <p:txBody>
+          <a:bodyPr rtlCol="0" anchor="ctr"/>
+          <a:lstStyle/>
+          <a:p>
+            <a:pPr algn="ctr"/>
+          </a:p>
+        </p:txBody>
+      </p:sp>
+      <p:sp>
+        <p:nvSpPr>
+          <p:cNvPr id="8" name="Oval 7"/>
+          <p:cNvSpPr/>
+          <p:nvPr/>
+        </p:nvSpPr>
+        <p:spPr>
+          <a:xfrm>
+            <a:off x="665760" y="1735000"/>
+            <a:ext cx="680000" cy="680000"/>
+          </a:xfrm>
+          <a:prstGeom prst="ellipse">
+            <a:avLst/>
+          </a:prstGeom>
+          <a:solidFill>
+            <a:srgbClr val="C0504D"/>
+          </a:solidFill>
+          <a:ln>
+            <a:noFill/>
+          </a:ln>
+          <a:effectLst/>
+        </p:spPr>
+        <p:style>
+          <a:lnRef idx="1">
+            <a:schemeClr val="accent1"/>
+          </a:lnRef>
+          <a:fillRef idx="3">
+            <a:schemeClr val="accent1"/>
+          </a:fillRef>
+          <a:effectRef idx="2">
+            <a:schemeClr val="accent1"/>
+          </a:effectRef>
+          <a:fontRef idx="minor">
+            <a:schemeClr val="lt1"/>
+          </a:fontRef>
+        </p:style>
+        <p:txBody>
+          <a:bodyPr rtlCol="0" anchor="ctr"/>
+          <a:lstStyle/>
+          <a:p>
+            <a:pPr algn="ctr"/>
           </a:p>
         </p:txBody>
       </p:sp>
@@ -15926,8 +15926,8 @@
         </p:nvSpPr>
         <p:spPr>
           <a:xfrm>
-            <a:off x="1665760" y="1230000"/>
-            <a:ext cx="9930000" cy="940000"/>
+            <a:off x="665760" y="1795000"/>
+            <a:ext cx="680000" cy="560000"/>
           </a:xfrm>
           <a:prstGeom prst="rect">
             <a:avLst/>
@@ -15940,177 +15940,29 @@
           </a:bodyPr>
           <a:lstStyle/>
           <a:p>
-            <a:pPr algn="l"/>
-            <a:r>
-              <a:rPr sz="2000" b="1" i="0">
-                <a:solidFill>
-                  <a:srgbClr val="C0504D"/>
-                </a:solidFill>
-                <a:latin typeface="Calibri"/>
-              </a:rPr>
-              <a:t>Not all blocks are needed</a:t>
-            </a:r>
-          </a:p>
-          <a:p>
-            <a:pPr algn="l">
-              <a:spcBef>
-                <a:spcPts val="800"/>
-              </a:spcBef>
-            </a:pPr>
-            <a:r>
-              <a:rPr sz="1500" b="0" i="0">
-                <a:solidFill>
-                  <a:srgbClr val="525252"/>
-                </a:solidFill>
-                <a:latin typeface="Calibri"/>
-              </a:rPr>
-              <a:t>Some blocks barely change the output — they could be removed ENTIRELY, not just shrunk. Uniform pruning keeps every block.</a:t>
-            </a:r>
-          </a:p>
-        </p:txBody>
-      </p:sp>
-      <p:sp>
-        <p:nvSpPr>
-          <p:cNvPr id="10" name="Rectangle 9"/>
-          <p:cNvSpPr/>
-          <p:nvPr/>
-        </p:nvSpPr>
-        <p:spPr>
-          <a:xfrm>
-            <a:off x="365760" y="2460000"/>
-            <a:ext cx="11430000" cy="1180000"/>
-          </a:xfrm>
-          <a:prstGeom prst="rect">
-            <a:avLst/>
-          </a:prstGeom>
-          <a:solidFill>
-            <a:srgbClr val="FFF2CC"/>
-          </a:solidFill>
-          <a:ln>
-            <a:noFill/>
-          </a:ln>
-          <a:effectLst/>
-        </p:spPr>
-        <p:style>
-          <a:lnRef idx="1">
-            <a:schemeClr val="accent1"/>
-          </a:lnRef>
-          <a:fillRef idx="3">
-            <a:schemeClr val="accent1"/>
-          </a:fillRef>
-          <a:effectRef idx="2">
-            <a:schemeClr val="accent1"/>
-          </a:effectRef>
-          <a:fontRef idx="minor">
-            <a:schemeClr val="lt1"/>
-          </a:fontRef>
-        </p:style>
-        <p:txBody>
-          <a:bodyPr rtlCol="0" anchor="ctr"/>
-          <a:lstStyle/>
-          <a:p>
-            <a:pPr algn="ctr"/>
-          </a:p>
-        </p:txBody>
-      </p:sp>
-      <p:sp>
-        <p:nvSpPr>
-          <p:cNvPr id="11" name="Rectangle 10"/>
-          <p:cNvSpPr/>
-          <p:nvPr/>
-        </p:nvSpPr>
-        <p:spPr>
-          <a:xfrm>
-            <a:off x="365760" y="2460000"/>
-            <a:ext cx="150000" cy="1180000"/>
-          </a:xfrm>
-          <a:prstGeom prst="rect">
-            <a:avLst/>
-          </a:prstGeom>
-          <a:solidFill>
-            <a:srgbClr val="FFA300"/>
-          </a:solidFill>
-          <a:ln>
-            <a:noFill/>
-          </a:ln>
-          <a:effectLst/>
-        </p:spPr>
-        <p:style>
-          <a:lnRef idx="1">
-            <a:schemeClr val="accent1"/>
-          </a:lnRef>
-          <a:fillRef idx="3">
-            <a:schemeClr val="accent1"/>
-          </a:fillRef>
-          <a:effectRef idx="2">
-            <a:schemeClr val="accent1"/>
-          </a:effectRef>
-          <a:fontRef idx="minor">
-            <a:schemeClr val="lt1"/>
-          </a:fontRef>
-        </p:style>
-        <p:txBody>
-          <a:bodyPr rtlCol="0" anchor="ctr"/>
-          <a:lstStyle/>
-          <a:p>
-            <a:pPr algn="ctr"/>
-          </a:p>
-        </p:txBody>
-      </p:sp>
-      <p:sp>
-        <p:nvSpPr>
-          <p:cNvPr id="12" name="Oval 11"/>
-          <p:cNvSpPr/>
-          <p:nvPr/>
-        </p:nvSpPr>
-        <p:spPr>
-          <a:xfrm>
-            <a:off x="685760" y="2690000"/>
-            <a:ext cx="720000" cy="720000"/>
-          </a:xfrm>
-          <a:prstGeom prst="ellipse">
-            <a:avLst/>
-          </a:prstGeom>
-          <a:solidFill>
-            <a:srgbClr val="FFA300"/>
-          </a:solidFill>
-          <a:ln>
-            <a:noFill/>
-          </a:ln>
-          <a:effectLst/>
-        </p:spPr>
-        <p:style>
-          <a:lnRef idx="1">
-            <a:schemeClr val="accent1"/>
-          </a:lnRef>
-          <a:fillRef idx="3">
-            <a:schemeClr val="accent1"/>
-          </a:fillRef>
-          <a:effectRef idx="2">
-            <a:schemeClr val="accent1"/>
-          </a:effectRef>
-          <a:fontRef idx="minor">
-            <a:schemeClr val="lt1"/>
-          </a:fontRef>
-        </p:style>
-        <p:txBody>
-          <a:bodyPr rtlCol="0" anchor="ctr"/>
-          <a:lstStyle/>
-          <a:p>
-            <a:pPr algn="ctr"/>
-          </a:p>
-        </p:txBody>
-      </p:sp>
-      <p:sp>
-        <p:nvSpPr>
-          <p:cNvPr id="13" name="TextBox 12"/>
+            <a:pPr algn="ctr"/>
+            <a:r>
+              <a:rPr sz="3200" b="1" i="0">
+                <a:solidFill>
+                  <a:srgbClr val="FFFFFF"/>
+                </a:solidFill>
+                <a:latin typeface="Calibri"/>
+              </a:rPr>
+              <a:t>1</a:t>
+            </a:r>
+          </a:p>
+        </p:txBody>
+      </p:sp>
+      <p:sp>
+        <p:nvSpPr>
+          <p:cNvPr id="10" name="TextBox 9"/>
           <p:cNvSpPr txBox="1"/>
           <p:nvPr/>
         </p:nvSpPr>
         <p:spPr>
           <a:xfrm>
-            <a:off x="685760" y="2750000"/>
-            <a:ext cx="720000" cy="600000"/>
+            <a:off x="1545760" y="1470000"/>
+            <a:ext cx="7580000" cy="1210000"/>
           </a:xfrm>
           <a:prstGeom prst="rect">
             <a:avLst/>
@@ -16123,29 +15975,77 @@
           </a:bodyPr>
           <a:lstStyle/>
           <a:p>
-            <a:pPr algn="ctr"/>
-            <a:r>
-              <a:rPr sz="3400" b="1" i="0">
-                <a:solidFill>
-                  <a:srgbClr val="FFFFFF"/>
-                </a:solidFill>
-                <a:latin typeface="Calibri"/>
-              </a:rPr>
-              <a:t>2</a:t>
-            </a:r>
-          </a:p>
-        </p:txBody>
-      </p:sp>
-      <p:sp>
-        <p:nvSpPr>
-          <p:cNvPr id="14" name="TextBox 13"/>
+            <a:pPr algn="l"/>
+            <a:r>
+              <a:rPr sz="1800" b="1" i="0">
+                <a:solidFill>
+                  <a:srgbClr val="C0504D"/>
+                </a:solidFill>
+                <a:latin typeface="Calibri"/>
+              </a:rPr>
+              <a:t>Some blocks are nearly dead weight</a:t>
+            </a:r>
+          </a:p>
+          <a:p>
+            <a:pPr algn="l">
+              <a:spcBef>
+                <a:spcPts val="600"/>
+              </a:spcBef>
+            </a:pPr>
+            <a:r>
+              <a:rPr sz="1300" b="0" i="0">
+                <a:solidFill>
+                  <a:srgbClr val="525252"/>
+                </a:solidFill>
+                <a:latin typeface="Calibri"/>
+              </a:rPr>
+              <a:t>Block sensitivity (output change when a block is bypassed) varies widely —</a:t>
+            </a:r>
+          </a:p>
+          <a:p>
+            <a:pPr algn="l">
+              <a:spcBef>
+                <a:spcPts val="200"/>
+              </a:spcBef>
+            </a:pPr>
+            <a:r>
+              <a:rPr sz="1300" b="0" i="0">
+                <a:solidFill>
+                  <a:srgbClr val="525252"/>
+                </a:solidFill>
+                <a:latin typeface="Calibri"/>
+              </a:rPr>
+              <a:t>a few blocks are close to identity, yet uniform pruning still keeps and shrinks them,</a:t>
+            </a:r>
+          </a:p>
+          <a:p>
+            <a:pPr algn="l">
+              <a:spcBef>
+                <a:spcPts val="200"/>
+              </a:spcBef>
+            </a:pPr>
+            <a:r>
+              <a:rPr sz="1300" b="0" i="0">
+                <a:solidFill>
+                  <a:srgbClr val="525252"/>
+                </a:solidFill>
+                <a:latin typeface="Calibri"/>
+              </a:rPr>
+              <a:t>spending MAC budget on blocks that contribute almost nothing.</a:t>
+            </a:r>
+          </a:p>
+        </p:txBody>
+      </p:sp>
+      <p:sp>
+        <p:nvSpPr>
+          <p:cNvPr id="11" name="TextBox 10"/>
           <p:cNvSpPr txBox="1"/>
           <p:nvPr/>
         </p:nvSpPr>
         <p:spPr>
           <a:xfrm>
-            <a:off x="1665760" y="2590000"/>
-            <a:ext cx="9930000" cy="940000"/>
+            <a:off x="1545760" y="2490000"/>
+            <a:ext cx="3000000" cy="240000"/>
           </a:xfrm>
           <a:prstGeom prst="rect">
             <a:avLst/>
@@ -16160,52 +16060,38 @@
           <a:p>
             <a:pPr algn="l"/>
             <a:r>
-              <a:rPr sz="2000" b="1" i="0">
-                <a:solidFill>
-                  <a:srgbClr val="FFA300"/>
-                </a:solidFill>
-                <a:latin typeface="Calibri"/>
-              </a:rPr>
-              <a:t>Blocks differ in importance</a:t>
-            </a:r>
-          </a:p>
-          <a:p>
-            <a:pPr algn="l">
-              <a:spcBef>
-                <a:spcPts val="800"/>
-              </a:spcBef>
-            </a:pPr>
-            <a:r>
-              <a:rPr sz="1500" b="0" i="0">
-                <a:solidFill>
-                  <a:srgbClr val="525252"/>
-                </a:solidFill>
-                <a:latin typeface="Calibri"/>
-              </a:rPr>
-              <a:t>A critical block and a near-redundant block get the SAME ratio. We over-prune the important one and waste budget on the redundant one.</a:t>
-            </a:r>
-          </a:p>
-        </p:txBody>
-      </p:sp>
-      <p:sp>
-        <p:nvSpPr>
-          <p:cNvPr id="15" name="Rectangle 14"/>
+              <a:rPr sz="1200" b="0" i="1">
+                <a:solidFill>
+                  <a:srgbClr val="C0504D"/>
+                </a:solidFill>
+                <a:latin typeface="Calibri"/>
+              </a:rPr>
+              <a:t>isomorphic: depth ignored</a:t>
+            </a:r>
+          </a:p>
+        </p:txBody>
+      </p:sp>
+      <p:sp>
+        <p:nvSpPr>
+          <p:cNvPr id="12" name="Rectangle 11"/>
           <p:cNvSpPr/>
           <p:nvPr/>
         </p:nvSpPr>
         <p:spPr>
           <a:xfrm>
-            <a:off x="365760" y="3820000"/>
-            <a:ext cx="11430000" cy="1180000"/>
-          </a:xfrm>
-          <a:prstGeom prst="rect">
-            <a:avLst/>
-          </a:prstGeom>
-          <a:solidFill>
-            <a:srgbClr val="DEEBF7"/>
-          </a:solidFill>
-          <a:ln>
-            <a:noFill/>
+            <a:off x="9125760" y="1510000"/>
+            <a:ext cx="2550000" cy="1130000"/>
+          </a:xfrm>
+          <a:prstGeom prst="rect">
+            <a:avLst/>
+          </a:prstGeom>
+          <a:solidFill>
+            <a:srgbClr val="FFFFFF"/>
+          </a:solidFill>
+          <a:ln w="19050">
+            <a:solidFill>
+              <a:srgbClr val="C0504D"/>
+            </a:solidFill>
           </a:ln>
           <a:effectLst/>
         </p:spPr>
@@ -16233,102 +16119,14 @@
       </p:sp>
       <p:sp>
         <p:nvSpPr>
-          <p:cNvPr id="16" name="Rectangle 15"/>
-          <p:cNvSpPr/>
-          <p:nvPr/>
-        </p:nvSpPr>
-        <p:spPr>
-          <a:xfrm>
-            <a:off x="365760" y="3820000"/>
-            <a:ext cx="150000" cy="1180000"/>
-          </a:xfrm>
-          <a:prstGeom prst="rect">
-            <a:avLst/>
-          </a:prstGeom>
-          <a:solidFill>
-            <a:srgbClr val="0068B5"/>
-          </a:solidFill>
-          <a:ln>
-            <a:noFill/>
-          </a:ln>
-          <a:effectLst/>
-        </p:spPr>
-        <p:style>
-          <a:lnRef idx="1">
-            <a:schemeClr val="accent1"/>
-          </a:lnRef>
-          <a:fillRef idx="3">
-            <a:schemeClr val="accent1"/>
-          </a:fillRef>
-          <a:effectRef idx="2">
-            <a:schemeClr val="accent1"/>
-          </a:effectRef>
-          <a:fontRef idx="minor">
-            <a:schemeClr val="lt1"/>
-          </a:fontRef>
-        </p:style>
-        <p:txBody>
-          <a:bodyPr rtlCol="0" anchor="ctr"/>
-          <a:lstStyle/>
-          <a:p>
-            <a:pPr algn="ctr"/>
-          </a:p>
-        </p:txBody>
-      </p:sp>
-      <p:sp>
-        <p:nvSpPr>
-          <p:cNvPr id="17" name="Oval 16"/>
-          <p:cNvSpPr/>
-          <p:nvPr/>
-        </p:nvSpPr>
-        <p:spPr>
-          <a:xfrm>
-            <a:off x="685760" y="4050000"/>
-            <a:ext cx="720000" cy="720000"/>
-          </a:xfrm>
-          <a:prstGeom prst="ellipse">
-            <a:avLst/>
-          </a:prstGeom>
-          <a:solidFill>
-            <a:srgbClr val="0068B5"/>
-          </a:solidFill>
-          <a:ln>
-            <a:noFill/>
-          </a:ln>
-          <a:effectLst/>
-        </p:spPr>
-        <p:style>
-          <a:lnRef idx="1">
-            <a:schemeClr val="accent1"/>
-          </a:lnRef>
-          <a:fillRef idx="3">
-            <a:schemeClr val="accent1"/>
-          </a:fillRef>
-          <a:effectRef idx="2">
-            <a:schemeClr val="accent1"/>
-          </a:effectRef>
-          <a:fontRef idx="minor">
-            <a:schemeClr val="lt1"/>
-          </a:fontRef>
-        </p:style>
-        <p:txBody>
-          <a:bodyPr rtlCol="0" anchor="ctr"/>
-          <a:lstStyle/>
-          <a:p>
-            <a:pPr algn="ctr"/>
-          </a:p>
-        </p:txBody>
-      </p:sp>
-      <p:sp>
-        <p:nvSpPr>
-          <p:cNvPr id="18" name="TextBox 17"/>
+          <p:cNvPr id="13" name="TextBox 12"/>
           <p:cNvSpPr txBox="1"/>
           <p:nvPr/>
         </p:nvSpPr>
         <p:spPr>
           <a:xfrm>
-            <a:off x="685760" y="4110000"/>
-            <a:ext cx="720000" cy="600000"/>
+            <a:off x="9245760" y="1590000"/>
+            <a:ext cx="2310000" cy="1010000"/>
           </a:xfrm>
           <a:prstGeom prst="rect">
             <a:avLst/>
@@ -16341,29 +16139,193 @@
           </a:bodyPr>
           <a:lstStyle/>
           <a:p>
-            <a:pPr algn="ctr"/>
-            <a:r>
-              <a:rPr sz="3400" b="1" i="0">
-                <a:solidFill>
-                  <a:srgbClr val="FFFFFF"/>
-                </a:solidFill>
-                <a:latin typeface="Calibri"/>
-              </a:rPr>
-              <a:t>3</a:t>
-            </a:r>
-          </a:p>
-        </p:txBody>
-      </p:sp>
-      <p:sp>
-        <p:nvSpPr>
-          <p:cNvPr id="19" name="TextBox 18"/>
+            <a:pPr algn="l"/>
+            <a:r>
+              <a:rPr sz="1100" b="1" i="0">
+                <a:solidFill>
+                  <a:srgbClr val="525252"/>
+                </a:solidFill>
+                <a:latin typeface="Calibri"/>
+              </a:rPr>
+              <a:t>our fix</a:t>
+            </a:r>
+          </a:p>
+          <a:p>
+            <a:pPr algn="l">
+              <a:spcBef>
+                <a:spcPts val="400"/>
+              </a:spcBef>
+            </a:pPr>
+            <a:r>
+              <a:rPr sz="2400" b="1" i="0">
+                <a:solidFill>
+                  <a:srgbClr val="C0504D"/>
+                </a:solidFill>
+                <a:latin typeface="Calibri"/>
+              </a:rPr>
+              <a:t>→  S_min</a:t>
+            </a:r>
+          </a:p>
+          <a:p>
+            <a:pPr algn="l">
+              <a:spcBef>
+                <a:spcPts val="400"/>
+              </a:spcBef>
+            </a:pPr>
+            <a:r>
+              <a:rPr sz="1300" b="0" i="0">
+                <a:solidFill>
+                  <a:srgbClr val="1A1A1A"/>
+                </a:solidFill>
+                <a:latin typeface="Calibri"/>
+              </a:rPr>
+              <a:t>remove them entirely</a:t>
+            </a:r>
+          </a:p>
+        </p:txBody>
+      </p:sp>
+      <p:sp>
+        <p:nvSpPr>
+          <p:cNvPr id="14" name="Rectangle 13"/>
+          <p:cNvSpPr/>
+          <p:nvPr/>
+        </p:nvSpPr>
+        <p:spPr>
+          <a:xfrm>
+            <a:off x="365760" y="2940000"/>
+            <a:ext cx="11430000" cy="1430000"/>
+          </a:xfrm>
+          <a:prstGeom prst="rect">
+            <a:avLst/>
+          </a:prstGeom>
+          <a:solidFill>
+            <a:srgbClr val="FFF2CC"/>
+          </a:solidFill>
+          <a:ln>
+            <a:noFill/>
+          </a:ln>
+          <a:effectLst/>
+        </p:spPr>
+        <p:style>
+          <a:lnRef idx="1">
+            <a:schemeClr val="accent1"/>
+          </a:lnRef>
+          <a:fillRef idx="3">
+            <a:schemeClr val="accent1"/>
+          </a:fillRef>
+          <a:effectRef idx="2">
+            <a:schemeClr val="accent1"/>
+          </a:effectRef>
+          <a:fontRef idx="minor">
+            <a:schemeClr val="lt1"/>
+          </a:fontRef>
+        </p:style>
+        <p:txBody>
+          <a:bodyPr rtlCol="0" anchor="ctr"/>
+          <a:lstStyle/>
+          <a:p>
+            <a:pPr algn="ctr"/>
+          </a:p>
+        </p:txBody>
+      </p:sp>
+      <p:sp>
+        <p:nvSpPr>
+          <p:cNvPr id="15" name="Rectangle 14"/>
+          <p:cNvSpPr/>
+          <p:nvPr/>
+        </p:nvSpPr>
+        <p:spPr>
+          <a:xfrm>
+            <a:off x="365760" y="2940000"/>
+            <a:ext cx="150000" cy="1430000"/>
+          </a:xfrm>
+          <a:prstGeom prst="rect">
+            <a:avLst/>
+          </a:prstGeom>
+          <a:solidFill>
+            <a:srgbClr val="FFA300"/>
+          </a:solidFill>
+          <a:ln>
+            <a:noFill/>
+          </a:ln>
+          <a:effectLst/>
+        </p:spPr>
+        <p:style>
+          <a:lnRef idx="1">
+            <a:schemeClr val="accent1"/>
+          </a:lnRef>
+          <a:fillRef idx="3">
+            <a:schemeClr val="accent1"/>
+          </a:fillRef>
+          <a:effectRef idx="2">
+            <a:schemeClr val="accent1"/>
+          </a:effectRef>
+          <a:fontRef idx="minor">
+            <a:schemeClr val="lt1"/>
+          </a:fontRef>
+        </p:style>
+        <p:txBody>
+          <a:bodyPr rtlCol="0" anchor="ctr"/>
+          <a:lstStyle/>
+          <a:p>
+            <a:pPr algn="ctr"/>
+          </a:p>
+        </p:txBody>
+      </p:sp>
+      <p:sp>
+        <p:nvSpPr>
+          <p:cNvPr id="16" name="Oval 15"/>
+          <p:cNvSpPr/>
+          <p:nvPr/>
+        </p:nvSpPr>
+        <p:spPr>
+          <a:xfrm>
+            <a:off x="665760" y="3315000"/>
+            <a:ext cx="680000" cy="680000"/>
+          </a:xfrm>
+          <a:prstGeom prst="ellipse">
+            <a:avLst/>
+          </a:prstGeom>
+          <a:solidFill>
+            <a:srgbClr val="FFA300"/>
+          </a:solidFill>
+          <a:ln>
+            <a:noFill/>
+          </a:ln>
+          <a:effectLst/>
+        </p:spPr>
+        <p:style>
+          <a:lnRef idx="1">
+            <a:schemeClr val="accent1"/>
+          </a:lnRef>
+          <a:fillRef idx="3">
+            <a:schemeClr val="accent1"/>
+          </a:fillRef>
+          <a:effectRef idx="2">
+            <a:schemeClr val="accent1"/>
+          </a:effectRef>
+          <a:fontRef idx="minor">
+            <a:schemeClr val="lt1"/>
+          </a:fontRef>
+        </p:style>
+        <p:txBody>
+          <a:bodyPr rtlCol="0" anchor="ctr"/>
+          <a:lstStyle/>
+          <a:p>
+            <a:pPr algn="ctr"/>
+          </a:p>
+        </p:txBody>
+      </p:sp>
+      <p:sp>
+        <p:nvSpPr>
+          <p:cNvPr id="17" name="TextBox 16"/>
           <p:cNvSpPr txBox="1"/>
           <p:nvPr/>
         </p:nvSpPr>
         <p:spPr>
           <a:xfrm>
-            <a:off x="1665760" y="3950000"/>
-            <a:ext cx="9930000" cy="940000"/>
+            <a:off x="665760" y="3375000"/>
+            <a:ext cx="680000" cy="560000"/>
           </a:xfrm>
           <a:prstGeom prst="rect">
             <a:avLst/>
@@ -16376,31 +16338,644 @@
           </a:bodyPr>
           <a:lstStyle/>
           <a:p>
+            <a:pPr algn="ctr"/>
+            <a:r>
+              <a:rPr sz="3200" b="1" i="0">
+                <a:solidFill>
+                  <a:srgbClr val="FFFFFF"/>
+                </a:solidFill>
+                <a:latin typeface="Calibri"/>
+              </a:rPr>
+              <a:t>2</a:t>
+            </a:r>
+          </a:p>
+        </p:txBody>
+      </p:sp>
+      <p:sp>
+        <p:nvSpPr>
+          <p:cNvPr id="18" name="TextBox 17"/>
+          <p:cNvSpPr txBox="1"/>
+          <p:nvPr/>
+        </p:nvSpPr>
+        <p:spPr>
+          <a:xfrm>
+            <a:off x="1545760" y="3050000"/>
+            <a:ext cx="7580000" cy="1210000"/>
+          </a:xfrm>
+          <a:prstGeom prst="rect">
+            <a:avLst/>
+          </a:prstGeom>
+          <a:noFill/>
+        </p:spPr>
+        <p:txBody>
+          <a:bodyPr wrap="square">
+            <a:spAutoFit/>
+          </a:bodyPr>
+          <a:lstStyle/>
+          <a:p>
             <a:pPr algn="l"/>
             <a:r>
-              <a:rPr sz="2000" b="1" i="0">
-                <a:solidFill>
-                  <a:srgbClr val="0068B5"/>
-                </a:solidFill>
-                <a:latin typeface="Calibri"/>
-              </a:rPr>
-              <a:t>Blocks are functionally coupled</a:t>
+              <a:rPr sz="1800" b="1" i="0">
+                <a:solidFill>
+                  <a:srgbClr val="FFA300"/>
+                </a:solidFill>
+                <a:latin typeface="Calibri"/>
+              </a:rPr>
+              <a:t>Blocks are not equally important</a:t>
             </a:r>
           </a:p>
           <a:p>
             <a:pPr algn="l">
               <a:spcBef>
-                <a:spcPts val="800"/>
+                <a:spcPts val="600"/>
               </a:spcBef>
             </a:pPr>
             <a:r>
-              <a:rPr sz="1500" b="0" i="0">
+              <a:rPr sz="1300" b="0" i="0">
                 <a:solidFill>
                   <a:srgbClr val="525252"/>
                 </a:solidFill>
                 <a:latin typeface="Calibri"/>
               </a:rPr>
-              <a:t>Some blocks rise and fall in importance together. Their pruning decisions should influence each other — uniform pruning treats every block in isolation.</a:t>
+              <a:t>Taylor importance (|grad × weight|) differs block-to-block. One global ratio</a:t>
+            </a:r>
+          </a:p>
+          <a:p>
+            <a:pPr algn="l">
+              <a:spcBef>
+                <a:spcPts val="200"/>
+              </a:spcBef>
+            </a:pPr>
+            <a:r>
+              <a:rPr sz="1300" b="0" i="0">
+                <a:solidFill>
+                  <a:srgbClr val="525252"/>
+                </a:solidFill>
+                <a:latin typeface="Calibri"/>
+              </a:rPr>
+              <a:t>over-prunes the critical blocks (accuracy drops) and under-prunes the redundant</a:t>
+            </a:r>
+          </a:p>
+          <a:p>
+            <a:pPr algn="l">
+              <a:spcBef>
+                <a:spcPts val="200"/>
+              </a:spcBef>
+            </a:pPr>
+            <a:r>
+              <a:rPr sz="1300" b="0" i="0">
+                <a:solidFill>
+                  <a:srgbClr val="525252"/>
+                </a:solidFill>
+                <a:latin typeface="Calibri"/>
+              </a:rPr>
+              <a:t>ones (budget wasted) — the cut lands in exactly the wrong places.</a:t>
+            </a:r>
+          </a:p>
+        </p:txBody>
+      </p:sp>
+      <p:sp>
+        <p:nvSpPr>
+          <p:cNvPr id="19" name="TextBox 18"/>
+          <p:cNvSpPr txBox="1"/>
+          <p:nvPr/>
+        </p:nvSpPr>
+        <p:spPr>
+          <a:xfrm>
+            <a:off x="1545760" y="4070000"/>
+            <a:ext cx="3000000" cy="240000"/>
+          </a:xfrm>
+          <a:prstGeom prst="rect">
+            <a:avLst/>
+          </a:prstGeom>
+          <a:noFill/>
+        </p:spPr>
+        <p:txBody>
+          <a:bodyPr wrap="square">
+            <a:spAutoFit/>
+          </a:bodyPr>
+          <a:lstStyle/>
+          <a:p>
+            <a:pPr algn="l"/>
+            <a:r>
+              <a:rPr sz="1200" b="0" i="1">
+                <a:solidFill>
+                  <a:srgbClr val="FFA300"/>
+                </a:solidFill>
+                <a:latin typeface="Calibri"/>
+              </a:rPr>
+              <a:t>isomorphic: width is flat</a:t>
+            </a:r>
+          </a:p>
+        </p:txBody>
+      </p:sp>
+      <p:sp>
+        <p:nvSpPr>
+          <p:cNvPr id="20" name="Rectangle 19"/>
+          <p:cNvSpPr/>
+          <p:nvPr/>
+        </p:nvSpPr>
+        <p:spPr>
+          <a:xfrm>
+            <a:off x="9125760" y="3090000"/>
+            <a:ext cx="2550000" cy="1130000"/>
+          </a:xfrm>
+          <a:prstGeom prst="rect">
+            <a:avLst/>
+          </a:prstGeom>
+          <a:solidFill>
+            <a:srgbClr val="FFFFFF"/>
+          </a:solidFill>
+          <a:ln w="19050">
+            <a:solidFill>
+              <a:srgbClr val="FFA300"/>
+            </a:solidFill>
+          </a:ln>
+          <a:effectLst/>
+        </p:spPr>
+        <p:style>
+          <a:lnRef idx="1">
+            <a:schemeClr val="accent1"/>
+          </a:lnRef>
+          <a:fillRef idx="3">
+            <a:schemeClr val="accent1"/>
+          </a:fillRef>
+          <a:effectRef idx="2">
+            <a:schemeClr val="accent1"/>
+          </a:effectRef>
+          <a:fontRef idx="minor">
+            <a:schemeClr val="lt1"/>
+          </a:fontRef>
+        </p:style>
+        <p:txBody>
+          <a:bodyPr rtlCol="0" anchor="ctr"/>
+          <a:lstStyle/>
+          <a:p>
+            <a:pPr algn="ctr"/>
+          </a:p>
+        </p:txBody>
+      </p:sp>
+      <p:sp>
+        <p:nvSpPr>
+          <p:cNvPr id="21" name="TextBox 20"/>
+          <p:cNvSpPr txBox="1"/>
+          <p:nvPr/>
+        </p:nvSpPr>
+        <p:spPr>
+          <a:xfrm>
+            <a:off x="9245760" y="3170000"/>
+            <a:ext cx="2310000" cy="1010000"/>
+          </a:xfrm>
+          <a:prstGeom prst="rect">
+            <a:avLst/>
+          </a:prstGeom>
+          <a:noFill/>
+        </p:spPr>
+        <p:txBody>
+          <a:bodyPr wrap="square">
+            <a:spAutoFit/>
+          </a:bodyPr>
+          <a:lstStyle/>
+          <a:p>
+            <a:pPr algn="l"/>
+            <a:r>
+              <a:rPr sz="1100" b="1" i="0">
+                <a:solidFill>
+                  <a:srgbClr val="525252"/>
+                </a:solidFill>
+                <a:latin typeface="Calibri"/>
+              </a:rPr>
+              <a:t>our fix</a:t>
+            </a:r>
+          </a:p>
+          <a:p>
+            <a:pPr algn="l">
+              <a:spcBef>
+                <a:spcPts val="400"/>
+              </a:spcBef>
+            </a:pPr>
+            <a:r>
+              <a:rPr sz="2400" b="1" i="0">
+                <a:solidFill>
+                  <a:srgbClr val="FFA300"/>
+                </a:solidFill>
+                <a:latin typeface="Calibri"/>
+              </a:rPr>
+              <a:t>→  θ</a:t>
+            </a:r>
+          </a:p>
+          <a:p>
+            <a:pPr algn="l">
+              <a:spcBef>
+                <a:spcPts val="400"/>
+              </a:spcBef>
+            </a:pPr>
+            <a:r>
+              <a:rPr sz="1300" b="0" i="0">
+                <a:solidFill>
+                  <a:srgbClr val="1A1A1A"/>
+                </a:solidFill>
+                <a:latin typeface="Calibri"/>
+              </a:rPr>
+              <a:t>per-group ratios</a:t>
+            </a:r>
+          </a:p>
+        </p:txBody>
+      </p:sp>
+      <p:sp>
+        <p:nvSpPr>
+          <p:cNvPr id="22" name="Rectangle 21"/>
+          <p:cNvSpPr/>
+          <p:nvPr/>
+        </p:nvSpPr>
+        <p:spPr>
+          <a:xfrm>
+            <a:off x="365760" y="4520000"/>
+            <a:ext cx="11430000" cy="1430000"/>
+          </a:xfrm>
+          <a:prstGeom prst="rect">
+            <a:avLst/>
+          </a:prstGeom>
+          <a:solidFill>
+            <a:srgbClr val="DEEBF7"/>
+          </a:solidFill>
+          <a:ln>
+            <a:noFill/>
+          </a:ln>
+          <a:effectLst/>
+        </p:spPr>
+        <p:style>
+          <a:lnRef idx="1">
+            <a:schemeClr val="accent1"/>
+          </a:lnRef>
+          <a:fillRef idx="3">
+            <a:schemeClr val="accent1"/>
+          </a:fillRef>
+          <a:effectRef idx="2">
+            <a:schemeClr val="accent1"/>
+          </a:effectRef>
+          <a:fontRef idx="minor">
+            <a:schemeClr val="lt1"/>
+          </a:fontRef>
+        </p:style>
+        <p:txBody>
+          <a:bodyPr rtlCol="0" anchor="ctr"/>
+          <a:lstStyle/>
+          <a:p>
+            <a:pPr algn="ctr"/>
+          </a:p>
+        </p:txBody>
+      </p:sp>
+      <p:sp>
+        <p:nvSpPr>
+          <p:cNvPr id="23" name="Rectangle 22"/>
+          <p:cNvSpPr/>
+          <p:nvPr/>
+        </p:nvSpPr>
+        <p:spPr>
+          <a:xfrm>
+            <a:off x="365760" y="4520000"/>
+            <a:ext cx="150000" cy="1430000"/>
+          </a:xfrm>
+          <a:prstGeom prst="rect">
+            <a:avLst/>
+          </a:prstGeom>
+          <a:solidFill>
+            <a:srgbClr val="0068B5"/>
+          </a:solidFill>
+          <a:ln>
+            <a:noFill/>
+          </a:ln>
+          <a:effectLst/>
+        </p:spPr>
+        <p:style>
+          <a:lnRef idx="1">
+            <a:schemeClr val="accent1"/>
+          </a:lnRef>
+          <a:fillRef idx="3">
+            <a:schemeClr val="accent1"/>
+          </a:fillRef>
+          <a:effectRef idx="2">
+            <a:schemeClr val="accent1"/>
+          </a:effectRef>
+          <a:fontRef idx="minor">
+            <a:schemeClr val="lt1"/>
+          </a:fontRef>
+        </p:style>
+        <p:txBody>
+          <a:bodyPr rtlCol="0" anchor="ctr"/>
+          <a:lstStyle/>
+          <a:p>
+            <a:pPr algn="ctr"/>
+          </a:p>
+        </p:txBody>
+      </p:sp>
+      <p:sp>
+        <p:nvSpPr>
+          <p:cNvPr id="24" name="Oval 23"/>
+          <p:cNvSpPr/>
+          <p:nvPr/>
+        </p:nvSpPr>
+        <p:spPr>
+          <a:xfrm>
+            <a:off x="665760" y="4895000"/>
+            <a:ext cx="680000" cy="680000"/>
+          </a:xfrm>
+          <a:prstGeom prst="ellipse">
+            <a:avLst/>
+          </a:prstGeom>
+          <a:solidFill>
+            <a:srgbClr val="0068B5"/>
+          </a:solidFill>
+          <a:ln>
+            <a:noFill/>
+          </a:ln>
+          <a:effectLst/>
+        </p:spPr>
+        <p:style>
+          <a:lnRef idx="1">
+            <a:schemeClr val="accent1"/>
+          </a:lnRef>
+          <a:fillRef idx="3">
+            <a:schemeClr val="accent1"/>
+          </a:fillRef>
+          <a:effectRef idx="2">
+            <a:schemeClr val="accent1"/>
+          </a:effectRef>
+          <a:fontRef idx="minor">
+            <a:schemeClr val="lt1"/>
+          </a:fontRef>
+        </p:style>
+        <p:txBody>
+          <a:bodyPr rtlCol="0" anchor="ctr"/>
+          <a:lstStyle/>
+          <a:p>
+            <a:pPr algn="ctr"/>
+          </a:p>
+        </p:txBody>
+      </p:sp>
+      <p:sp>
+        <p:nvSpPr>
+          <p:cNvPr id="25" name="TextBox 24"/>
+          <p:cNvSpPr txBox="1"/>
+          <p:nvPr/>
+        </p:nvSpPr>
+        <p:spPr>
+          <a:xfrm>
+            <a:off x="665760" y="4955000"/>
+            <a:ext cx="680000" cy="560000"/>
+          </a:xfrm>
+          <a:prstGeom prst="rect">
+            <a:avLst/>
+          </a:prstGeom>
+          <a:noFill/>
+        </p:spPr>
+        <p:txBody>
+          <a:bodyPr wrap="square">
+            <a:spAutoFit/>
+          </a:bodyPr>
+          <a:lstStyle/>
+          <a:p>
+            <a:pPr algn="ctr"/>
+            <a:r>
+              <a:rPr sz="3200" b="1" i="0">
+                <a:solidFill>
+                  <a:srgbClr val="FFFFFF"/>
+                </a:solidFill>
+                <a:latin typeface="Calibri"/>
+              </a:rPr>
+              <a:t>3</a:t>
+            </a:r>
+          </a:p>
+        </p:txBody>
+      </p:sp>
+      <p:sp>
+        <p:nvSpPr>
+          <p:cNvPr id="26" name="TextBox 25"/>
+          <p:cNvSpPr txBox="1"/>
+          <p:nvPr/>
+        </p:nvSpPr>
+        <p:spPr>
+          <a:xfrm>
+            <a:off x="1545760" y="4630000"/>
+            <a:ext cx="7580000" cy="1210000"/>
+          </a:xfrm>
+          <a:prstGeom prst="rect">
+            <a:avLst/>
+          </a:prstGeom>
+          <a:noFill/>
+        </p:spPr>
+        <p:txBody>
+          <a:bodyPr wrap="square">
+            <a:spAutoFit/>
+          </a:bodyPr>
+          <a:lstStyle/>
+          <a:p>
+            <a:pPr algn="l"/>
+            <a:r>
+              <a:rPr sz="1800" b="1" i="0">
+                <a:solidFill>
+                  <a:srgbClr val="0068B5"/>
+                </a:solidFill>
+                <a:latin typeface="Calibri"/>
+              </a:rPr>
+              <a:t>Block importances are not independent</a:t>
+            </a:r>
+          </a:p>
+          <a:p>
+            <a:pPr algn="l">
+              <a:spcBef>
+                <a:spcPts val="600"/>
+              </a:spcBef>
+            </a:pPr>
+            <a:r>
+              <a:rPr sz="1300" b="0" i="0">
+                <a:solidFill>
+                  <a:srgbClr val="525252"/>
+                </a:solidFill>
+                <a:latin typeface="Calibri"/>
+              </a:rPr>
+              <a:t>Some blocks rise and fall in importance together (their scores are correlated).</a:t>
+            </a:r>
+          </a:p>
+          <a:p>
+            <a:pPr algn="l">
+              <a:spcBef>
+                <a:spcPts val="200"/>
+              </a:spcBef>
+            </a:pPr>
+            <a:r>
+              <a:rPr sz="1300" b="0" i="0">
+                <a:solidFill>
+                  <a:srgbClr val="525252"/>
+                </a:solidFill>
+                <a:latin typeface="Calibri"/>
+              </a:rPr>
+              <a:t>Pruning each block in isolation ignores that a surviving block may depend on a</a:t>
+            </a:r>
+          </a:p>
+          <a:p>
+            <a:pPr algn="l">
+              <a:spcBef>
+                <a:spcPts val="200"/>
+              </a:spcBef>
+            </a:pPr>
+            <a:r>
+              <a:rPr sz="1300" b="0" i="0">
+                <a:solidFill>
+                  <a:srgbClr val="525252"/>
+                </a:solidFill>
+                <a:latin typeface="Calibri"/>
+              </a:rPr>
+              <a:t>neighbour you just pruned — the decisions should inform each other.</a:t>
+            </a:r>
+          </a:p>
+        </p:txBody>
+      </p:sp>
+      <p:sp>
+        <p:nvSpPr>
+          <p:cNvPr id="27" name="TextBox 26"/>
+          <p:cNvSpPr txBox="1"/>
+          <p:nvPr/>
+        </p:nvSpPr>
+        <p:spPr>
+          <a:xfrm>
+            <a:off x="1545760" y="5650000"/>
+            <a:ext cx="3000000" cy="240000"/>
+          </a:xfrm>
+          <a:prstGeom prst="rect">
+            <a:avLst/>
+          </a:prstGeom>
+          <a:noFill/>
+        </p:spPr>
+        <p:txBody>
+          <a:bodyPr wrap="square">
+            <a:spAutoFit/>
+          </a:bodyPr>
+          <a:lstStyle/>
+          <a:p>
+            <a:pPr algn="l"/>
+            <a:r>
+              <a:rPr sz="1200" b="0" i="1">
+                <a:solidFill>
+                  <a:srgbClr val="0068B5"/>
+                </a:solidFill>
+                <a:latin typeface="Calibri"/>
+              </a:rPr>
+              <a:t>isomorphic: coupling ignored</a:t>
+            </a:r>
+          </a:p>
+        </p:txBody>
+      </p:sp>
+      <p:sp>
+        <p:nvSpPr>
+          <p:cNvPr id="28" name="Rectangle 27"/>
+          <p:cNvSpPr/>
+          <p:nvPr/>
+        </p:nvSpPr>
+        <p:spPr>
+          <a:xfrm>
+            <a:off x="9125760" y="4670000"/>
+            <a:ext cx="2550000" cy="1130000"/>
+          </a:xfrm>
+          <a:prstGeom prst="rect">
+            <a:avLst/>
+          </a:prstGeom>
+          <a:solidFill>
+            <a:srgbClr val="FFFFFF"/>
+          </a:solidFill>
+          <a:ln w="19050">
+            <a:solidFill>
+              <a:srgbClr val="0068B5"/>
+            </a:solidFill>
+          </a:ln>
+          <a:effectLst/>
+        </p:spPr>
+        <p:style>
+          <a:lnRef idx="1">
+            <a:schemeClr val="accent1"/>
+          </a:lnRef>
+          <a:fillRef idx="3">
+            <a:schemeClr val="accent1"/>
+          </a:fillRef>
+          <a:effectRef idx="2">
+            <a:schemeClr val="accent1"/>
+          </a:effectRef>
+          <a:fontRef idx="minor">
+            <a:schemeClr val="lt1"/>
+          </a:fontRef>
+        </p:style>
+        <p:txBody>
+          <a:bodyPr rtlCol="0" anchor="ctr"/>
+          <a:lstStyle/>
+          <a:p>
+            <a:pPr algn="ctr"/>
+          </a:p>
+        </p:txBody>
+      </p:sp>
+      <p:sp>
+        <p:nvSpPr>
+          <p:cNvPr id="29" name="TextBox 28"/>
+          <p:cNvSpPr txBox="1"/>
+          <p:nvPr/>
+        </p:nvSpPr>
+        <p:spPr>
+          <a:xfrm>
+            <a:off x="9245760" y="4750000"/>
+            <a:ext cx="2310000" cy="1010000"/>
+          </a:xfrm>
+          <a:prstGeom prst="rect">
+            <a:avLst/>
+          </a:prstGeom>
+          <a:noFill/>
+        </p:spPr>
+        <p:txBody>
+          <a:bodyPr wrap="square">
+            <a:spAutoFit/>
+          </a:bodyPr>
+          <a:lstStyle/>
+          <a:p>
+            <a:pPr algn="l"/>
+            <a:r>
+              <a:rPr sz="1100" b="1" i="0">
+                <a:solidFill>
+                  <a:srgbClr val="525252"/>
+                </a:solidFill>
+                <a:latin typeface="Calibri"/>
+              </a:rPr>
+              <a:t>our fix</a:t>
+            </a:r>
+          </a:p>
+          <a:p>
+            <a:pPr algn="l">
+              <a:spcBef>
+                <a:spcPts val="400"/>
+              </a:spcBef>
+            </a:pPr>
+            <a:r>
+              <a:rPr sz="2400" b="1" i="0">
+                <a:solidFill>
+                  <a:srgbClr val="0068B5"/>
+                </a:solidFill>
+                <a:latin typeface="Calibri"/>
+              </a:rPr>
+              <a:t>→  α</a:t>
+            </a:r>
+          </a:p>
+          <a:p>
+            <a:pPr algn="l">
+              <a:spcBef>
+                <a:spcPts val="400"/>
+              </a:spcBef>
+            </a:pPr>
+            <a:r>
+              <a:rPr sz="1300" b="0" i="0">
+                <a:solidFill>
+                  <a:srgbClr val="1A1A1A"/>
+                </a:solidFill>
+                <a:latin typeface="Calibri"/>
+              </a:rPr>
+              <a:t>functional edges</a:t>
             </a:r>
           </a:p>
         </p:txBody>

</xml_diff>

<commit_message>
Worked example: show per-node values + labeled group brackets
Enhanced slide 9: each node now shows its S/I value below it, and the theta
row draws labeled brackets (Group A r-down / Group B r-up). Reworked the
example values so groups are contiguous ({B0,B1} high, {B3,B4} low) — brackets
and within-group coupling arcs (B0-B1, B3-B4) read cleanly without crossing.

Co-Authored-By: Claude Sonnet 4.6 <noreply@anthropic.com>
</commit_message>
<xml_diff>
--- a/hypergraph_slides.pptx
+++ b/hypergraph_slides.pptx
@@ -20408,7 +20408,7 @@
         <p:spPr>
           <a:xfrm>
             <a:off x="365760" y="1020000"/>
-            <a:ext cx="11430000" cy="1120000"/>
+            <a:ext cx="11430000" cy="1220000"/>
           </a:xfrm>
           <a:prstGeom prst="rect">
             <a:avLst/>
@@ -20452,7 +20452,7 @@
         <p:spPr>
           <a:xfrm>
             <a:off x="365760" y="1140000"/>
-            <a:ext cx="110000" cy="860000"/>
+            <a:ext cx="110000" cy="960000"/>
           </a:xfrm>
           <a:prstGeom prst="rect">
             <a:avLst/>
@@ -20495,8 +20495,8 @@
         </p:nvSpPr>
         <p:spPr>
           <a:xfrm>
-            <a:off x="565760" y="1150000"/>
-            <a:ext cx="3000000" cy="920000"/>
+            <a:off x="565760" y="1170000"/>
+            <a:ext cx="3000000" cy="1000000"/>
           </a:xfrm>
           <a:prstGeom prst="rect">
             <a:avLst/>
@@ -20546,8 +20546,8 @@
         </p:nvCxnSpPr>
         <p:spPr>
           <a:xfrm>
-            <a:off x="4335760" y="1650000"/>
-            <a:ext cx="1402620" cy="0"/>
+            <a:off x="4305760" y="1690000"/>
+            <a:ext cx="1440120" cy="0"/>
           </a:xfrm>
           <a:prstGeom prst="bentConnector3">
             <a:avLst/>
@@ -20582,8 +20582,8 @@
         </p:nvCxnSpPr>
         <p:spPr>
           <a:xfrm>
-            <a:off x="6208380" y="1650000"/>
-            <a:ext cx="1402620" cy="0"/>
+            <a:off x="6185880" y="1690000"/>
+            <a:ext cx="1440120" cy="0"/>
           </a:xfrm>
           <a:prstGeom prst="bentConnector3">
             <a:avLst/>
@@ -20618,8 +20618,8 @@
         </p:nvCxnSpPr>
         <p:spPr>
           <a:xfrm>
-            <a:off x="8081000" y="1650000"/>
-            <a:ext cx="1402620" cy="0"/>
+            <a:off x="8066000" y="1690000"/>
+            <a:ext cx="1440120" cy="0"/>
           </a:xfrm>
           <a:prstGeom prst="bentConnector3">
             <a:avLst/>
@@ -20654,8 +20654,8 @@
         </p:nvCxnSpPr>
         <p:spPr>
           <a:xfrm>
-            <a:off x="9953620" y="1650000"/>
-            <a:ext cx="1402620" cy="0"/>
+            <a:off x="9946120" y="1690000"/>
+            <a:ext cx="1440120" cy="0"/>
           </a:xfrm>
           <a:prstGeom prst="bentConnector3">
             <a:avLst/>
@@ -20690,8 +20690,8 @@
         </p:nvSpPr>
         <p:spPr>
           <a:xfrm>
-            <a:off x="3865760" y="1415000"/>
-            <a:ext cx="470000" cy="470000"/>
+            <a:off x="3865760" y="1470000"/>
+            <a:ext cx="440000" cy="440000"/>
           </a:xfrm>
           <a:prstGeom prst="ellipse">
             <a:avLst/>
@@ -20734,8 +20734,8 @@
         </p:nvSpPr>
         <p:spPr>
           <a:xfrm>
-            <a:off x="3865760" y="1530000"/>
-            <a:ext cx="470000" cy="240000"/>
+            <a:off x="3865760" y="1570000"/>
+            <a:ext cx="440000" cy="240000"/>
           </a:xfrm>
           <a:prstGeom prst="rect">
             <a:avLst/>
@@ -20769,8 +20769,8 @@
         </p:nvSpPr>
         <p:spPr>
           <a:xfrm>
-            <a:off x="5738380" y="1415000"/>
-            <a:ext cx="470000" cy="470000"/>
+            <a:off x="5745880" y="1470000"/>
+            <a:ext cx="440000" cy="440000"/>
           </a:xfrm>
           <a:prstGeom prst="ellipse">
             <a:avLst/>
@@ -20813,8 +20813,8 @@
         </p:nvSpPr>
         <p:spPr>
           <a:xfrm>
-            <a:off x="5738380" y="1530000"/>
-            <a:ext cx="470000" cy="240000"/>
+            <a:off x="5745880" y="1570000"/>
+            <a:ext cx="440000" cy="240000"/>
           </a:xfrm>
           <a:prstGeom prst="rect">
             <a:avLst/>
@@ -20848,8 +20848,8 @@
         </p:nvSpPr>
         <p:spPr>
           <a:xfrm>
-            <a:off x="7611000" y="1415000"/>
-            <a:ext cx="470000" cy="470000"/>
+            <a:off x="7626000" y="1470000"/>
+            <a:ext cx="440000" cy="440000"/>
           </a:xfrm>
           <a:prstGeom prst="ellipse">
             <a:avLst/>
@@ -20892,8 +20892,8 @@
         </p:nvSpPr>
         <p:spPr>
           <a:xfrm>
-            <a:off x="7611000" y="1530000"/>
-            <a:ext cx="470000" cy="240000"/>
+            <a:off x="7626000" y="1570000"/>
+            <a:ext cx="440000" cy="240000"/>
           </a:xfrm>
           <a:prstGeom prst="rect">
             <a:avLst/>
@@ -20927,8 +20927,8 @@
         </p:nvSpPr>
         <p:spPr>
           <a:xfrm>
-            <a:off x="9483620" y="1415000"/>
-            <a:ext cx="470000" cy="470000"/>
+            <a:off x="9506120" y="1470000"/>
+            <a:ext cx="440000" cy="440000"/>
           </a:xfrm>
           <a:prstGeom prst="ellipse">
             <a:avLst/>
@@ -20971,8 +20971,8 @@
         </p:nvSpPr>
         <p:spPr>
           <a:xfrm>
-            <a:off x="9483620" y="1530000"/>
-            <a:ext cx="470000" cy="240000"/>
+            <a:off x="9506120" y="1570000"/>
+            <a:ext cx="440000" cy="240000"/>
           </a:xfrm>
           <a:prstGeom prst="rect">
             <a:avLst/>
@@ -21006,8 +21006,8 @@
         </p:nvSpPr>
         <p:spPr>
           <a:xfrm>
-            <a:off x="11356240" y="1415000"/>
-            <a:ext cx="470000" cy="470000"/>
+            <a:off x="11386240" y="1470000"/>
+            <a:ext cx="440000" cy="440000"/>
           </a:xfrm>
           <a:prstGeom prst="ellipse">
             <a:avLst/>
@@ -21050,8 +21050,8 @@
         </p:nvSpPr>
         <p:spPr>
           <a:xfrm>
-            <a:off x="11356240" y="1530000"/>
-            <a:ext cx="470000" cy="240000"/>
+            <a:off x="11386240" y="1570000"/>
+            <a:ext cx="440000" cy="240000"/>
           </a:xfrm>
           <a:prstGeom prst="rect">
             <a:avLst/>
@@ -21085,8 +21085,8 @@
         </p:nvSpPr>
         <p:spPr>
           <a:xfrm>
-            <a:off x="365760" y="2320000"/>
-            <a:ext cx="110000" cy="860000"/>
+            <a:off x="365760" y="2420000"/>
+            <a:ext cx="110000" cy="960000"/>
           </a:xfrm>
           <a:prstGeom prst="rect">
             <a:avLst/>
@@ -21129,8 +21129,8 @@
         </p:nvSpPr>
         <p:spPr>
           <a:xfrm>
-            <a:off x="565760" y="2330000"/>
-            <a:ext cx="3000000" cy="920000"/>
+            <a:off x="565760" y="2450000"/>
+            <a:ext cx="3000000" cy="1000000"/>
           </a:xfrm>
           <a:prstGeom prst="rect">
             <a:avLst/>
@@ -21180,8 +21180,8 @@
         </p:nvCxnSpPr>
         <p:spPr>
           <a:xfrm>
-            <a:off x="4335760" y="2830000"/>
-            <a:ext cx="1402620" cy="0"/>
+            <a:off x="4305760" y="2970000"/>
+            <a:ext cx="1440120" cy="0"/>
           </a:xfrm>
           <a:prstGeom prst="bentConnector3">
             <a:avLst/>
@@ -21216,8 +21216,8 @@
         </p:nvCxnSpPr>
         <p:spPr>
           <a:xfrm>
-            <a:off x="6208380" y="2830000"/>
-            <a:ext cx="3275240" cy="0"/>
+            <a:off x="6185880" y="2970000"/>
+            <a:ext cx="3320240" cy="0"/>
           </a:xfrm>
           <a:prstGeom prst="bentConnector3">
             <a:avLst/>
@@ -21252,8 +21252,8 @@
         </p:nvCxnSpPr>
         <p:spPr>
           <a:xfrm>
-            <a:off x="9953620" y="2830000"/>
-            <a:ext cx="1402620" cy="0"/>
+            <a:off x="9946120" y="2970000"/>
+            <a:ext cx="1440120" cy="0"/>
           </a:xfrm>
           <a:prstGeom prst="bentConnector3">
             <a:avLst/>
@@ -21288,8 +21288,8 @@
         </p:nvSpPr>
         <p:spPr>
           <a:xfrm>
-            <a:off x="3865760" y="2595000"/>
-            <a:ext cx="470000" cy="470000"/>
+            <a:off x="3865760" y="2750000"/>
+            <a:ext cx="440000" cy="440000"/>
           </a:xfrm>
           <a:prstGeom prst="ellipse">
             <a:avLst/>
@@ -21332,8 +21332,8 @@
         </p:nvSpPr>
         <p:spPr>
           <a:xfrm>
-            <a:off x="3865760" y="2710000"/>
-            <a:ext cx="470000" cy="240000"/>
+            <a:off x="3865760" y="2850000"/>
+            <a:ext cx="440000" cy="240000"/>
           </a:xfrm>
           <a:prstGeom prst="rect">
             <a:avLst/>
@@ -21361,58 +21361,14 @@
       </p:sp>
       <p:sp>
         <p:nvSpPr>
-          <p:cNvPr id="29" name="Oval 28"/>
-          <p:cNvSpPr/>
-          <p:nvPr/>
-        </p:nvSpPr>
-        <p:spPr>
-          <a:xfrm>
-            <a:off x="5738380" y="2595000"/>
-            <a:ext cx="470000" cy="470000"/>
-          </a:xfrm>
-          <a:prstGeom prst="ellipse">
-            <a:avLst/>
-          </a:prstGeom>
-          <a:solidFill>
-            <a:srgbClr val="0068B5"/>
-          </a:solidFill>
-          <a:ln>
-            <a:noFill/>
-          </a:ln>
-          <a:effectLst/>
-        </p:spPr>
-        <p:style>
-          <a:lnRef idx="1">
-            <a:schemeClr val="accent1"/>
-          </a:lnRef>
-          <a:fillRef idx="3">
-            <a:schemeClr val="accent1"/>
-          </a:fillRef>
-          <a:effectRef idx="2">
-            <a:schemeClr val="accent1"/>
-          </a:effectRef>
-          <a:fontRef idx="minor">
-            <a:schemeClr val="lt1"/>
-          </a:fontRef>
-        </p:style>
-        <p:txBody>
-          <a:bodyPr rtlCol="0" anchor="ctr"/>
-          <a:lstStyle/>
-          <a:p>
-            <a:pPr algn="ctr"/>
-          </a:p>
-        </p:txBody>
-      </p:sp>
-      <p:sp>
-        <p:nvSpPr>
-          <p:cNvPr id="30" name="TextBox 29"/>
+          <p:cNvPr id="29" name="TextBox 28"/>
           <p:cNvSpPr txBox="1"/>
           <p:nvPr/>
         </p:nvSpPr>
         <p:spPr>
           <a:xfrm>
-            <a:off x="5738380" y="2710000"/>
-            <a:ext cx="470000" cy="240000"/>
+            <a:off x="3785760" y="3215000"/>
+            <a:ext cx="600000" cy="200000"/>
           </a:xfrm>
           <a:prstGeom prst="rect">
             <a:avLst/>
@@ -21427,6 +21383,85 @@
           <a:p>
             <a:pPr algn="ctr"/>
             <a:r>
+              <a:rPr sz="1000" b="0" i="0">
+                <a:solidFill>
+                  <a:srgbClr val="1A1A1A"/>
+                </a:solidFill>
+                <a:latin typeface="Calibri"/>
+              </a:rPr>
+              <a:t>S=.90</a:t>
+            </a:r>
+          </a:p>
+        </p:txBody>
+      </p:sp>
+      <p:sp>
+        <p:nvSpPr>
+          <p:cNvPr id="30" name="Oval 29"/>
+          <p:cNvSpPr/>
+          <p:nvPr/>
+        </p:nvSpPr>
+        <p:spPr>
+          <a:xfrm>
+            <a:off x="5745880" y="2750000"/>
+            <a:ext cx="440000" cy="440000"/>
+          </a:xfrm>
+          <a:prstGeom prst="ellipse">
+            <a:avLst/>
+          </a:prstGeom>
+          <a:solidFill>
+            <a:srgbClr val="0068B5"/>
+          </a:solidFill>
+          <a:ln>
+            <a:noFill/>
+          </a:ln>
+          <a:effectLst/>
+        </p:spPr>
+        <p:style>
+          <a:lnRef idx="1">
+            <a:schemeClr val="accent1"/>
+          </a:lnRef>
+          <a:fillRef idx="3">
+            <a:schemeClr val="accent1"/>
+          </a:fillRef>
+          <a:effectRef idx="2">
+            <a:schemeClr val="accent1"/>
+          </a:effectRef>
+          <a:fontRef idx="minor">
+            <a:schemeClr val="lt1"/>
+          </a:fontRef>
+        </p:style>
+        <p:txBody>
+          <a:bodyPr rtlCol="0" anchor="ctr"/>
+          <a:lstStyle/>
+          <a:p>
+            <a:pPr algn="ctr"/>
+          </a:p>
+        </p:txBody>
+      </p:sp>
+      <p:sp>
+        <p:nvSpPr>
+          <p:cNvPr id="31" name="TextBox 30"/>
+          <p:cNvSpPr txBox="1"/>
+          <p:nvPr/>
+        </p:nvSpPr>
+        <p:spPr>
+          <a:xfrm>
+            <a:off x="5745880" y="2850000"/>
+            <a:ext cx="440000" cy="240000"/>
+          </a:xfrm>
+          <a:prstGeom prst="rect">
+            <a:avLst/>
+          </a:prstGeom>
+          <a:noFill/>
+        </p:spPr>
+        <p:txBody>
+          <a:bodyPr wrap="square">
+            <a:spAutoFit/>
+          </a:bodyPr>
+          <a:lstStyle/>
+          <a:p>
+            <a:pPr algn="ctr"/>
+            <a:r>
               <a:rPr sz="1100" b="1" i="0">
                 <a:solidFill>
                   <a:srgbClr val="FFFFFF"/>
@@ -21440,14 +21475,49 @@
       </p:sp>
       <p:sp>
         <p:nvSpPr>
-          <p:cNvPr id="31" name="Oval 30"/>
+          <p:cNvPr id="32" name="TextBox 31"/>
+          <p:cNvSpPr txBox="1"/>
+          <p:nvPr/>
+        </p:nvSpPr>
+        <p:spPr>
+          <a:xfrm>
+            <a:off x="5665880" y="3215000"/>
+            <a:ext cx="600000" cy="200000"/>
+          </a:xfrm>
+          <a:prstGeom prst="rect">
+            <a:avLst/>
+          </a:prstGeom>
+          <a:noFill/>
+        </p:spPr>
+        <p:txBody>
+          <a:bodyPr wrap="square">
+            <a:spAutoFit/>
+          </a:bodyPr>
+          <a:lstStyle/>
+          <a:p>
+            <a:pPr algn="ctr"/>
+            <a:r>
+              <a:rPr sz="1000" b="0" i="0">
+                <a:solidFill>
+                  <a:srgbClr val="1A1A1A"/>
+                </a:solidFill>
+                <a:latin typeface="Calibri"/>
+              </a:rPr>
+              <a:t>S=.85</a:t>
+            </a:r>
+          </a:p>
+        </p:txBody>
+      </p:sp>
+      <p:sp>
+        <p:nvSpPr>
+          <p:cNvPr id="33" name="Oval 32"/>
           <p:cNvSpPr/>
           <p:nvPr/>
         </p:nvSpPr>
         <p:spPr>
           <a:xfrm>
-            <a:off x="7611000" y="2595000"/>
-            <a:ext cx="470000" cy="470000"/>
+            <a:off x="7626000" y="2750000"/>
+            <a:ext cx="440000" cy="440000"/>
           </a:xfrm>
           <a:prstGeom prst="ellipse">
             <a:avLst/>
@@ -21486,14 +21556,14 @@
       </p:sp>
       <p:sp>
         <p:nvSpPr>
-          <p:cNvPr id="32" name="TextBox 31"/>
+          <p:cNvPr id="34" name="TextBox 33"/>
           <p:cNvSpPr txBox="1"/>
           <p:nvPr/>
         </p:nvSpPr>
         <p:spPr>
           <a:xfrm>
-            <a:off x="7611000" y="2680000"/>
-            <a:ext cx="470000" cy="300000"/>
+            <a:off x="7626000" y="2820000"/>
+            <a:ext cx="440000" cy="300000"/>
           </a:xfrm>
           <a:prstGeom prst="rect">
             <a:avLst/>
@@ -21521,58 +21591,14 @@
       </p:sp>
       <p:sp>
         <p:nvSpPr>
-          <p:cNvPr id="33" name="Oval 32"/>
-          <p:cNvSpPr/>
-          <p:nvPr/>
-        </p:nvSpPr>
-        <p:spPr>
-          <a:xfrm>
-            <a:off x="9483620" y="2595000"/>
-            <a:ext cx="470000" cy="470000"/>
-          </a:xfrm>
-          <a:prstGeom prst="ellipse">
-            <a:avLst/>
-          </a:prstGeom>
-          <a:solidFill>
-            <a:srgbClr val="0068B5"/>
-          </a:solidFill>
-          <a:ln>
-            <a:noFill/>
-          </a:ln>
-          <a:effectLst/>
-        </p:spPr>
-        <p:style>
-          <a:lnRef idx="1">
-            <a:schemeClr val="accent1"/>
-          </a:lnRef>
-          <a:fillRef idx="3">
-            <a:schemeClr val="accent1"/>
-          </a:fillRef>
-          <a:effectRef idx="2">
-            <a:schemeClr val="accent1"/>
-          </a:effectRef>
-          <a:fontRef idx="minor">
-            <a:schemeClr val="lt1"/>
-          </a:fontRef>
-        </p:style>
-        <p:txBody>
-          <a:bodyPr rtlCol="0" anchor="ctr"/>
-          <a:lstStyle/>
-          <a:p>
-            <a:pPr algn="ctr"/>
-          </a:p>
-        </p:txBody>
-      </p:sp>
-      <p:sp>
-        <p:nvSpPr>
-          <p:cNvPr id="34" name="TextBox 33"/>
+          <p:cNvPr id="35" name="TextBox 34"/>
           <p:cNvSpPr txBox="1"/>
           <p:nvPr/>
         </p:nvSpPr>
         <p:spPr>
           <a:xfrm>
-            <a:off x="9483620" y="2710000"/>
-            <a:ext cx="470000" cy="240000"/>
+            <a:off x="7546000" y="3215000"/>
+            <a:ext cx="600000" cy="200000"/>
           </a:xfrm>
           <a:prstGeom prst="rect">
             <a:avLst/>
@@ -21587,27 +21613,27 @@
           <a:p>
             <a:pPr algn="ctr"/>
             <a:r>
-              <a:rPr sz="1100" b="1" i="0">
-                <a:solidFill>
-                  <a:srgbClr val="FFFFFF"/>
-                </a:solidFill>
-                <a:latin typeface="Calibri"/>
-              </a:rPr>
-              <a:t>B3</a:t>
-            </a:r>
-          </a:p>
-        </p:txBody>
-      </p:sp>
-      <p:sp>
-        <p:nvSpPr>
-          <p:cNvPr id="35" name="Oval 34"/>
+              <a:rPr sz="1000" b="1" i="0">
+                <a:solidFill>
+                  <a:srgbClr val="C0504D"/>
+                </a:solidFill>
+                <a:latin typeface="Calibri"/>
+              </a:rPr>
+              <a:t>S=.35</a:t>
+            </a:r>
+          </a:p>
+        </p:txBody>
+      </p:sp>
+      <p:sp>
+        <p:nvSpPr>
+          <p:cNvPr id="36" name="Oval 35"/>
           <p:cNvSpPr/>
           <p:nvPr/>
         </p:nvSpPr>
         <p:spPr>
           <a:xfrm>
-            <a:off x="11356240" y="2595000"/>
-            <a:ext cx="470000" cy="470000"/>
+            <a:off x="9506120" y="2750000"/>
+            <a:ext cx="440000" cy="440000"/>
           </a:xfrm>
           <a:prstGeom prst="ellipse">
             <a:avLst/>
@@ -21644,14 +21670,14 @@
       </p:sp>
       <p:sp>
         <p:nvSpPr>
-          <p:cNvPr id="36" name="TextBox 35"/>
+          <p:cNvPr id="37" name="TextBox 36"/>
           <p:cNvSpPr txBox="1"/>
           <p:nvPr/>
         </p:nvSpPr>
         <p:spPr>
           <a:xfrm>
-            <a:off x="11356240" y="2710000"/>
-            <a:ext cx="470000" cy="240000"/>
+            <a:off x="9506120" y="2850000"/>
+            <a:ext cx="440000" cy="240000"/>
           </a:xfrm>
           <a:prstGeom prst="rect">
             <a:avLst/>
@@ -21672,27 +21698,62 @@
                 </a:solidFill>
                 <a:latin typeface="Calibri"/>
               </a:rPr>
-              <a:t>B4</a:t>
-            </a:r>
-          </a:p>
-        </p:txBody>
-      </p:sp>
-      <p:sp>
-        <p:nvSpPr>
-          <p:cNvPr id="37" name="Rectangle 36"/>
+              <a:t>B3</a:t>
+            </a:r>
+          </a:p>
+        </p:txBody>
+      </p:sp>
+      <p:sp>
+        <p:nvSpPr>
+          <p:cNvPr id="38" name="TextBox 37"/>
+          <p:cNvSpPr txBox="1"/>
+          <p:nvPr/>
+        </p:nvSpPr>
+        <p:spPr>
+          <a:xfrm>
+            <a:off x="9426120" y="3215000"/>
+            <a:ext cx="600000" cy="200000"/>
+          </a:xfrm>
+          <a:prstGeom prst="rect">
+            <a:avLst/>
+          </a:prstGeom>
+          <a:noFill/>
+        </p:spPr>
+        <p:txBody>
+          <a:bodyPr wrap="square">
+            <a:spAutoFit/>
+          </a:bodyPr>
+          <a:lstStyle/>
+          <a:p>
+            <a:pPr algn="ctr"/>
+            <a:r>
+              <a:rPr sz="1000" b="0" i="0">
+                <a:solidFill>
+                  <a:srgbClr val="1A1A1A"/>
+                </a:solidFill>
+                <a:latin typeface="Calibri"/>
+              </a:rPr>
+              <a:t>S=.55</a:t>
+            </a:r>
+          </a:p>
+        </p:txBody>
+      </p:sp>
+      <p:sp>
+        <p:nvSpPr>
+          <p:cNvPr id="39" name="Oval 38"/>
           <p:cNvSpPr/>
           <p:nvPr/>
         </p:nvSpPr>
         <p:spPr>
           <a:xfrm>
-            <a:off x="365760" y="3380000"/>
-            <a:ext cx="11430000" cy="1120000"/>
-          </a:xfrm>
-          <a:prstGeom prst="rect">
-            <a:avLst/>
-          </a:prstGeom>
-          <a:solidFill>
-            <a:srgbClr val="F7F9FC"/>
+            <a:off x="11386240" y="2750000"/>
+            <a:ext cx="440000" cy="440000"/>
+          </a:xfrm>
+          <a:prstGeom prst="ellipse">
+            <a:avLst/>
+          </a:prstGeom>
+          <a:solidFill>
+            <a:srgbClr val="0068B5"/>
           </a:solidFill>
           <a:ln>
             <a:noFill/>
@@ -21723,20 +21784,90 @@
       </p:sp>
       <p:sp>
         <p:nvSpPr>
-          <p:cNvPr id="38" name="Rectangle 37"/>
+          <p:cNvPr id="40" name="TextBox 39"/>
+          <p:cNvSpPr txBox="1"/>
+          <p:nvPr/>
+        </p:nvSpPr>
+        <p:spPr>
+          <a:xfrm>
+            <a:off x="11386240" y="2850000"/>
+            <a:ext cx="440000" cy="240000"/>
+          </a:xfrm>
+          <a:prstGeom prst="rect">
+            <a:avLst/>
+          </a:prstGeom>
+          <a:noFill/>
+        </p:spPr>
+        <p:txBody>
+          <a:bodyPr wrap="square">
+            <a:spAutoFit/>
+          </a:bodyPr>
+          <a:lstStyle/>
+          <a:p>
+            <a:pPr algn="ctr"/>
+            <a:r>
+              <a:rPr sz="1100" b="1" i="0">
+                <a:solidFill>
+                  <a:srgbClr val="FFFFFF"/>
+                </a:solidFill>
+                <a:latin typeface="Calibri"/>
+              </a:rPr>
+              <a:t>B4</a:t>
+            </a:r>
+          </a:p>
+        </p:txBody>
+      </p:sp>
+      <p:sp>
+        <p:nvSpPr>
+          <p:cNvPr id="41" name="TextBox 40"/>
+          <p:cNvSpPr txBox="1"/>
+          <p:nvPr/>
+        </p:nvSpPr>
+        <p:spPr>
+          <a:xfrm>
+            <a:off x="11306240" y="3215000"/>
+            <a:ext cx="600000" cy="200000"/>
+          </a:xfrm>
+          <a:prstGeom prst="rect">
+            <a:avLst/>
+          </a:prstGeom>
+          <a:noFill/>
+        </p:spPr>
+        <p:txBody>
+          <a:bodyPr wrap="square">
+            <a:spAutoFit/>
+          </a:bodyPr>
+          <a:lstStyle/>
+          <a:p>
+            <a:pPr algn="ctr"/>
+            <a:r>
+              <a:rPr sz="1000" b="0" i="0">
+                <a:solidFill>
+                  <a:srgbClr val="1A1A1A"/>
+                </a:solidFill>
+                <a:latin typeface="Calibri"/>
+              </a:rPr>
+              <a:t>S=.60</a:t>
+            </a:r>
+          </a:p>
+        </p:txBody>
+      </p:sp>
+      <p:sp>
+        <p:nvSpPr>
+          <p:cNvPr id="42" name="Rectangle 41"/>
           <p:cNvSpPr/>
           <p:nvPr/>
         </p:nvSpPr>
         <p:spPr>
           <a:xfrm>
-            <a:off x="365760" y="3500000"/>
-            <a:ext cx="110000" cy="860000"/>
-          </a:xfrm>
-          <a:prstGeom prst="rect">
-            <a:avLst/>
-          </a:prstGeom>
-          <a:solidFill>
-            <a:srgbClr val="0068B5"/>
+            <a:off x="365760" y="3580000"/>
+            <a:ext cx="11430000" cy="1220000"/>
+          </a:xfrm>
+          <a:prstGeom prst="rect">
+            <a:avLst/>
+          </a:prstGeom>
+          <a:solidFill>
+            <a:srgbClr val="F7F9FC"/>
           </a:solidFill>
           <a:ln>
             <a:noFill/>
@@ -21767,14 +21898,58 @@
       </p:sp>
       <p:sp>
         <p:nvSpPr>
-          <p:cNvPr id="39" name="TextBox 38"/>
+          <p:cNvPr id="43" name="Rectangle 42"/>
+          <p:cNvSpPr/>
+          <p:nvPr/>
+        </p:nvSpPr>
+        <p:spPr>
+          <a:xfrm>
+            <a:off x="365760" y="3700000"/>
+            <a:ext cx="110000" cy="960000"/>
+          </a:xfrm>
+          <a:prstGeom prst="rect">
+            <a:avLst/>
+          </a:prstGeom>
+          <a:solidFill>
+            <a:srgbClr val="0068B5"/>
+          </a:solidFill>
+          <a:ln>
+            <a:noFill/>
+          </a:ln>
+          <a:effectLst/>
+        </p:spPr>
+        <p:style>
+          <a:lnRef idx="1">
+            <a:schemeClr val="accent1"/>
+          </a:lnRef>
+          <a:fillRef idx="3">
+            <a:schemeClr val="accent1"/>
+          </a:fillRef>
+          <a:effectRef idx="2">
+            <a:schemeClr val="accent1"/>
+          </a:effectRef>
+          <a:fontRef idx="minor">
+            <a:schemeClr val="lt1"/>
+          </a:fontRef>
+        </p:style>
+        <p:txBody>
+          <a:bodyPr rtlCol="0" anchor="ctr"/>
+          <a:lstStyle/>
+          <a:p>
+            <a:pPr algn="ctr"/>
+          </a:p>
+        </p:txBody>
+      </p:sp>
+      <p:sp>
+        <p:nvSpPr>
+          <p:cNvPr id="44" name="TextBox 43"/>
           <p:cNvSpPr txBox="1"/>
           <p:nvPr/>
         </p:nvSpPr>
         <p:spPr>
           <a:xfrm>
-            <a:off x="565760" y="3510000"/>
-            <a:ext cx="3000000" cy="920000"/>
+            <a:off x="565760" y="3730000"/>
+            <a:ext cx="3000000" cy="1000000"/>
           </a:xfrm>
           <a:prstGeom prst="rect">
             <a:avLst/>
@@ -21811,21 +21986,21 @@
                 </a:solidFill>
                 <a:latin typeface="Calibri"/>
               </a:rPr>
-              <a:t>Group by importance: {B0,B4} high → pruned less,  {B1,B3} low → pruned more</a:t>
+              <a:t>Group by importance:  {B0,B1} high → r↓ ,   {B3,B4} low → r↑</a:t>
             </a:r>
           </a:p>
         </p:txBody>
       </p:sp>
       <p:cxnSp>
         <p:nvCxnSpPr>
-          <p:cNvPr id="40" name="Connector 39"/>
+          <p:cNvPr id="45" name="Connector 44"/>
           <p:cNvCxnSpPr/>
           <p:nvPr/>
         </p:nvCxnSpPr>
         <p:spPr>
           <a:xfrm>
-            <a:off x="4335760" y="4010000"/>
-            <a:ext cx="1402620" cy="0"/>
+            <a:off x="4305760" y="4250000"/>
+            <a:ext cx="1440120" cy="0"/>
           </a:xfrm>
           <a:prstGeom prst="bentConnector3">
             <a:avLst/>
@@ -21854,14 +22029,14 @@
       </p:cxnSp>
       <p:cxnSp>
         <p:nvCxnSpPr>
-          <p:cNvPr id="41" name="Connector 40"/>
+          <p:cNvPr id="46" name="Connector 45"/>
           <p:cNvCxnSpPr/>
           <p:nvPr/>
         </p:nvCxnSpPr>
         <p:spPr>
           <a:xfrm>
-            <a:off x="6208380" y="4010000"/>
-            <a:ext cx="3275240" cy="0"/>
+            <a:off x="6185880" y="4250000"/>
+            <a:ext cx="3320240" cy="0"/>
           </a:xfrm>
           <a:prstGeom prst="bentConnector3">
             <a:avLst/>
@@ -21890,14 +22065,14 @@
       </p:cxnSp>
       <p:cxnSp>
         <p:nvCxnSpPr>
-          <p:cNvPr id="42" name="Connector 41"/>
+          <p:cNvPr id="47" name="Connector 46"/>
           <p:cNvCxnSpPr/>
           <p:nvPr/>
         </p:nvCxnSpPr>
         <p:spPr>
           <a:xfrm>
-            <a:off x="9953620" y="4010000"/>
-            <a:ext cx="1402620" cy="0"/>
+            <a:off x="9946120" y="4250000"/>
+            <a:ext cx="1440120" cy="0"/>
           </a:xfrm>
           <a:prstGeom prst="bentConnector3">
             <a:avLst/>
@@ -21924,60 +22099,124 @@
           </a:fontRef>
         </p:style>
       </p:cxnSp>
-      <p:sp>
-        <p:nvSpPr>
-          <p:cNvPr id="43" name="Oval 42"/>
-          <p:cNvSpPr/>
-          <p:nvPr/>
-        </p:nvSpPr>
-        <p:spPr>
-          <a:xfrm>
-            <a:off x="3865760" y="3775000"/>
-            <a:ext cx="470000" cy="470000"/>
-          </a:xfrm>
-          <a:prstGeom prst="ellipse">
-            <a:avLst/>
-          </a:prstGeom>
-          <a:solidFill>
-            <a:srgbClr val="70AD47"/>
-          </a:solidFill>
-          <a:ln>
-            <a:noFill/>
-          </a:ln>
-          <a:effectLst/>
-        </p:spPr>
-        <p:style>
-          <a:lnRef idx="1">
-            <a:schemeClr val="accent1"/>
-          </a:lnRef>
-          <a:fillRef idx="3">
-            <a:schemeClr val="accent1"/>
-          </a:fillRef>
-          <a:effectRef idx="2">
-            <a:schemeClr val="accent1"/>
-          </a:effectRef>
-          <a:fontRef idx="minor">
-            <a:schemeClr val="lt1"/>
-          </a:fontRef>
-        </p:style>
-        <p:txBody>
-          <a:bodyPr rtlCol="0" anchor="ctr"/>
-          <a:lstStyle/>
-          <a:p>
-            <a:pPr algn="ctr"/>
-          </a:p>
-        </p:txBody>
-      </p:sp>
-      <p:sp>
-        <p:nvSpPr>
-          <p:cNvPr id="44" name="TextBox 43"/>
+      <p:cxnSp>
+        <p:nvCxnSpPr>
+          <p:cNvPr id="48" name="Connector 47"/>
+          <p:cNvCxnSpPr/>
+          <p:nvPr/>
+        </p:nvCxnSpPr>
+        <p:spPr>
+          <a:xfrm>
+            <a:off x="3865760" y="3880000"/>
+            <a:ext cx="2320120" cy="0"/>
+          </a:xfrm>
+          <a:prstGeom prst="bentConnector3">
+            <a:avLst/>
+          </a:prstGeom>
+          <a:ln w="15875">
+            <a:solidFill>
+              <a:srgbClr val="70AD47"/>
+            </a:solidFill>
+          </a:ln>
+          <a:effectLst/>
+        </p:spPr>
+        <p:style>
+          <a:lnRef idx="2">
+            <a:schemeClr val="accent1"/>
+          </a:lnRef>
+          <a:fillRef idx="0">
+            <a:schemeClr val="accent1"/>
+          </a:fillRef>
+          <a:effectRef idx="1">
+            <a:schemeClr val="accent1"/>
+          </a:effectRef>
+          <a:fontRef idx="minor">
+            <a:schemeClr val="tx1"/>
+          </a:fontRef>
+        </p:style>
+      </p:cxnSp>
+      <p:cxnSp>
+        <p:nvCxnSpPr>
+          <p:cNvPr id="49" name="Connector 48"/>
+          <p:cNvCxnSpPr/>
+          <p:nvPr/>
+        </p:nvCxnSpPr>
+        <p:spPr>
+          <a:xfrm>
+            <a:off x="3865760" y="3880000"/>
+            <a:ext cx="0" cy="70000"/>
+          </a:xfrm>
+          <a:prstGeom prst="bentConnector3">
+            <a:avLst/>
+          </a:prstGeom>
+          <a:ln w="15875">
+            <a:solidFill>
+              <a:srgbClr val="70AD47"/>
+            </a:solidFill>
+          </a:ln>
+          <a:effectLst/>
+        </p:spPr>
+        <p:style>
+          <a:lnRef idx="2">
+            <a:schemeClr val="accent1"/>
+          </a:lnRef>
+          <a:fillRef idx="0">
+            <a:schemeClr val="accent1"/>
+          </a:fillRef>
+          <a:effectRef idx="1">
+            <a:schemeClr val="accent1"/>
+          </a:effectRef>
+          <a:fontRef idx="minor">
+            <a:schemeClr val="tx1"/>
+          </a:fontRef>
+        </p:style>
+      </p:cxnSp>
+      <p:cxnSp>
+        <p:nvCxnSpPr>
+          <p:cNvPr id="50" name="Connector 49"/>
+          <p:cNvCxnSpPr/>
+          <p:nvPr/>
+        </p:nvCxnSpPr>
+        <p:spPr>
+          <a:xfrm>
+            <a:off x="6185880" y="3880000"/>
+            <a:ext cx="0" cy="70000"/>
+          </a:xfrm>
+          <a:prstGeom prst="bentConnector3">
+            <a:avLst/>
+          </a:prstGeom>
+          <a:ln w="15875">
+            <a:solidFill>
+              <a:srgbClr val="70AD47"/>
+            </a:solidFill>
+          </a:ln>
+          <a:effectLst/>
+        </p:spPr>
+        <p:style>
+          <a:lnRef idx="2">
+            <a:schemeClr val="accent1"/>
+          </a:lnRef>
+          <a:fillRef idx="0">
+            <a:schemeClr val="accent1"/>
+          </a:fillRef>
+          <a:effectRef idx="1">
+            <a:schemeClr val="accent1"/>
+          </a:effectRef>
+          <a:fontRef idx="minor">
+            <a:schemeClr val="tx1"/>
+          </a:fontRef>
+        </p:style>
+      </p:cxnSp>
+      <p:sp>
+        <p:nvSpPr>
+          <p:cNvPr id="51" name="TextBox 50"/>
           <p:cNvSpPr txBox="1"/>
           <p:nvPr/>
         </p:nvSpPr>
         <p:spPr>
           <a:xfrm>
-            <a:off x="3865760" y="3890000"/>
-            <a:ext cx="470000" cy="240000"/>
+            <a:off x="4275820" y="3630000"/>
+            <a:ext cx="1500000" cy="230000"/>
           </a:xfrm>
           <a:prstGeom prst="rect">
             <a:avLst/>
@@ -21994,69 +22233,133 @@
             <a:r>
               <a:rPr sz="1100" b="1" i="0">
                 <a:solidFill>
-                  <a:srgbClr val="FFFFFF"/>
-                </a:solidFill>
-                <a:latin typeface="Calibri"/>
-              </a:rPr>
-              <a:t>B0</a:t>
-            </a:r>
-          </a:p>
-        </p:txBody>
-      </p:sp>
-      <p:sp>
-        <p:nvSpPr>
-          <p:cNvPr id="45" name="Oval 44"/>
-          <p:cNvSpPr/>
-          <p:nvPr/>
-        </p:nvSpPr>
-        <p:spPr>
-          <a:xfrm>
-            <a:off x="5738380" y="3775000"/>
-            <a:ext cx="470000" cy="470000"/>
-          </a:xfrm>
-          <a:prstGeom prst="ellipse">
-            <a:avLst/>
-          </a:prstGeom>
-          <a:solidFill>
-            <a:srgbClr val="C0504D"/>
-          </a:solidFill>
-          <a:ln>
-            <a:noFill/>
-          </a:ln>
-          <a:effectLst/>
-        </p:spPr>
-        <p:style>
-          <a:lnRef idx="1">
-            <a:schemeClr val="accent1"/>
-          </a:lnRef>
-          <a:fillRef idx="3">
-            <a:schemeClr val="accent1"/>
-          </a:fillRef>
-          <a:effectRef idx="2">
-            <a:schemeClr val="accent1"/>
-          </a:effectRef>
-          <a:fontRef idx="minor">
-            <a:schemeClr val="lt1"/>
-          </a:fontRef>
-        </p:style>
-        <p:txBody>
-          <a:bodyPr rtlCol="0" anchor="ctr"/>
-          <a:lstStyle/>
-          <a:p>
-            <a:pPr algn="ctr"/>
-          </a:p>
-        </p:txBody>
-      </p:sp>
-      <p:sp>
-        <p:nvSpPr>
-          <p:cNvPr id="46" name="TextBox 45"/>
+                  <a:srgbClr val="70AD47"/>
+                </a:solidFill>
+                <a:latin typeface="Calibri"/>
+              </a:rPr>
+              <a:t>Group A · r↓</a:t>
+            </a:r>
+          </a:p>
+        </p:txBody>
+      </p:sp>
+      <p:cxnSp>
+        <p:nvCxnSpPr>
+          <p:cNvPr id="52" name="Connector 51"/>
+          <p:cNvCxnSpPr/>
+          <p:nvPr/>
+        </p:nvCxnSpPr>
+        <p:spPr>
+          <a:xfrm>
+            <a:off x="9506120" y="3880000"/>
+            <a:ext cx="2320120" cy="0"/>
+          </a:xfrm>
+          <a:prstGeom prst="bentConnector3">
+            <a:avLst/>
+          </a:prstGeom>
+          <a:ln w="15875">
+            <a:solidFill>
+              <a:srgbClr val="C0504D"/>
+            </a:solidFill>
+          </a:ln>
+          <a:effectLst/>
+        </p:spPr>
+        <p:style>
+          <a:lnRef idx="2">
+            <a:schemeClr val="accent1"/>
+          </a:lnRef>
+          <a:fillRef idx="0">
+            <a:schemeClr val="accent1"/>
+          </a:fillRef>
+          <a:effectRef idx="1">
+            <a:schemeClr val="accent1"/>
+          </a:effectRef>
+          <a:fontRef idx="minor">
+            <a:schemeClr val="tx1"/>
+          </a:fontRef>
+        </p:style>
+      </p:cxnSp>
+      <p:cxnSp>
+        <p:nvCxnSpPr>
+          <p:cNvPr id="53" name="Connector 52"/>
+          <p:cNvCxnSpPr/>
+          <p:nvPr/>
+        </p:nvCxnSpPr>
+        <p:spPr>
+          <a:xfrm>
+            <a:off x="9506120" y="3880000"/>
+            <a:ext cx="0" cy="70000"/>
+          </a:xfrm>
+          <a:prstGeom prst="bentConnector3">
+            <a:avLst/>
+          </a:prstGeom>
+          <a:ln w="15875">
+            <a:solidFill>
+              <a:srgbClr val="C0504D"/>
+            </a:solidFill>
+          </a:ln>
+          <a:effectLst/>
+        </p:spPr>
+        <p:style>
+          <a:lnRef idx="2">
+            <a:schemeClr val="accent1"/>
+          </a:lnRef>
+          <a:fillRef idx="0">
+            <a:schemeClr val="accent1"/>
+          </a:fillRef>
+          <a:effectRef idx="1">
+            <a:schemeClr val="accent1"/>
+          </a:effectRef>
+          <a:fontRef idx="minor">
+            <a:schemeClr val="tx1"/>
+          </a:fontRef>
+        </p:style>
+      </p:cxnSp>
+      <p:cxnSp>
+        <p:nvCxnSpPr>
+          <p:cNvPr id="54" name="Connector 53"/>
+          <p:cNvCxnSpPr/>
+          <p:nvPr/>
+        </p:nvCxnSpPr>
+        <p:spPr>
+          <a:xfrm>
+            <a:off x="11826240" y="3880000"/>
+            <a:ext cx="0" cy="70000"/>
+          </a:xfrm>
+          <a:prstGeom prst="bentConnector3">
+            <a:avLst/>
+          </a:prstGeom>
+          <a:ln w="15875">
+            <a:solidFill>
+              <a:srgbClr val="C0504D"/>
+            </a:solidFill>
+          </a:ln>
+          <a:effectLst/>
+        </p:spPr>
+        <p:style>
+          <a:lnRef idx="2">
+            <a:schemeClr val="accent1"/>
+          </a:lnRef>
+          <a:fillRef idx="0">
+            <a:schemeClr val="accent1"/>
+          </a:fillRef>
+          <a:effectRef idx="1">
+            <a:schemeClr val="accent1"/>
+          </a:effectRef>
+          <a:fontRef idx="minor">
+            <a:schemeClr val="tx1"/>
+          </a:fontRef>
+        </p:style>
+      </p:cxnSp>
+      <p:sp>
+        <p:nvSpPr>
+          <p:cNvPr id="55" name="TextBox 54"/>
           <p:cNvSpPr txBox="1"/>
           <p:nvPr/>
         </p:nvSpPr>
         <p:spPr>
           <a:xfrm>
-            <a:off x="5738380" y="3890000"/>
-            <a:ext cx="470000" cy="240000"/>
+            <a:off x="9916180" y="3630000"/>
+            <a:ext cx="1500000" cy="230000"/>
           </a:xfrm>
           <a:prstGeom prst="rect">
             <a:avLst/>
@@ -22073,10 +22376,203 @@
             <a:r>
               <a:rPr sz="1100" b="1" i="0">
                 <a:solidFill>
+                  <a:srgbClr val="C0504D"/>
+                </a:solidFill>
+                <a:latin typeface="Calibri"/>
+              </a:rPr>
+              <a:t>Group B · r↑</a:t>
+            </a:r>
+          </a:p>
+        </p:txBody>
+      </p:sp>
+      <p:sp>
+        <p:nvSpPr>
+          <p:cNvPr id="56" name="Oval 55"/>
+          <p:cNvSpPr/>
+          <p:nvPr/>
+        </p:nvSpPr>
+        <p:spPr>
+          <a:xfrm>
+            <a:off x="3865760" y="4030000"/>
+            <a:ext cx="440000" cy="440000"/>
+          </a:xfrm>
+          <a:prstGeom prst="ellipse">
+            <a:avLst/>
+          </a:prstGeom>
+          <a:solidFill>
+            <a:srgbClr val="70AD47"/>
+          </a:solidFill>
+          <a:ln>
+            <a:noFill/>
+          </a:ln>
+          <a:effectLst/>
+        </p:spPr>
+        <p:style>
+          <a:lnRef idx="1">
+            <a:schemeClr val="accent1"/>
+          </a:lnRef>
+          <a:fillRef idx="3">
+            <a:schemeClr val="accent1"/>
+          </a:fillRef>
+          <a:effectRef idx="2">
+            <a:schemeClr val="accent1"/>
+          </a:effectRef>
+          <a:fontRef idx="minor">
+            <a:schemeClr val="lt1"/>
+          </a:fontRef>
+        </p:style>
+        <p:txBody>
+          <a:bodyPr rtlCol="0" anchor="ctr"/>
+          <a:lstStyle/>
+          <a:p>
+            <a:pPr algn="ctr"/>
+          </a:p>
+        </p:txBody>
+      </p:sp>
+      <p:sp>
+        <p:nvSpPr>
+          <p:cNvPr id="57" name="TextBox 56"/>
+          <p:cNvSpPr txBox="1"/>
+          <p:nvPr/>
+        </p:nvSpPr>
+        <p:spPr>
+          <a:xfrm>
+            <a:off x="3865760" y="4130000"/>
+            <a:ext cx="440000" cy="240000"/>
+          </a:xfrm>
+          <a:prstGeom prst="rect">
+            <a:avLst/>
+          </a:prstGeom>
+          <a:noFill/>
+        </p:spPr>
+        <p:txBody>
+          <a:bodyPr wrap="square">
+            <a:spAutoFit/>
+          </a:bodyPr>
+          <a:lstStyle/>
+          <a:p>
+            <a:pPr algn="ctr"/>
+            <a:r>
+              <a:rPr sz="1100" b="1" i="0">
+                <a:solidFill>
                   <a:srgbClr val="FFFFFF"/>
                 </a:solidFill>
                 <a:latin typeface="Calibri"/>
               </a:rPr>
+              <a:t>B0</a:t>
+            </a:r>
+          </a:p>
+        </p:txBody>
+      </p:sp>
+      <p:sp>
+        <p:nvSpPr>
+          <p:cNvPr id="58" name="TextBox 57"/>
+          <p:cNvSpPr txBox="1"/>
+          <p:nvPr/>
+        </p:nvSpPr>
+        <p:spPr>
+          <a:xfrm>
+            <a:off x="3785760" y="4495000"/>
+            <a:ext cx="600000" cy="200000"/>
+          </a:xfrm>
+          <a:prstGeom prst="rect">
+            <a:avLst/>
+          </a:prstGeom>
+          <a:noFill/>
+        </p:spPr>
+        <p:txBody>
+          <a:bodyPr wrap="square">
+            <a:spAutoFit/>
+          </a:bodyPr>
+          <a:lstStyle/>
+          <a:p>
+            <a:pPr algn="ctr"/>
+            <a:r>
+              <a:rPr sz="1000" b="0" i="0">
+                <a:solidFill>
+                  <a:srgbClr val="1A1A1A"/>
+                </a:solidFill>
+                <a:latin typeface="Calibri"/>
+              </a:rPr>
+              <a:t>I=.45</a:t>
+            </a:r>
+          </a:p>
+        </p:txBody>
+      </p:sp>
+      <p:sp>
+        <p:nvSpPr>
+          <p:cNvPr id="59" name="Oval 58"/>
+          <p:cNvSpPr/>
+          <p:nvPr/>
+        </p:nvSpPr>
+        <p:spPr>
+          <a:xfrm>
+            <a:off x="5745880" y="4030000"/>
+            <a:ext cx="440000" cy="440000"/>
+          </a:xfrm>
+          <a:prstGeom prst="ellipse">
+            <a:avLst/>
+          </a:prstGeom>
+          <a:solidFill>
+            <a:srgbClr val="70AD47"/>
+          </a:solidFill>
+          <a:ln>
+            <a:noFill/>
+          </a:ln>
+          <a:effectLst/>
+        </p:spPr>
+        <p:style>
+          <a:lnRef idx="1">
+            <a:schemeClr val="accent1"/>
+          </a:lnRef>
+          <a:fillRef idx="3">
+            <a:schemeClr val="accent1"/>
+          </a:fillRef>
+          <a:effectRef idx="2">
+            <a:schemeClr val="accent1"/>
+          </a:effectRef>
+          <a:fontRef idx="minor">
+            <a:schemeClr val="lt1"/>
+          </a:fontRef>
+        </p:style>
+        <p:txBody>
+          <a:bodyPr rtlCol="0" anchor="ctr"/>
+          <a:lstStyle/>
+          <a:p>
+            <a:pPr algn="ctr"/>
+          </a:p>
+        </p:txBody>
+      </p:sp>
+      <p:sp>
+        <p:nvSpPr>
+          <p:cNvPr id="60" name="TextBox 59"/>
+          <p:cNvSpPr txBox="1"/>
+          <p:nvPr/>
+        </p:nvSpPr>
+        <p:spPr>
+          <a:xfrm>
+            <a:off x="5745880" y="4130000"/>
+            <a:ext cx="440000" cy="240000"/>
+          </a:xfrm>
+          <a:prstGeom prst="rect">
+            <a:avLst/>
+          </a:prstGeom>
+          <a:noFill/>
+        </p:spPr>
+        <p:txBody>
+          <a:bodyPr wrap="square">
+            <a:spAutoFit/>
+          </a:bodyPr>
+          <a:lstStyle/>
+          <a:p>
+            <a:pPr algn="ctr"/>
+            <a:r>
+              <a:rPr sz="1100" b="1" i="0">
+                <a:solidFill>
+                  <a:srgbClr val="FFFFFF"/>
+                </a:solidFill>
+                <a:latin typeface="Calibri"/>
+              </a:rPr>
               <a:t>B1</a:t>
             </a:r>
           </a:p>
@@ -22084,14 +22580,49 @@
       </p:sp>
       <p:sp>
         <p:nvSpPr>
-          <p:cNvPr id="47" name="Oval 46"/>
+          <p:cNvPr id="61" name="TextBox 60"/>
+          <p:cNvSpPr txBox="1"/>
+          <p:nvPr/>
+        </p:nvSpPr>
+        <p:spPr>
+          <a:xfrm>
+            <a:off x="5665880" y="4495000"/>
+            <a:ext cx="600000" cy="200000"/>
+          </a:xfrm>
+          <a:prstGeom prst="rect">
+            <a:avLst/>
+          </a:prstGeom>
+          <a:noFill/>
+        </p:spPr>
+        <p:txBody>
+          <a:bodyPr wrap="square">
+            <a:spAutoFit/>
+          </a:bodyPr>
+          <a:lstStyle/>
+          <a:p>
+            <a:pPr algn="ctr"/>
+            <a:r>
+              <a:rPr sz="1000" b="0" i="0">
+                <a:solidFill>
+                  <a:srgbClr val="1A1A1A"/>
+                </a:solidFill>
+                <a:latin typeface="Calibri"/>
+              </a:rPr>
+              <a:t>I=.42</a:t>
+            </a:r>
+          </a:p>
+        </p:txBody>
+      </p:sp>
+      <p:sp>
+        <p:nvSpPr>
+          <p:cNvPr id="62" name="Oval 61"/>
           <p:cNvSpPr/>
           <p:nvPr/>
         </p:nvSpPr>
         <p:spPr>
           <a:xfrm>
-            <a:off x="7611000" y="3775000"/>
-            <a:ext cx="470000" cy="470000"/>
+            <a:off x="7626000" y="4030000"/>
+            <a:ext cx="440000" cy="440000"/>
           </a:xfrm>
           <a:prstGeom prst="ellipse">
             <a:avLst/>
@@ -22130,14 +22661,14 @@
       </p:sp>
       <p:sp>
         <p:nvSpPr>
-          <p:cNvPr id="48" name="TextBox 47"/>
+          <p:cNvPr id="63" name="TextBox 62"/>
           <p:cNvSpPr txBox="1"/>
           <p:nvPr/>
         </p:nvSpPr>
         <p:spPr>
           <a:xfrm>
-            <a:off x="7611000" y="3860000"/>
-            <a:ext cx="470000" cy="300000"/>
+            <a:off x="7626000" y="4100000"/>
+            <a:ext cx="440000" cy="300000"/>
           </a:xfrm>
           <a:prstGeom prst="rect">
             <a:avLst/>
@@ -22165,14 +22696,14 @@
       </p:sp>
       <p:sp>
         <p:nvSpPr>
-          <p:cNvPr id="49" name="Oval 48"/>
+          <p:cNvPr id="64" name="Oval 63"/>
           <p:cNvSpPr/>
           <p:nvPr/>
         </p:nvSpPr>
         <p:spPr>
           <a:xfrm>
-            <a:off x="9483620" y="3775000"/>
-            <a:ext cx="470000" cy="470000"/>
+            <a:off x="9506120" y="4030000"/>
+            <a:ext cx="440000" cy="440000"/>
           </a:xfrm>
           <a:prstGeom prst="ellipse">
             <a:avLst/>
@@ -22209,14 +22740,14 @@
       </p:sp>
       <p:sp>
         <p:nvSpPr>
-          <p:cNvPr id="50" name="TextBox 49"/>
+          <p:cNvPr id="65" name="TextBox 64"/>
           <p:cNvSpPr txBox="1"/>
           <p:nvPr/>
         </p:nvSpPr>
         <p:spPr>
           <a:xfrm>
-            <a:off x="9483620" y="3890000"/>
-            <a:ext cx="470000" cy="240000"/>
+            <a:off x="9506120" y="4130000"/>
+            <a:ext cx="440000" cy="240000"/>
           </a:xfrm>
           <a:prstGeom prst="rect">
             <a:avLst/>
@@ -22244,58 +22775,14 @@
       </p:sp>
       <p:sp>
         <p:nvSpPr>
-          <p:cNvPr id="51" name="Oval 50"/>
-          <p:cNvSpPr/>
-          <p:nvPr/>
-        </p:nvSpPr>
-        <p:spPr>
-          <a:xfrm>
-            <a:off x="11356240" y="3775000"/>
-            <a:ext cx="470000" cy="470000"/>
-          </a:xfrm>
-          <a:prstGeom prst="ellipse">
-            <a:avLst/>
-          </a:prstGeom>
-          <a:solidFill>
-            <a:srgbClr val="70AD47"/>
-          </a:solidFill>
-          <a:ln>
-            <a:noFill/>
-          </a:ln>
-          <a:effectLst/>
-        </p:spPr>
-        <p:style>
-          <a:lnRef idx="1">
-            <a:schemeClr val="accent1"/>
-          </a:lnRef>
-          <a:fillRef idx="3">
-            <a:schemeClr val="accent1"/>
-          </a:fillRef>
-          <a:effectRef idx="2">
-            <a:schemeClr val="accent1"/>
-          </a:effectRef>
-          <a:fontRef idx="minor">
-            <a:schemeClr val="lt1"/>
-          </a:fontRef>
-        </p:style>
-        <p:txBody>
-          <a:bodyPr rtlCol="0" anchor="ctr"/>
-          <a:lstStyle/>
-          <a:p>
-            <a:pPr algn="ctr"/>
-          </a:p>
-        </p:txBody>
-      </p:sp>
-      <p:sp>
-        <p:nvSpPr>
-          <p:cNvPr id="52" name="TextBox 51"/>
+          <p:cNvPr id="66" name="TextBox 65"/>
           <p:cNvSpPr txBox="1"/>
           <p:nvPr/>
         </p:nvSpPr>
         <p:spPr>
           <a:xfrm>
-            <a:off x="11356240" y="3890000"/>
-            <a:ext cx="470000" cy="240000"/>
+            <a:off x="9426120" y="4495000"/>
+            <a:ext cx="600000" cy="200000"/>
           </a:xfrm>
           <a:prstGeom prst="rect">
             <a:avLst/>
@@ -22310,33 +22797,33 @@
           <a:p>
             <a:pPr algn="ctr"/>
             <a:r>
-              <a:rPr sz="1100" b="1" i="0">
-                <a:solidFill>
-                  <a:srgbClr val="FFFFFF"/>
-                </a:solidFill>
-                <a:latin typeface="Calibri"/>
-              </a:rPr>
-              <a:t>B4</a:t>
-            </a:r>
-          </a:p>
-        </p:txBody>
-      </p:sp>
-      <p:sp>
-        <p:nvSpPr>
-          <p:cNvPr id="53" name="Rectangle 52"/>
+              <a:rPr sz="1000" b="0" i="0">
+                <a:solidFill>
+                  <a:srgbClr val="1A1A1A"/>
+                </a:solidFill>
+                <a:latin typeface="Calibri"/>
+              </a:rPr>
+              <a:t>I=.24</a:t>
+            </a:r>
+          </a:p>
+        </p:txBody>
+      </p:sp>
+      <p:sp>
+        <p:nvSpPr>
+          <p:cNvPr id="67" name="Oval 66"/>
           <p:cNvSpPr/>
           <p:nvPr/>
         </p:nvSpPr>
         <p:spPr>
           <a:xfrm>
-            <a:off x="365760" y="4680000"/>
-            <a:ext cx="110000" cy="860000"/>
-          </a:xfrm>
-          <a:prstGeom prst="rect">
-            <a:avLst/>
-          </a:prstGeom>
-          <a:solidFill>
-            <a:srgbClr val="FFA300"/>
+            <a:off x="11386240" y="4030000"/>
+            <a:ext cx="440000" cy="440000"/>
+          </a:xfrm>
+          <a:prstGeom prst="ellipse">
+            <a:avLst/>
+          </a:prstGeom>
+          <a:solidFill>
+            <a:srgbClr val="C0504D"/>
           </a:solidFill>
           <a:ln>
             <a:noFill/>
@@ -22367,14 +22854,128 @@
       </p:sp>
       <p:sp>
         <p:nvSpPr>
-          <p:cNvPr id="54" name="TextBox 53"/>
+          <p:cNvPr id="68" name="TextBox 67"/>
           <p:cNvSpPr txBox="1"/>
           <p:nvPr/>
         </p:nvSpPr>
         <p:spPr>
           <a:xfrm>
-            <a:off x="565760" y="4690000"/>
-            <a:ext cx="3000000" cy="920000"/>
+            <a:off x="11386240" y="4130000"/>
+            <a:ext cx="440000" cy="240000"/>
+          </a:xfrm>
+          <a:prstGeom prst="rect">
+            <a:avLst/>
+          </a:prstGeom>
+          <a:noFill/>
+        </p:spPr>
+        <p:txBody>
+          <a:bodyPr wrap="square">
+            <a:spAutoFit/>
+          </a:bodyPr>
+          <a:lstStyle/>
+          <a:p>
+            <a:pPr algn="ctr"/>
+            <a:r>
+              <a:rPr sz="1100" b="1" i="0">
+                <a:solidFill>
+                  <a:srgbClr val="FFFFFF"/>
+                </a:solidFill>
+                <a:latin typeface="Calibri"/>
+              </a:rPr>
+              <a:t>B4</a:t>
+            </a:r>
+          </a:p>
+        </p:txBody>
+      </p:sp>
+      <p:sp>
+        <p:nvSpPr>
+          <p:cNvPr id="69" name="TextBox 68"/>
+          <p:cNvSpPr txBox="1"/>
+          <p:nvPr/>
+        </p:nvSpPr>
+        <p:spPr>
+          <a:xfrm>
+            <a:off x="11306240" y="4495000"/>
+            <a:ext cx="600000" cy="200000"/>
+          </a:xfrm>
+          <a:prstGeom prst="rect">
+            <a:avLst/>
+          </a:prstGeom>
+          <a:noFill/>
+        </p:spPr>
+        <p:txBody>
+          <a:bodyPr wrap="square">
+            <a:spAutoFit/>
+          </a:bodyPr>
+          <a:lstStyle/>
+          <a:p>
+            <a:pPr algn="ctr"/>
+            <a:r>
+              <a:rPr sz="1000" b="0" i="0">
+                <a:solidFill>
+                  <a:srgbClr val="1A1A1A"/>
+                </a:solidFill>
+                <a:latin typeface="Calibri"/>
+              </a:rPr>
+              <a:t>I=.22</a:t>
+            </a:r>
+          </a:p>
+        </p:txBody>
+      </p:sp>
+      <p:sp>
+        <p:nvSpPr>
+          <p:cNvPr id="70" name="Rectangle 69"/>
+          <p:cNvSpPr/>
+          <p:nvPr/>
+        </p:nvSpPr>
+        <p:spPr>
+          <a:xfrm>
+            <a:off x="365760" y="4980000"/>
+            <a:ext cx="110000" cy="960000"/>
+          </a:xfrm>
+          <a:prstGeom prst="rect">
+            <a:avLst/>
+          </a:prstGeom>
+          <a:solidFill>
+            <a:srgbClr val="FFA300"/>
+          </a:solidFill>
+          <a:ln>
+            <a:noFill/>
+          </a:ln>
+          <a:effectLst/>
+        </p:spPr>
+        <p:style>
+          <a:lnRef idx="1">
+            <a:schemeClr val="accent1"/>
+          </a:lnRef>
+          <a:fillRef idx="3">
+            <a:schemeClr val="accent1"/>
+          </a:fillRef>
+          <a:effectRef idx="2">
+            <a:schemeClr val="accent1"/>
+          </a:effectRef>
+          <a:fontRef idx="minor">
+            <a:schemeClr val="lt1"/>
+          </a:fontRef>
+        </p:style>
+        <p:txBody>
+          <a:bodyPr rtlCol="0" anchor="ctr"/>
+          <a:lstStyle/>
+          <a:p>
+            <a:pPr algn="ctr"/>
+          </a:p>
+        </p:txBody>
+      </p:sp>
+      <p:sp>
+        <p:nvSpPr>
+          <p:cNvPr id="71" name="TextBox 70"/>
+          <p:cNvSpPr txBox="1"/>
+          <p:nvPr/>
+        </p:nvSpPr>
+        <p:spPr>
+          <a:xfrm>
+            <a:off x="565760" y="5010000"/>
+            <a:ext cx="3000000" cy="1000000"/>
           </a:xfrm>
           <a:prstGeom prst="rect">
             <a:avLst/>
@@ -22411,21 +23012,21 @@
                 </a:solidFill>
                 <a:latin typeface="Calibri"/>
               </a:rPr>
-              <a:t>Functional edges link similar blocks: B0–B4 and B1–B3 boost each other</a:t>
+              <a:t>Functional edges couple within groups:  B0–B1  and  B3–B4  boost each other</a:t>
             </a:r>
           </a:p>
         </p:txBody>
       </p:sp>
       <p:cxnSp>
         <p:nvCxnSpPr>
-          <p:cNvPr id="55" name="Connector 54"/>
+          <p:cNvPr id="72" name="Connector 71"/>
           <p:cNvCxnSpPr/>
           <p:nvPr/>
         </p:nvCxnSpPr>
         <p:spPr>
           <a:xfrm>
-            <a:off x="4335760" y="5190000"/>
-            <a:ext cx="1402620" cy="0"/>
+            <a:off x="4305760" y="5530000"/>
+            <a:ext cx="1440120" cy="0"/>
           </a:xfrm>
           <a:prstGeom prst="bentConnector3">
             <a:avLst/>
@@ -22454,14 +23055,14 @@
       </p:cxnSp>
       <p:cxnSp>
         <p:nvCxnSpPr>
-          <p:cNvPr id="56" name="Connector 55"/>
+          <p:cNvPr id="73" name="Connector 72"/>
           <p:cNvCxnSpPr/>
           <p:nvPr/>
         </p:nvCxnSpPr>
         <p:spPr>
           <a:xfrm>
-            <a:off x="6208380" y="5190000"/>
-            <a:ext cx="3275240" cy="0"/>
+            <a:off x="6185880" y="5530000"/>
+            <a:ext cx="3320240" cy="0"/>
           </a:xfrm>
           <a:prstGeom prst="bentConnector3">
             <a:avLst/>
@@ -22490,14 +23091,14 @@
       </p:cxnSp>
       <p:cxnSp>
         <p:nvCxnSpPr>
-          <p:cNvPr id="57" name="Connector 56"/>
+          <p:cNvPr id="74" name="Connector 73"/>
           <p:cNvCxnSpPr/>
           <p:nvPr/>
         </p:nvCxnSpPr>
         <p:spPr>
           <a:xfrm>
-            <a:off x="9953620" y="5190000"/>
-            <a:ext cx="1402620" cy="0"/>
+            <a:off x="9946120" y="5530000"/>
+            <a:ext cx="1440120" cy="0"/>
           </a:xfrm>
           <a:prstGeom prst="bentConnector3">
             <a:avLst/>
@@ -22526,13 +23127,13 @@
       </p:cxnSp>
       <p:cxnSp>
         <p:nvCxnSpPr>
-          <p:cNvPr id="58" name="Connector 57"/>
+          <p:cNvPr id="75" name="Connector 74"/>
           <p:cNvCxnSpPr/>
           <p:nvPr/>
         </p:nvCxnSpPr>
         <p:spPr>
           <a:xfrm flipV="1">
-            <a:off x="4100760" y="4655000"/>
+            <a:off x="4085760" y="5010000"/>
             <a:ext cx="0" cy="300000"/>
           </a:xfrm>
           <a:prstGeom prst="bentConnector3">
@@ -22563,14 +23164,14 @@
       </p:cxnSp>
       <p:cxnSp>
         <p:nvCxnSpPr>
-          <p:cNvPr id="59" name="Connector 58"/>
+          <p:cNvPr id="76" name="Connector 75"/>
           <p:cNvCxnSpPr/>
           <p:nvPr/>
         </p:nvCxnSpPr>
         <p:spPr>
           <a:xfrm>
-            <a:off x="4100760" y="4655000"/>
-            <a:ext cx="7490480" cy="0"/>
+            <a:off x="4085760" y="5010000"/>
+            <a:ext cx="1880120" cy="0"/>
           </a:xfrm>
           <a:prstGeom prst="bentConnector3">
             <a:avLst/>
@@ -22600,13 +23201,13 @@
       </p:cxnSp>
       <p:cxnSp>
         <p:nvCxnSpPr>
-          <p:cNvPr id="60" name="Connector 59"/>
+          <p:cNvPr id="77" name="Connector 76"/>
           <p:cNvCxnSpPr/>
           <p:nvPr/>
         </p:nvCxnSpPr>
         <p:spPr>
           <a:xfrm>
-            <a:off x="11591240" y="4655000"/>
+            <a:off x="5965880" y="5010000"/>
             <a:ext cx="0" cy="300000"/>
           </a:xfrm>
           <a:prstGeom prst="bentConnector3">
@@ -22637,13 +23238,13 @@
       </p:cxnSp>
       <p:cxnSp>
         <p:nvCxnSpPr>
-          <p:cNvPr id="61" name="Connector 60"/>
+          <p:cNvPr id="78" name="Connector 77"/>
           <p:cNvCxnSpPr/>
           <p:nvPr/>
         </p:nvCxnSpPr>
         <p:spPr>
           <a:xfrm flipV="1">
-            <a:off x="5973380" y="4805000"/>
+            <a:off x="9726120" y="5160000"/>
             <a:ext cx="0" cy="150000"/>
           </a:xfrm>
           <a:prstGeom prst="bentConnector3">
@@ -22674,14 +23275,14 @@
       </p:cxnSp>
       <p:cxnSp>
         <p:nvCxnSpPr>
-          <p:cNvPr id="62" name="Connector 61"/>
+          <p:cNvPr id="79" name="Connector 78"/>
           <p:cNvCxnSpPr/>
           <p:nvPr/>
         </p:nvCxnSpPr>
         <p:spPr>
           <a:xfrm>
-            <a:off x="5973380" y="4805000"/>
-            <a:ext cx="3745240" cy="0"/>
+            <a:off x="9726120" y="5160000"/>
+            <a:ext cx="1880120" cy="0"/>
           </a:xfrm>
           <a:prstGeom prst="bentConnector3">
             <a:avLst/>
@@ -22711,13 +23312,13 @@
       </p:cxnSp>
       <p:cxnSp>
         <p:nvCxnSpPr>
-          <p:cNvPr id="63" name="Connector 62"/>
+          <p:cNvPr id="80" name="Connector 79"/>
           <p:cNvCxnSpPr/>
           <p:nvPr/>
         </p:nvCxnSpPr>
         <p:spPr>
           <a:xfrm>
-            <a:off x="9718620" y="4805000"/>
+            <a:off x="11606240" y="5160000"/>
             <a:ext cx="0" cy="150000"/>
           </a:xfrm>
           <a:prstGeom prst="bentConnector3">
@@ -22748,14 +23349,14 @@
       </p:cxnSp>
       <p:sp>
         <p:nvSpPr>
-          <p:cNvPr id="64" name="Oval 63"/>
+          <p:cNvPr id="81" name="Oval 80"/>
           <p:cNvSpPr/>
           <p:nvPr/>
         </p:nvSpPr>
         <p:spPr>
           <a:xfrm>
-            <a:off x="3865760" y="4955000"/>
-            <a:ext cx="470000" cy="470000"/>
+            <a:off x="3865760" y="5310000"/>
+            <a:ext cx="440000" cy="440000"/>
           </a:xfrm>
           <a:prstGeom prst="ellipse">
             <a:avLst/>
@@ -22792,14 +23393,14 @@
       </p:sp>
       <p:sp>
         <p:nvSpPr>
-          <p:cNvPr id="65" name="TextBox 64"/>
+          <p:cNvPr id="82" name="TextBox 81"/>
           <p:cNvSpPr txBox="1"/>
           <p:nvPr/>
         </p:nvSpPr>
         <p:spPr>
           <a:xfrm>
-            <a:off x="3865760" y="5070000"/>
-            <a:ext cx="470000" cy="240000"/>
+            <a:off x="3865760" y="5410000"/>
+            <a:ext cx="440000" cy="240000"/>
           </a:xfrm>
           <a:prstGeom prst="rect">
             <a:avLst/>
@@ -22827,20 +23428,20 @@
       </p:sp>
       <p:sp>
         <p:nvSpPr>
-          <p:cNvPr id="66" name="Oval 65"/>
+          <p:cNvPr id="83" name="Oval 82"/>
           <p:cNvSpPr/>
           <p:nvPr/>
         </p:nvSpPr>
         <p:spPr>
           <a:xfrm>
-            <a:off x="5738380" y="4955000"/>
-            <a:ext cx="470000" cy="470000"/>
+            <a:off x="5745880" y="5310000"/>
+            <a:ext cx="440000" cy="440000"/>
           </a:xfrm>
           <a:prstGeom prst="ellipse">
             <a:avLst/>
           </a:prstGeom>
           <a:solidFill>
-            <a:srgbClr val="C0504D"/>
+            <a:srgbClr val="70AD47"/>
           </a:solidFill>
           <a:ln>
             <a:noFill/>
@@ -22871,14 +23472,14 @@
       </p:sp>
       <p:sp>
         <p:nvSpPr>
-          <p:cNvPr id="67" name="TextBox 66"/>
+          <p:cNvPr id="84" name="TextBox 83"/>
           <p:cNvSpPr txBox="1"/>
           <p:nvPr/>
         </p:nvSpPr>
         <p:spPr>
           <a:xfrm>
-            <a:off x="5738380" y="5070000"/>
-            <a:ext cx="470000" cy="240000"/>
+            <a:off x="5745880" y="5410000"/>
+            <a:ext cx="440000" cy="240000"/>
           </a:xfrm>
           <a:prstGeom prst="rect">
             <a:avLst/>
@@ -22906,14 +23507,14 @@
       </p:sp>
       <p:sp>
         <p:nvSpPr>
-          <p:cNvPr id="68" name="Oval 67"/>
+          <p:cNvPr id="85" name="Oval 84"/>
           <p:cNvSpPr/>
           <p:nvPr/>
         </p:nvSpPr>
         <p:spPr>
           <a:xfrm>
-            <a:off x="7611000" y="4955000"/>
-            <a:ext cx="470000" cy="470000"/>
+            <a:off x="7626000" y="5310000"/>
+            <a:ext cx="440000" cy="440000"/>
           </a:xfrm>
           <a:prstGeom prst="ellipse">
             <a:avLst/>
@@ -22952,14 +23553,14 @@
       </p:sp>
       <p:sp>
         <p:nvSpPr>
-          <p:cNvPr id="69" name="TextBox 68"/>
+          <p:cNvPr id="86" name="TextBox 85"/>
           <p:cNvSpPr txBox="1"/>
           <p:nvPr/>
         </p:nvSpPr>
         <p:spPr>
           <a:xfrm>
-            <a:off x="7611000" y="5040000"/>
-            <a:ext cx="470000" cy="300000"/>
+            <a:off x="7626000" y="5380000"/>
+            <a:ext cx="440000" cy="300000"/>
           </a:xfrm>
           <a:prstGeom prst="rect">
             <a:avLst/>
@@ -22987,14 +23588,14 @@
       </p:sp>
       <p:sp>
         <p:nvSpPr>
-          <p:cNvPr id="70" name="Oval 69"/>
+          <p:cNvPr id="87" name="Oval 86"/>
           <p:cNvSpPr/>
           <p:nvPr/>
         </p:nvSpPr>
         <p:spPr>
           <a:xfrm>
-            <a:off x="9483620" y="4955000"/>
-            <a:ext cx="470000" cy="470000"/>
+            <a:off x="9506120" y="5310000"/>
+            <a:ext cx="440000" cy="440000"/>
           </a:xfrm>
           <a:prstGeom prst="ellipse">
             <a:avLst/>
@@ -23031,14 +23632,14 @@
       </p:sp>
       <p:sp>
         <p:nvSpPr>
-          <p:cNvPr id="71" name="TextBox 70"/>
+          <p:cNvPr id="88" name="TextBox 87"/>
           <p:cNvSpPr txBox="1"/>
           <p:nvPr/>
         </p:nvSpPr>
         <p:spPr>
           <a:xfrm>
-            <a:off x="9483620" y="5070000"/>
-            <a:ext cx="470000" cy="240000"/>
+            <a:off x="9506120" y="5410000"/>
+            <a:ext cx="440000" cy="240000"/>
           </a:xfrm>
           <a:prstGeom prst="rect">
             <a:avLst/>
@@ -23066,20 +23667,20 @@
       </p:sp>
       <p:sp>
         <p:nvSpPr>
-          <p:cNvPr id="72" name="Oval 71"/>
+          <p:cNvPr id="89" name="Oval 88"/>
           <p:cNvSpPr/>
           <p:nvPr/>
         </p:nvSpPr>
         <p:spPr>
           <a:xfrm>
-            <a:off x="11356240" y="4955000"/>
-            <a:ext cx="470000" cy="470000"/>
+            <a:off x="11386240" y="5310000"/>
+            <a:ext cx="440000" cy="440000"/>
           </a:xfrm>
           <a:prstGeom prst="ellipse">
             <a:avLst/>
           </a:prstGeom>
           <a:solidFill>
-            <a:srgbClr val="70AD47"/>
+            <a:srgbClr val="C0504D"/>
           </a:solidFill>
           <a:ln>
             <a:noFill/>
@@ -23110,14 +23711,14 @@
       </p:sp>
       <p:sp>
         <p:nvSpPr>
-          <p:cNvPr id="73" name="TextBox 72"/>
+          <p:cNvPr id="90" name="TextBox 89"/>
           <p:cNvSpPr txBox="1"/>
           <p:nvPr/>
         </p:nvSpPr>
         <p:spPr>
           <a:xfrm>
-            <a:off x="11356240" y="5070000"/>
-            <a:ext cx="470000" cy="240000"/>
+            <a:off x="11386240" y="5410000"/>
+            <a:ext cx="440000" cy="240000"/>
           </a:xfrm>
           <a:prstGeom prst="rect">
             <a:avLst/>
@@ -23145,7 +23746,7 @@
       </p:sp>
       <p:sp>
         <p:nvSpPr>
-          <p:cNvPr id="74" name="TextBox 73"/>
+          <p:cNvPr id="91" name="TextBox 90"/>
           <p:cNvSpPr txBox="1"/>
           <p:nvPr/>
         </p:nvSpPr>

</xml_diff>

<commit_message>
Findings slides (3): error-prop curve, banded coupling graph, beats FLAT-LLM -4.2%
Slide 12 updated with faithful FLAT-LLM head-to-head (Llama-2-7B, keep 50%):
JOINT 13.96 vs FLAT-LLM 14.56 (-4.2%) vs Uniform 17.39 (-19.7%) at iso-budget.

Co-Authored-By: Claude Sonnet 4.6 <noreply@anthropic.com>
</commit_message>
<xml_diff>
--- a/hypergraph_slides.pptx
+++ b/hypergraph_slides.pptx
@@ -14,6 +14,9 @@
     <p:sldId id="262" r:id="rId13"/>
     <p:sldId id="263" r:id="rId14"/>
     <p:sldId id="264" r:id="rId15"/>
+    <p:sldId id="265" r:id="rId16"/>
+    <p:sldId id="266" r:id="rId17"/>
+    <p:sldId id="267" r:id="rId18"/>
   </p:sldIdLst>
   <p:sldSz cx="12192000" cy="6858000" type="screen4x3"/>
   <p:notesSz cx="6858000" cy="9144000"/>
@@ -3653,6 +3656,3601 @@
                 <a:latin typeface="Calibri"/>
               </a:rPr>
               <a:t>We generalize Isomorphic Pruning (Fang et al.) with a typed dependency graph</a:t>
+            </a:r>
+          </a:p>
+        </p:txBody>
+      </p:sp>
+    </p:spTree>
+  </p:cSld>
+  <p:clrMapOvr>
+    <a:masterClrMapping/>
+  </p:clrMapOvr>
+</p:sld>
+</file>
+
+<file path=ppt/slides/slide10.xml><?xml version="1.0" encoding="utf-8"?>
+<p:sld xmlns:a="http://schemas.openxmlformats.org/drawingml/2006/main" xmlns:p="http://schemas.openxmlformats.org/presentationml/2006/main" xmlns:r="http://schemas.openxmlformats.org/officeDocument/2006/relationships">
+  <p:cSld>
+    <p:spTree>
+      <p:nvGrpSpPr>
+        <p:cNvPr id="1" name=""/>
+        <p:cNvGrpSpPr/>
+        <p:nvPr/>
+      </p:nvGrpSpPr>
+      <p:grpSpPr/>
+      <p:sp>
+        <p:nvSpPr>
+          <p:cNvPr id="2" name="TextBox 1"/>
+          <p:cNvSpPr txBox="1"/>
+          <p:nvPr/>
+        </p:nvSpPr>
+        <p:spPr>
+          <a:xfrm>
+            <a:off x="365760" y="228600"/>
+            <a:ext cx="11430000" cy="548640"/>
+          </a:xfrm>
+          <a:prstGeom prst="rect">
+            <a:avLst/>
+          </a:prstGeom>
+          <a:noFill/>
+        </p:spPr>
+        <p:txBody>
+          <a:bodyPr wrap="square" anchor="t" lIns="0" rIns="0" tIns="0" bIns="0">
+            <a:spAutoFit/>
+          </a:bodyPr>
+          <a:lstStyle/>
+          <a:p>
+            <a:pPr algn="l"/>
+            <a:r>
+              <a:rPr sz="2800" b="1">
+                <a:solidFill>
+                  <a:srgbClr val="1A1A1A"/>
+                </a:solidFill>
+                <a:latin typeface="Calibri"/>
+              </a:rPr>
+              <a:t>Finding 1:  Compression Error Amplifies with Depth</a:t>
+            </a:r>
+          </a:p>
+        </p:txBody>
+      </p:sp>
+      <p:sp>
+        <p:nvSpPr>
+          <p:cNvPr id="3" name="Rectangle 2"/>
+          <p:cNvSpPr/>
+          <p:nvPr/>
+        </p:nvSpPr>
+        <p:spPr>
+          <a:xfrm>
+            <a:off x="365760" y="795528"/>
+            <a:ext cx="11457432" cy="27432"/>
+          </a:xfrm>
+          <a:prstGeom prst="rect">
+            <a:avLst/>
+          </a:prstGeom>
+          <a:solidFill>
+            <a:srgbClr val="0068B5"/>
+          </a:solidFill>
+          <a:ln>
+            <a:noFill/>
+          </a:ln>
+          <a:effectLst/>
+        </p:spPr>
+        <p:style>
+          <a:lnRef idx="1">
+            <a:schemeClr val="accent1"/>
+          </a:lnRef>
+          <a:fillRef idx="3">
+            <a:schemeClr val="accent1"/>
+          </a:fillRef>
+          <a:effectRef idx="2">
+            <a:schemeClr val="accent1"/>
+          </a:effectRef>
+          <a:fontRef idx="minor">
+            <a:schemeClr val="lt1"/>
+          </a:fontRef>
+        </p:style>
+        <p:txBody>
+          <a:bodyPr rtlCol="0" anchor="ctr"/>
+          <a:lstStyle/>
+          <a:p>
+            <a:pPr algn="ctr"/>
+          </a:p>
+        </p:txBody>
+      </p:sp>
+      <p:sp>
+        <p:nvSpPr>
+          <p:cNvPr id="4" name="TextBox 3"/>
+          <p:cNvSpPr txBox="1"/>
+          <p:nvPr/>
+        </p:nvSpPr>
+        <p:spPr>
+          <a:xfrm>
+            <a:off x="11430000" y="6492240"/>
+            <a:ext cx="640080" cy="274320"/>
+          </a:xfrm>
+          <a:prstGeom prst="rect">
+            <a:avLst/>
+          </a:prstGeom>
+          <a:noFill/>
+        </p:spPr>
+        <p:txBody>
+          <a:bodyPr wrap="square" anchor="t" lIns="0" rIns="0" tIns="0" bIns="0">
+            <a:spAutoFit/>
+          </a:bodyPr>
+          <a:lstStyle/>
+          <a:p>
+            <a:pPr algn="r"/>
+            <a:r>
+              <a:rPr sz="1000" b="0">
+                <a:solidFill>
+                  <a:srgbClr val="AAAAAA"/>
+                </a:solidFill>
+                <a:latin typeface="Calibri"/>
+              </a:rPr>
+              <a:t>10</a:t>
+            </a:r>
+          </a:p>
+        </p:txBody>
+      </p:sp>
+      <p:sp>
+        <p:nvSpPr>
+          <p:cNvPr id="5" name="TextBox 4"/>
+          <p:cNvSpPr txBox="1"/>
+          <p:nvPr/>
+        </p:nvSpPr>
+        <p:spPr>
+          <a:xfrm>
+            <a:off x="365760" y="932688"/>
+            <a:ext cx="11430000" cy="365760"/>
+          </a:xfrm>
+          <a:prstGeom prst="rect">
+            <a:avLst/>
+          </a:prstGeom>
+          <a:noFill/>
+        </p:spPr>
+        <p:txBody>
+          <a:bodyPr wrap="square" anchor="t" lIns="0" rIns="0" tIns="0" bIns="0">
+            <a:spAutoFit/>
+          </a:bodyPr>
+          <a:lstStyle/>
+          <a:p>
+            <a:pPr algn="l"/>
+            <a:r>
+              <a:rPr sz="1500" b="1">
+                <a:solidFill>
+                  <a:srgbClr val="1A1A1A"/>
+                </a:solidFill>
+                <a:latin typeface="Calibri"/>
+              </a:rPr>
+              <a:t>A layer's </a:t>
+            </a:r>
+            <a:r>
+              <a:rPr sz="1500" b="1">
+                <a:solidFill>
+                  <a:srgbClr val="C0504D"/>
+                </a:solidFill>
+                <a:latin typeface="Calibri"/>
+              </a:rPr>
+              <a:t>local</a:t>
+            </a:r>
+            <a:r>
+              <a:rPr sz="1500" b="1">
+                <a:solidFill>
+                  <a:srgbClr val="1A1A1A"/>
+                </a:solidFill>
+                <a:latin typeface="Calibri"/>
+              </a:rPr>
+              <a:t> error is not its true cost — it propagates to the output, and the amplification depends on depth.</a:t>
+            </a:r>
+          </a:p>
+        </p:txBody>
+      </p:sp>
+      <p:sp>
+        <p:nvSpPr>
+          <p:cNvPr id="6" name="Rectangle 5"/>
+          <p:cNvSpPr/>
+          <p:nvPr/>
+        </p:nvSpPr>
+        <p:spPr>
+          <a:xfrm>
+            <a:off x="365760" y="1417320"/>
+            <a:ext cx="11430000" cy="566928"/>
+          </a:xfrm>
+          <a:prstGeom prst="rect">
+            <a:avLst/>
+          </a:prstGeom>
+          <a:solidFill>
+            <a:srgbClr val="DEEBF7"/>
+          </a:solidFill>
+          <a:ln>
+            <a:noFill/>
+          </a:ln>
+          <a:effectLst/>
+        </p:spPr>
+        <p:style>
+          <a:lnRef idx="1">
+            <a:schemeClr val="accent1"/>
+          </a:lnRef>
+          <a:fillRef idx="3">
+            <a:schemeClr val="accent1"/>
+          </a:fillRef>
+          <a:effectRef idx="2">
+            <a:schemeClr val="accent1"/>
+          </a:effectRef>
+          <a:fontRef idx="minor">
+            <a:schemeClr val="lt1"/>
+          </a:fontRef>
+        </p:style>
+        <p:txBody>
+          <a:bodyPr rtlCol="0" anchor="ctr"/>
+          <a:lstStyle/>
+          <a:p>
+            <a:pPr algn="ctr"/>
+          </a:p>
+        </p:txBody>
+      </p:sp>
+      <p:sp>
+        <p:nvSpPr>
+          <p:cNvPr id="7" name="TextBox 6"/>
+          <p:cNvSpPr txBox="1"/>
+          <p:nvPr/>
+        </p:nvSpPr>
+        <p:spPr>
+          <a:xfrm>
+            <a:off x="566928" y="1481328"/>
+            <a:ext cx="11064240" cy="457200"/>
+          </a:xfrm>
+          <a:prstGeom prst="rect">
+            <a:avLst/>
+          </a:prstGeom>
+          <a:noFill/>
+        </p:spPr>
+        <p:txBody>
+          <a:bodyPr wrap="square" anchor="t" lIns="0" rIns="0" tIns="0" bIns="0">
+            <a:spAutoFit/>
+          </a:bodyPr>
+          <a:lstStyle/>
+          <a:p>
+            <a:pPr algn="l"/>
+            <a:r>
+              <a:rPr sz="1200" b="1">
+                <a:solidFill>
+                  <a:srgbClr val="0068B5"/>
+                </a:solidFill>
+                <a:latin typeface="Calibri"/>
+              </a:rPr>
+              <a:t>Probe:  </a:t>
+            </a:r>
+            <a:r>
+              <a:rPr sz="1200" b="0">
+                <a:solidFill>
+                  <a:srgbClr val="525252"/>
+                </a:solidFill>
+                <a:latin typeface="Calibri"/>
+              </a:rPr>
+              <a:t>rank-truncate ONE layer's FFN, measure </a:t>
+            </a:r>
+            <a:r>
+              <a:rPr sz="1200" b="1">
+                <a:solidFill>
+                  <a:srgbClr val="1A1A1A"/>
+                </a:solidFill>
+                <a:latin typeface="Calibri"/>
+              </a:rPr>
+              <a:t>Δ end-to-end output ÷ Δ local output</a:t>
+            </a:r>
+            <a:r>
+              <a:rPr sz="1200" b="0">
+                <a:solidFill>
+                  <a:srgbClr val="525252"/>
+                </a:solidFill>
+                <a:latin typeface="Calibri"/>
+              </a:rPr>
+              <a:t>   ( = how much that layer's error blows up by the time it reaches the logits )</a:t>
+            </a:r>
+          </a:p>
+        </p:txBody>
+      </p:sp>
+      <p:sp>
+        <p:nvSpPr>
+          <p:cNvPr id="8" name="Rounded Rectangle 7"/>
+          <p:cNvSpPr/>
+          <p:nvPr/>
+        </p:nvSpPr>
+        <p:spPr>
+          <a:xfrm>
+            <a:off x="868680" y="-594359"/>
+            <a:ext cx="960120" cy="2834640"/>
+          </a:xfrm>
+          <a:prstGeom prst="roundRect">
+            <a:avLst/>
+          </a:prstGeom>
+          <a:solidFill>
+            <a:srgbClr val="C0504D"/>
+          </a:solidFill>
+          <a:ln>
+            <a:noFill/>
+          </a:ln>
+          <a:effectLst/>
+        </p:spPr>
+        <p:style>
+          <a:lnRef idx="1">
+            <a:schemeClr val="accent1"/>
+          </a:lnRef>
+          <a:fillRef idx="3">
+            <a:schemeClr val="accent1"/>
+          </a:fillRef>
+          <a:effectRef idx="2">
+            <a:schemeClr val="accent1"/>
+          </a:effectRef>
+          <a:fontRef idx="minor">
+            <a:schemeClr val="lt1"/>
+          </a:fontRef>
+        </p:style>
+        <p:txBody>
+          <a:bodyPr rtlCol="0" anchor="ctr"/>
+          <a:lstStyle/>
+          <a:p>
+            <a:pPr algn="ctr"/>
+          </a:p>
+        </p:txBody>
+      </p:sp>
+      <p:sp>
+        <p:nvSpPr>
+          <p:cNvPr id="9" name="TextBox 8"/>
+          <p:cNvSpPr txBox="1"/>
+          <p:nvPr/>
+        </p:nvSpPr>
+        <p:spPr>
+          <a:xfrm>
+            <a:off x="731519" y="-886968"/>
+            <a:ext cx="1234440" cy="274320"/>
+          </a:xfrm>
+          <a:prstGeom prst="rect">
+            <a:avLst/>
+          </a:prstGeom>
+          <a:noFill/>
+        </p:spPr>
+        <p:txBody>
+          <a:bodyPr wrap="square" anchor="t" lIns="0" rIns="0" tIns="0" bIns="0">
+            <a:spAutoFit/>
+          </a:bodyPr>
+          <a:lstStyle/>
+          <a:p>
+            <a:pPr algn="ctr"/>
+            <a:r>
+              <a:rPr sz="1300" b="1">
+                <a:solidFill>
+                  <a:srgbClr val="C0504D"/>
+                </a:solidFill>
+                <a:latin typeface="Calibri"/>
+              </a:rPr>
+              <a:t>30.8×</a:t>
+            </a:r>
+          </a:p>
+        </p:txBody>
+      </p:sp>
+      <p:sp>
+        <p:nvSpPr>
+          <p:cNvPr id="10" name="TextBox 9"/>
+          <p:cNvSpPr txBox="1"/>
+          <p:nvPr/>
+        </p:nvSpPr>
+        <p:spPr>
+          <a:xfrm>
+            <a:off x="731519" y="2276856"/>
+            <a:ext cx="1234440" cy="228600"/>
+          </a:xfrm>
+          <a:prstGeom prst="rect">
+            <a:avLst/>
+          </a:prstGeom>
+          <a:noFill/>
+        </p:spPr>
+        <p:txBody>
+          <a:bodyPr wrap="square" anchor="t" lIns="0" rIns="0" tIns="0" bIns="0">
+            <a:spAutoFit/>
+          </a:bodyPr>
+          <a:lstStyle/>
+          <a:p>
+            <a:pPr algn="ctr"/>
+            <a:r>
+              <a:rPr sz="1100" b="0">
+                <a:solidFill>
+                  <a:srgbClr val="525252"/>
+                </a:solidFill>
+                <a:latin typeface="Calibri"/>
+              </a:rPr>
+              <a:t>L0</a:t>
+            </a:r>
+          </a:p>
+        </p:txBody>
+      </p:sp>
+      <p:sp>
+        <p:nvSpPr>
+          <p:cNvPr id="11" name="Rounded Rectangle 10"/>
+          <p:cNvSpPr/>
+          <p:nvPr/>
+        </p:nvSpPr>
+        <p:spPr>
+          <a:xfrm>
+            <a:off x="2194560" y="-26404"/>
+            <a:ext cx="960120" cy="2266684"/>
+          </a:xfrm>
+          <a:prstGeom prst="roundRect">
+            <a:avLst/>
+          </a:prstGeom>
+          <a:solidFill>
+            <a:srgbClr val="C0504D"/>
+          </a:solidFill>
+          <a:ln>
+            <a:noFill/>
+          </a:ln>
+          <a:effectLst/>
+        </p:spPr>
+        <p:style>
+          <a:lnRef idx="1">
+            <a:schemeClr val="accent1"/>
+          </a:lnRef>
+          <a:fillRef idx="3">
+            <a:schemeClr val="accent1"/>
+          </a:fillRef>
+          <a:effectRef idx="2">
+            <a:schemeClr val="accent1"/>
+          </a:effectRef>
+          <a:fontRef idx="minor">
+            <a:schemeClr val="lt1"/>
+          </a:fontRef>
+        </p:style>
+        <p:txBody>
+          <a:bodyPr rtlCol="0" anchor="ctr"/>
+          <a:lstStyle/>
+          <a:p>
+            <a:pPr algn="ctr"/>
+          </a:p>
+        </p:txBody>
+      </p:sp>
+      <p:sp>
+        <p:nvSpPr>
+          <p:cNvPr id="12" name="TextBox 11"/>
+          <p:cNvSpPr txBox="1"/>
+          <p:nvPr/>
+        </p:nvSpPr>
+        <p:spPr>
+          <a:xfrm>
+            <a:off x="2057400" y="-319012"/>
+            <a:ext cx="1234440" cy="274320"/>
+          </a:xfrm>
+          <a:prstGeom prst="rect">
+            <a:avLst/>
+          </a:prstGeom>
+          <a:noFill/>
+        </p:spPr>
+        <p:txBody>
+          <a:bodyPr wrap="square" anchor="t" lIns="0" rIns="0" tIns="0" bIns="0">
+            <a:spAutoFit/>
+          </a:bodyPr>
+          <a:lstStyle/>
+          <a:p>
+            <a:pPr algn="ctr"/>
+            <a:r>
+              <a:rPr sz="1300" b="1">
+                <a:solidFill>
+                  <a:srgbClr val="C0504D"/>
+                </a:solidFill>
+                <a:latin typeface="Calibri"/>
+              </a:rPr>
+              <a:t>14.9×</a:t>
+            </a:r>
+          </a:p>
+        </p:txBody>
+      </p:sp>
+      <p:sp>
+        <p:nvSpPr>
+          <p:cNvPr id="13" name="TextBox 12"/>
+          <p:cNvSpPr txBox="1"/>
+          <p:nvPr/>
+        </p:nvSpPr>
+        <p:spPr>
+          <a:xfrm>
+            <a:off x="2057400" y="2276856"/>
+            <a:ext cx="1234440" cy="228600"/>
+          </a:xfrm>
+          <a:prstGeom prst="rect">
+            <a:avLst/>
+          </a:prstGeom>
+          <a:noFill/>
+        </p:spPr>
+        <p:txBody>
+          <a:bodyPr wrap="square" anchor="t" lIns="0" rIns="0" tIns="0" bIns="0">
+            <a:spAutoFit/>
+          </a:bodyPr>
+          <a:lstStyle/>
+          <a:p>
+            <a:pPr algn="ctr"/>
+            <a:r>
+              <a:rPr sz="1100" b="0">
+                <a:solidFill>
+                  <a:srgbClr val="525252"/>
+                </a:solidFill>
+                <a:latin typeface="Calibri"/>
+              </a:rPr>
+              <a:t>L1</a:t>
+            </a:r>
+          </a:p>
+        </p:txBody>
+      </p:sp>
+      <p:sp>
+        <p:nvSpPr>
+          <p:cNvPr id="14" name="Rounded Rectangle 13"/>
+          <p:cNvSpPr/>
+          <p:nvPr/>
+        </p:nvSpPr>
+        <p:spPr>
+          <a:xfrm>
+            <a:off x="3520440" y="54789"/>
+            <a:ext cx="960120" cy="2185490"/>
+          </a:xfrm>
+          <a:prstGeom prst="roundRect">
+            <a:avLst/>
+          </a:prstGeom>
+          <a:solidFill>
+            <a:srgbClr val="C0504D"/>
+          </a:solidFill>
+          <a:ln>
+            <a:noFill/>
+          </a:ln>
+          <a:effectLst/>
+        </p:spPr>
+        <p:style>
+          <a:lnRef idx="1">
+            <a:schemeClr val="accent1"/>
+          </a:lnRef>
+          <a:fillRef idx="3">
+            <a:schemeClr val="accent1"/>
+          </a:fillRef>
+          <a:effectRef idx="2">
+            <a:schemeClr val="accent1"/>
+          </a:effectRef>
+          <a:fontRef idx="minor">
+            <a:schemeClr val="lt1"/>
+          </a:fontRef>
+        </p:style>
+        <p:txBody>
+          <a:bodyPr rtlCol="0" anchor="ctr"/>
+          <a:lstStyle/>
+          <a:p>
+            <a:pPr algn="ctr"/>
+          </a:p>
+        </p:txBody>
+      </p:sp>
+      <p:sp>
+        <p:nvSpPr>
+          <p:cNvPr id="15" name="TextBox 14"/>
+          <p:cNvSpPr txBox="1"/>
+          <p:nvPr/>
+        </p:nvSpPr>
+        <p:spPr>
+          <a:xfrm>
+            <a:off x="3383280" y="-237818"/>
+            <a:ext cx="1234440" cy="274320"/>
+          </a:xfrm>
+          <a:prstGeom prst="rect">
+            <a:avLst/>
+          </a:prstGeom>
+          <a:noFill/>
+        </p:spPr>
+        <p:txBody>
+          <a:bodyPr wrap="square" anchor="t" lIns="0" rIns="0" tIns="0" bIns="0">
+            <a:spAutoFit/>
+          </a:bodyPr>
+          <a:lstStyle/>
+          <a:p>
+            <a:pPr algn="ctr"/>
+            <a:r>
+              <a:rPr sz="1300" b="1">
+                <a:solidFill>
+                  <a:srgbClr val="C0504D"/>
+                </a:solidFill>
+                <a:latin typeface="Calibri"/>
+              </a:rPr>
+              <a:t>13.4×</a:t>
+            </a:r>
+          </a:p>
+        </p:txBody>
+      </p:sp>
+      <p:sp>
+        <p:nvSpPr>
+          <p:cNvPr id="16" name="TextBox 15"/>
+          <p:cNvSpPr txBox="1"/>
+          <p:nvPr/>
+        </p:nvSpPr>
+        <p:spPr>
+          <a:xfrm>
+            <a:off x="3383280" y="2276856"/>
+            <a:ext cx="1234440" cy="228600"/>
+          </a:xfrm>
+          <a:prstGeom prst="rect">
+            <a:avLst/>
+          </a:prstGeom>
+          <a:noFill/>
+        </p:spPr>
+        <p:txBody>
+          <a:bodyPr wrap="square" anchor="t" lIns="0" rIns="0" tIns="0" bIns="0">
+            <a:spAutoFit/>
+          </a:bodyPr>
+          <a:lstStyle/>
+          <a:p>
+            <a:pPr algn="ctr"/>
+            <a:r>
+              <a:rPr sz="1100" b="0">
+                <a:solidFill>
+                  <a:srgbClr val="525252"/>
+                </a:solidFill>
+                <a:latin typeface="Calibri"/>
+              </a:rPr>
+              <a:t>L3</a:t>
+            </a:r>
+          </a:p>
+        </p:txBody>
+      </p:sp>
+      <p:sp>
+        <p:nvSpPr>
+          <p:cNvPr id="17" name="Rounded Rectangle 16"/>
+          <p:cNvSpPr/>
+          <p:nvPr/>
+        </p:nvSpPr>
+        <p:spPr>
+          <a:xfrm>
+            <a:off x="4846320" y="719254"/>
+            <a:ext cx="960120" cy="1521025"/>
+          </a:xfrm>
+          <a:prstGeom prst="roundRect">
+            <a:avLst/>
+          </a:prstGeom>
+          <a:solidFill>
+            <a:srgbClr val="C0504D"/>
+          </a:solidFill>
+          <a:ln>
+            <a:noFill/>
+          </a:ln>
+          <a:effectLst/>
+        </p:spPr>
+        <p:style>
+          <a:lnRef idx="1">
+            <a:schemeClr val="accent1"/>
+          </a:lnRef>
+          <a:fillRef idx="3">
+            <a:schemeClr val="accent1"/>
+          </a:fillRef>
+          <a:effectRef idx="2">
+            <a:schemeClr val="accent1"/>
+          </a:effectRef>
+          <a:fontRef idx="minor">
+            <a:schemeClr val="lt1"/>
+          </a:fontRef>
+        </p:style>
+        <p:txBody>
+          <a:bodyPr rtlCol="0" anchor="ctr"/>
+          <a:lstStyle/>
+          <a:p>
+            <a:pPr algn="ctr"/>
+          </a:p>
+        </p:txBody>
+      </p:sp>
+      <p:sp>
+        <p:nvSpPr>
+          <p:cNvPr id="18" name="TextBox 17"/>
+          <p:cNvSpPr txBox="1"/>
+          <p:nvPr/>
+        </p:nvSpPr>
+        <p:spPr>
+          <a:xfrm>
+            <a:off x="4709160" y="426646"/>
+            <a:ext cx="1234440" cy="274320"/>
+          </a:xfrm>
+          <a:prstGeom prst="rect">
+            <a:avLst/>
+          </a:prstGeom>
+          <a:noFill/>
+        </p:spPr>
+        <p:txBody>
+          <a:bodyPr wrap="square" anchor="t" lIns="0" rIns="0" tIns="0" bIns="0">
+            <a:spAutoFit/>
+          </a:bodyPr>
+          <a:lstStyle/>
+          <a:p>
+            <a:pPr algn="ctr"/>
+            <a:r>
+              <a:rPr sz="1300" b="1">
+                <a:solidFill>
+                  <a:srgbClr val="C0504D"/>
+                </a:solidFill>
+                <a:latin typeface="Calibri"/>
+              </a:rPr>
+              <a:t>5.4×</a:t>
+            </a:r>
+          </a:p>
+        </p:txBody>
+      </p:sp>
+      <p:sp>
+        <p:nvSpPr>
+          <p:cNvPr id="19" name="TextBox 18"/>
+          <p:cNvSpPr txBox="1"/>
+          <p:nvPr/>
+        </p:nvSpPr>
+        <p:spPr>
+          <a:xfrm>
+            <a:off x="4709160" y="2276856"/>
+            <a:ext cx="1234440" cy="228600"/>
+          </a:xfrm>
+          <a:prstGeom prst="rect">
+            <a:avLst/>
+          </a:prstGeom>
+          <a:noFill/>
+        </p:spPr>
+        <p:txBody>
+          <a:bodyPr wrap="square" anchor="t" lIns="0" rIns="0" tIns="0" bIns="0">
+            <a:spAutoFit/>
+          </a:bodyPr>
+          <a:lstStyle/>
+          <a:p>
+            <a:pPr algn="ctr"/>
+            <a:r>
+              <a:rPr sz="1100" b="0">
+                <a:solidFill>
+                  <a:srgbClr val="525252"/>
+                </a:solidFill>
+                <a:latin typeface="Calibri"/>
+              </a:rPr>
+              <a:t>L5</a:t>
+            </a:r>
+          </a:p>
+        </p:txBody>
+      </p:sp>
+      <p:sp>
+        <p:nvSpPr>
+          <p:cNvPr id="20" name="Rounded Rectangle 19"/>
+          <p:cNvSpPr/>
+          <p:nvPr/>
+        </p:nvSpPr>
+        <p:spPr>
+          <a:xfrm>
+            <a:off x="6172200" y="1340091"/>
+            <a:ext cx="960120" cy="900188"/>
+          </a:xfrm>
+          <a:prstGeom prst="roundRect">
+            <a:avLst/>
+          </a:prstGeom>
+          <a:solidFill>
+            <a:srgbClr val="FFA300"/>
+          </a:solidFill>
+          <a:ln>
+            <a:noFill/>
+          </a:ln>
+          <a:effectLst/>
+        </p:spPr>
+        <p:style>
+          <a:lnRef idx="1">
+            <a:schemeClr val="accent1"/>
+          </a:lnRef>
+          <a:fillRef idx="3">
+            <a:schemeClr val="accent1"/>
+          </a:fillRef>
+          <a:effectRef idx="2">
+            <a:schemeClr val="accent1"/>
+          </a:effectRef>
+          <a:fontRef idx="minor">
+            <a:schemeClr val="lt1"/>
+          </a:fontRef>
+        </p:style>
+        <p:txBody>
+          <a:bodyPr rtlCol="0" anchor="ctr"/>
+          <a:lstStyle/>
+          <a:p>
+            <a:pPr algn="ctr"/>
+          </a:p>
+        </p:txBody>
+      </p:sp>
+      <p:sp>
+        <p:nvSpPr>
+          <p:cNvPr id="21" name="TextBox 20"/>
+          <p:cNvSpPr txBox="1"/>
+          <p:nvPr/>
+        </p:nvSpPr>
+        <p:spPr>
+          <a:xfrm>
+            <a:off x="6035040" y="1047483"/>
+            <a:ext cx="1234440" cy="274320"/>
+          </a:xfrm>
+          <a:prstGeom prst="rect">
+            <a:avLst/>
+          </a:prstGeom>
+          <a:noFill/>
+        </p:spPr>
+        <p:txBody>
+          <a:bodyPr wrap="square" anchor="t" lIns="0" rIns="0" tIns="0" bIns="0">
+            <a:spAutoFit/>
+          </a:bodyPr>
+          <a:lstStyle/>
+          <a:p>
+            <a:pPr algn="ctr"/>
+            <a:r>
+              <a:rPr sz="1300" b="1">
+                <a:solidFill>
+                  <a:srgbClr val="FFA300"/>
+                </a:solidFill>
+                <a:latin typeface="Calibri"/>
+              </a:rPr>
+              <a:t>2.0×</a:t>
+            </a:r>
+          </a:p>
+        </p:txBody>
+      </p:sp>
+      <p:sp>
+        <p:nvSpPr>
+          <p:cNvPr id="22" name="TextBox 21"/>
+          <p:cNvSpPr txBox="1"/>
+          <p:nvPr/>
+        </p:nvSpPr>
+        <p:spPr>
+          <a:xfrm>
+            <a:off x="6035040" y="2276856"/>
+            <a:ext cx="1234440" cy="228600"/>
+          </a:xfrm>
+          <a:prstGeom prst="rect">
+            <a:avLst/>
+          </a:prstGeom>
+          <a:noFill/>
+        </p:spPr>
+        <p:txBody>
+          <a:bodyPr wrap="square" anchor="t" lIns="0" rIns="0" tIns="0" bIns="0">
+            <a:spAutoFit/>
+          </a:bodyPr>
+          <a:lstStyle/>
+          <a:p>
+            <a:pPr algn="ctr"/>
+            <a:r>
+              <a:rPr sz="1100" b="0">
+                <a:solidFill>
+                  <a:srgbClr val="525252"/>
+                </a:solidFill>
+                <a:latin typeface="Calibri"/>
+              </a:rPr>
+              <a:t>L10</a:t>
+            </a:r>
+          </a:p>
+        </p:txBody>
+      </p:sp>
+      <p:sp>
+        <p:nvSpPr>
+          <p:cNvPr id="23" name="Rounded Rectangle 22"/>
+          <p:cNvSpPr/>
+          <p:nvPr/>
+        </p:nvSpPr>
+        <p:spPr>
+          <a:xfrm>
+            <a:off x="7498080" y="1396623"/>
+            <a:ext cx="960120" cy="843656"/>
+          </a:xfrm>
+          <a:prstGeom prst="roundRect">
+            <a:avLst/>
+          </a:prstGeom>
+          <a:solidFill>
+            <a:srgbClr val="FFA300"/>
+          </a:solidFill>
+          <a:ln>
+            <a:noFill/>
+          </a:ln>
+          <a:effectLst/>
+        </p:spPr>
+        <p:style>
+          <a:lnRef idx="1">
+            <a:schemeClr val="accent1"/>
+          </a:lnRef>
+          <a:fillRef idx="3">
+            <a:schemeClr val="accent1"/>
+          </a:fillRef>
+          <a:effectRef idx="2">
+            <a:schemeClr val="accent1"/>
+          </a:effectRef>
+          <a:fontRef idx="minor">
+            <a:schemeClr val="lt1"/>
+          </a:fontRef>
+        </p:style>
+        <p:txBody>
+          <a:bodyPr rtlCol="0" anchor="ctr"/>
+          <a:lstStyle/>
+          <a:p>
+            <a:pPr algn="ctr"/>
+          </a:p>
+        </p:txBody>
+      </p:sp>
+      <p:sp>
+        <p:nvSpPr>
+          <p:cNvPr id="24" name="TextBox 23"/>
+          <p:cNvSpPr txBox="1"/>
+          <p:nvPr/>
+        </p:nvSpPr>
+        <p:spPr>
+          <a:xfrm>
+            <a:off x="7360920" y="1104015"/>
+            <a:ext cx="1234440" cy="274320"/>
+          </a:xfrm>
+          <a:prstGeom prst="rect">
+            <a:avLst/>
+          </a:prstGeom>
+          <a:noFill/>
+        </p:spPr>
+        <p:txBody>
+          <a:bodyPr wrap="square" anchor="t" lIns="0" rIns="0" tIns="0" bIns="0">
+            <a:spAutoFit/>
+          </a:bodyPr>
+          <a:lstStyle/>
+          <a:p>
+            <a:pPr algn="ctr"/>
+            <a:r>
+              <a:rPr sz="1300" b="1">
+                <a:solidFill>
+                  <a:srgbClr val="FFA300"/>
+                </a:solidFill>
+                <a:latin typeface="Calibri"/>
+              </a:rPr>
+              <a:t>1.8×</a:t>
+            </a:r>
+          </a:p>
+        </p:txBody>
+      </p:sp>
+      <p:sp>
+        <p:nvSpPr>
+          <p:cNvPr id="25" name="TextBox 24"/>
+          <p:cNvSpPr txBox="1"/>
+          <p:nvPr/>
+        </p:nvSpPr>
+        <p:spPr>
+          <a:xfrm>
+            <a:off x="7360920" y="2276856"/>
+            <a:ext cx="1234440" cy="228600"/>
+          </a:xfrm>
+          <a:prstGeom prst="rect">
+            <a:avLst/>
+          </a:prstGeom>
+          <a:noFill/>
+        </p:spPr>
+        <p:txBody>
+          <a:bodyPr wrap="square" anchor="t" lIns="0" rIns="0" tIns="0" bIns="0">
+            <a:spAutoFit/>
+          </a:bodyPr>
+          <a:lstStyle/>
+          <a:p>
+            <a:pPr algn="ctr"/>
+            <a:r>
+              <a:rPr sz="1100" b="0">
+                <a:solidFill>
+                  <a:srgbClr val="525252"/>
+                </a:solidFill>
+                <a:latin typeface="Calibri"/>
+              </a:rPr>
+              <a:t>L16</a:t>
+            </a:r>
+          </a:p>
+        </p:txBody>
+      </p:sp>
+      <p:sp>
+        <p:nvSpPr>
+          <p:cNvPr id="26" name="Rounded Rectangle 25"/>
+          <p:cNvSpPr/>
+          <p:nvPr/>
+        </p:nvSpPr>
+        <p:spPr>
+          <a:xfrm>
+            <a:off x="8823960" y="1594228"/>
+            <a:ext cx="960120" cy="646051"/>
+          </a:xfrm>
+          <a:prstGeom prst="roundRect">
+            <a:avLst/>
+          </a:prstGeom>
+          <a:solidFill>
+            <a:srgbClr val="0068B5"/>
+          </a:solidFill>
+          <a:ln>
+            <a:noFill/>
+          </a:ln>
+          <a:effectLst/>
+        </p:spPr>
+        <p:style>
+          <a:lnRef idx="1">
+            <a:schemeClr val="accent1"/>
+          </a:lnRef>
+          <a:fillRef idx="3">
+            <a:schemeClr val="accent1"/>
+          </a:fillRef>
+          <a:effectRef idx="2">
+            <a:schemeClr val="accent1"/>
+          </a:effectRef>
+          <a:fontRef idx="minor">
+            <a:schemeClr val="lt1"/>
+          </a:fontRef>
+        </p:style>
+        <p:txBody>
+          <a:bodyPr rtlCol="0" anchor="ctr"/>
+          <a:lstStyle/>
+          <a:p>
+            <a:pPr algn="ctr"/>
+          </a:p>
+        </p:txBody>
+      </p:sp>
+      <p:sp>
+        <p:nvSpPr>
+          <p:cNvPr id="27" name="TextBox 26"/>
+          <p:cNvSpPr txBox="1"/>
+          <p:nvPr/>
+        </p:nvSpPr>
+        <p:spPr>
+          <a:xfrm>
+            <a:off x="8686800" y="1301620"/>
+            <a:ext cx="1234440" cy="274320"/>
+          </a:xfrm>
+          <a:prstGeom prst="rect">
+            <a:avLst/>
+          </a:prstGeom>
+          <a:noFill/>
+        </p:spPr>
+        <p:txBody>
+          <a:bodyPr wrap="square" anchor="t" lIns="0" rIns="0" tIns="0" bIns="0">
+            <a:spAutoFit/>
+          </a:bodyPr>
+          <a:lstStyle/>
+          <a:p>
+            <a:pPr algn="ctr"/>
+            <a:r>
+              <a:rPr sz="1300" b="1">
+                <a:solidFill>
+                  <a:srgbClr val="0068B5"/>
+                </a:solidFill>
+                <a:latin typeface="Calibri"/>
+              </a:rPr>
+              <a:t>1.2×</a:t>
+            </a:r>
+          </a:p>
+        </p:txBody>
+      </p:sp>
+      <p:sp>
+        <p:nvSpPr>
+          <p:cNvPr id="28" name="TextBox 27"/>
+          <p:cNvSpPr txBox="1"/>
+          <p:nvPr/>
+        </p:nvSpPr>
+        <p:spPr>
+          <a:xfrm>
+            <a:off x="8686800" y="2276856"/>
+            <a:ext cx="1234440" cy="228600"/>
+          </a:xfrm>
+          <a:prstGeom prst="rect">
+            <a:avLst/>
+          </a:prstGeom>
+          <a:noFill/>
+        </p:spPr>
+        <p:txBody>
+          <a:bodyPr wrap="square" anchor="t" lIns="0" rIns="0" tIns="0" bIns="0">
+            <a:spAutoFit/>
+          </a:bodyPr>
+          <a:lstStyle/>
+          <a:p>
+            <a:pPr algn="ctr"/>
+            <a:r>
+              <a:rPr sz="1100" b="0">
+                <a:solidFill>
+                  <a:srgbClr val="525252"/>
+                </a:solidFill>
+                <a:latin typeface="Calibri"/>
+              </a:rPr>
+              <a:t>L24</a:t>
+            </a:r>
+          </a:p>
+        </p:txBody>
+      </p:sp>
+      <p:sp>
+        <p:nvSpPr>
+          <p:cNvPr id="29" name="Rounded Rectangle 28"/>
+          <p:cNvSpPr/>
+          <p:nvPr/>
+        </p:nvSpPr>
+        <p:spPr>
+          <a:xfrm>
+            <a:off x="10149840" y="1805490"/>
+            <a:ext cx="960120" cy="434789"/>
+          </a:xfrm>
+          <a:prstGeom prst="roundRect">
+            <a:avLst/>
+          </a:prstGeom>
+          <a:solidFill>
+            <a:srgbClr val="0068B5"/>
+          </a:solidFill>
+          <a:ln>
+            <a:noFill/>
+          </a:ln>
+          <a:effectLst/>
+        </p:spPr>
+        <p:style>
+          <a:lnRef idx="1">
+            <a:schemeClr val="accent1"/>
+          </a:lnRef>
+          <a:fillRef idx="3">
+            <a:schemeClr val="accent1"/>
+          </a:fillRef>
+          <a:effectRef idx="2">
+            <a:schemeClr val="accent1"/>
+          </a:effectRef>
+          <a:fontRef idx="minor">
+            <a:schemeClr val="lt1"/>
+          </a:fontRef>
+        </p:style>
+        <p:txBody>
+          <a:bodyPr rtlCol="0" anchor="ctr"/>
+          <a:lstStyle/>
+          <a:p>
+            <a:pPr algn="ctr"/>
+          </a:p>
+        </p:txBody>
+      </p:sp>
+      <p:sp>
+        <p:nvSpPr>
+          <p:cNvPr id="30" name="TextBox 29"/>
+          <p:cNvSpPr txBox="1"/>
+          <p:nvPr/>
+        </p:nvSpPr>
+        <p:spPr>
+          <a:xfrm>
+            <a:off x="10012680" y="1512882"/>
+            <a:ext cx="1234440" cy="274320"/>
+          </a:xfrm>
+          <a:prstGeom prst="rect">
+            <a:avLst/>
+          </a:prstGeom>
+          <a:noFill/>
+        </p:spPr>
+        <p:txBody>
+          <a:bodyPr wrap="square" anchor="t" lIns="0" rIns="0" tIns="0" bIns="0">
+            <a:spAutoFit/>
+          </a:bodyPr>
+          <a:lstStyle/>
+          <a:p>
+            <a:pPr algn="ctr"/>
+            <a:r>
+              <a:rPr sz="1300" b="1">
+                <a:solidFill>
+                  <a:srgbClr val="0068B5"/>
+                </a:solidFill>
+                <a:latin typeface="Calibri"/>
+              </a:rPr>
+              <a:t>0.7×</a:t>
+            </a:r>
+          </a:p>
+        </p:txBody>
+      </p:sp>
+      <p:sp>
+        <p:nvSpPr>
+          <p:cNvPr id="31" name="TextBox 30"/>
+          <p:cNvSpPr txBox="1"/>
+          <p:nvPr/>
+        </p:nvSpPr>
+        <p:spPr>
+          <a:xfrm>
+            <a:off x="10012680" y="2276856"/>
+            <a:ext cx="1234440" cy="228600"/>
+          </a:xfrm>
+          <a:prstGeom prst="rect">
+            <a:avLst/>
+          </a:prstGeom>
+          <a:noFill/>
+        </p:spPr>
+        <p:txBody>
+          <a:bodyPr wrap="square" anchor="t" lIns="0" rIns="0" tIns="0" bIns="0">
+            <a:spAutoFit/>
+          </a:bodyPr>
+          <a:lstStyle/>
+          <a:p>
+            <a:pPr algn="ctr"/>
+            <a:r>
+              <a:rPr sz="1100" b="0">
+                <a:solidFill>
+                  <a:srgbClr val="525252"/>
+                </a:solidFill>
+                <a:latin typeface="Calibri"/>
+              </a:rPr>
+              <a:t>L31</a:t>
+            </a:r>
+          </a:p>
+        </p:txBody>
+      </p:sp>
+      <p:sp>
+        <p:nvSpPr>
+          <p:cNvPr id="32" name="TextBox 31"/>
+          <p:cNvSpPr txBox="1"/>
+          <p:nvPr/>
+        </p:nvSpPr>
+        <p:spPr>
+          <a:xfrm>
+            <a:off x="566928" y="2331720"/>
+            <a:ext cx="3657600" cy="228600"/>
+          </a:xfrm>
+          <a:prstGeom prst="rect">
+            <a:avLst/>
+          </a:prstGeom>
+          <a:noFill/>
+        </p:spPr>
+        <p:txBody>
+          <a:bodyPr wrap="square" anchor="t" lIns="0" rIns="0" tIns="0" bIns="0">
+            <a:spAutoFit/>
+          </a:bodyPr>
+          <a:lstStyle/>
+          <a:p>
+            <a:pPr algn="l"/>
+            <a:r>
+              <a:rPr sz="1100" b="1">
+                <a:solidFill>
+                  <a:srgbClr val="525252"/>
+                </a:solidFill>
+                <a:latin typeface="Calibri"/>
+              </a:rPr>
+              <a:t>amplification (Δe2e / Δlocal)</a:t>
+            </a:r>
+          </a:p>
+        </p:txBody>
+      </p:sp>
+      <p:sp>
+        <p:nvSpPr>
+          <p:cNvPr id="33" name="TextBox 32"/>
+          <p:cNvSpPr txBox="1"/>
+          <p:nvPr/>
+        </p:nvSpPr>
+        <p:spPr>
+          <a:xfrm>
+            <a:off x="566928" y="5166360"/>
+            <a:ext cx="10972800" cy="228600"/>
+          </a:xfrm>
+          <a:prstGeom prst="rect">
+            <a:avLst/>
+          </a:prstGeom>
+          <a:noFill/>
+        </p:spPr>
+        <p:txBody>
+          <a:bodyPr wrap="square" anchor="t" lIns="0" rIns="0" tIns="0" bIns="0">
+            <a:spAutoFit/>
+          </a:bodyPr>
+          <a:lstStyle/>
+          <a:p>
+            <a:pPr algn="l"/>
+            <a:r>
+              <a:rPr sz="1100" b="1">
+                <a:solidFill>
+                  <a:srgbClr val="C0504D"/>
+                </a:solidFill>
+                <a:latin typeface="Calibri"/>
+              </a:rPr>
+              <a:t>early layers  →  amplify ~30×</a:t>
+            </a:r>
+            <a:r>
+              <a:rPr sz="1100" b="1">
+                <a:solidFill>
+                  <a:srgbClr val="0068B5"/>
+                </a:solidFill>
+                <a:latin typeface="Calibri"/>
+              </a:rPr>
+              <a:t>        late layers  →  damp (&lt;1×)</a:t>
+            </a:r>
+          </a:p>
+        </p:txBody>
+      </p:sp>
+      <p:sp>
+        <p:nvSpPr>
+          <p:cNvPr id="34" name="Rectangle 33"/>
+          <p:cNvSpPr/>
+          <p:nvPr/>
+        </p:nvSpPr>
+        <p:spPr>
+          <a:xfrm>
+            <a:off x="365760" y="5897880"/>
+            <a:ext cx="11430000" cy="658368"/>
+          </a:xfrm>
+          <a:prstGeom prst="rect">
+            <a:avLst/>
+          </a:prstGeom>
+          <a:solidFill>
+            <a:srgbClr val="FCE4D6"/>
+          </a:solidFill>
+          <a:ln>
+            <a:noFill/>
+          </a:ln>
+          <a:effectLst/>
+        </p:spPr>
+        <p:style>
+          <a:lnRef idx="1">
+            <a:schemeClr val="accent1"/>
+          </a:lnRef>
+          <a:fillRef idx="3">
+            <a:schemeClr val="accent1"/>
+          </a:fillRef>
+          <a:effectRef idx="2">
+            <a:schemeClr val="accent1"/>
+          </a:effectRef>
+          <a:fontRef idx="minor">
+            <a:schemeClr val="lt1"/>
+          </a:fontRef>
+        </p:style>
+        <p:txBody>
+          <a:bodyPr rtlCol="0" anchor="ctr"/>
+          <a:lstStyle/>
+          <a:p>
+            <a:pPr algn="ctr"/>
+          </a:p>
+        </p:txBody>
+      </p:sp>
+      <p:sp>
+        <p:nvSpPr>
+          <p:cNvPr id="35" name="Rectangle 34"/>
+          <p:cNvSpPr/>
+          <p:nvPr/>
+        </p:nvSpPr>
+        <p:spPr>
+          <a:xfrm>
+            <a:off x="365760" y="5897880"/>
+            <a:ext cx="146304" cy="658368"/>
+          </a:xfrm>
+          <a:prstGeom prst="rect">
+            <a:avLst/>
+          </a:prstGeom>
+          <a:solidFill>
+            <a:srgbClr val="C0504D"/>
+          </a:solidFill>
+          <a:ln>
+            <a:noFill/>
+          </a:ln>
+          <a:effectLst/>
+        </p:spPr>
+        <p:style>
+          <a:lnRef idx="1">
+            <a:schemeClr val="accent1"/>
+          </a:lnRef>
+          <a:fillRef idx="3">
+            <a:schemeClr val="accent1"/>
+          </a:fillRef>
+          <a:effectRef idx="2">
+            <a:schemeClr val="accent1"/>
+          </a:effectRef>
+          <a:fontRef idx="minor">
+            <a:schemeClr val="lt1"/>
+          </a:fontRef>
+        </p:style>
+        <p:txBody>
+          <a:bodyPr rtlCol="0" anchor="ctr"/>
+          <a:lstStyle/>
+          <a:p>
+            <a:pPr algn="ctr"/>
+          </a:p>
+        </p:txBody>
+      </p:sp>
+      <p:sp>
+        <p:nvSpPr>
+          <p:cNvPr id="36" name="TextBox 35"/>
+          <p:cNvSpPr txBox="1"/>
+          <p:nvPr/>
+        </p:nvSpPr>
+        <p:spPr>
+          <a:xfrm>
+            <a:off x="685800" y="5961888"/>
+            <a:ext cx="10972800" cy="548640"/>
+          </a:xfrm>
+          <a:prstGeom prst="rect">
+            <a:avLst/>
+          </a:prstGeom>
+          <a:noFill/>
+        </p:spPr>
+        <p:txBody>
+          <a:bodyPr wrap="square" anchor="t" lIns="0" rIns="0" tIns="0" bIns="0">
+            <a:spAutoFit/>
+          </a:bodyPr>
+          <a:lstStyle/>
+          <a:p>
+            <a:pPr algn="l"/>
+            <a:r>
+              <a:rPr sz="1300" b="1">
+                <a:solidFill>
+                  <a:srgbClr val="C0504D"/>
+                </a:solidFill>
+                <a:latin typeface="Calibri"/>
+              </a:rPr>
+              <a:t>Implication:  </a:t>
+            </a:r>
+            <a:r>
+              <a:rPr sz="1300" b="0">
+                <a:solidFill>
+                  <a:srgbClr val="1A1A1A"/>
+                </a:solidFill>
+                <a:latin typeface="Calibri"/>
+              </a:rPr>
+              <a:t>the true cost of compressing a layer varies ~43× by depth. Methods that allocate rank by </a:t>
+            </a:r>
+            <a:r>
+              <a:rPr sz="1300" b="1">
+                <a:solidFill>
+                  <a:srgbClr val="1A1A1A"/>
+                </a:solidFill>
+                <a:latin typeface="Calibri"/>
+              </a:rPr>
+              <a:t>local</a:t>
+            </a:r>
+            <a:r>
+              <a:rPr sz="1300" b="0">
+                <a:solidFill>
+                  <a:srgbClr val="1A1A1A"/>
+                </a:solidFill>
+                <a:latin typeface="Calibri"/>
+              </a:rPr>
+              <a:t> error (FLAT-LLM, ASVD, SVD-LLM) optimize the wrong quantity.</a:t>
+            </a:r>
+          </a:p>
+        </p:txBody>
+      </p:sp>
+    </p:spTree>
+  </p:cSld>
+  <p:clrMapOvr>
+    <a:masterClrMapping/>
+  </p:clrMapOvr>
+</p:sld>
+</file>
+
+<file path=ppt/slides/slide11.xml><?xml version="1.0" encoding="utf-8"?>
+<p:sld xmlns:a="http://schemas.openxmlformats.org/drawingml/2006/main" xmlns:p="http://schemas.openxmlformats.org/presentationml/2006/main" xmlns:r="http://schemas.openxmlformats.org/officeDocument/2006/relationships">
+  <p:cSld>
+    <p:spTree>
+      <p:nvGrpSpPr>
+        <p:cNvPr id="1" name=""/>
+        <p:cNvGrpSpPr/>
+        <p:nvPr/>
+      </p:nvGrpSpPr>
+      <p:grpSpPr/>
+      <p:sp>
+        <p:nvSpPr>
+          <p:cNvPr id="2" name="TextBox 1"/>
+          <p:cNvSpPr txBox="1"/>
+          <p:nvPr/>
+        </p:nvSpPr>
+        <p:spPr>
+          <a:xfrm>
+            <a:off x="365760" y="228600"/>
+            <a:ext cx="11430000" cy="548640"/>
+          </a:xfrm>
+          <a:prstGeom prst="rect">
+            <a:avLst/>
+          </a:prstGeom>
+          <a:noFill/>
+        </p:spPr>
+        <p:txBody>
+          <a:bodyPr wrap="square" anchor="t" lIns="0" rIns="0" tIns="0" bIns="0">
+            <a:spAutoFit/>
+          </a:bodyPr>
+          <a:lstStyle/>
+          <a:p>
+            <a:pPr algn="l"/>
+            <a:r>
+              <a:rPr sz="2800" b="1">
+                <a:solidFill>
+                  <a:srgbClr val="1A1A1A"/>
+                </a:solidFill>
+                <a:latin typeface="Calibri"/>
+              </a:rPr>
+              <a:t>Finding 2:  Layer Errors Couple — a Graph, Not Just a Curve</a:t>
+            </a:r>
+          </a:p>
+        </p:txBody>
+      </p:sp>
+      <p:sp>
+        <p:nvSpPr>
+          <p:cNvPr id="3" name="Rectangle 2"/>
+          <p:cNvSpPr/>
+          <p:nvPr/>
+        </p:nvSpPr>
+        <p:spPr>
+          <a:xfrm>
+            <a:off x="365760" y="795528"/>
+            <a:ext cx="11457432" cy="27432"/>
+          </a:xfrm>
+          <a:prstGeom prst="rect">
+            <a:avLst/>
+          </a:prstGeom>
+          <a:solidFill>
+            <a:srgbClr val="0068B5"/>
+          </a:solidFill>
+          <a:ln>
+            <a:noFill/>
+          </a:ln>
+          <a:effectLst/>
+        </p:spPr>
+        <p:style>
+          <a:lnRef idx="1">
+            <a:schemeClr val="accent1"/>
+          </a:lnRef>
+          <a:fillRef idx="3">
+            <a:schemeClr val="accent1"/>
+          </a:fillRef>
+          <a:effectRef idx="2">
+            <a:schemeClr val="accent1"/>
+          </a:effectRef>
+          <a:fontRef idx="minor">
+            <a:schemeClr val="lt1"/>
+          </a:fontRef>
+        </p:style>
+        <p:txBody>
+          <a:bodyPr rtlCol="0" anchor="ctr"/>
+          <a:lstStyle/>
+          <a:p>
+            <a:pPr algn="ctr"/>
+          </a:p>
+        </p:txBody>
+      </p:sp>
+      <p:sp>
+        <p:nvSpPr>
+          <p:cNvPr id="4" name="TextBox 3"/>
+          <p:cNvSpPr txBox="1"/>
+          <p:nvPr/>
+        </p:nvSpPr>
+        <p:spPr>
+          <a:xfrm>
+            <a:off x="11430000" y="6492240"/>
+            <a:ext cx="640080" cy="274320"/>
+          </a:xfrm>
+          <a:prstGeom prst="rect">
+            <a:avLst/>
+          </a:prstGeom>
+          <a:noFill/>
+        </p:spPr>
+        <p:txBody>
+          <a:bodyPr wrap="square" anchor="t" lIns="0" rIns="0" tIns="0" bIns="0">
+            <a:spAutoFit/>
+          </a:bodyPr>
+          <a:lstStyle/>
+          <a:p>
+            <a:pPr algn="r"/>
+            <a:r>
+              <a:rPr sz="1000" b="0">
+                <a:solidFill>
+                  <a:srgbClr val="AAAAAA"/>
+                </a:solidFill>
+                <a:latin typeface="Calibri"/>
+              </a:rPr>
+              <a:t>11</a:t>
+            </a:r>
+          </a:p>
+        </p:txBody>
+      </p:sp>
+      <p:sp>
+        <p:nvSpPr>
+          <p:cNvPr id="5" name="TextBox 4"/>
+          <p:cNvSpPr txBox="1"/>
+          <p:nvPr/>
+        </p:nvSpPr>
+        <p:spPr>
+          <a:xfrm>
+            <a:off x="365760" y="932688"/>
+            <a:ext cx="11430000" cy="365760"/>
+          </a:xfrm>
+          <a:prstGeom prst="rect">
+            <a:avLst/>
+          </a:prstGeom>
+          <a:noFill/>
+        </p:spPr>
+        <p:txBody>
+          <a:bodyPr wrap="square" anchor="t" lIns="0" rIns="0" tIns="0" bIns="0">
+            <a:spAutoFit/>
+          </a:bodyPr>
+          <a:lstStyle/>
+          <a:p>
+            <a:pPr algn="l"/>
+            <a:r>
+              <a:rPr sz="1500" b="1">
+                <a:solidFill>
+                  <a:srgbClr val="1A1A1A"/>
+                </a:solidFill>
+                <a:latin typeface="Calibri"/>
+              </a:rPr>
+              <a:t>Do layers' compression errors </a:t>
+            </a:r>
+            <a:r>
+              <a:rPr sz="1500" b="1">
+                <a:solidFill>
+                  <a:srgbClr val="0068B5"/>
+                </a:solidFill>
+                <a:latin typeface="Calibri"/>
+              </a:rPr>
+              <a:t>interact</a:t>
+            </a:r>
+            <a:r>
+              <a:rPr sz="1500" b="1">
+                <a:solidFill>
+                  <a:srgbClr val="1A1A1A"/>
+                </a:solidFill>
+                <a:latin typeface="Calibri"/>
+              </a:rPr>
+              <a:t>?  If so, rank must be allocated jointly, not greedily per-layer.</a:t>
+            </a:r>
+          </a:p>
+        </p:txBody>
+      </p:sp>
+      <p:sp>
+        <p:nvSpPr>
+          <p:cNvPr id="6" name="Rectangle 5"/>
+          <p:cNvSpPr/>
+          <p:nvPr/>
+        </p:nvSpPr>
+        <p:spPr>
+          <a:xfrm>
+            <a:off x="365760" y="1481328"/>
+            <a:ext cx="11430000" cy="1243584"/>
+          </a:xfrm>
+          <a:prstGeom prst="rect">
+            <a:avLst/>
+          </a:prstGeom>
+          <a:solidFill>
+            <a:srgbClr val="FFF2CC"/>
+          </a:solidFill>
+          <a:ln>
+            <a:noFill/>
+          </a:ln>
+          <a:effectLst/>
+        </p:spPr>
+        <p:style>
+          <a:lnRef idx="1">
+            <a:schemeClr val="accent1"/>
+          </a:lnRef>
+          <a:fillRef idx="3">
+            <a:schemeClr val="accent1"/>
+          </a:fillRef>
+          <a:effectRef idx="2">
+            <a:schemeClr val="accent1"/>
+          </a:effectRef>
+          <a:fontRef idx="minor">
+            <a:schemeClr val="lt1"/>
+          </a:fontRef>
+        </p:style>
+        <p:txBody>
+          <a:bodyPr rtlCol="0" anchor="ctr"/>
+          <a:lstStyle/>
+          <a:p>
+            <a:pPr algn="ctr"/>
+          </a:p>
+        </p:txBody>
+      </p:sp>
+      <p:sp>
+        <p:nvSpPr>
+          <p:cNvPr id="7" name="Rectangle 6"/>
+          <p:cNvSpPr/>
+          <p:nvPr/>
+        </p:nvSpPr>
+        <p:spPr>
+          <a:xfrm>
+            <a:off x="365760" y="1481328"/>
+            <a:ext cx="146304" cy="1243584"/>
+          </a:xfrm>
+          <a:prstGeom prst="rect">
+            <a:avLst/>
+          </a:prstGeom>
+          <a:solidFill>
+            <a:srgbClr val="FFA300"/>
+          </a:solidFill>
+          <a:ln>
+            <a:noFill/>
+          </a:ln>
+          <a:effectLst/>
+        </p:spPr>
+        <p:style>
+          <a:lnRef idx="1">
+            <a:schemeClr val="accent1"/>
+          </a:lnRef>
+          <a:fillRef idx="3">
+            <a:schemeClr val="accent1"/>
+          </a:fillRef>
+          <a:effectRef idx="2">
+            <a:schemeClr val="accent1"/>
+          </a:effectRef>
+          <a:fontRef idx="minor">
+            <a:schemeClr val="lt1"/>
+          </a:fontRef>
+        </p:style>
+        <p:txBody>
+          <a:bodyPr rtlCol="0" anchor="ctr"/>
+          <a:lstStyle/>
+          <a:p>
+            <a:pPr algn="ctr"/>
+          </a:p>
+        </p:txBody>
+      </p:sp>
+      <p:sp>
+        <p:nvSpPr>
+          <p:cNvPr id="8" name="Oval 7"/>
+          <p:cNvSpPr/>
+          <p:nvPr/>
+        </p:nvSpPr>
+        <p:spPr>
+          <a:xfrm>
+            <a:off x="667512" y="1764792"/>
+            <a:ext cx="676656" cy="676656"/>
+          </a:xfrm>
+          <a:prstGeom prst="ellipse">
+            <a:avLst/>
+          </a:prstGeom>
+          <a:solidFill>
+            <a:srgbClr val="FFA300"/>
+          </a:solidFill>
+          <a:ln>
+            <a:noFill/>
+          </a:ln>
+          <a:effectLst/>
+        </p:spPr>
+        <p:style>
+          <a:lnRef idx="1">
+            <a:schemeClr val="accent1"/>
+          </a:lnRef>
+          <a:fillRef idx="3">
+            <a:schemeClr val="accent1"/>
+          </a:fillRef>
+          <a:effectRef idx="2">
+            <a:schemeClr val="accent1"/>
+          </a:effectRef>
+          <a:fontRef idx="minor">
+            <a:schemeClr val="lt1"/>
+          </a:fontRef>
+        </p:style>
+        <p:txBody>
+          <a:bodyPr rtlCol="0" anchor="ctr"/>
+          <a:lstStyle/>
+          <a:p>
+            <a:pPr algn="ctr"/>
+          </a:p>
+        </p:txBody>
+      </p:sp>
+      <p:sp>
+        <p:nvSpPr>
+          <p:cNvPr id="9" name="TextBox 8"/>
+          <p:cNvSpPr txBox="1"/>
+          <p:nvPr/>
+        </p:nvSpPr>
+        <p:spPr>
+          <a:xfrm>
+            <a:off x="667512" y="1792224"/>
+            <a:ext cx="676656" cy="640080"/>
+          </a:xfrm>
+          <a:prstGeom prst="rect">
+            <a:avLst/>
+          </a:prstGeom>
+          <a:noFill/>
+        </p:spPr>
+        <p:txBody>
+          <a:bodyPr wrap="square" anchor="ctr" lIns="0" rIns="0" tIns="0" bIns="0">
+            <a:spAutoFit/>
+          </a:bodyPr>
+          <a:lstStyle/>
+          <a:p>
+            <a:pPr algn="ctr"/>
+            <a:r>
+              <a:rPr sz="2600" b="1">
+                <a:solidFill>
+                  <a:srgbClr val="FFFFFF"/>
+                </a:solidFill>
+                <a:latin typeface="Calibri"/>
+              </a:rPr>
+              <a:t>ι</a:t>
+            </a:r>
+          </a:p>
+        </p:txBody>
+      </p:sp>
+      <p:sp>
+        <p:nvSpPr>
+          <p:cNvPr id="10" name="TextBox 9"/>
+          <p:cNvSpPr txBox="1"/>
+          <p:nvPr/>
+        </p:nvSpPr>
+        <p:spPr>
+          <a:xfrm>
+            <a:off x="1545336" y="1645920"/>
+            <a:ext cx="9966960" cy="365760"/>
+          </a:xfrm>
+          <a:prstGeom prst="rect">
+            <a:avLst/>
+          </a:prstGeom>
+          <a:noFill/>
+        </p:spPr>
+        <p:txBody>
+          <a:bodyPr wrap="square" anchor="t" lIns="0" rIns="0" tIns="0" bIns="0">
+            <a:spAutoFit/>
+          </a:bodyPr>
+          <a:lstStyle/>
+          <a:p>
+            <a:pPr algn="l"/>
+            <a:r>
+              <a:rPr sz="1800" b="1">
+                <a:solidFill>
+                  <a:srgbClr val="FFA300"/>
+                </a:solidFill>
+                <a:latin typeface="Calibri"/>
+              </a:rPr>
+              <a:t>Errors are non-additive</a:t>
+            </a:r>
+          </a:p>
+        </p:txBody>
+      </p:sp>
+      <p:sp>
+        <p:nvSpPr>
+          <p:cNvPr id="11" name="TextBox 10"/>
+          <p:cNvSpPr txBox="1"/>
+          <p:nvPr/>
+        </p:nvSpPr>
+        <p:spPr>
+          <a:xfrm>
+            <a:off x="1545336" y="2048256"/>
+            <a:ext cx="9966960" cy="640080"/>
+          </a:xfrm>
+          <a:prstGeom prst="rect">
+            <a:avLst/>
+          </a:prstGeom>
+          <a:noFill/>
+        </p:spPr>
+        <p:txBody>
+          <a:bodyPr wrap="square" anchor="t" lIns="0" rIns="0" tIns="0" bIns="0">
+            <a:spAutoFit/>
+          </a:bodyPr>
+          <a:lstStyle/>
+          <a:p>
+            <a:pPr algn="l"/>
+            <a:r>
+              <a:rPr sz="1300" b="0">
+                <a:solidFill>
+                  <a:srgbClr val="525252"/>
+                </a:solidFill>
+                <a:latin typeface="Calibri"/>
+              </a:rPr>
+              <a:t>Compressing two layers together ≠ sum of each alone.  Interaction ι (mean 0.60) is large — joint effects matter.</a:t>
+            </a:r>
+          </a:p>
+        </p:txBody>
+      </p:sp>
+      <p:sp>
+        <p:nvSpPr>
+          <p:cNvPr id="12" name="Rectangle 11"/>
+          <p:cNvSpPr/>
+          <p:nvPr/>
+        </p:nvSpPr>
+        <p:spPr>
+          <a:xfrm>
+            <a:off x="365760" y="2852928"/>
+            <a:ext cx="11430000" cy="1243584"/>
+          </a:xfrm>
+          <a:prstGeom prst="rect">
+            <a:avLst/>
+          </a:prstGeom>
+          <a:solidFill>
+            <a:srgbClr val="DEEBF7"/>
+          </a:solidFill>
+          <a:ln>
+            <a:noFill/>
+          </a:ln>
+          <a:effectLst/>
+        </p:spPr>
+        <p:style>
+          <a:lnRef idx="1">
+            <a:schemeClr val="accent1"/>
+          </a:lnRef>
+          <a:fillRef idx="3">
+            <a:schemeClr val="accent1"/>
+          </a:fillRef>
+          <a:effectRef idx="2">
+            <a:schemeClr val="accent1"/>
+          </a:effectRef>
+          <a:fontRef idx="minor">
+            <a:schemeClr val="lt1"/>
+          </a:fontRef>
+        </p:style>
+        <p:txBody>
+          <a:bodyPr rtlCol="0" anchor="ctr"/>
+          <a:lstStyle/>
+          <a:p>
+            <a:pPr algn="ctr"/>
+          </a:p>
+        </p:txBody>
+      </p:sp>
+      <p:sp>
+        <p:nvSpPr>
+          <p:cNvPr id="13" name="Rectangle 12"/>
+          <p:cNvSpPr/>
+          <p:nvPr/>
+        </p:nvSpPr>
+        <p:spPr>
+          <a:xfrm>
+            <a:off x="365760" y="2852928"/>
+            <a:ext cx="146304" cy="1243584"/>
+          </a:xfrm>
+          <a:prstGeom prst="rect">
+            <a:avLst/>
+          </a:prstGeom>
+          <a:solidFill>
+            <a:srgbClr val="0068B5"/>
+          </a:solidFill>
+          <a:ln>
+            <a:noFill/>
+          </a:ln>
+          <a:effectLst/>
+        </p:spPr>
+        <p:style>
+          <a:lnRef idx="1">
+            <a:schemeClr val="accent1"/>
+          </a:lnRef>
+          <a:fillRef idx="3">
+            <a:schemeClr val="accent1"/>
+          </a:fillRef>
+          <a:effectRef idx="2">
+            <a:schemeClr val="accent1"/>
+          </a:effectRef>
+          <a:fontRef idx="minor">
+            <a:schemeClr val="lt1"/>
+          </a:fontRef>
+        </p:style>
+        <p:txBody>
+          <a:bodyPr rtlCol="0" anchor="ctr"/>
+          <a:lstStyle/>
+          <a:p>
+            <a:pPr algn="ctr"/>
+          </a:p>
+        </p:txBody>
+      </p:sp>
+      <p:sp>
+        <p:nvSpPr>
+          <p:cNvPr id="14" name="Oval 13"/>
+          <p:cNvSpPr/>
+          <p:nvPr/>
+        </p:nvSpPr>
+        <p:spPr>
+          <a:xfrm>
+            <a:off x="667512" y="3136392"/>
+            <a:ext cx="676656" cy="676656"/>
+          </a:xfrm>
+          <a:prstGeom prst="ellipse">
+            <a:avLst/>
+          </a:prstGeom>
+          <a:solidFill>
+            <a:srgbClr val="0068B5"/>
+          </a:solidFill>
+          <a:ln>
+            <a:noFill/>
+          </a:ln>
+          <a:effectLst/>
+        </p:spPr>
+        <p:style>
+          <a:lnRef idx="1">
+            <a:schemeClr val="accent1"/>
+          </a:lnRef>
+          <a:fillRef idx="3">
+            <a:schemeClr val="accent1"/>
+          </a:fillRef>
+          <a:effectRef idx="2">
+            <a:schemeClr val="accent1"/>
+          </a:effectRef>
+          <a:fontRef idx="minor">
+            <a:schemeClr val="lt1"/>
+          </a:fontRef>
+        </p:style>
+        <p:txBody>
+          <a:bodyPr rtlCol="0" anchor="ctr"/>
+          <a:lstStyle/>
+          <a:p>
+            <a:pPr algn="ctr"/>
+          </a:p>
+        </p:txBody>
+      </p:sp>
+      <p:sp>
+        <p:nvSpPr>
+          <p:cNvPr id="15" name="TextBox 14"/>
+          <p:cNvSpPr txBox="1"/>
+          <p:nvPr/>
+        </p:nvSpPr>
+        <p:spPr>
+          <a:xfrm>
+            <a:off x="667512" y="3163824"/>
+            <a:ext cx="676656" cy="640080"/>
+          </a:xfrm>
+          <a:prstGeom prst="rect">
+            <a:avLst/>
+          </a:prstGeom>
+          <a:noFill/>
+        </p:spPr>
+        <p:txBody>
+          <a:bodyPr wrap="square" anchor="ctr" lIns="0" rIns="0" tIns="0" bIns="0">
+            <a:spAutoFit/>
+          </a:bodyPr>
+          <a:lstStyle/>
+          <a:p>
+            <a:pPr algn="ctr"/>
+            <a:r>
+              <a:rPr sz="1800" b="1">
+                <a:solidFill>
+                  <a:srgbClr val="FFFFFF"/>
+                </a:solidFill>
+                <a:latin typeface="Calibri"/>
+              </a:rPr>
+              <a:t>|cos|</a:t>
+            </a:r>
+          </a:p>
+        </p:txBody>
+      </p:sp>
+      <p:sp>
+        <p:nvSpPr>
+          <p:cNvPr id="16" name="TextBox 15"/>
+          <p:cNvSpPr txBox="1"/>
+          <p:nvPr/>
+        </p:nvSpPr>
+        <p:spPr>
+          <a:xfrm>
+            <a:off x="1545336" y="3017520"/>
+            <a:ext cx="9966960" cy="365760"/>
+          </a:xfrm>
+          <a:prstGeom prst="rect">
+            <a:avLst/>
+          </a:prstGeom>
+          <a:noFill/>
+        </p:spPr>
+        <p:txBody>
+          <a:bodyPr wrap="square" anchor="t" lIns="0" rIns="0" tIns="0" bIns="0">
+            <a:spAutoFit/>
+          </a:bodyPr>
+          <a:lstStyle/>
+          <a:p>
+            <a:pPr algn="l"/>
+            <a:r>
+              <a:rPr sz="1800" b="1">
+                <a:solidFill>
+                  <a:srgbClr val="0068B5"/>
+                </a:solidFill>
+                <a:latin typeface="Calibri"/>
+              </a:rPr>
+              <a:t>Coupling is local (banded)</a:t>
+            </a:r>
+          </a:p>
+        </p:txBody>
+      </p:sp>
+      <p:sp>
+        <p:nvSpPr>
+          <p:cNvPr id="17" name="TextBox 16"/>
+          <p:cNvSpPr txBox="1"/>
+          <p:nvPr/>
+        </p:nvSpPr>
+        <p:spPr>
+          <a:xfrm>
+            <a:off x="1545336" y="3419856"/>
+            <a:ext cx="9966960" cy="640080"/>
+          </a:xfrm>
+          <a:prstGeom prst="rect">
+            <a:avLst/>
+          </a:prstGeom>
+          <a:noFill/>
+        </p:spPr>
+        <p:txBody>
+          <a:bodyPr wrap="square" anchor="t" lIns="0" rIns="0" tIns="0" bIns="0">
+            <a:spAutoFit/>
+          </a:bodyPr>
+          <a:lstStyle/>
+          <a:p>
+            <a:pPr algn="l"/>
+            <a:r>
+              <a:rPr sz="1300" b="0">
+                <a:solidFill>
+                  <a:srgbClr val="525252"/>
+                </a:solidFill>
+                <a:latin typeface="Calibri"/>
+              </a:rPr>
+              <a:t>Error directions align for nearby layers, decay with distance:  adjacent 0.46  ›  distant 0.28.  A banded graph.</a:t>
+            </a:r>
+          </a:p>
+        </p:txBody>
+      </p:sp>
+      <p:sp>
+        <p:nvSpPr>
+          <p:cNvPr id="18" name="Rectangle 17"/>
+          <p:cNvSpPr/>
+          <p:nvPr/>
+        </p:nvSpPr>
+        <p:spPr>
+          <a:xfrm>
+            <a:off x="365760" y="4224528"/>
+            <a:ext cx="11430000" cy="1243584"/>
+          </a:xfrm>
+          <a:prstGeom prst="rect">
+            <a:avLst/>
+          </a:prstGeom>
+          <a:solidFill>
+            <a:srgbClr val="FCE4D6"/>
+          </a:solidFill>
+          <a:ln>
+            <a:noFill/>
+          </a:ln>
+          <a:effectLst/>
+        </p:spPr>
+        <p:style>
+          <a:lnRef idx="1">
+            <a:schemeClr val="accent1"/>
+          </a:lnRef>
+          <a:fillRef idx="3">
+            <a:schemeClr val="accent1"/>
+          </a:fillRef>
+          <a:effectRef idx="2">
+            <a:schemeClr val="accent1"/>
+          </a:effectRef>
+          <a:fontRef idx="minor">
+            <a:schemeClr val="lt1"/>
+          </a:fontRef>
+        </p:style>
+        <p:txBody>
+          <a:bodyPr rtlCol="0" anchor="ctr"/>
+          <a:lstStyle/>
+          <a:p>
+            <a:pPr algn="ctr"/>
+          </a:p>
+        </p:txBody>
+      </p:sp>
+      <p:sp>
+        <p:nvSpPr>
+          <p:cNvPr id="19" name="Rectangle 18"/>
+          <p:cNvSpPr/>
+          <p:nvPr/>
+        </p:nvSpPr>
+        <p:spPr>
+          <a:xfrm>
+            <a:off x="365760" y="4224528"/>
+            <a:ext cx="146304" cy="1243584"/>
+          </a:xfrm>
+          <a:prstGeom prst="rect">
+            <a:avLst/>
+          </a:prstGeom>
+          <a:solidFill>
+            <a:srgbClr val="C0504D"/>
+          </a:solidFill>
+          <a:ln>
+            <a:noFill/>
+          </a:ln>
+          <a:effectLst/>
+        </p:spPr>
+        <p:style>
+          <a:lnRef idx="1">
+            <a:schemeClr val="accent1"/>
+          </a:lnRef>
+          <a:fillRef idx="3">
+            <a:schemeClr val="accent1"/>
+          </a:fillRef>
+          <a:effectRef idx="2">
+            <a:schemeClr val="accent1"/>
+          </a:effectRef>
+          <a:fontRef idx="minor">
+            <a:schemeClr val="lt1"/>
+          </a:fontRef>
+        </p:style>
+        <p:txBody>
+          <a:bodyPr rtlCol="0" anchor="ctr"/>
+          <a:lstStyle/>
+          <a:p>
+            <a:pPr algn="ctr"/>
+          </a:p>
+        </p:txBody>
+      </p:sp>
+      <p:sp>
+        <p:nvSpPr>
+          <p:cNvPr id="20" name="Oval 19"/>
+          <p:cNvSpPr/>
+          <p:nvPr/>
+        </p:nvSpPr>
+        <p:spPr>
+          <a:xfrm>
+            <a:off x="667512" y="4507992"/>
+            <a:ext cx="676656" cy="676656"/>
+          </a:xfrm>
+          <a:prstGeom prst="ellipse">
+            <a:avLst/>
+          </a:prstGeom>
+          <a:solidFill>
+            <a:srgbClr val="C0504D"/>
+          </a:solidFill>
+          <a:ln>
+            <a:noFill/>
+          </a:ln>
+          <a:effectLst/>
+        </p:spPr>
+        <p:style>
+          <a:lnRef idx="1">
+            <a:schemeClr val="accent1"/>
+          </a:lnRef>
+          <a:fillRef idx="3">
+            <a:schemeClr val="accent1"/>
+          </a:fillRef>
+          <a:effectRef idx="2">
+            <a:schemeClr val="accent1"/>
+          </a:effectRef>
+          <a:fontRef idx="minor">
+            <a:schemeClr val="lt1"/>
+          </a:fontRef>
+        </p:style>
+        <p:txBody>
+          <a:bodyPr rtlCol="0" anchor="ctr"/>
+          <a:lstStyle/>
+          <a:p>
+            <a:pPr algn="ctr"/>
+          </a:p>
+        </p:txBody>
+      </p:sp>
+      <p:sp>
+        <p:nvSpPr>
+          <p:cNvPr id="21" name="TextBox 20"/>
+          <p:cNvSpPr txBox="1"/>
+          <p:nvPr/>
+        </p:nvSpPr>
+        <p:spPr>
+          <a:xfrm>
+            <a:off x="667512" y="4535424"/>
+            <a:ext cx="676656" cy="640080"/>
+          </a:xfrm>
+          <a:prstGeom prst="rect">
+            <a:avLst/>
+          </a:prstGeom>
+          <a:noFill/>
+        </p:spPr>
+        <p:txBody>
+          <a:bodyPr wrap="square" anchor="ctr" lIns="0" rIns="0" tIns="0" bIns="0">
+            <a:spAutoFit/>
+          </a:bodyPr>
+          <a:lstStyle/>
+          <a:p>
+            <a:pPr algn="ctr"/>
+            <a:r>
+              <a:rPr sz="1800" b="1">
+                <a:solidFill>
+                  <a:srgbClr val="FFFFFF"/>
+                </a:solidFill>
+                <a:latin typeface="Calibri"/>
+              </a:rPr>
+              <a:t>28–31</a:t>
+            </a:r>
+          </a:p>
+        </p:txBody>
+      </p:sp>
+      <p:sp>
+        <p:nvSpPr>
+          <p:cNvPr id="22" name="TextBox 21"/>
+          <p:cNvSpPr txBox="1"/>
+          <p:nvPr/>
+        </p:nvSpPr>
+        <p:spPr>
+          <a:xfrm>
+            <a:off x="1545336" y="4389120"/>
+            <a:ext cx="9966960" cy="365760"/>
+          </a:xfrm>
+          <a:prstGeom prst="rect">
+            <a:avLst/>
+          </a:prstGeom>
+          <a:noFill/>
+        </p:spPr>
+        <p:txBody>
+          <a:bodyPr wrap="square" anchor="t" lIns="0" rIns="0" tIns="0" bIns="0">
+            <a:spAutoFit/>
+          </a:bodyPr>
+          <a:lstStyle/>
+          <a:p>
+            <a:pPr algn="l"/>
+            <a:r>
+              <a:rPr sz="1800" b="1">
+                <a:solidFill>
+                  <a:srgbClr val="C0504D"/>
+                </a:solidFill>
+                <a:latin typeface="Calibri"/>
+              </a:rPr>
+              <a:t>The tail decouples</a:t>
+            </a:r>
+          </a:p>
+        </p:txBody>
+      </p:sp>
+      <p:sp>
+        <p:nvSpPr>
+          <p:cNvPr id="23" name="TextBox 22"/>
+          <p:cNvSpPr txBox="1"/>
+          <p:nvPr/>
+        </p:nvSpPr>
+        <p:spPr>
+          <a:xfrm>
+            <a:off x="1545336" y="4791456"/>
+            <a:ext cx="9966960" cy="640080"/>
+          </a:xfrm>
+          <a:prstGeom prst="rect">
+            <a:avLst/>
+          </a:prstGeom>
+          <a:noFill/>
+        </p:spPr>
+        <p:txBody>
+          <a:bodyPr wrap="square" anchor="t" lIns="0" rIns="0" tIns="0" bIns="0">
+            <a:spAutoFit/>
+          </a:bodyPr>
+          <a:lstStyle/>
+          <a:p>
+            <a:pPr algn="l"/>
+            <a:r>
+              <a:rPr sz="1300" b="0">
+                <a:solidFill>
+                  <a:srgbClr val="525252"/>
+                </a:solidFill>
+                <a:latin typeface="Calibri"/>
+              </a:rPr>
+              <a:t>Final block (layers 28–31) is weakly coupled to all others (|cos| 0.12–0.24) — a separate, compressible group.</a:t>
+            </a:r>
+          </a:p>
+        </p:txBody>
+      </p:sp>
+      <p:sp>
+        <p:nvSpPr>
+          <p:cNvPr id="24" name="Rectangle 23"/>
+          <p:cNvSpPr/>
+          <p:nvPr/>
+        </p:nvSpPr>
+        <p:spPr>
+          <a:xfrm>
+            <a:off x="365760" y="5897880"/>
+            <a:ext cx="11430000" cy="658368"/>
+          </a:xfrm>
+          <a:prstGeom prst="rect">
+            <a:avLst/>
+          </a:prstGeom>
+          <a:solidFill>
+            <a:srgbClr val="DEEBF7"/>
+          </a:solidFill>
+          <a:ln>
+            <a:noFill/>
+          </a:ln>
+          <a:effectLst/>
+        </p:spPr>
+        <p:style>
+          <a:lnRef idx="1">
+            <a:schemeClr val="accent1"/>
+          </a:lnRef>
+          <a:fillRef idx="3">
+            <a:schemeClr val="accent1"/>
+          </a:fillRef>
+          <a:effectRef idx="2">
+            <a:schemeClr val="accent1"/>
+          </a:effectRef>
+          <a:fontRef idx="minor">
+            <a:schemeClr val="lt1"/>
+          </a:fontRef>
+        </p:style>
+        <p:txBody>
+          <a:bodyPr rtlCol="0" anchor="ctr"/>
+          <a:lstStyle/>
+          <a:p>
+            <a:pPr algn="ctr"/>
+          </a:p>
+        </p:txBody>
+      </p:sp>
+      <p:sp>
+        <p:nvSpPr>
+          <p:cNvPr id="25" name="Rectangle 24"/>
+          <p:cNvSpPr/>
+          <p:nvPr/>
+        </p:nvSpPr>
+        <p:spPr>
+          <a:xfrm>
+            <a:off x="365760" y="5897880"/>
+            <a:ext cx="146304" cy="658368"/>
+          </a:xfrm>
+          <a:prstGeom prst="rect">
+            <a:avLst/>
+          </a:prstGeom>
+          <a:solidFill>
+            <a:srgbClr val="0068B5"/>
+          </a:solidFill>
+          <a:ln>
+            <a:noFill/>
+          </a:ln>
+          <a:effectLst/>
+        </p:spPr>
+        <p:style>
+          <a:lnRef idx="1">
+            <a:schemeClr val="accent1"/>
+          </a:lnRef>
+          <a:fillRef idx="3">
+            <a:schemeClr val="accent1"/>
+          </a:fillRef>
+          <a:effectRef idx="2">
+            <a:schemeClr val="accent1"/>
+          </a:effectRef>
+          <a:fontRef idx="minor">
+            <a:schemeClr val="lt1"/>
+          </a:fontRef>
+        </p:style>
+        <p:txBody>
+          <a:bodyPr rtlCol="0" anchor="ctr"/>
+          <a:lstStyle/>
+          <a:p>
+            <a:pPr algn="ctr"/>
+          </a:p>
+        </p:txBody>
+      </p:sp>
+      <p:sp>
+        <p:nvSpPr>
+          <p:cNvPr id="26" name="TextBox 25"/>
+          <p:cNvSpPr txBox="1"/>
+          <p:nvPr/>
+        </p:nvSpPr>
+        <p:spPr>
+          <a:xfrm>
+            <a:off x="685800" y="5961888"/>
+            <a:ext cx="10972800" cy="548640"/>
+          </a:xfrm>
+          <a:prstGeom prst="rect">
+            <a:avLst/>
+          </a:prstGeom>
+          <a:noFill/>
+        </p:spPr>
+        <p:txBody>
+          <a:bodyPr wrap="square" anchor="t" lIns="0" rIns="0" tIns="0" bIns="0">
+            <a:spAutoFit/>
+          </a:bodyPr>
+          <a:lstStyle/>
+          <a:p>
+            <a:pPr algn="l"/>
+            <a:r>
+              <a:rPr sz="1300" b="1">
+                <a:solidFill>
+                  <a:srgbClr val="0068B5"/>
+                </a:solidFill>
+                <a:latin typeface="Calibri"/>
+              </a:rPr>
+              <a:t>The adjacency is real:  </a:t>
+            </a:r>
+            <a:r>
+              <a:rPr sz="1300" b="0">
+                <a:solidFill>
+                  <a:srgbClr val="1A1A1A"/>
+                </a:solidFill>
+                <a:latin typeface="Calibri"/>
+              </a:rPr>
+              <a:t>a banded error-coupling graph over the residual stream.  Rank allocation is a </a:t>
+            </a:r>
+            <a:r>
+              <a:rPr sz="1300" b="1">
+                <a:solidFill>
+                  <a:srgbClr val="1A1A1A"/>
+                </a:solidFill>
+                <a:latin typeface="Calibri"/>
+              </a:rPr>
+              <a:t>joint</a:t>
+            </a:r>
+            <a:r>
+              <a:rPr sz="1300" b="0">
+                <a:solidFill>
+                  <a:srgbClr val="1A1A1A"/>
+                </a:solidFill>
+                <a:latin typeface="Calibri"/>
+              </a:rPr>
+              <a:t> problem — exactly what per-layer greedy methods cannot solve.</a:t>
+            </a:r>
+          </a:p>
+        </p:txBody>
+      </p:sp>
+    </p:spTree>
+  </p:cSld>
+  <p:clrMapOvr>
+    <a:masterClrMapping/>
+  </p:clrMapOvr>
+</p:sld>
+</file>
+
+<file path=ppt/slides/slide12.xml><?xml version="1.0" encoding="utf-8"?>
+<p:sld xmlns:a="http://schemas.openxmlformats.org/drawingml/2006/main" xmlns:p="http://schemas.openxmlformats.org/presentationml/2006/main" xmlns:r="http://schemas.openxmlformats.org/officeDocument/2006/relationships">
+  <p:cSld>
+    <p:spTree>
+      <p:nvGrpSpPr>
+        <p:cNvPr id="1" name=""/>
+        <p:cNvGrpSpPr/>
+        <p:nvPr/>
+      </p:nvGrpSpPr>
+      <p:grpSpPr/>
+      <p:sp>
+        <p:nvSpPr>
+          <p:cNvPr id="2" name="TextBox 1"/>
+          <p:cNvSpPr txBox="1"/>
+          <p:nvPr/>
+        </p:nvSpPr>
+        <p:spPr>
+          <a:xfrm>
+            <a:off x="365760" y="228600"/>
+            <a:ext cx="11430000" cy="548640"/>
+          </a:xfrm>
+          <a:prstGeom prst="rect">
+            <a:avLst/>
+          </a:prstGeom>
+          <a:noFill/>
+        </p:spPr>
+        <p:txBody>
+          <a:bodyPr wrap="square" anchor="t" lIns="0" rIns="0" tIns="0" bIns="0">
+            <a:spAutoFit/>
+          </a:bodyPr>
+          <a:lstStyle/>
+          <a:p>
+            <a:pPr algn="l"/>
+            <a:r>
+              <a:rPr sz="2800" b="1">
+                <a:solidFill>
+                  <a:srgbClr val="1A1A1A"/>
+                </a:solidFill>
+                <a:latin typeface="Calibri"/>
+              </a:rPr>
+              <a:t>Finding 3:  Amplification-Aware Allocation Beats FLAT-LLM</a:t>
+            </a:r>
+          </a:p>
+        </p:txBody>
+      </p:sp>
+      <p:sp>
+        <p:nvSpPr>
+          <p:cNvPr id="3" name="Rectangle 2"/>
+          <p:cNvSpPr/>
+          <p:nvPr/>
+        </p:nvSpPr>
+        <p:spPr>
+          <a:xfrm>
+            <a:off x="365760" y="795528"/>
+            <a:ext cx="11457432" cy="27432"/>
+          </a:xfrm>
+          <a:prstGeom prst="rect">
+            <a:avLst/>
+          </a:prstGeom>
+          <a:solidFill>
+            <a:srgbClr val="0068B5"/>
+          </a:solidFill>
+          <a:ln>
+            <a:noFill/>
+          </a:ln>
+          <a:effectLst/>
+        </p:spPr>
+        <p:style>
+          <a:lnRef idx="1">
+            <a:schemeClr val="accent1"/>
+          </a:lnRef>
+          <a:fillRef idx="3">
+            <a:schemeClr val="accent1"/>
+          </a:fillRef>
+          <a:effectRef idx="2">
+            <a:schemeClr val="accent1"/>
+          </a:effectRef>
+          <a:fontRef idx="minor">
+            <a:schemeClr val="lt1"/>
+          </a:fontRef>
+        </p:style>
+        <p:txBody>
+          <a:bodyPr rtlCol="0" anchor="ctr"/>
+          <a:lstStyle/>
+          <a:p>
+            <a:pPr algn="ctr"/>
+          </a:p>
+        </p:txBody>
+      </p:sp>
+      <p:sp>
+        <p:nvSpPr>
+          <p:cNvPr id="4" name="TextBox 3"/>
+          <p:cNvSpPr txBox="1"/>
+          <p:nvPr/>
+        </p:nvSpPr>
+        <p:spPr>
+          <a:xfrm>
+            <a:off x="11430000" y="6492240"/>
+            <a:ext cx="640080" cy="274320"/>
+          </a:xfrm>
+          <a:prstGeom prst="rect">
+            <a:avLst/>
+          </a:prstGeom>
+          <a:noFill/>
+        </p:spPr>
+        <p:txBody>
+          <a:bodyPr wrap="square" anchor="t" lIns="0" rIns="0" tIns="0" bIns="0">
+            <a:spAutoFit/>
+          </a:bodyPr>
+          <a:lstStyle/>
+          <a:p>
+            <a:pPr algn="r"/>
+            <a:r>
+              <a:rPr sz="1000" b="0">
+                <a:solidFill>
+                  <a:srgbClr val="AAAAAA"/>
+                </a:solidFill>
+                <a:latin typeface="Calibri"/>
+              </a:rPr>
+              <a:t>12</a:t>
+            </a:r>
+          </a:p>
+        </p:txBody>
+      </p:sp>
+      <p:sp>
+        <p:nvSpPr>
+          <p:cNvPr id="5" name="TextBox 4"/>
+          <p:cNvSpPr txBox="1"/>
+          <p:nvPr/>
+        </p:nvSpPr>
+        <p:spPr>
+          <a:xfrm>
+            <a:off x="365760" y="932688"/>
+            <a:ext cx="11430000" cy="365760"/>
+          </a:xfrm>
+          <a:prstGeom prst="rect">
+            <a:avLst/>
+          </a:prstGeom>
+          <a:noFill/>
+        </p:spPr>
+        <p:txBody>
+          <a:bodyPr wrap="square" anchor="t" lIns="0" rIns="0" tIns="0" bIns="0">
+            <a:spAutoFit/>
+          </a:bodyPr>
+          <a:lstStyle/>
+          <a:p>
+            <a:pPr algn="l"/>
+            <a:r>
+              <a:rPr sz="1500" b="1">
+                <a:solidFill>
+                  <a:srgbClr val="1A1A1A"/>
+                </a:solidFill>
+                <a:latin typeface="Calibri"/>
+              </a:rPr>
+              <a:t>Same low-rank primitive, same total budget (</a:t>
+            </a:r>
+            <a:r>
+              <a:rPr sz="1500" b="1">
+                <a:solidFill>
+                  <a:srgbClr val="2E8B57"/>
+                </a:solidFill>
+                <a:latin typeface="Calibri"/>
+              </a:rPr>
+              <a:t>keep 50%</a:t>
+            </a:r>
+            <a:r>
+              <a:rPr sz="1500" b="1">
+                <a:solidFill>
+                  <a:srgbClr val="1A1A1A"/>
+                </a:solidFill>
+                <a:latin typeface="Calibri"/>
+              </a:rPr>
+              <a:t>), Llama-2-7B WikiText perplexity — only the </a:t>
+            </a:r>
+            <a:r>
+              <a:rPr sz="1500" b="1">
+                <a:solidFill>
+                  <a:srgbClr val="2E8B57"/>
+                </a:solidFill>
+                <a:latin typeface="Calibri"/>
+              </a:rPr>
+              <a:t>allocation</a:t>
+            </a:r>
+            <a:r>
+              <a:rPr sz="1500" b="1">
+                <a:solidFill>
+                  <a:srgbClr val="1A1A1A"/>
+                </a:solidFill>
+                <a:latin typeface="Calibri"/>
+              </a:rPr>
+              <a:t> differs.</a:t>
+            </a:r>
+          </a:p>
+        </p:txBody>
+      </p:sp>
+      <p:sp>
+        <p:nvSpPr>
+          <p:cNvPr id="6" name="TextBox 5"/>
+          <p:cNvSpPr txBox="1"/>
+          <p:nvPr/>
+        </p:nvSpPr>
+        <p:spPr>
+          <a:xfrm>
+            <a:off x="502920" y="1719072"/>
+            <a:ext cx="3520440" cy="457200"/>
+          </a:xfrm>
+          <a:prstGeom prst="rect">
+            <a:avLst/>
+          </a:prstGeom>
+          <a:noFill/>
+        </p:spPr>
+        <p:txBody>
+          <a:bodyPr wrap="square" anchor="t" lIns="0" rIns="0" tIns="0" bIns="0">
+            <a:spAutoFit/>
+          </a:bodyPr>
+          <a:lstStyle/>
+          <a:p>
+            <a:pPr algn="r"/>
+            <a:r>
+              <a:rPr sz="1400" b="1">
+                <a:solidFill>
+                  <a:srgbClr val="525252"/>
+                </a:solidFill>
+                <a:latin typeface="Calibri"/>
+              </a:rPr>
+              <a:t>No compression</a:t>
+            </a:r>
+          </a:p>
+        </p:txBody>
+      </p:sp>
+      <p:sp>
+        <p:nvSpPr>
+          <p:cNvPr id="7" name="Rounded Rectangle 6"/>
+          <p:cNvSpPr/>
+          <p:nvPr/>
+        </p:nvSpPr>
+        <p:spPr>
+          <a:xfrm>
+            <a:off x="4160520" y="1664208"/>
+            <a:ext cx="2709284" cy="420624"/>
+          </a:xfrm>
+          <a:prstGeom prst="roundRect">
+            <a:avLst/>
+          </a:prstGeom>
+          <a:solidFill>
+            <a:srgbClr val="525252"/>
+          </a:solidFill>
+          <a:ln>
+            <a:noFill/>
+          </a:ln>
+          <a:effectLst/>
+        </p:spPr>
+        <p:style>
+          <a:lnRef idx="1">
+            <a:schemeClr val="accent1"/>
+          </a:lnRef>
+          <a:fillRef idx="3">
+            <a:schemeClr val="accent1"/>
+          </a:fillRef>
+          <a:effectRef idx="2">
+            <a:schemeClr val="accent1"/>
+          </a:effectRef>
+          <a:fontRef idx="minor">
+            <a:schemeClr val="lt1"/>
+          </a:fontRef>
+        </p:style>
+        <p:txBody>
+          <a:bodyPr rtlCol="0" anchor="ctr"/>
+          <a:lstStyle/>
+          <a:p>
+            <a:pPr algn="ctr"/>
+          </a:p>
+        </p:txBody>
+      </p:sp>
+      <p:sp>
+        <p:nvSpPr>
+          <p:cNvPr id="8" name="TextBox 7"/>
+          <p:cNvSpPr txBox="1"/>
+          <p:nvPr/>
+        </p:nvSpPr>
+        <p:spPr>
+          <a:xfrm>
+            <a:off x="6961244" y="1700784"/>
+            <a:ext cx="1280160" cy="365760"/>
+          </a:xfrm>
+          <a:prstGeom prst="rect">
+            <a:avLst/>
+          </a:prstGeom>
+          <a:noFill/>
+        </p:spPr>
+        <p:txBody>
+          <a:bodyPr wrap="square" anchor="t" lIns="0" rIns="0" tIns="0" bIns="0">
+            <a:spAutoFit/>
+          </a:bodyPr>
+          <a:lstStyle/>
+          <a:p>
+            <a:pPr algn="l"/>
+            <a:r>
+              <a:rPr sz="1500" b="1">
+                <a:solidFill>
+                  <a:srgbClr val="525252"/>
+                </a:solidFill>
+                <a:latin typeface="Calibri"/>
+              </a:rPr>
+              <a:t>6.87</a:t>
+            </a:r>
+          </a:p>
+        </p:txBody>
+      </p:sp>
+      <p:sp>
+        <p:nvSpPr>
+          <p:cNvPr id="9" name="TextBox 8"/>
+          <p:cNvSpPr txBox="1"/>
+          <p:nvPr/>
+        </p:nvSpPr>
+        <p:spPr>
+          <a:xfrm>
+            <a:off x="502920" y="2359152"/>
+            <a:ext cx="3520440" cy="457200"/>
+          </a:xfrm>
+          <a:prstGeom prst="rect">
+            <a:avLst/>
+          </a:prstGeom>
+          <a:noFill/>
+        </p:spPr>
+        <p:txBody>
+          <a:bodyPr wrap="square" anchor="t" lIns="0" rIns="0" tIns="0" bIns="0">
+            <a:spAutoFit/>
+          </a:bodyPr>
+          <a:lstStyle/>
+          <a:p>
+            <a:pPr algn="r"/>
+            <a:r>
+              <a:rPr sz="1400" b="1">
+                <a:solidFill>
+                  <a:srgbClr val="525252"/>
+                </a:solidFill>
+                <a:latin typeface="Calibri"/>
+              </a:rPr>
+              <a:t>Uniform</a:t>
+            </a:r>
+          </a:p>
+        </p:txBody>
+      </p:sp>
+      <p:sp>
+        <p:nvSpPr>
+          <p:cNvPr id="10" name="Rounded Rectangle 9"/>
+          <p:cNvSpPr/>
+          <p:nvPr/>
+        </p:nvSpPr>
+        <p:spPr>
+          <a:xfrm>
+            <a:off x="4160520" y="2304288"/>
+            <a:ext cx="6858000" cy="420624"/>
+          </a:xfrm>
+          <a:prstGeom prst="roundRect">
+            <a:avLst/>
+          </a:prstGeom>
+          <a:solidFill>
+            <a:srgbClr val="9E9E9E"/>
+          </a:solidFill>
+          <a:ln>
+            <a:noFill/>
+          </a:ln>
+          <a:effectLst/>
+        </p:spPr>
+        <p:style>
+          <a:lnRef idx="1">
+            <a:schemeClr val="accent1"/>
+          </a:lnRef>
+          <a:fillRef idx="3">
+            <a:schemeClr val="accent1"/>
+          </a:fillRef>
+          <a:effectRef idx="2">
+            <a:schemeClr val="accent1"/>
+          </a:effectRef>
+          <a:fontRef idx="minor">
+            <a:schemeClr val="lt1"/>
+          </a:fontRef>
+        </p:style>
+        <p:txBody>
+          <a:bodyPr rtlCol="0" anchor="ctr"/>
+          <a:lstStyle/>
+          <a:p>
+            <a:pPr algn="ctr"/>
+          </a:p>
+        </p:txBody>
+      </p:sp>
+      <p:sp>
+        <p:nvSpPr>
+          <p:cNvPr id="11" name="TextBox 10"/>
+          <p:cNvSpPr txBox="1"/>
+          <p:nvPr/>
+        </p:nvSpPr>
+        <p:spPr>
+          <a:xfrm>
+            <a:off x="11109960" y="2340864"/>
+            <a:ext cx="1280160" cy="365760"/>
+          </a:xfrm>
+          <a:prstGeom prst="rect">
+            <a:avLst/>
+          </a:prstGeom>
+          <a:noFill/>
+        </p:spPr>
+        <p:txBody>
+          <a:bodyPr wrap="square" anchor="t" lIns="0" rIns="0" tIns="0" bIns="0">
+            <a:spAutoFit/>
+          </a:bodyPr>
+          <a:lstStyle/>
+          <a:p>
+            <a:pPr algn="l"/>
+            <a:r>
+              <a:rPr sz="1500" b="1">
+                <a:solidFill>
+                  <a:srgbClr val="9E9E9E"/>
+                </a:solidFill>
+                <a:latin typeface="Calibri"/>
+              </a:rPr>
+              <a:t>17.39</a:t>
+            </a:r>
+          </a:p>
+        </p:txBody>
+      </p:sp>
+      <p:sp>
+        <p:nvSpPr>
+          <p:cNvPr id="12" name="TextBox 11"/>
+          <p:cNvSpPr txBox="1"/>
+          <p:nvPr/>
+        </p:nvSpPr>
+        <p:spPr>
+          <a:xfrm>
+            <a:off x="502920" y="2999232"/>
+            <a:ext cx="3520440" cy="457200"/>
+          </a:xfrm>
+          <a:prstGeom prst="rect">
+            <a:avLst/>
+          </a:prstGeom>
+          <a:noFill/>
+        </p:spPr>
+        <p:txBody>
+          <a:bodyPr wrap="square" anchor="t" lIns="0" rIns="0" tIns="0" bIns="0">
+            <a:spAutoFit/>
+          </a:bodyPr>
+          <a:lstStyle/>
+          <a:p>
+            <a:pPr algn="r"/>
+            <a:r>
+              <a:rPr sz="1400" b="1">
+                <a:solidFill>
+                  <a:srgbClr val="1A1A1A"/>
+                </a:solidFill>
+                <a:latin typeface="Calibri"/>
+              </a:rPr>
+              <a:t>FLAT-LLM  (SOTA)</a:t>
+            </a:r>
+          </a:p>
+        </p:txBody>
+      </p:sp>
+      <p:sp>
+        <p:nvSpPr>
+          <p:cNvPr id="13" name="Rounded Rectangle 12"/>
+          <p:cNvSpPr/>
+          <p:nvPr/>
+        </p:nvSpPr>
+        <p:spPr>
+          <a:xfrm>
+            <a:off x="4160520" y="2944368"/>
+            <a:ext cx="5741948" cy="420624"/>
+          </a:xfrm>
+          <a:prstGeom prst="roundRect">
+            <a:avLst/>
+          </a:prstGeom>
+          <a:solidFill>
+            <a:srgbClr val="FFA300"/>
+          </a:solidFill>
+          <a:ln>
+            <a:noFill/>
+          </a:ln>
+          <a:effectLst/>
+        </p:spPr>
+        <p:style>
+          <a:lnRef idx="1">
+            <a:schemeClr val="accent1"/>
+          </a:lnRef>
+          <a:fillRef idx="3">
+            <a:schemeClr val="accent1"/>
+          </a:fillRef>
+          <a:effectRef idx="2">
+            <a:schemeClr val="accent1"/>
+          </a:effectRef>
+          <a:fontRef idx="minor">
+            <a:schemeClr val="lt1"/>
+          </a:fontRef>
+        </p:style>
+        <p:txBody>
+          <a:bodyPr rtlCol="0" anchor="ctr"/>
+          <a:lstStyle/>
+          <a:p>
+            <a:pPr algn="ctr"/>
+          </a:p>
+        </p:txBody>
+      </p:sp>
+      <p:sp>
+        <p:nvSpPr>
+          <p:cNvPr id="14" name="TextBox 13"/>
+          <p:cNvSpPr txBox="1"/>
+          <p:nvPr/>
+        </p:nvSpPr>
+        <p:spPr>
+          <a:xfrm>
+            <a:off x="9993908" y="2980944"/>
+            <a:ext cx="1280160" cy="365760"/>
+          </a:xfrm>
+          <a:prstGeom prst="rect">
+            <a:avLst/>
+          </a:prstGeom>
+          <a:noFill/>
+        </p:spPr>
+        <p:txBody>
+          <a:bodyPr wrap="square" anchor="t" lIns="0" rIns="0" tIns="0" bIns="0">
+            <a:spAutoFit/>
+          </a:bodyPr>
+          <a:lstStyle/>
+          <a:p>
+            <a:pPr algn="l"/>
+            <a:r>
+              <a:rPr sz="1500" b="1">
+                <a:solidFill>
+                  <a:srgbClr val="FFA300"/>
+                </a:solidFill>
+                <a:latin typeface="Calibri"/>
+              </a:rPr>
+              <a:t>14.56</a:t>
+            </a:r>
+          </a:p>
+        </p:txBody>
+      </p:sp>
+      <p:sp>
+        <p:nvSpPr>
+          <p:cNvPr id="15" name="TextBox 14"/>
+          <p:cNvSpPr txBox="1"/>
+          <p:nvPr/>
+        </p:nvSpPr>
+        <p:spPr>
+          <a:xfrm>
+            <a:off x="502920" y="3639312"/>
+            <a:ext cx="3520440" cy="457200"/>
+          </a:xfrm>
+          <a:prstGeom prst="rect">
+            <a:avLst/>
+          </a:prstGeom>
+          <a:noFill/>
+        </p:spPr>
+        <p:txBody>
+          <a:bodyPr wrap="square" anchor="t" lIns="0" rIns="0" tIns="0" bIns="0">
+            <a:spAutoFit/>
+          </a:bodyPr>
+          <a:lstStyle/>
+          <a:p>
+            <a:pPr algn="r"/>
+            <a:r>
+              <a:rPr sz="1400" b="1">
+                <a:solidFill>
+                  <a:srgbClr val="1A1A1A"/>
+                </a:solidFill>
+                <a:latin typeface="Calibri"/>
+              </a:rPr>
+              <a:t>Ours (amplification-joint)</a:t>
+            </a:r>
+          </a:p>
+        </p:txBody>
+      </p:sp>
+      <p:sp>
+        <p:nvSpPr>
+          <p:cNvPr id="16" name="Rounded Rectangle 15"/>
+          <p:cNvSpPr/>
+          <p:nvPr/>
+        </p:nvSpPr>
+        <p:spPr>
+          <a:xfrm>
+            <a:off x="4160520" y="3584448"/>
+            <a:ext cx="5505329" cy="420624"/>
+          </a:xfrm>
+          <a:prstGeom prst="roundRect">
+            <a:avLst/>
+          </a:prstGeom>
+          <a:solidFill>
+            <a:srgbClr val="2E8B57"/>
+          </a:solidFill>
+          <a:ln>
+            <a:noFill/>
+          </a:ln>
+          <a:effectLst/>
+        </p:spPr>
+        <p:style>
+          <a:lnRef idx="1">
+            <a:schemeClr val="accent1"/>
+          </a:lnRef>
+          <a:fillRef idx="3">
+            <a:schemeClr val="accent1"/>
+          </a:fillRef>
+          <a:effectRef idx="2">
+            <a:schemeClr val="accent1"/>
+          </a:effectRef>
+          <a:fontRef idx="minor">
+            <a:schemeClr val="lt1"/>
+          </a:fontRef>
+        </p:style>
+        <p:txBody>
+          <a:bodyPr rtlCol="0" anchor="ctr"/>
+          <a:lstStyle/>
+          <a:p>
+            <a:pPr algn="ctr"/>
+          </a:p>
+        </p:txBody>
+      </p:sp>
+      <p:sp>
+        <p:nvSpPr>
+          <p:cNvPr id="17" name="TextBox 16"/>
+          <p:cNvSpPr txBox="1"/>
+          <p:nvPr/>
+        </p:nvSpPr>
+        <p:spPr>
+          <a:xfrm>
+            <a:off x="9757289" y="3621024"/>
+            <a:ext cx="1280160" cy="365760"/>
+          </a:xfrm>
+          <a:prstGeom prst="rect">
+            <a:avLst/>
+          </a:prstGeom>
+          <a:noFill/>
+        </p:spPr>
+        <p:txBody>
+          <a:bodyPr wrap="square" anchor="t" lIns="0" rIns="0" tIns="0" bIns="0">
+            <a:spAutoFit/>
+          </a:bodyPr>
+          <a:lstStyle/>
+          <a:p>
+            <a:pPr algn="l"/>
+            <a:r>
+              <a:rPr sz="1500" b="1">
+                <a:solidFill>
+                  <a:srgbClr val="2E8B57"/>
+                </a:solidFill>
+                <a:latin typeface="Calibri"/>
+              </a:rPr>
+              <a:t>13.96</a:t>
+            </a:r>
+          </a:p>
+        </p:txBody>
+      </p:sp>
+      <p:sp>
+        <p:nvSpPr>
+          <p:cNvPr id="18" name="TextBox 17"/>
+          <p:cNvSpPr txBox="1"/>
+          <p:nvPr/>
+        </p:nvSpPr>
+        <p:spPr>
+          <a:xfrm>
+            <a:off x="4160520" y="4206240"/>
+            <a:ext cx="6858000" cy="274320"/>
+          </a:xfrm>
+          <a:prstGeom prst="rect">
+            <a:avLst/>
+          </a:prstGeom>
+          <a:noFill/>
+        </p:spPr>
+        <p:txBody>
+          <a:bodyPr wrap="square" anchor="t" lIns="0" rIns="0" tIns="0" bIns="0">
+            <a:spAutoFit/>
+          </a:bodyPr>
+          <a:lstStyle/>
+          <a:p>
+            <a:pPr algn="l"/>
+            <a:r>
+              <a:rPr sz="1100" b="1">
+                <a:solidFill>
+                  <a:srgbClr val="525252"/>
+                </a:solidFill>
+                <a:latin typeface="Calibri"/>
+              </a:rPr>
+              <a:t>perplexity  (lower = better)</a:t>
+            </a:r>
+          </a:p>
+        </p:txBody>
+      </p:sp>
+      <p:sp>
+        <p:nvSpPr>
+          <p:cNvPr id="19" name="Rectangle 18"/>
+          <p:cNvSpPr/>
+          <p:nvPr/>
+        </p:nvSpPr>
+        <p:spPr>
+          <a:xfrm>
+            <a:off x="365760" y="4617720"/>
+            <a:ext cx="5623560" cy="841248"/>
+          </a:xfrm>
+          <a:prstGeom prst="rect">
+            <a:avLst/>
+          </a:prstGeom>
+          <a:solidFill>
+            <a:srgbClr val="E2F0D9"/>
+          </a:solidFill>
+          <a:ln>
+            <a:noFill/>
+          </a:ln>
+          <a:effectLst/>
+        </p:spPr>
+        <p:style>
+          <a:lnRef idx="1">
+            <a:schemeClr val="accent1"/>
+          </a:lnRef>
+          <a:fillRef idx="3">
+            <a:schemeClr val="accent1"/>
+          </a:fillRef>
+          <a:effectRef idx="2">
+            <a:schemeClr val="accent1"/>
+          </a:effectRef>
+          <a:fontRef idx="minor">
+            <a:schemeClr val="lt1"/>
+          </a:fontRef>
+        </p:style>
+        <p:txBody>
+          <a:bodyPr rtlCol="0" anchor="ctr"/>
+          <a:lstStyle/>
+          <a:p>
+            <a:pPr algn="ctr"/>
+          </a:p>
+        </p:txBody>
+      </p:sp>
+      <p:sp>
+        <p:nvSpPr>
+          <p:cNvPr id="20" name="Rectangle 19"/>
+          <p:cNvSpPr/>
+          <p:nvPr/>
+        </p:nvSpPr>
+        <p:spPr>
+          <a:xfrm>
+            <a:off x="365760" y="4617720"/>
+            <a:ext cx="146304" cy="841248"/>
+          </a:xfrm>
+          <a:prstGeom prst="rect">
+            <a:avLst/>
+          </a:prstGeom>
+          <a:solidFill>
+            <a:srgbClr val="2E8B57"/>
+          </a:solidFill>
+          <a:ln>
+            <a:noFill/>
+          </a:ln>
+          <a:effectLst/>
+        </p:spPr>
+        <p:style>
+          <a:lnRef idx="1">
+            <a:schemeClr val="accent1"/>
+          </a:lnRef>
+          <a:fillRef idx="3">
+            <a:schemeClr val="accent1"/>
+          </a:fillRef>
+          <a:effectRef idx="2">
+            <a:schemeClr val="accent1"/>
+          </a:effectRef>
+          <a:fontRef idx="minor">
+            <a:schemeClr val="lt1"/>
+          </a:fontRef>
+        </p:style>
+        <p:txBody>
+          <a:bodyPr rtlCol="0" anchor="ctr"/>
+          <a:lstStyle/>
+          <a:p>
+            <a:pPr algn="ctr"/>
+          </a:p>
+        </p:txBody>
+      </p:sp>
+      <p:sp>
+        <p:nvSpPr>
+          <p:cNvPr id="21" name="TextBox 20"/>
+          <p:cNvSpPr txBox="1"/>
+          <p:nvPr/>
+        </p:nvSpPr>
+        <p:spPr>
+          <a:xfrm>
+            <a:off x="685800" y="4700016"/>
+            <a:ext cx="5212080" cy="731520"/>
+          </a:xfrm>
+          <a:prstGeom prst="rect">
+            <a:avLst/>
+          </a:prstGeom>
+          <a:noFill/>
+        </p:spPr>
+        <p:txBody>
+          <a:bodyPr wrap="square" anchor="t" lIns="0" rIns="0" tIns="0" bIns="0">
+            <a:spAutoFit/>
+          </a:bodyPr>
+          <a:lstStyle/>
+          <a:p>
+            <a:pPr algn="l"/>
+            <a:r>
+              <a:rPr sz="2600" b="1">
+                <a:solidFill>
+                  <a:srgbClr val="2E8B57"/>
+                </a:solidFill>
+                <a:latin typeface="Calibri"/>
+              </a:rPr>
+              <a:t>−4.2%</a:t>
+            </a:r>
+          </a:p>
+          <a:p>
+            <a:pPr algn="l"/>
+            <a:r>
+              <a:rPr sz="1200" b="0">
+                <a:solidFill>
+                  <a:srgbClr val="525252"/>
+                </a:solidFill>
+                <a:latin typeface="Calibri"/>
+              </a:rPr>
+              <a:t>vs FLAT-LLM  (faithful angular-BI baseline)</a:t>
+            </a:r>
+          </a:p>
+        </p:txBody>
+      </p:sp>
+      <p:sp>
+        <p:nvSpPr>
+          <p:cNvPr id="22" name="Rectangle 21"/>
+          <p:cNvSpPr/>
+          <p:nvPr/>
+        </p:nvSpPr>
+        <p:spPr>
+          <a:xfrm>
+            <a:off x="6172200" y="4617720"/>
+            <a:ext cx="5623560" cy="841248"/>
+          </a:xfrm>
+          <a:prstGeom prst="rect">
+            <a:avLst/>
+          </a:prstGeom>
+          <a:solidFill>
+            <a:srgbClr val="DEEBF7"/>
+          </a:solidFill>
+          <a:ln>
+            <a:noFill/>
+          </a:ln>
+          <a:effectLst/>
+        </p:spPr>
+        <p:style>
+          <a:lnRef idx="1">
+            <a:schemeClr val="accent1"/>
+          </a:lnRef>
+          <a:fillRef idx="3">
+            <a:schemeClr val="accent1"/>
+          </a:fillRef>
+          <a:effectRef idx="2">
+            <a:schemeClr val="accent1"/>
+          </a:effectRef>
+          <a:fontRef idx="minor">
+            <a:schemeClr val="lt1"/>
+          </a:fontRef>
+        </p:style>
+        <p:txBody>
+          <a:bodyPr rtlCol="0" anchor="ctr"/>
+          <a:lstStyle/>
+          <a:p>
+            <a:pPr algn="ctr"/>
+          </a:p>
+        </p:txBody>
+      </p:sp>
+      <p:sp>
+        <p:nvSpPr>
+          <p:cNvPr id="23" name="Rectangle 22"/>
+          <p:cNvSpPr/>
+          <p:nvPr/>
+        </p:nvSpPr>
+        <p:spPr>
+          <a:xfrm>
+            <a:off x="6172200" y="4617720"/>
+            <a:ext cx="146304" cy="841248"/>
+          </a:xfrm>
+          <a:prstGeom prst="rect">
+            <a:avLst/>
+          </a:prstGeom>
+          <a:solidFill>
+            <a:srgbClr val="0068B5"/>
+          </a:solidFill>
+          <a:ln>
+            <a:noFill/>
+          </a:ln>
+          <a:effectLst/>
+        </p:spPr>
+        <p:style>
+          <a:lnRef idx="1">
+            <a:schemeClr val="accent1"/>
+          </a:lnRef>
+          <a:fillRef idx="3">
+            <a:schemeClr val="accent1"/>
+          </a:fillRef>
+          <a:effectRef idx="2">
+            <a:schemeClr val="accent1"/>
+          </a:effectRef>
+          <a:fontRef idx="minor">
+            <a:schemeClr val="lt1"/>
+          </a:fontRef>
+        </p:style>
+        <p:txBody>
+          <a:bodyPr rtlCol="0" anchor="ctr"/>
+          <a:lstStyle/>
+          <a:p>
+            <a:pPr algn="ctr"/>
+          </a:p>
+        </p:txBody>
+      </p:sp>
+      <p:sp>
+        <p:nvSpPr>
+          <p:cNvPr id="24" name="TextBox 23"/>
+          <p:cNvSpPr txBox="1"/>
+          <p:nvPr/>
+        </p:nvSpPr>
+        <p:spPr>
+          <a:xfrm>
+            <a:off x="6492240" y="4700016"/>
+            <a:ext cx="5212080" cy="731520"/>
+          </a:xfrm>
+          <a:prstGeom prst="rect">
+            <a:avLst/>
+          </a:prstGeom>
+          <a:noFill/>
+        </p:spPr>
+        <p:txBody>
+          <a:bodyPr wrap="square" anchor="t" lIns="0" rIns="0" tIns="0" bIns="0">
+            <a:spAutoFit/>
+          </a:bodyPr>
+          <a:lstStyle/>
+          <a:p>
+            <a:pPr algn="l"/>
+            <a:r>
+              <a:rPr sz="2600" b="1">
+                <a:solidFill>
+                  <a:srgbClr val="0068B5"/>
+                </a:solidFill>
+                <a:latin typeface="Calibri"/>
+              </a:rPr>
+              <a:t>−19.7%</a:t>
+            </a:r>
+          </a:p>
+          <a:p>
+            <a:pPr algn="l"/>
+            <a:r>
+              <a:rPr sz="1200" b="0">
+                <a:solidFill>
+                  <a:srgbClr val="525252"/>
+                </a:solidFill>
+                <a:latin typeface="Calibri"/>
+              </a:rPr>
+              <a:t>vs Uniform allocation</a:t>
+            </a:r>
+          </a:p>
+        </p:txBody>
+      </p:sp>
+      <p:sp>
+        <p:nvSpPr>
+          <p:cNvPr id="25" name="Rectangle 24"/>
+          <p:cNvSpPr/>
+          <p:nvPr/>
+        </p:nvSpPr>
+        <p:spPr>
+          <a:xfrm>
+            <a:off x="365760" y="5605272"/>
+            <a:ext cx="11430000" cy="868680"/>
+          </a:xfrm>
+          <a:prstGeom prst="rect">
+            <a:avLst/>
+          </a:prstGeom>
+          <a:solidFill>
+            <a:srgbClr val="FFF2CC"/>
+          </a:solidFill>
+          <a:ln>
+            <a:noFill/>
+          </a:ln>
+          <a:effectLst/>
+        </p:spPr>
+        <p:style>
+          <a:lnRef idx="1">
+            <a:schemeClr val="accent1"/>
+          </a:lnRef>
+          <a:fillRef idx="3">
+            <a:schemeClr val="accent1"/>
+          </a:fillRef>
+          <a:effectRef idx="2">
+            <a:schemeClr val="accent1"/>
+          </a:effectRef>
+          <a:fontRef idx="minor">
+            <a:schemeClr val="lt1"/>
+          </a:fontRef>
+        </p:style>
+        <p:txBody>
+          <a:bodyPr rtlCol="0" anchor="ctr"/>
+          <a:lstStyle/>
+          <a:p>
+            <a:pPr algn="ctr"/>
+          </a:p>
+        </p:txBody>
+      </p:sp>
+      <p:sp>
+        <p:nvSpPr>
+          <p:cNvPr id="26" name="Rectangle 25"/>
+          <p:cNvSpPr/>
+          <p:nvPr/>
+        </p:nvSpPr>
+        <p:spPr>
+          <a:xfrm>
+            <a:off x="365760" y="5605272"/>
+            <a:ext cx="146304" cy="868680"/>
+          </a:xfrm>
+          <a:prstGeom prst="rect">
+            <a:avLst/>
+          </a:prstGeom>
+          <a:solidFill>
+            <a:srgbClr val="FFA300"/>
+          </a:solidFill>
+          <a:ln>
+            <a:noFill/>
+          </a:ln>
+          <a:effectLst/>
+        </p:spPr>
+        <p:style>
+          <a:lnRef idx="1">
+            <a:schemeClr val="accent1"/>
+          </a:lnRef>
+          <a:fillRef idx="3">
+            <a:schemeClr val="accent1"/>
+          </a:fillRef>
+          <a:effectRef idx="2">
+            <a:schemeClr val="accent1"/>
+          </a:effectRef>
+          <a:fontRef idx="minor">
+            <a:schemeClr val="lt1"/>
+          </a:fontRef>
+        </p:style>
+        <p:txBody>
+          <a:bodyPr rtlCol="0" anchor="ctr"/>
+          <a:lstStyle/>
+          <a:p>
+            <a:pPr algn="ctr"/>
+          </a:p>
+        </p:txBody>
+      </p:sp>
+      <p:sp>
+        <p:nvSpPr>
+          <p:cNvPr id="27" name="TextBox 26"/>
+          <p:cNvSpPr txBox="1"/>
+          <p:nvPr/>
+        </p:nvSpPr>
+        <p:spPr>
+          <a:xfrm>
+            <a:off x="685800" y="5669280"/>
+            <a:ext cx="10972800" cy="777240"/>
+          </a:xfrm>
+          <a:prstGeom prst="rect">
+            <a:avLst/>
+          </a:prstGeom>
+          <a:noFill/>
+        </p:spPr>
+        <p:txBody>
+          <a:bodyPr wrap="square" anchor="t" lIns="0" rIns="0" tIns="0" bIns="0">
+            <a:spAutoFit/>
+          </a:bodyPr>
+          <a:lstStyle/>
+          <a:p>
+            <a:pPr algn="l"/>
+            <a:r>
+              <a:rPr sz="1200" b="1">
+                <a:solidFill>
+                  <a:srgbClr val="FFA300"/>
+                </a:solidFill>
+                <a:latin typeface="Calibri"/>
+              </a:rPr>
+              <a:t>Why we win — the signals disagree:  </a:t>
+            </a:r>
+            <a:r>
+              <a:rPr sz="1200" b="0">
+                <a:solidFill>
+                  <a:srgbClr val="1A1A1A"/>
+                </a:solidFill>
+                <a:latin typeface="Calibri"/>
+              </a:rPr>
+              <a:t>FLAT-LLM’s angular BI protects boundary layers (0, 31, high residual rotation);</a:t>
+            </a:r>
+          </a:p>
+          <a:p>
+            <a:pPr algn="l"/>
+            <a:r>
+              <a:rPr sz="1200" b="0">
+                <a:solidFill>
+                  <a:srgbClr val="1A1A1A"/>
+                </a:solidFill>
+                <a:latin typeface="Calibri"/>
+              </a:rPr>
+              <a:t>amplification instead protects high-downstream-impact mid-early layers (2–5) and drains the damping tail.  </a:t>
+            </a:r>
+            <a:r>
+              <a:rPr sz="1200" b="1">
+                <a:solidFill>
+                  <a:srgbClr val="1A1A1A"/>
+                </a:solidFill>
+                <a:latin typeface="Calibri"/>
+              </a:rPr>
+              <a:t>Amp captures sensitivity BI misses.</a:t>
             </a:r>
           </a:p>
         </p:txBody>

</xml_diff>

<commit_message>
Add 2 setup slides before findings: what SOTA/FLAT-LLM does + the weakness we cure
Deck now 14 slides: setup (low-rank primitive, budget, FLAT-LLM IPRS) and the
novelty (error-propagation-aware joint allocation) precede the 3 findings.
Reordered + renumbered shifted slides.

Co-Authored-By: Claude Sonnet 4.6 <noreply@anthropic.com>
</commit_message>
<xml_diff>
--- a/hypergraph_slides.pptx
+++ b/hypergraph_slides.pptx
@@ -14,6 +14,8 @@
     <p:sldId id="262" r:id="rId13"/>
     <p:sldId id="263" r:id="rId14"/>
     <p:sldId id="264" r:id="rId15"/>
+    <p:sldId id="268" r:id="rId19"/>
+    <p:sldId id="269" r:id="rId20"/>
     <p:sldId id="265" r:id="rId16"/>
     <p:sldId id="266" r:id="rId17"/>
     <p:sldId id="267" r:id="rId18"/>
@@ -3787,7 +3789,7 @@
                 </a:solidFill>
                 <a:latin typeface="Calibri"/>
               </a:rPr>
-              <a:t>10</a:t>
+              <a:t>11</a:t>
             </a:r>
           </a:p>
         </p:txBody>
@@ -5219,7 +5221,7 @@
                 </a:solidFill>
                 <a:latin typeface="Calibri"/>
               </a:rPr>
-              <a:t>11</a:t>
+              <a:t>12</a:t>
             </a:r>
           </a:p>
         </p:txBody>
@@ -6265,7 +6267,7 @@
                 </a:solidFill>
                 <a:latin typeface="Calibri"/>
               </a:rPr>
-              <a:t>12</a:t>
+              <a:t>13</a:t>
             </a:r>
           </a:p>
         </p:txBody>
@@ -7251,6 +7253,1895 @@
                 <a:latin typeface="Calibri"/>
               </a:rPr>
               <a:t>Amp captures sensitivity BI misses.</a:t>
+            </a:r>
+          </a:p>
+        </p:txBody>
+      </p:sp>
+    </p:spTree>
+  </p:cSld>
+  <p:clrMapOvr>
+    <a:masterClrMapping/>
+  </p:clrMapOvr>
+</p:sld>
+</file>
+
+<file path=ppt/slides/slide13.xml><?xml version="1.0" encoding="utf-8"?>
+<p:sld xmlns:a="http://schemas.openxmlformats.org/drawingml/2006/main" xmlns:p="http://schemas.openxmlformats.org/presentationml/2006/main" xmlns:r="http://schemas.openxmlformats.org/officeDocument/2006/relationships">
+  <p:cSld>
+    <p:spTree>
+      <p:nvGrpSpPr>
+        <p:cNvPr id="1" name=""/>
+        <p:cNvGrpSpPr/>
+        <p:nvPr/>
+      </p:nvGrpSpPr>
+      <p:grpSpPr/>
+      <p:sp>
+        <p:nvSpPr>
+          <p:cNvPr id="2" name="TextBox 1"/>
+          <p:cNvSpPr txBox="1"/>
+          <p:nvPr/>
+        </p:nvSpPr>
+        <p:spPr>
+          <a:xfrm>
+            <a:off x="365760" y="228600"/>
+            <a:ext cx="11430000" cy="548640"/>
+          </a:xfrm>
+          <a:prstGeom prst="rect">
+            <a:avLst/>
+          </a:prstGeom>
+          <a:noFill/>
+        </p:spPr>
+        <p:txBody>
+          <a:bodyPr wrap="square" anchor="t" lIns="0" rIns="0" tIns="0" bIns="0">
+            <a:spAutoFit/>
+          </a:bodyPr>
+          <a:lstStyle/>
+          <a:p>
+            <a:pPr algn="l"/>
+            <a:r>
+              <a:rPr sz="2800" b="1">
+                <a:solidFill>
+                  <a:srgbClr val="1A1A1A"/>
+                </a:solidFill>
+                <a:latin typeface="Calibri"/>
+              </a:rPr>
+              <a:t>Background:  How SOTA Compresses an LLM (e.g. FLAT-LLM)</a:t>
+            </a:r>
+          </a:p>
+        </p:txBody>
+      </p:sp>
+      <p:sp>
+        <p:nvSpPr>
+          <p:cNvPr id="3" name="Rectangle 2"/>
+          <p:cNvSpPr/>
+          <p:nvPr/>
+        </p:nvSpPr>
+        <p:spPr>
+          <a:xfrm>
+            <a:off x="365760" y="795528"/>
+            <a:ext cx="11457432" cy="27432"/>
+          </a:xfrm>
+          <a:prstGeom prst="rect">
+            <a:avLst/>
+          </a:prstGeom>
+          <a:solidFill>
+            <a:srgbClr val="0068B5"/>
+          </a:solidFill>
+          <a:ln>
+            <a:noFill/>
+          </a:ln>
+          <a:effectLst/>
+        </p:spPr>
+        <p:style>
+          <a:lnRef idx="1">
+            <a:schemeClr val="accent1"/>
+          </a:lnRef>
+          <a:fillRef idx="3">
+            <a:schemeClr val="accent1"/>
+          </a:fillRef>
+          <a:effectRef idx="2">
+            <a:schemeClr val="accent1"/>
+          </a:effectRef>
+          <a:fontRef idx="minor">
+            <a:schemeClr val="lt1"/>
+          </a:fontRef>
+        </p:style>
+        <p:txBody>
+          <a:bodyPr rtlCol="0" anchor="ctr"/>
+          <a:lstStyle/>
+          <a:p>
+            <a:pPr algn="ctr"/>
+          </a:p>
+        </p:txBody>
+      </p:sp>
+      <p:sp>
+        <p:nvSpPr>
+          <p:cNvPr id="4" name="TextBox 3"/>
+          <p:cNvSpPr txBox="1"/>
+          <p:nvPr/>
+        </p:nvSpPr>
+        <p:spPr>
+          <a:xfrm>
+            <a:off x="11430000" y="6492240"/>
+            <a:ext cx="640080" cy="274320"/>
+          </a:xfrm>
+          <a:prstGeom prst="rect">
+            <a:avLst/>
+          </a:prstGeom>
+          <a:noFill/>
+        </p:spPr>
+        <p:txBody>
+          <a:bodyPr wrap="square" anchor="t" lIns="0" rIns="0" tIns="0" bIns="0">
+            <a:spAutoFit/>
+          </a:bodyPr>
+          <a:lstStyle/>
+          <a:p>
+            <a:pPr algn="r"/>
+            <a:r>
+              <a:rPr sz="1000" b="0">
+                <a:solidFill>
+                  <a:srgbClr val="AAAAAA"/>
+                </a:solidFill>
+                <a:latin typeface="Calibri"/>
+              </a:rPr>
+              <a:t>9</a:t>
+            </a:r>
+          </a:p>
+        </p:txBody>
+      </p:sp>
+      <p:sp>
+        <p:nvSpPr>
+          <p:cNvPr id="5" name="TextBox 4"/>
+          <p:cNvSpPr txBox="1"/>
+          <p:nvPr/>
+        </p:nvSpPr>
+        <p:spPr>
+          <a:xfrm>
+            <a:off x="365760" y="932688"/>
+            <a:ext cx="11430000" cy="365760"/>
+          </a:xfrm>
+          <a:prstGeom prst="rect">
+            <a:avLst/>
+          </a:prstGeom>
+          <a:noFill/>
+        </p:spPr>
+        <p:txBody>
+          <a:bodyPr wrap="square" anchor="t" lIns="0" rIns="0" tIns="0" bIns="0">
+            <a:spAutoFit/>
+          </a:bodyPr>
+          <a:lstStyle/>
+          <a:p>
+            <a:pPr algn="l"/>
+            <a:r>
+              <a:rPr sz="1500" b="1">
+                <a:solidFill>
+                  <a:srgbClr val="1A1A1A"/>
+                </a:solidFill>
+                <a:latin typeface="Calibri"/>
+              </a:rPr>
+              <a:t>To shrink a model, low-rank methods replace each layer's FFN with a </a:t>
+            </a:r>
+            <a:r>
+              <a:rPr sz="1500" b="1">
+                <a:solidFill>
+                  <a:srgbClr val="0068B5"/>
+                </a:solidFill>
+                <a:latin typeface="Calibri"/>
+              </a:rPr>
+              <a:t>smaller approximation</a:t>
+            </a:r>
+            <a:r>
+              <a:rPr sz="1500" b="1">
+                <a:solidFill>
+                  <a:srgbClr val="1A1A1A"/>
+                </a:solidFill>
+                <a:latin typeface="Calibri"/>
+              </a:rPr>
+              <a:t> that keeps only its most useful directions.</a:t>
+            </a:r>
+          </a:p>
+        </p:txBody>
+      </p:sp>
+      <p:sp>
+        <p:nvSpPr>
+          <p:cNvPr id="6" name="Rectangle 5"/>
+          <p:cNvSpPr/>
+          <p:nvPr/>
+        </p:nvSpPr>
+        <p:spPr>
+          <a:xfrm>
+            <a:off x="365760" y="1481328"/>
+            <a:ext cx="11430000" cy="1243584"/>
+          </a:xfrm>
+          <a:prstGeom prst="rect">
+            <a:avLst/>
+          </a:prstGeom>
+          <a:solidFill>
+            <a:srgbClr val="DEEBF7"/>
+          </a:solidFill>
+          <a:ln>
+            <a:noFill/>
+          </a:ln>
+          <a:effectLst/>
+        </p:spPr>
+        <p:style>
+          <a:lnRef idx="1">
+            <a:schemeClr val="accent1"/>
+          </a:lnRef>
+          <a:fillRef idx="3">
+            <a:schemeClr val="accent1"/>
+          </a:fillRef>
+          <a:effectRef idx="2">
+            <a:schemeClr val="accent1"/>
+          </a:effectRef>
+          <a:fontRef idx="minor">
+            <a:schemeClr val="lt1"/>
+          </a:fontRef>
+        </p:style>
+        <p:txBody>
+          <a:bodyPr rtlCol="0" anchor="ctr"/>
+          <a:lstStyle/>
+          <a:p>
+            <a:pPr algn="ctr"/>
+          </a:p>
+        </p:txBody>
+      </p:sp>
+      <p:sp>
+        <p:nvSpPr>
+          <p:cNvPr id="7" name="Rectangle 6"/>
+          <p:cNvSpPr/>
+          <p:nvPr/>
+        </p:nvSpPr>
+        <p:spPr>
+          <a:xfrm>
+            <a:off x="365760" y="1481328"/>
+            <a:ext cx="146304" cy="1243584"/>
+          </a:xfrm>
+          <a:prstGeom prst="rect">
+            <a:avLst/>
+          </a:prstGeom>
+          <a:solidFill>
+            <a:srgbClr val="0068B5"/>
+          </a:solidFill>
+          <a:ln>
+            <a:noFill/>
+          </a:ln>
+          <a:effectLst/>
+        </p:spPr>
+        <p:style>
+          <a:lnRef idx="1">
+            <a:schemeClr val="accent1"/>
+          </a:lnRef>
+          <a:fillRef idx="3">
+            <a:schemeClr val="accent1"/>
+          </a:fillRef>
+          <a:effectRef idx="2">
+            <a:schemeClr val="accent1"/>
+          </a:effectRef>
+          <a:fontRef idx="minor">
+            <a:schemeClr val="lt1"/>
+          </a:fontRef>
+        </p:style>
+        <p:txBody>
+          <a:bodyPr rtlCol="0" anchor="ctr"/>
+          <a:lstStyle/>
+          <a:p>
+            <a:pPr algn="ctr"/>
+          </a:p>
+        </p:txBody>
+      </p:sp>
+      <p:sp>
+        <p:nvSpPr>
+          <p:cNvPr id="8" name="Oval 7"/>
+          <p:cNvSpPr/>
+          <p:nvPr/>
+        </p:nvSpPr>
+        <p:spPr>
+          <a:xfrm>
+            <a:off x="667512" y="1764792"/>
+            <a:ext cx="676656" cy="676656"/>
+          </a:xfrm>
+          <a:prstGeom prst="ellipse">
+            <a:avLst/>
+          </a:prstGeom>
+          <a:solidFill>
+            <a:srgbClr val="0068B5"/>
+          </a:solidFill>
+          <a:ln>
+            <a:noFill/>
+          </a:ln>
+          <a:effectLst/>
+        </p:spPr>
+        <p:style>
+          <a:lnRef idx="1">
+            <a:schemeClr val="accent1"/>
+          </a:lnRef>
+          <a:fillRef idx="3">
+            <a:schemeClr val="accent1"/>
+          </a:fillRef>
+          <a:effectRef idx="2">
+            <a:schemeClr val="accent1"/>
+          </a:effectRef>
+          <a:fontRef idx="minor">
+            <a:schemeClr val="lt1"/>
+          </a:fontRef>
+        </p:style>
+        <p:txBody>
+          <a:bodyPr rtlCol="0" anchor="ctr"/>
+          <a:lstStyle/>
+          <a:p>
+            <a:pPr algn="ctr"/>
+          </a:p>
+        </p:txBody>
+      </p:sp>
+      <p:sp>
+        <p:nvSpPr>
+          <p:cNvPr id="9" name="TextBox 8"/>
+          <p:cNvSpPr txBox="1"/>
+          <p:nvPr/>
+        </p:nvSpPr>
+        <p:spPr>
+          <a:xfrm>
+            <a:off x="667512" y="1792224"/>
+            <a:ext cx="676656" cy="640080"/>
+          </a:xfrm>
+          <a:prstGeom prst="rect">
+            <a:avLst/>
+          </a:prstGeom>
+          <a:noFill/>
+        </p:spPr>
+        <p:txBody>
+          <a:bodyPr wrap="square" anchor="ctr" lIns="0" rIns="0" tIns="0" bIns="0">
+            <a:spAutoFit/>
+          </a:bodyPr>
+          <a:lstStyle/>
+          <a:p>
+            <a:pPr algn="ctr"/>
+            <a:r>
+              <a:rPr sz="2600" b="1">
+                <a:solidFill>
+                  <a:srgbClr val="FFFFFF"/>
+                </a:solidFill>
+                <a:latin typeface="Calibri"/>
+              </a:rPr>
+              <a:t>1</a:t>
+            </a:r>
+          </a:p>
+        </p:txBody>
+      </p:sp>
+      <p:sp>
+        <p:nvSpPr>
+          <p:cNvPr id="10" name="TextBox 9"/>
+          <p:cNvSpPr txBox="1"/>
+          <p:nvPr/>
+        </p:nvSpPr>
+        <p:spPr>
+          <a:xfrm>
+            <a:off x="1545336" y="1645920"/>
+            <a:ext cx="9966960" cy="365760"/>
+          </a:xfrm>
+          <a:prstGeom prst="rect">
+            <a:avLst/>
+          </a:prstGeom>
+          <a:noFill/>
+        </p:spPr>
+        <p:txBody>
+          <a:bodyPr wrap="square" anchor="t" lIns="0" rIns="0" tIns="0" bIns="0">
+            <a:spAutoFit/>
+          </a:bodyPr>
+          <a:lstStyle/>
+          <a:p>
+            <a:pPr algn="l"/>
+            <a:r>
+              <a:rPr sz="1800" b="1">
+                <a:solidFill>
+                  <a:srgbClr val="0068B5"/>
+                </a:solidFill>
+                <a:latin typeface="Calibri"/>
+              </a:rPr>
+              <a:t>The primitive</a:t>
+            </a:r>
+          </a:p>
+        </p:txBody>
+      </p:sp>
+      <p:sp>
+        <p:nvSpPr>
+          <p:cNvPr id="11" name="TextBox 10"/>
+          <p:cNvSpPr txBox="1"/>
+          <p:nvPr/>
+        </p:nvSpPr>
+        <p:spPr>
+          <a:xfrm>
+            <a:off x="1545336" y="2048256"/>
+            <a:ext cx="9966960" cy="640080"/>
+          </a:xfrm>
+          <a:prstGeom prst="rect">
+            <a:avLst/>
+          </a:prstGeom>
+          <a:noFill/>
+        </p:spPr>
+        <p:txBody>
+          <a:bodyPr wrap="square" anchor="t" lIns="0" rIns="0" tIns="0" bIns="0">
+            <a:spAutoFit/>
+          </a:bodyPr>
+          <a:lstStyle/>
+          <a:p>
+            <a:pPr algn="l"/>
+            <a:r>
+              <a:rPr sz="1300" b="0">
+                <a:solidFill>
+                  <a:srgbClr val="525252"/>
+                </a:solidFill>
+                <a:latin typeface="Calibri"/>
+              </a:rPr>
+              <a:t>Each FFN is approximated by a low-rank factor in activation space (keep the top-k PCA directions of its hidden units).  Fewer directions = less compute.</a:t>
+            </a:r>
+          </a:p>
+        </p:txBody>
+      </p:sp>
+      <p:sp>
+        <p:nvSpPr>
+          <p:cNvPr id="12" name="Rectangle 11"/>
+          <p:cNvSpPr/>
+          <p:nvPr/>
+        </p:nvSpPr>
+        <p:spPr>
+          <a:xfrm>
+            <a:off x="365760" y="2852928"/>
+            <a:ext cx="11430000" cy="1243584"/>
+          </a:xfrm>
+          <a:prstGeom prst="rect">
+            <a:avLst/>
+          </a:prstGeom>
+          <a:solidFill>
+            <a:srgbClr val="FFF2CC"/>
+          </a:solidFill>
+          <a:ln>
+            <a:noFill/>
+          </a:ln>
+          <a:effectLst/>
+        </p:spPr>
+        <p:style>
+          <a:lnRef idx="1">
+            <a:schemeClr val="accent1"/>
+          </a:lnRef>
+          <a:fillRef idx="3">
+            <a:schemeClr val="accent1"/>
+          </a:fillRef>
+          <a:effectRef idx="2">
+            <a:schemeClr val="accent1"/>
+          </a:effectRef>
+          <a:fontRef idx="minor">
+            <a:schemeClr val="lt1"/>
+          </a:fontRef>
+        </p:style>
+        <p:txBody>
+          <a:bodyPr rtlCol="0" anchor="ctr"/>
+          <a:lstStyle/>
+          <a:p>
+            <a:pPr algn="ctr"/>
+          </a:p>
+        </p:txBody>
+      </p:sp>
+      <p:sp>
+        <p:nvSpPr>
+          <p:cNvPr id="13" name="Rectangle 12"/>
+          <p:cNvSpPr/>
+          <p:nvPr/>
+        </p:nvSpPr>
+        <p:spPr>
+          <a:xfrm>
+            <a:off x="365760" y="2852928"/>
+            <a:ext cx="146304" cy="1243584"/>
+          </a:xfrm>
+          <a:prstGeom prst="rect">
+            <a:avLst/>
+          </a:prstGeom>
+          <a:solidFill>
+            <a:srgbClr val="FFA300"/>
+          </a:solidFill>
+          <a:ln>
+            <a:noFill/>
+          </a:ln>
+          <a:effectLst/>
+        </p:spPr>
+        <p:style>
+          <a:lnRef idx="1">
+            <a:schemeClr val="accent1"/>
+          </a:lnRef>
+          <a:fillRef idx="3">
+            <a:schemeClr val="accent1"/>
+          </a:fillRef>
+          <a:effectRef idx="2">
+            <a:schemeClr val="accent1"/>
+          </a:effectRef>
+          <a:fontRef idx="minor">
+            <a:schemeClr val="lt1"/>
+          </a:fontRef>
+        </p:style>
+        <p:txBody>
+          <a:bodyPr rtlCol="0" anchor="ctr"/>
+          <a:lstStyle/>
+          <a:p>
+            <a:pPr algn="ctr"/>
+          </a:p>
+        </p:txBody>
+      </p:sp>
+      <p:sp>
+        <p:nvSpPr>
+          <p:cNvPr id="14" name="Oval 13"/>
+          <p:cNvSpPr/>
+          <p:nvPr/>
+        </p:nvSpPr>
+        <p:spPr>
+          <a:xfrm>
+            <a:off x="667512" y="3136392"/>
+            <a:ext cx="676656" cy="676656"/>
+          </a:xfrm>
+          <a:prstGeom prst="ellipse">
+            <a:avLst/>
+          </a:prstGeom>
+          <a:solidFill>
+            <a:srgbClr val="FFA300"/>
+          </a:solidFill>
+          <a:ln>
+            <a:noFill/>
+          </a:ln>
+          <a:effectLst/>
+        </p:spPr>
+        <p:style>
+          <a:lnRef idx="1">
+            <a:schemeClr val="accent1"/>
+          </a:lnRef>
+          <a:fillRef idx="3">
+            <a:schemeClr val="accent1"/>
+          </a:fillRef>
+          <a:effectRef idx="2">
+            <a:schemeClr val="accent1"/>
+          </a:effectRef>
+          <a:fontRef idx="minor">
+            <a:schemeClr val="lt1"/>
+          </a:fontRef>
+        </p:style>
+        <p:txBody>
+          <a:bodyPr rtlCol="0" anchor="ctr"/>
+          <a:lstStyle/>
+          <a:p>
+            <a:pPr algn="ctr"/>
+          </a:p>
+        </p:txBody>
+      </p:sp>
+      <p:sp>
+        <p:nvSpPr>
+          <p:cNvPr id="15" name="TextBox 14"/>
+          <p:cNvSpPr txBox="1"/>
+          <p:nvPr/>
+        </p:nvSpPr>
+        <p:spPr>
+          <a:xfrm>
+            <a:off x="667512" y="3163824"/>
+            <a:ext cx="676656" cy="640080"/>
+          </a:xfrm>
+          <a:prstGeom prst="rect">
+            <a:avLst/>
+          </a:prstGeom>
+          <a:noFill/>
+        </p:spPr>
+        <p:txBody>
+          <a:bodyPr wrap="square" anchor="ctr" lIns="0" rIns="0" tIns="0" bIns="0">
+            <a:spAutoFit/>
+          </a:bodyPr>
+          <a:lstStyle/>
+          <a:p>
+            <a:pPr algn="ctr"/>
+            <a:r>
+              <a:rPr sz="2600" b="1">
+                <a:solidFill>
+                  <a:srgbClr val="FFFFFF"/>
+                </a:solidFill>
+                <a:latin typeface="Calibri"/>
+              </a:rPr>
+              <a:t>2</a:t>
+            </a:r>
+          </a:p>
+        </p:txBody>
+      </p:sp>
+      <p:sp>
+        <p:nvSpPr>
+          <p:cNvPr id="16" name="TextBox 15"/>
+          <p:cNvSpPr txBox="1"/>
+          <p:nvPr/>
+        </p:nvSpPr>
+        <p:spPr>
+          <a:xfrm>
+            <a:off x="1545336" y="3017520"/>
+            <a:ext cx="9966960" cy="365760"/>
+          </a:xfrm>
+          <a:prstGeom prst="rect">
+            <a:avLst/>
+          </a:prstGeom>
+          <a:noFill/>
+        </p:spPr>
+        <p:txBody>
+          <a:bodyPr wrap="square" anchor="t" lIns="0" rIns="0" tIns="0" bIns="0">
+            <a:spAutoFit/>
+          </a:bodyPr>
+          <a:lstStyle/>
+          <a:p>
+            <a:pPr algn="l"/>
+            <a:r>
+              <a:rPr sz="1800" b="1">
+                <a:solidFill>
+                  <a:srgbClr val="FFA300"/>
+                </a:solidFill>
+                <a:latin typeface="Calibri"/>
+              </a:rPr>
+              <a:t>The budget</a:t>
+            </a:r>
+          </a:p>
+        </p:txBody>
+      </p:sp>
+      <p:sp>
+        <p:nvSpPr>
+          <p:cNvPr id="17" name="TextBox 16"/>
+          <p:cNvSpPr txBox="1"/>
+          <p:nvPr/>
+        </p:nvSpPr>
+        <p:spPr>
+          <a:xfrm>
+            <a:off x="1545336" y="3419856"/>
+            <a:ext cx="9966960" cy="640080"/>
+          </a:xfrm>
+          <a:prstGeom prst="rect">
+            <a:avLst/>
+          </a:prstGeom>
+          <a:noFill/>
+        </p:spPr>
+        <p:txBody>
+          <a:bodyPr wrap="square" anchor="t" lIns="0" rIns="0" tIns="0" bIns="0">
+            <a:spAutoFit/>
+          </a:bodyPr>
+          <a:lstStyle/>
+          <a:p>
+            <a:pPr algn="l"/>
+            <a:r>
+              <a:rPr sz="1300" b="0">
+                <a:solidFill>
+                  <a:srgbClr val="525252"/>
+                </a:solidFill>
+                <a:latin typeface="Calibri"/>
+              </a:rPr>
+              <a:t>A fixed total rank is shared across all 32 layers.  The core question: how much rank does each layer get?</a:t>
+            </a:r>
+          </a:p>
+        </p:txBody>
+      </p:sp>
+      <p:sp>
+        <p:nvSpPr>
+          <p:cNvPr id="18" name="Rectangle 17"/>
+          <p:cNvSpPr/>
+          <p:nvPr/>
+        </p:nvSpPr>
+        <p:spPr>
+          <a:xfrm>
+            <a:off x="365760" y="4224528"/>
+            <a:ext cx="11430000" cy="1243584"/>
+          </a:xfrm>
+          <a:prstGeom prst="rect">
+            <a:avLst/>
+          </a:prstGeom>
+          <a:solidFill>
+            <a:srgbClr val="FCE4D6"/>
+          </a:solidFill>
+          <a:ln>
+            <a:noFill/>
+          </a:ln>
+          <a:effectLst/>
+        </p:spPr>
+        <p:style>
+          <a:lnRef idx="1">
+            <a:schemeClr val="accent1"/>
+          </a:lnRef>
+          <a:fillRef idx="3">
+            <a:schemeClr val="accent1"/>
+          </a:fillRef>
+          <a:effectRef idx="2">
+            <a:schemeClr val="accent1"/>
+          </a:effectRef>
+          <a:fontRef idx="minor">
+            <a:schemeClr val="lt1"/>
+          </a:fontRef>
+        </p:style>
+        <p:txBody>
+          <a:bodyPr rtlCol="0" anchor="ctr"/>
+          <a:lstStyle/>
+          <a:p>
+            <a:pPr algn="ctr"/>
+          </a:p>
+        </p:txBody>
+      </p:sp>
+      <p:sp>
+        <p:nvSpPr>
+          <p:cNvPr id="19" name="Rectangle 18"/>
+          <p:cNvSpPr/>
+          <p:nvPr/>
+        </p:nvSpPr>
+        <p:spPr>
+          <a:xfrm>
+            <a:off x="365760" y="4224528"/>
+            <a:ext cx="146304" cy="1243584"/>
+          </a:xfrm>
+          <a:prstGeom prst="rect">
+            <a:avLst/>
+          </a:prstGeom>
+          <a:solidFill>
+            <a:srgbClr val="C0504D"/>
+          </a:solidFill>
+          <a:ln>
+            <a:noFill/>
+          </a:ln>
+          <a:effectLst/>
+        </p:spPr>
+        <p:style>
+          <a:lnRef idx="1">
+            <a:schemeClr val="accent1"/>
+          </a:lnRef>
+          <a:fillRef idx="3">
+            <a:schemeClr val="accent1"/>
+          </a:fillRef>
+          <a:effectRef idx="2">
+            <a:schemeClr val="accent1"/>
+          </a:effectRef>
+          <a:fontRef idx="minor">
+            <a:schemeClr val="lt1"/>
+          </a:fontRef>
+        </p:style>
+        <p:txBody>
+          <a:bodyPr rtlCol="0" anchor="ctr"/>
+          <a:lstStyle/>
+          <a:p>
+            <a:pPr algn="ctr"/>
+          </a:p>
+        </p:txBody>
+      </p:sp>
+      <p:sp>
+        <p:nvSpPr>
+          <p:cNvPr id="20" name="Oval 19"/>
+          <p:cNvSpPr/>
+          <p:nvPr/>
+        </p:nvSpPr>
+        <p:spPr>
+          <a:xfrm>
+            <a:off x="667512" y="4507992"/>
+            <a:ext cx="676656" cy="676656"/>
+          </a:xfrm>
+          <a:prstGeom prst="ellipse">
+            <a:avLst/>
+          </a:prstGeom>
+          <a:solidFill>
+            <a:srgbClr val="C0504D"/>
+          </a:solidFill>
+          <a:ln>
+            <a:noFill/>
+          </a:ln>
+          <a:effectLst/>
+        </p:spPr>
+        <p:style>
+          <a:lnRef idx="1">
+            <a:schemeClr val="accent1"/>
+          </a:lnRef>
+          <a:fillRef idx="3">
+            <a:schemeClr val="accent1"/>
+          </a:fillRef>
+          <a:effectRef idx="2">
+            <a:schemeClr val="accent1"/>
+          </a:effectRef>
+          <a:fontRef idx="minor">
+            <a:schemeClr val="lt1"/>
+          </a:fontRef>
+        </p:style>
+        <p:txBody>
+          <a:bodyPr rtlCol="0" anchor="ctr"/>
+          <a:lstStyle/>
+          <a:p>
+            <a:pPr algn="ctr"/>
+          </a:p>
+        </p:txBody>
+      </p:sp>
+      <p:sp>
+        <p:nvSpPr>
+          <p:cNvPr id="21" name="TextBox 20"/>
+          <p:cNvSpPr txBox="1"/>
+          <p:nvPr/>
+        </p:nvSpPr>
+        <p:spPr>
+          <a:xfrm>
+            <a:off x="667512" y="4535424"/>
+            <a:ext cx="676656" cy="640080"/>
+          </a:xfrm>
+          <a:prstGeom prst="rect">
+            <a:avLst/>
+          </a:prstGeom>
+          <a:noFill/>
+        </p:spPr>
+        <p:txBody>
+          <a:bodyPr wrap="square" anchor="ctr" lIns="0" rIns="0" tIns="0" bIns="0">
+            <a:spAutoFit/>
+          </a:bodyPr>
+          <a:lstStyle/>
+          <a:p>
+            <a:pPr algn="ctr"/>
+            <a:r>
+              <a:rPr sz="2600" b="1">
+                <a:solidFill>
+                  <a:srgbClr val="FFFFFF"/>
+                </a:solidFill>
+                <a:latin typeface="Calibri"/>
+              </a:rPr>
+              <a:t>3</a:t>
+            </a:r>
+          </a:p>
+        </p:txBody>
+      </p:sp>
+      <p:sp>
+        <p:nvSpPr>
+          <p:cNvPr id="22" name="TextBox 21"/>
+          <p:cNvSpPr txBox="1"/>
+          <p:nvPr/>
+        </p:nvSpPr>
+        <p:spPr>
+          <a:xfrm>
+            <a:off x="1545336" y="4389120"/>
+            <a:ext cx="9966960" cy="365760"/>
+          </a:xfrm>
+          <a:prstGeom prst="rect">
+            <a:avLst/>
+          </a:prstGeom>
+          <a:noFill/>
+        </p:spPr>
+        <p:txBody>
+          <a:bodyPr wrap="square" anchor="t" lIns="0" rIns="0" tIns="0" bIns="0">
+            <a:spAutoFit/>
+          </a:bodyPr>
+          <a:lstStyle/>
+          <a:p>
+            <a:pPr algn="l"/>
+            <a:r>
+              <a:rPr sz="1800" b="1">
+                <a:solidFill>
+                  <a:srgbClr val="C0504D"/>
+                </a:solidFill>
+                <a:latin typeface="Calibri"/>
+              </a:rPr>
+              <a:t>The allocation (FLAT-LLM)</a:t>
+            </a:r>
+          </a:p>
+        </p:txBody>
+      </p:sp>
+      <p:sp>
+        <p:nvSpPr>
+          <p:cNvPr id="23" name="TextBox 22"/>
+          <p:cNvSpPr txBox="1"/>
+          <p:nvPr/>
+        </p:nvSpPr>
+        <p:spPr>
+          <a:xfrm>
+            <a:off x="1545336" y="4791456"/>
+            <a:ext cx="9966960" cy="640080"/>
+          </a:xfrm>
+          <a:prstGeom prst="rect">
+            <a:avLst/>
+          </a:prstGeom>
+          <a:noFill/>
+        </p:spPr>
+        <p:txBody>
+          <a:bodyPr wrap="square" anchor="t" lIns="0" rIns="0" tIns="0" bIns="0">
+            <a:spAutoFit/>
+          </a:bodyPr>
+          <a:lstStyle/>
+          <a:p>
+            <a:pPr algn="l"/>
+            <a:r>
+              <a:rPr sz="1300" b="0">
+                <a:solidFill>
+                  <a:srgbClr val="525252"/>
+                </a:solidFill>
+                <a:latin typeface="Calibri"/>
+              </a:rPr>
+              <a:t>Score each layer by a LOCAL importance — FLAT-LLM uses angular Block-Influence: how much that block rotates the residual.  Give rank in proportion (IPRS).</a:t>
+            </a:r>
+          </a:p>
+        </p:txBody>
+      </p:sp>
+      <p:sp>
+        <p:nvSpPr>
+          <p:cNvPr id="24" name="Rectangle 23"/>
+          <p:cNvSpPr/>
+          <p:nvPr/>
+        </p:nvSpPr>
+        <p:spPr>
+          <a:xfrm>
+            <a:off x="365760" y="5897880"/>
+            <a:ext cx="11430000" cy="658368"/>
+          </a:xfrm>
+          <a:prstGeom prst="rect">
+            <a:avLst/>
+          </a:prstGeom>
+          <a:solidFill>
+            <a:srgbClr val="DEEBF7"/>
+          </a:solidFill>
+          <a:ln>
+            <a:noFill/>
+          </a:ln>
+          <a:effectLst/>
+        </p:spPr>
+        <p:style>
+          <a:lnRef idx="1">
+            <a:schemeClr val="accent1"/>
+          </a:lnRef>
+          <a:fillRef idx="3">
+            <a:schemeClr val="accent1"/>
+          </a:fillRef>
+          <a:effectRef idx="2">
+            <a:schemeClr val="accent1"/>
+          </a:effectRef>
+          <a:fontRef idx="minor">
+            <a:schemeClr val="lt1"/>
+          </a:fontRef>
+        </p:style>
+        <p:txBody>
+          <a:bodyPr rtlCol="0" anchor="ctr"/>
+          <a:lstStyle/>
+          <a:p>
+            <a:pPr algn="ctr"/>
+          </a:p>
+        </p:txBody>
+      </p:sp>
+      <p:sp>
+        <p:nvSpPr>
+          <p:cNvPr id="25" name="Rectangle 24"/>
+          <p:cNvSpPr/>
+          <p:nvPr/>
+        </p:nvSpPr>
+        <p:spPr>
+          <a:xfrm>
+            <a:off x="365760" y="5897880"/>
+            <a:ext cx="146304" cy="658368"/>
+          </a:xfrm>
+          <a:prstGeom prst="rect">
+            <a:avLst/>
+          </a:prstGeom>
+          <a:solidFill>
+            <a:srgbClr val="0068B5"/>
+          </a:solidFill>
+          <a:ln>
+            <a:noFill/>
+          </a:ln>
+          <a:effectLst/>
+        </p:spPr>
+        <p:style>
+          <a:lnRef idx="1">
+            <a:schemeClr val="accent1"/>
+          </a:lnRef>
+          <a:fillRef idx="3">
+            <a:schemeClr val="accent1"/>
+          </a:fillRef>
+          <a:effectRef idx="2">
+            <a:schemeClr val="accent1"/>
+          </a:effectRef>
+          <a:fontRef idx="minor">
+            <a:schemeClr val="lt1"/>
+          </a:fontRef>
+        </p:style>
+        <p:txBody>
+          <a:bodyPr rtlCol="0" anchor="ctr"/>
+          <a:lstStyle/>
+          <a:p>
+            <a:pPr algn="ctr"/>
+          </a:p>
+        </p:txBody>
+      </p:sp>
+      <p:sp>
+        <p:nvSpPr>
+          <p:cNvPr id="26" name="TextBox 25"/>
+          <p:cNvSpPr txBox="1"/>
+          <p:nvPr/>
+        </p:nvSpPr>
+        <p:spPr>
+          <a:xfrm>
+            <a:off x="685800" y="5961888"/>
+            <a:ext cx="10972800" cy="548640"/>
+          </a:xfrm>
+          <a:prstGeom prst="rect">
+            <a:avLst/>
+          </a:prstGeom>
+          <a:noFill/>
+        </p:spPr>
+        <p:txBody>
+          <a:bodyPr wrap="square" anchor="t" lIns="0" rIns="0" tIns="0" bIns="0">
+            <a:spAutoFit/>
+          </a:bodyPr>
+          <a:lstStyle/>
+          <a:p>
+            <a:pPr algn="l"/>
+            <a:r>
+              <a:rPr sz="1300" b="1">
+                <a:solidFill>
+                  <a:srgbClr val="0068B5"/>
+                </a:solidFill>
+                <a:latin typeface="Calibri"/>
+              </a:rPr>
+              <a:t>All SOTA low-rank methods (ASVD, SVD-LLM, FLAT-LLM) share this template:  </a:t>
+            </a:r>
+            <a:r>
+              <a:rPr sz="1300" b="0">
+                <a:solidFill>
+                  <a:srgbClr val="1A1A1A"/>
+                </a:solidFill>
+                <a:latin typeface="Calibri"/>
+              </a:rPr>
+              <a:t>a per-layer LOCAL score, and each layer allocated independently.</a:t>
+            </a:r>
+          </a:p>
+        </p:txBody>
+      </p:sp>
+    </p:spTree>
+  </p:cSld>
+  <p:clrMapOvr>
+    <a:masterClrMapping/>
+  </p:clrMapOvr>
+</p:sld>
+</file>
+
+<file path=ppt/slides/slide14.xml><?xml version="1.0" encoding="utf-8"?>
+<p:sld xmlns:a="http://schemas.openxmlformats.org/drawingml/2006/main" xmlns:p="http://schemas.openxmlformats.org/presentationml/2006/main" xmlns:r="http://schemas.openxmlformats.org/officeDocument/2006/relationships">
+  <p:cSld>
+    <p:spTree>
+      <p:nvGrpSpPr>
+        <p:cNvPr id="1" name=""/>
+        <p:cNvGrpSpPr/>
+        <p:nvPr/>
+      </p:nvGrpSpPr>
+      <p:grpSpPr/>
+      <p:sp>
+        <p:nvSpPr>
+          <p:cNvPr id="2" name="TextBox 1"/>
+          <p:cNvSpPr txBox="1"/>
+          <p:nvPr/>
+        </p:nvSpPr>
+        <p:spPr>
+          <a:xfrm>
+            <a:off x="365760" y="228600"/>
+            <a:ext cx="11430000" cy="548640"/>
+          </a:xfrm>
+          <a:prstGeom prst="rect">
+            <a:avLst/>
+          </a:prstGeom>
+          <a:noFill/>
+        </p:spPr>
+        <p:txBody>
+          <a:bodyPr wrap="square" anchor="t" lIns="0" rIns="0" tIns="0" bIns="0">
+            <a:spAutoFit/>
+          </a:bodyPr>
+          <a:lstStyle/>
+          <a:p>
+            <a:pPr algn="l"/>
+            <a:r>
+              <a:rPr sz="2800" b="1">
+                <a:solidFill>
+                  <a:srgbClr val="1A1A1A"/>
+                </a:solidFill>
+                <a:latin typeface="Calibri"/>
+              </a:rPr>
+              <a:t>The Weakness We Cure:  Layers Are Scored in Isolation</a:t>
+            </a:r>
+          </a:p>
+        </p:txBody>
+      </p:sp>
+      <p:sp>
+        <p:nvSpPr>
+          <p:cNvPr id="3" name="Rectangle 2"/>
+          <p:cNvSpPr/>
+          <p:nvPr/>
+        </p:nvSpPr>
+        <p:spPr>
+          <a:xfrm>
+            <a:off x="365760" y="795528"/>
+            <a:ext cx="11457432" cy="27432"/>
+          </a:xfrm>
+          <a:prstGeom prst="rect">
+            <a:avLst/>
+          </a:prstGeom>
+          <a:solidFill>
+            <a:srgbClr val="0068B5"/>
+          </a:solidFill>
+          <a:ln>
+            <a:noFill/>
+          </a:ln>
+          <a:effectLst/>
+        </p:spPr>
+        <p:style>
+          <a:lnRef idx="1">
+            <a:schemeClr val="accent1"/>
+          </a:lnRef>
+          <a:fillRef idx="3">
+            <a:schemeClr val="accent1"/>
+          </a:fillRef>
+          <a:effectRef idx="2">
+            <a:schemeClr val="accent1"/>
+          </a:effectRef>
+          <a:fontRef idx="minor">
+            <a:schemeClr val="lt1"/>
+          </a:fontRef>
+        </p:style>
+        <p:txBody>
+          <a:bodyPr rtlCol="0" anchor="ctr"/>
+          <a:lstStyle/>
+          <a:p>
+            <a:pPr algn="ctr"/>
+          </a:p>
+        </p:txBody>
+      </p:sp>
+      <p:sp>
+        <p:nvSpPr>
+          <p:cNvPr id="4" name="TextBox 3"/>
+          <p:cNvSpPr txBox="1"/>
+          <p:nvPr/>
+        </p:nvSpPr>
+        <p:spPr>
+          <a:xfrm>
+            <a:off x="11430000" y="6492240"/>
+            <a:ext cx="640080" cy="274320"/>
+          </a:xfrm>
+          <a:prstGeom prst="rect">
+            <a:avLst/>
+          </a:prstGeom>
+          <a:noFill/>
+        </p:spPr>
+        <p:txBody>
+          <a:bodyPr wrap="square" anchor="t" lIns="0" rIns="0" tIns="0" bIns="0">
+            <a:spAutoFit/>
+          </a:bodyPr>
+          <a:lstStyle/>
+          <a:p>
+            <a:pPr algn="r"/>
+            <a:r>
+              <a:rPr sz="1000" b="0">
+                <a:solidFill>
+                  <a:srgbClr val="AAAAAA"/>
+                </a:solidFill>
+                <a:latin typeface="Calibri"/>
+              </a:rPr>
+              <a:t>10</a:t>
+            </a:r>
+          </a:p>
+        </p:txBody>
+      </p:sp>
+      <p:sp>
+        <p:nvSpPr>
+          <p:cNvPr id="5" name="TextBox 4"/>
+          <p:cNvSpPr txBox="1"/>
+          <p:nvPr/>
+        </p:nvSpPr>
+        <p:spPr>
+          <a:xfrm>
+            <a:off x="365760" y="932688"/>
+            <a:ext cx="11430000" cy="365760"/>
+          </a:xfrm>
+          <a:prstGeom prst="rect">
+            <a:avLst/>
+          </a:prstGeom>
+          <a:noFill/>
+        </p:spPr>
+        <p:txBody>
+          <a:bodyPr wrap="square" anchor="t" lIns="0" rIns="0" tIns="0" bIns="0">
+            <a:spAutoFit/>
+          </a:bodyPr>
+          <a:lstStyle/>
+          <a:p>
+            <a:pPr algn="l"/>
+            <a:r>
+              <a:rPr sz="1500" b="1">
+                <a:solidFill>
+                  <a:srgbClr val="1A1A1A"/>
+                </a:solidFill>
+                <a:latin typeface="Calibri"/>
+              </a:rPr>
+              <a:t>A local, per-layer score cannot see how a layer's compression error </a:t>
+            </a:r>
+            <a:r>
+              <a:rPr sz="1500" b="1">
+                <a:solidFill>
+                  <a:srgbClr val="C0504D"/>
+                </a:solidFill>
+                <a:latin typeface="Calibri"/>
+              </a:rPr>
+              <a:t>travels through the rest of the network.</a:t>
+            </a:r>
+          </a:p>
+        </p:txBody>
+      </p:sp>
+      <p:sp>
+        <p:nvSpPr>
+          <p:cNvPr id="6" name="Rectangle 5"/>
+          <p:cNvSpPr/>
+          <p:nvPr/>
+        </p:nvSpPr>
+        <p:spPr>
+          <a:xfrm>
+            <a:off x="365760" y="1481328"/>
+            <a:ext cx="5623560" cy="3611880"/>
+          </a:xfrm>
+          <a:prstGeom prst="rect">
+            <a:avLst/>
+          </a:prstGeom>
+          <a:solidFill>
+            <a:srgbClr val="FCE4D6"/>
+          </a:solidFill>
+          <a:ln>
+            <a:noFill/>
+          </a:ln>
+          <a:effectLst/>
+        </p:spPr>
+        <p:style>
+          <a:lnRef idx="1">
+            <a:schemeClr val="accent1"/>
+          </a:lnRef>
+          <a:fillRef idx="3">
+            <a:schemeClr val="accent1"/>
+          </a:fillRef>
+          <a:effectRef idx="2">
+            <a:schemeClr val="accent1"/>
+          </a:effectRef>
+          <a:fontRef idx="minor">
+            <a:schemeClr val="lt1"/>
+          </a:fontRef>
+        </p:style>
+        <p:txBody>
+          <a:bodyPr rtlCol="0" anchor="ctr"/>
+          <a:lstStyle/>
+          <a:p>
+            <a:pPr algn="ctr"/>
+          </a:p>
+        </p:txBody>
+      </p:sp>
+      <p:sp>
+        <p:nvSpPr>
+          <p:cNvPr id="7" name="Rectangle 6"/>
+          <p:cNvSpPr/>
+          <p:nvPr/>
+        </p:nvSpPr>
+        <p:spPr>
+          <a:xfrm>
+            <a:off x="365760" y="1481328"/>
+            <a:ext cx="146304" cy="3611880"/>
+          </a:xfrm>
+          <a:prstGeom prst="rect">
+            <a:avLst/>
+          </a:prstGeom>
+          <a:solidFill>
+            <a:srgbClr val="C0504D"/>
+          </a:solidFill>
+          <a:ln>
+            <a:noFill/>
+          </a:ln>
+          <a:effectLst/>
+        </p:spPr>
+        <p:style>
+          <a:lnRef idx="1">
+            <a:schemeClr val="accent1"/>
+          </a:lnRef>
+          <a:fillRef idx="3">
+            <a:schemeClr val="accent1"/>
+          </a:fillRef>
+          <a:effectRef idx="2">
+            <a:schemeClr val="accent1"/>
+          </a:effectRef>
+          <a:fontRef idx="minor">
+            <a:schemeClr val="lt1"/>
+          </a:fontRef>
+        </p:style>
+        <p:txBody>
+          <a:bodyPr rtlCol="0" anchor="ctr"/>
+          <a:lstStyle/>
+          <a:p>
+            <a:pPr algn="ctr"/>
+          </a:p>
+        </p:txBody>
+      </p:sp>
+      <p:sp>
+        <p:nvSpPr>
+          <p:cNvPr id="8" name="TextBox 7"/>
+          <p:cNvSpPr txBox="1"/>
+          <p:nvPr/>
+        </p:nvSpPr>
+        <p:spPr>
+          <a:xfrm>
+            <a:off x="685800" y="1627632"/>
+            <a:ext cx="5120640" cy="457200"/>
+          </a:xfrm>
+          <a:prstGeom prst="rect">
+            <a:avLst/>
+          </a:prstGeom>
+          <a:noFill/>
+        </p:spPr>
+        <p:txBody>
+          <a:bodyPr wrap="square" anchor="t" lIns="0" rIns="0" tIns="0" bIns="0">
+            <a:spAutoFit/>
+          </a:bodyPr>
+          <a:lstStyle/>
+          <a:p>
+            <a:pPr algn="l"/>
+            <a:r>
+              <a:rPr sz="2000" b="1">
+                <a:solidFill>
+                  <a:srgbClr val="C0504D"/>
+                </a:solidFill>
+                <a:latin typeface="Calibri"/>
+              </a:rPr>
+              <a:t>The blind spot</a:t>
+            </a:r>
+          </a:p>
+        </p:txBody>
+      </p:sp>
+      <p:sp>
+        <p:nvSpPr>
+          <p:cNvPr id="9" name="TextBox 8"/>
+          <p:cNvSpPr txBox="1"/>
+          <p:nvPr/>
+        </p:nvSpPr>
+        <p:spPr>
+          <a:xfrm>
+            <a:off x="685800" y="2194560"/>
+            <a:ext cx="5120640" cy="2743200"/>
+          </a:xfrm>
+          <a:prstGeom prst="rect">
+            <a:avLst/>
+          </a:prstGeom>
+          <a:noFill/>
+        </p:spPr>
+        <p:txBody>
+          <a:bodyPr wrap="square" anchor="t" lIns="0" rIns="0" tIns="0" bIns="0">
+            <a:spAutoFit/>
+          </a:bodyPr>
+          <a:lstStyle/>
+          <a:p>
+            <a:pPr algn="l"/>
+            <a:r>
+              <a:rPr sz="1300" b="1">
+                <a:solidFill>
+                  <a:srgbClr val="1A1A1A"/>
+                </a:solidFill>
+                <a:latin typeface="Calibri"/>
+              </a:rPr>
+              <a:t>Transformer layers form a chain through the residual stream.</a:t>
+            </a:r>
+          </a:p>
+          <a:p>
+            <a:pPr algn="l"/>
+            <a:r>
+              <a:rPr sz="600" b="0">
+                <a:solidFill>
+                  <a:srgbClr val="1A1A1A"/>
+                </a:solidFill>
+                <a:latin typeface="Calibri"/>
+              </a:rPr>
+              <a:t/>
+            </a:r>
+          </a:p>
+          <a:p>
+            <a:pPr algn="l"/>
+            <a:r>
+              <a:rPr sz="1300" b="0">
+                <a:solidFill>
+                  <a:srgbClr val="525252"/>
+                </a:solidFill>
+                <a:latin typeface="Calibri"/>
+              </a:rPr>
+              <a:t>An error introduced when compressing an </a:t>
+            </a:r>
+            <a:r>
+              <a:rPr sz="1300" b="1">
+                <a:solidFill>
+                  <a:srgbClr val="1A1A1A"/>
+                </a:solidFill>
+                <a:latin typeface="Calibri"/>
+              </a:rPr>
+              <a:t>early</a:t>
+            </a:r>
+            <a:r>
+              <a:rPr sz="1300" b="0">
+                <a:solidFill>
+                  <a:srgbClr val="525252"/>
+                </a:solidFill>
+                <a:latin typeface="Calibri"/>
+              </a:rPr>
+              <a:t> layer does not stay local — it </a:t>
+            </a:r>
+            <a:r>
+              <a:rPr sz="1300" b="1">
+                <a:solidFill>
+                  <a:srgbClr val="C0504D"/>
+                </a:solidFill>
+                <a:latin typeface="Calibri"/>
+              </a:rPr>
+              <a:t>propagates and amplifies</a:t>
+            </a:r>
+            <a:r>
+              <a:rPr sz="1300" b="0">
+                <a:solidFill>
+                  <a:srgbClr val="525252"/>
+                </a:solidFill>
+                <a:latin typeface="Calibri"/>
+              </a:rPr>
+              <a:t> downstream (we measure up to ~30× by the output).</a:t>
+            </a:r>
+          </a:p>
+          <a:p>
+            <a:pPr algn="l"/>
+            <a:r>
+              <a:rPr sz="600" b="0">
+                <a:solidFill>
+                  <a:srgbClr val="1A1A1A"/>
+                </a:solidFill>
+                <a:latin typeface="Calibri"/>
+              </a:rPr>
+              <a:t/>
+            </a:r>
+          </a:p>
+          <a:p>
+            <a:pPr algn="l"/>
+            <a:r>
+              <a:rPr sz="1300" b="0">
+                <a:solidFill>
+                  <a:srgbClr val="525252"/>
+                </a:solidFill>
+                <a:latin typeface="Calibri"/>
+              </a:rPr>
+              <a:t>A local score (reconstruction error, block-influence) is computed at </a:t>
+            </a:r>
+            <a:r>
+              <a:rPr sz="1300" b="1">
+                <a:solidFill>
+                  <a:srgbClr val="1A1A1A"/>
+                </a:solidFill>
+                <a:latin typeface="Calibri"/>
+              </a:rPr>
+              <a:t>one layer in isolation</a:t>
+            </a:r>
+            <a:r>
+              <a:rPr sz="1300" b="0">
+                <a:solidFill>
+                  <a:srgbClr val="525252"/>
+                </a:solidFill>
+                <a:latin typeface="Calibri"/>
+              </a:rPr>
+              <a:t> — it is structurally blind to this propagation.</a:t>
+            </a:r>
+          </a:p>
+        </p:txBody>
+      </p:sp>
+      <p:sp>
+        <p:nvSpPr>
+          <p:cNvPr id="10" name="Rectangle 9"/>
+          <p:cNvSpPr/>
+          <p:nvPr/>
+        </p:nvSpPr>
+        <p:spPr>
+          <a:xfrm>
+            <a:off x="6172200" y="1481328"/>
+            <a:ext cx="5623560" cy="3611880"/>
+          </a:xfrm>
+          <a:prstGeom prst="rect">
+            <a:avLst/>
+          </a:prstGeom>
+          <a:solidFill>
+            <a:srgbClr val="E2F0D9"/>
+          </a:solidFill>
+          <a:ln>
+            <a:noFill/>
+          </a:ln>
+          <a:effectLst/>
+        </p:spPr>
+        <p:style>
+          <a:lnRef idx="1">
+            <a:schemeClr val="accent1"/>
+          </a:lnRef>
+          <a:fillRef idx="3">
+            <a:schemeClr val="accent1"/>
+          </a:fillRef>
+          <a:effectRef idx="2">
+            <a:schemeClr val="accent1"/>
+          </a:effectRef>
+          <a:fontRef idx="minor">
+            <a:schemeClr val="lt1"/>
+          </a:fontRef>
+        </p:style>
+        <p:txBody>
+          <a:bodyPr rtlCol="0" anchor="ctr"/>
+          <a:lstStyle/>
+          <a:p>
+            <a:pPr algn="ctr"/>
+          </a:p>
+        </p:txBody>
+      </p:sp>
+      <p:sp>
+        <p:nvSpPr>
+          <p:cNvPr id="11" name="Rectangle 10"/>
+          <p:cNvSpPr/>
+          <p:nvPr/>
+        </p:nvSpPr>
+        <p:spPr>
+          <a:xfrm>
+            <a:off x="6172200" y="1481328"/>
+            <a:ext cx="146304" cy="3611880"/>
+          </a:xfrm>
+          <a:prstGeom prst="rect">
+            <a:avLst/>
+          </a:prstGeom>
+          <a:solidFill>
+            <a:srgbClr val="2E8B57"/>
+          </a:solidFill>
+          <a:ln>
+            <a:noFill/>
+          </a:ln>
+          <a:effectLst/>
+        </p:spPr>
+        <p:style>
+          <a:lnRef idx="1">
+            <a:schemeClr val="accent1"/>
+          </a:lnRef>
+          <a:fillRef idx="3">
+            <a:schemeClr val="accent1"/>
+          </a:fillRef>
+          <a:effectRef idx="2">
+            <a:schemeClr val="accent1"/>
+          </a:effectRef>
+          <a:fontRef idx="minor">
+            <a:schemeClr val="lt1"/>
+          </a:fontRef>
+        </p:style>
+        <p:txBody>
+          <a:bodyPr rtlCol="0" anchor="ctr"/>
+          <a:lstStyle/>
+          <a:p>
+            <a:pPr algn="ctr"/>
+          </a:p>
+        </p:txBody>
+      </p:sp>
+      <p:sp>
+        <p:nvSpPr>
+          <p:cNvPr id="12" name="TextBox 11"/>
+          <p:cNvSpPr txBox="1"/>
+          <p:nvPr/>
+        </p:nvSpPr>
+        <p:spPr>
+          <a:xfrm>
+            <a:off x="6492240" y="1627632"/>
+            <a:ext cx="5120640" cy="457200"/>
+          </a:xfrm>
+          <a:prstGeom prst="rect">
+            <a:avLst/>
+          </a:prstGeom>
+          <a:noFill/>
+        </p:spPr>
+        <p:txBody>
+          <a:bodyPr wrap="square" anchor="t" lIns="0" rIns="0" tIns="0" bIns="0">
+            <a:spAutoFit/>
+          </a:bodyPr>
+          <a:lstStyle/>
+          <a:p>
+            <a:pPr algn="l"/>
+            <a:r>
+              <a:rPr sz="2000" b="1">
+                <a:solidFill>
+                  <a:srgbClr val="2E8B57"/>
+                </a:solidFill>
+                <a:latin typeface="Calibri"/>
+              </a:rPr>
+              <a:t>Our cure  (the novelty)</a:t>
+            </a:r>
+          </a:p>
+        </p:txBody>
+      </p:sp>
+      <p:sp>
+        <p:nvSpPr>
+          <p:cNvPr id="13" name="TextBox 12"/>
+          <p:cNvSpPr txBox="1"/>
+          <p:nvPr/>
+        </p:nvSpPr>
+        <p:spPr>
+          <a:xfrm>
+            <a:off x="6492240" y="2194560"/>
+            <a:ext cx="5120640" cy="2743200"/>
+          </a:xfrm>
+          <a:prstGeom prst="rect">
+            <a:avLst/>
+          </a:prstGeom>
+          <a:noFill/>
+        </p:spPr>
+        <p:txBody>
+          <a:bodyPr wrap="square" anchor="t" lIns="0" rIns="0" tIns="0" bIns="0">
+            <a:spAutoFit/>
+          </a:bodyPr>
+          <a:lstStyle/>
+          <a:p>
+            <a:pPr algn="l"/>
+            <a:r>
+              <a:rPr sz="1300" b="0">
+                <a:solidFill>
+                  <a:srgbClr val="525252"/>
+                </a:solidFill>
+                <a:latin typeface="Calibri"/>
+              </a:rPr>
+              <a:t>Allocate rank by </a:t>
+            </a:r>
+            <a:r>
+              <a:rPr sz="1300" b="1">
+                <a:solidFill>
+                  <a:srgbClr val="1A1A1A"/>
+                </a:solidFill>
+                <a:latin typeface="Calibri"/>
+              </a:rPr>
+              <a:t>downstream impact</a:t>
+            </a:r>
+            <a:r>
+              <a:rPr sz="1300" b="0">
+                <a:solidFill>
+                  <a:srgbClr val="525252"/>
+                </a:solidFill>
+                <a:latin typeface="Calibri"/>
+              </a:rPr>
+              <a:t>, not local importance.</a:t>
+            </a:r>
+          </a:p>
+          <a:p>
+            <a:pPr algn="l"/>
+            <a:r>
+              <a:rPr sz="600" b="0">
+                <a:solidFill>
+                  <a:srgbClr val="1A1A1A"/>
+                </a:solidFill>
+                <a:latin typeface="Calibri"/>
+              </a:rPr>
+              <a:t/>
+            </a:r>
+          </a:p>
+          <a:p>
+            <a:pPr algn="l"/>
+            <a:r>
+              <a:rPr sz="1300" b="0">
+                <a:solidFill>
+                  <a:srgbClr val="525252"/>
+                </a:solidFill>
+                <a:latin typeface="Calibri"/>
+              </a:rPr>
+              <a:t>• Measure each layer's </a:t>
+            </a:r>
+            <a:r>
+              <a:rPr sz="1300" b="1">
+                <a:solidFill>
+                  <a:srgbClr val="2E8B57"/>
+                </a:solidFill>
+                <a:latin typeface="Calibri"/>
+              </a:rPr>
+              <a:t>error amplification</a:t>
+            </a:r>
+            <a:r>
+              <a:rPr sz="1300" b="0">
+                <a:solidFill>
+                  <a:srgbClr val="525252"/>
+                </a:solidFill>
+                <a:latin typeface="Calibri"/>
+              </a:rPr>
+              <a:t> to the final output.</a:t>
+            </a:r>
+          </a:p>
+          <a:p>
+            <a:pPr algn="l"/>
+            <a:r>
+              <a:rPr sz="1300" b="0">
+                <a:solidFill>
+                  <a:srgbClr val="525252"/>
+                </a:solidFill>
+                <a:latin typeface="Calibri"/>
+              </a:rPr>
+              <a:t>• Account for </a:t>
+            </a:r>
+            <a:r>
+              <a:rPr sz="1300" b="1">
+                <a:solidFill>
+                  <a:srgbClr val="2E8B57"/>
+                </a:solidFill>
+                <a:latin typeface="Calibri"/>
+              </a:rPr>
+              <a:t>cross-layer coupling</a:t>
+            </a:r>
+            <a:r>
+              <a:rPr sz="1300" b="0">
+                <a:solidFill>
+                  <a:srgbClr val="525252"/>
+                </a:solidFill>
+                <a:latin typeface="Calibri"/>
+              </a:rPr>
+              <a:t> (errors interact; allocate jointly, not greedily).</a:t>
+            </a:r>
+          </a:p>
+          <a:p>
+            <a:pPr algn="l"/>
+            <a:r>
+              <a:rPr sz="600" b="0">
+                <a:solidFill>
+                  <a:srgbClr val="1A1A1A"/>
+                </a:solidFill>
+                <a:latin typeface="Calibri"/>
+              </a:rPr>
+              <a:t/>
+            </a:r>
+          </a:p>
+          <a:p>
+            <a:pPr algn="l"/>
+            <a:r>
+              <a:rPr sz="1300" b="1">
+                <a:solidFill>
+                  <a:srgbClr val="1A1A1A"/>
+                </a:solidFill>
+                <a:latin typeface="Calibri"/>
+              </a:rPr>
+              <a:t>Protect layers whose errors blow up;  compress hard where they damp.</a:t>
+            </a:r>
+          </a:p>
+        </p:txBody>
+      </p:sp>
+      <p:sp>
+        <p:nvSpPr>
+          <p:cNvPr id="14" name="Rectangle 13"/>
+          <p:cNvSpPr/>
+          <p:nvPr/>
+        </p:nvSpPr>
+        <p:spPr>
+          <a:xfrm>
+            <a:off x="365760" y="5257800"/>
+            <a:ext cx="11430000" cy="960120"/>
+          </a:xfrm>
+          <a:prstGeom prst="rect">
+            <a:avLst/>
+          </a:prstGeom>
+          <a:solidFill>
+            <a:srgbClr val="DEEBF7"/>
+          </a:solidFill>
+          <a:ln>
+            <a:noFill/>
+          </a:ln>
+          <a:effectLst/>
+        </p:spPr>
+        <p:style>
+          <a:lnRef idx="1">
+            <a:schemeClr val="accent1"/>
+          </a:lnRef>
+          <a:fillRef idx="3">
+            <a:schemeClr val="accent1"/>
+          </a:fillRef>
+          <a:effectRef idx="2">
+            <a:schemeClr val="accent1"/>
+          </a:effectRef>
+          <a:fontRef idx="minor">
+            <a:schemeClr val="lt1"/>
+          </a:fontRef>
+        </p:style>
+        <p:txBody>
+          <a:bodyPr rtlCol="0" anchor="ctr"/>
+          <a:lstStyle/>
+          <a:p>
+            <a:pPr algn="ctr"/>
+          </a:p>
+        </p:txBody>
+      </p:sp>
+      <p:sp>
+        <p:nvSpPr>
+          <p:cNvPr id="15" name="Rectangle 14"/>
+          <p:cNvSpPr/>
+          <p:nvPr/>
+        </p:nvSpPr>
+        <p:spPr>
+          <a:xfrm>
+            <a:off x="365760" y="5257800"/>
+            <a:ext cx="146304" cy="960120"/>
+          </a:xfrm>
+          <a:prstGeom prst="rect">
+            <a:avLst/>
+          </a:prstGeom>
+          <a:solidFill>
+            <a:srgbClr val="0068B5"/>
+          </a:solidFill>
+          <a:ln>
+            <a:noFill/>
+          </a:ln>
+          <a:effectLst/>
+        </p:spPr>
+        <p:style>
+          <a:lnRef idx="1">
+            <a:schemeClr val="accent1"/>
+          </a:lnRef>
+          <a:fillRef idx="3">
+            <a:schemeClr val="accent1"/>
+          </a:fillRef>
+          <a:effectRef idx="2">
+            <a:schemeClr val="accent1"/>
+          </a:effectRef>
+          <a:fontRef idx="minor">
+            <a:schemeClr val="lt1"/>
+          </a:fontRef>
+        </p:style>
+        <p:txBody>
+          <a:bodyPr rtlCol="0" anchor="ctr"/>
+          <a:lstStyle/>
+          <a:p>
+            <a:pPr algn="ctr"/>
+          </a:p>
+        </p:txBody>
+      </p:sp>
+      <p:sp>
+        <p:nvSpPr>
+          <p:cNvPr id="16" name="TextBox 15"/>
+          <p:cNvSpPr txBox="1"/>
+          <p:nvPr/>
+        </p:nvSpPr>
+        <p:spPr>
+          <a:xfrm>
+            <a:off x="685800" y="5349240"/>
+            <a:ext cx="10972800" cy="822960"/>
+          </a:xfrm>
+          <a:prstGeom prst="rect">
+            <a:avLst/>
+          </a:prstGeom>
+          <a:noFill/>
+        </p:spPr>
+        <p:txBody>
+          <a:bodyPr wrap="square" anchor="t" lIns="0" rIns="0" tIns="0" bIns="0">
+            <a:spAutoFit/>
+          </a:bodyPr>
+          <a:lstStyle/>
+          <a:p>
+            <a:pPr algn="l"/>
+            <a:r>
+              <a:rPr sz="1300" b="1">
+                <a:solidFill>
+                  <a:srgbClr val="0068B5"/>
+                </a:solidFill>
+                <a:latin typeface="Calibri"/>
+              </a:rPr>
+              <a:t>Novelty in one line:  </a:t>
+            </a:r>
+            <a:r>
+              <a:rPr sz="1300" b="1">
+                <a:solidFill>
+                  <a:srgbClr val="1A1A1A"/>
+                </a:solidFill>
+                <a:latin typeface="Calibri"/>
+              </a:rPr>
+              <a:t>the first error-propagation-aware, cross-layer-coupled rank allocation for low-rank LLM compression.</a:t>
+            </a:r>
+          </a:p>
+          <a:p>
+            <a:pPr algn="l"/>
+            <a:r>
+              <a:rPr sz="1200" b="0">
+                <a:solidFill>
+                  <a:srgbClr val="525252"/>
+                </a:solidFill>
+                <a:latin typeface="Calibri"/>
+              </a:rPr>
+              <a:t>Everything prior allocates per layer in isolation; we allocate over the propagation graph.  </a:t>
+            </a:r>
+            <a:r>
+              <a:rPr sz="1200" b="0">
+                <a:solidFill>
+                  <a:srgbClr val="2E8B57"/>
+                </a:solidFill>
+                <a:latin typeface="Calibri"/>
+              </a:rPr>
+              <a:t>(Result on the next slides: beats FLAT-LLM at the same budget.)</a:t>
             </a:r>
           </a:p>
         </p:txBody>

</xml_diff>

<commit_message>
Slide 10: contrast low-rank vs unit-removal pruning; explain block-influence (drop 'BI' jargon)
Slide 10 now contrasts the two structured-pruning families (remove units vs reduce
rank) then states the shared local-scoring weakness + our cure. Slides 9/13 spell out
block-influence (input-vs-output residual angle) instead of the unexplained 'BI'.

Co-Authored-By: Claude Sonnet 4.6 <noreply@anthropic.com>
</commit_message>
<xml_diff>
--- a/hypergraph_slides.pptx
+++ b/hypergraph_slides.pptx
@@ -4715,7 +4715,7 @@
                 </a:solidFill>
                 <a:latin typeface="Calibri"/>
               </a:rPr>
-              <a:t>Score each layer LOCALLY (angular block-influence = how much it rotates the residual); give rank in proportion (IPRS).</a:t>
+              <a:t>Score each layer by its block-influence — how much it changes the residual (the angle between what goes in and what comes out). More influence → keep more rank.</a:t>
             </a:r>
           </a:p>
         </p:txBody>
@@ -4900,7 +4900,7 @@
                 </a:solidFill>
                 <a:latin typeface="Calibri"/>
               </a:rPr>
-              <a:t>The Weakness We Cure:  Layers Are Scored in Isolation</a:t>
+              <a:t>Low-Rank vs. Other Structured Pruning</a:t>
             </a:r>
           </a:p>
         </p:txBody>
@@ -5014,16 +5014,16 @@
                 </a:solidFill>
                 <a:latin typeface="Calibri"/>
               </a:rPr>
-              <a:t>A local, per-layer score cannot see how a layer's compression error </a:t>
+              <a:t>Both are “structured” pruning (regular, hardware-friendly shapes) — they differ in </a:t>
             </a:r>
             <a:r>
               <a:rPr sz="1400" b="1">
                 <a:solidFill>
-                  <a:srgbClr val="C0504D"/>
-                </a:solidFill>
-                <a:latin typeface="Calibri"/>
-              </a:rPr>
-              <a:t>travels through the rest of the network.</a:t>
+                  <a:srgbClr val="0068B5"/>
+                </a:solidFill>
+                <a:latin typeface="Calibri"/>
+              </a:rPr>
+              <a:t>what they keep.</a:t>
             </a:r>
           </a:p>
         </p:txBody>
@@ -5036,8 +5036,8 @@
         </p:nvSpPr>
         <p:spPr>
           <a:xfrm>
-            <a:off x="365760" y="1417320"/>
-            <a:ext cx="5623560" cy="3611880"/>
+            <a:off x="365760" y="1371600"/>
+            <a:ext cx="5623560" cy="1847088"/>
           </a:xfrm>
           <a:prstGeom prst="rect">
             <a:avLst/>
@@ -5080,14 +5080,14 @@
         </p:nvSpPr>
         <p:spPr>
           <a:xfrm>
-            <a:off x="365760" y="1417320"/>
-            <a:ext cx="146304" cy="3611880"/>
-          </a:xfrm>
-          <a:prstGeom prst="rect">
-            <a:avLst/>
-          </a:prstGeom>
-          <a:solidFill>
-            <a:srgbClr val="C0504D"/>
+            <a:off x="365760" y="1371600"/>
+            <a:ext cx="146304" cy="1847088"/>
+          </a:xfrm>
+          <a:prstGeom prst="rect">
+            <a:avLst/>
+          </a:prstGeom>
+          <a:solidFill>
+            <a:srgbClr val="FFA300"/>
           </a:solidFill>
           <a:ln>
             <a:noFill/>
@@ -5124,8 +5124,8 @@
         </p:nvSpPr>
         <p:spPr>
           <a:xfrm>
-            <a:off x="685800" y="1554480"/>
-            <a:ext cx="5120640" cy="457200"/>
+            <a:off x="685800" y="1490472"/>
+            <a:ext cx="5120640" cy="365760"/>
           </a:xfrm>
           <a:prstGeom prst="rect">
             <a:avLst/>
@@ -5140,13 +5140,13 @@
           <a:p>
             <a:pPr algn="l"/>
             <a:r>
-              <a:rPr sz="1900" b="1">
-                <a:solidFill>
-                  <a:srgbClr val="C0504D"/>
-                </a:solidFill>
-                <a:latin typeface="Calibri"/>
-              </a:rPr>
-              <a:t>The blind spot</a:t>
+              <a:rPr sz="1800" b="1">
+                <a:solidFill>
+                  <a:srgbClr val="FFA300"/>
+                </a:solidFill>
+                <a:latin typeface="Calibri"/>
+              </a:rPr>
+              <a:t>Remove units</a:t>
             </a:r>
           </a:p>
         </p:txBody>
@@ -5159,8 +5159,8 @@
         </p:nvSpPr>
         <p:spPr>
           <a:xfrm>
-            <a:off x="685800" y="2121408"/>
-            <a:ext cx="5120640" cy="2743200"/>
+            <a:off x="685800" y="1920240"/>
+            <a:ext cx="5120640" cy="914400"/>
           </a:xfrm>
           <a:prstGeom prst="rect">
             <a:avLst/>
@@ -5175,29 +5175,23 @@
           <a:p>
             <a:pPr algn="l"/>
             <a:r>
+              <a:rPr sz="1300" b="0">
+                <a:solidFill>
+                  <a:srgbClr val="525252"/>
+                </a:solidFill>
+                <a:latin typeface="Calibri"/>
+              </a:rPr>
+              <a:t>Delete whole </a:t>
+            </a:r>
+            <a:r>
               <a:rPr sz="1300" b="1">
                 <a:solidFill>
                   <a:srgbClr val="1A1A1A"/>
                 </a:solidFill>
                 <a:latin typeface="Calibri"/>
               </a:rPr>
-              <a:t>Transformer layers form a chain through the residual stream.</a:t>
-            </a:r>
-          </a:p>
-          <a:p>
-            <a:pPr algn="l"/>
-            <a:r>
-              <a:rPr sz="700" b="0">
-                <a:solidFill>
-                  <a:srgbClr val="1A1A1A"/>
-                </a:solidFill>
-                <a:latin typeface="Calibri"/>
-              </a:rPr>
-              <a:t/>
-            </a:r>
-          </a:p>
-          <a:p>
-            <a:pPr algn="l"/>
+              <a:t>channels, attention heads, or blocks</a:t>
+            </a:r>
             <a:r>
               <a:rPr sz="1300" b="0">
                 <a:solidFill>
@@ -5205,187 +5199,21 @@
                 </a:solidFill>
                 <a:latin typeface="Calibri"/>
               </a:rPr>
-              <a:t>An error from compressing an </a:t>
-            </a:r>
-            <a:r>
-              <a:rPr sz="1300" b="1">
-                <a:solidFill>
-                  <a:srgbClr val="1A1A1A"/>
-                </a:solidFill>
-                <a:latin typeface="Calibri"/>
-              </a:rPr>
-              <a:t>early</a:t>
-            </a:r>
-            <a:r>
-              <a:rPr sz="1300" b="0">
-                <a:solidFill>
-                  <a:srgbClr val="525252"/>
-                </a:solidFill>
-                <a:latin typeface="Calibri"/>
-              </a:rPr>
-              <a:t> layer does not stay local — it </a:t>
-            </a:r>
-            <a:r>
-              <a:rPr sz="1300" b="1">
-                <a:solidFill>
-                  <a:srgbClr val="C0504D"/>
-                </a:solidFill>
-                <a:latin typeface="Calibri"/>
-              </a:rPr>
-              <a:t>propagates and amplifies</a:t>
-            </a:r>
-            <a:r>
-              <a:rPr sz="1300" b="0">
-                <a:solidFill>
-                  <a:srgbClr val="525252"/>
-                </a:solidFill>
-                <a:latin typeface="Calibri"/>
-              </a:rPr>
-              <a:t> downstream (we measure up to ~30× at the output).</a:t>
-            </a:r>
-          </a:p>
-          <a:p>
-            <a:pPr algn="l"/>
-            <a:r>
-              <a:rPr sz="700" b="0">
-                <a:solidFill>
-                  <a:srgbClr val="1A1A1A"/>
-                </a:solidFill>
-                <a:latin typeface="Calibri"/>
-              </a:rPr>
-              <a:t/>
-            </a:r>
-          </a:p>
-          <a:p>
-            <a:pPr algn="l"/>
-            <a:r>
-              <a:rPr sz="1300" b="0">
-                <a:solidFill>
-                  <a:srgbClr val="525252"/>
-                </a:solidFill>
-                <a:latin typeface="Calibri"/>
-              </a:rPr>
-              <a:t>A local score is computed at </a:t>
-            </a:r>
-            <a:r>
-              <a:rPr sz="1300" b="1">
-                <a:solidFill>
-                  <a:srgbClr val="1A1A1A"/>
-                </a:solidFill>
-                <a:latin typeface="Calibri"/>
-              </a:rPr>
-              <a:t>one layer in isolation</a:t>
-            </a:r>
-            <a:r>
-              <a:rPr sz="1300" b="0">
-                <a:solidFill>
-                  <a:srgbClr val="525252"/>
-                </a:solidFill>
-                <a:latin typeface="Calibri"/>
-              </a:rPr>
-              <a:t> — structurally blind to this propagation.</a:t>
-            </a:r>
-          </a:p>
-        </p:txBody>
-      </p:sp>
-      <p:sp>
-        <p:nvSpPr>
-          <p:cNvPr id="10" name="Rectangle 9"/>
-          <p:cNvSpPr/>
-          <p:nvPr/>
-        </p:nvSpPr>
-        <p:spPr>
-          <a:xfrm>
-            <a:off x="6172200" y="1417320"/>
-            <a:ext cx="5623560" cy="3611880"/>
-          </a:xfrm>
-          <a:prstGeom prst="rect">
-            <a:avLst/>
-          </a:prstGeom>
-          <a:solidFill>
-            <a:srgbClr val="E2F0D9"/>
-          </a:solidFill>
-          <a:ln>
-            <a:noFill/>
-          </a:ln>
-          <a:effectLst/>
-        </p:spPr>
-        <p:style>
-          <a:lnRef idx="1">
-            <a:schemeClr val="accent1"/>
-          </a:lnRef>
-          <a:fillRef idx="3">
-            <a:schemeClr val="accent1"/>
-          </a:fillRef>
-          <a:effectRef idx="2">
-            <a:schemeClr val="accent1"/>
-          </a:effectRef>
-          <a:fontRef idx="minor">
-            <a:schemeClr val="lt1"/>
-          </a:fontRef>
-        </p:style>
-        <p:txBody>
-          <a:bodyPr rtlCol="0" anchor="ctr"/>
-          <a:lstStyle/>
-          <a:p>
-            <a:pPr algn="ctr"/>
-          </a:p>
-        </p:txBody>
-      </p:sp>
-      <p:sp>
-        <p:nvSpPr>
-          <p:cNvPr id="11" name="Rectangle 10"/>
-          <p:cNvSpPr/>
-          <p:nvPr/>
-        </p:nvSpPr>
-        <p:spPr>
-          <a:xfrm>
-            <a:off x="6172200" y="1417320"/>
-            <a:ext cx="146304" cy="3611880"/>
-          </a:xfrm>
-          <a:prstGeom prst="rect">
-            <a:avLst/>
-          </a:prstGeom>
-          <a:solidFill>
-            <a:srgbClr val="2E8B57"/>
-          </a:solidFill>
-          <a:ln>
-            <a:noFill/>
-          </a:ln>
-          <a:effectLst/>
-        </p:spPr>
-        <p:style>
-          <a:lnRef idx="1">
-            <a:schemeClr val="accent1"/>
-          </a:lnRef>
-          <a:fillRef idx="3">
-            <a:schemeClr val="accent1"/>
-          </a:fillRef>
-          <a:effectRef idx="2">
-            <a:schemeClr val="accent1"/>
-          </a:effectRef>
-          <a:fontRef idx="minor">
-            <a:schemeClr val="lt1"/>
-          </a:fontRef>
-        </p:style>
-        <p:txBody>
-          <a:bodyPr rtlCol="0" anchor="ctr"/>
-          <a:lstStyle/>
-          <a:p>
-            <a:pPr algn="ctr"/>
-          </a:p>
-        </p:txBody>
-      </p:sp>
-      <p:sp>
-        <p:nvSpPr>
-          <p:cNvPr id="12" name="TextBox 11"/>
+              <a:t>.  The units left behind are the originals, unchanged.</a:t>
+            </a:r>
+          </a:p>
+        </p:txBody>
+      </p:sp>
+      <p:sp>
+        <p:nvSpPr>
+          <p:cNvPr id="10" name="TextBox 9"/>
           <p:cNvSpPr txBox="1"/>
           <p:nvPr/>
         </p:nvSpPr>
         <p:spPr>
           <a:xfrm>
-            <a:off x="6492240" y="1554480"/>
-            <a:ext cx="5120640" cy="457200"/>
+            <a:off x="685800" y="2779776"/>
+            <a:ext cx="5120640" cy="365760"/>
           </a:xfrm>
           <a:prstGeom prst="rect">
             <a:avLst/>
@@ -5400,14 +5228,102 @@
           <a:p>
             <a:pPr algn="l"/>
             <a:r>
-              <a:rPr sz="1900" b="1">
-                <a:solidFill>
-                  <a:srgbClr val="2E8B57"/>
-                </a:solidFill>
-                <a:latin typeface="Calibri"/>
-              </a:rPr>
-              <a:t>Our cure  (the novelty)</a:t>
-            </a:r>
+              <a:rPr sz="1200" b="0">
+                <a:solidFill>
+                  <a:srgbClr val="FFA300"/>
+                </a:solidFill>
+                <a:latin typeface="Calibri"/>
+              </a:rPr>
+              <a:t>‹ the ViT channel / block pruning earlier in this talk ›</a:t>
+            </a:r>
+          </a:p>
+        </p:txBody>
+      </p:sp>
+      <p:sp>
+        <p:nvSpPr>
+          <p:cNvPr id="11" name="Rectangle 10"/>
+          <p:cNvSpPr/>
+          <p:nvPr/>
+        </p:nvSpPr>
+        <p:spPr>
+          <a:xfrm>
+            <a:off x="6172200" y="1371600"/>
+            <a:ext cx="5623560" cy="1847088"/>
+          </a:xfrm>
+          <a:prstGeom prst="rect">
+            <a:avLst/>
+          </a:prstGeom>
+          <a:solidFill>
+            <a:srgbClr val="DEEBF7"/>
+          </a:solidFill>
+          <a:ln>
+            <a:noFill/>
+          </a:ln>
+          <a:effectLst/>
+        </p:spPr>
+        <p:style>
+          <a:lnRef idx="1">
+            <a:schemeClr val="accent1"/>
+          </a:lnRef>
+          <a:fillRef idx="3">
+            <a:schemeClr val="accent1"/>
+          </a:fillRef>
+          <a:effectRef idx="2">
+            <a:schemeClr val="accent1"/>
+          </a:effectRef>
+          <a:fontRef idx="minor">
+            <a:schemeClr val="lt1"/>
+          </a:fontRef>
+        </p:style>
+        <p:txBody>
+          <a:bodyPr rtlCol="0" anchor="ctr"/>
+          <a:lstStyle/>
+          <a:p>
+            <a:pPr algn="ctr"/>
+          </a:p>
+        </p:txBody>
+      </p:sp>
+      <p:sp>
+        <p:nvSpPr>
+          <p:cNvPr id="12" name="Rectangle 11"/>
+          <p:cNvSpPr/>
+          <p:nvPr/>
+        </p:nvSpPr>
+        <p:spPr>
+          <a:xfrm>
+            <a:off x="6172200" y="1371600"/>
+            <a:ext cx="146304" cy="1847088"/>
+          </a:xfrm>
+          <a:prstGeom prst="rect">
+            <a:avLst/>
+          </a:prstGeom>
+          <a:solidFill>
+            <a:srgbClr val="0068B5"/>
+          </a:solidFill>
+          <a:ln>
+            <a:noFill/>
+          </a:ln>
+          <a:effectLst/>
+        </p:spPr>
+        <p:style>
+          <a:lnRef idx="1">
+            <a:schemeClr val="accent1"/>
+          </a:lnRef>
+          <a:fillRef idx="3">
+            <a:schemeClr val="accent1"/>
+          </a:fillRef>
+          <a:effectRef idx="2">
+            <a:schemeClr val="accent1"/>
+          </a:effectRef>
+          <a:fontRef idx="minor">
+            <a:schemeClr val="lt1"/>
+          </a:fontRef>
+        </p:style>
+        <p:txBody>
+          <a:bodyPr rtlCol="0" anchor="ctr"/>
+          <a:lstStyle/>
+          <a:p>
+            <a:pPr algn="ctr"/>
           </a:p>
         </p:txBody>
       </p:sp>
@@ -5419,8 +5335,8 @@
         </p:nvSpPr>
         <p:spPr>
           <a:xfrm>
-            <a:off x="6492240" y="2121408"/>
-            <a:ext cx="5120640" cy="2743200"/>
+            <a:off x="6492240" y="1490472"/>
+            <a:ext cx="5120640" cy="365760"/>
           </a:xfrm>
           <a:prstGeom prst="rect">
             <a:avLst/>
@@ -5435,13 +5351,48 @@
           <a:p>
             <a:pPr algn="l"/>
             <a:r>
+              <a:rPr sz="1800" b="1">
+                <a:solidFill>
+                  <a:srgbClr val="0068B5"/>
+                </a:solidFill>
+                <a:latin typeface="Calibri"/>
+              </a:rPr>
+              <a:t>Reduce rank   (these methods)</a:t>
+            </a:r>
+          </a:p>
+        </p:txBody>
+      </p:sp>
+      <p:sp>
+        <p:nvSpPr>
+          <p:cNvPr id="14" name="TextBox 13"/>
+          <p:cNvSpPr txBox="1"/>
+          <p:nvPr/>
+        </p:nvSpPr>
+        <p:spPr>
+          <a:xfrm>
+            <a:off x="6492240" y="1920240"/>
+            <a:ext cx="5120640" cy="1188720"/>
+          </a:xfrm>
+          <a:prstGeom prst="rect">
+            <a:avLst/>
+          </a:prstGeom>
+          <a:noFill/>
+        </p:spPr>
+        <p:txBody>
+          <a:bodyPr wrap="square" anchor="t" lIns="0" rIns="0" tIns="0" bIns="0">
+            <a:spAutoFit/>
+          </a:bodyPr>
+          <a:lstStyle/>
+          <a:p>
+            <a:pPr algn="l"/>
+            <a:r>
               <a:rPr sz="1300" b="0">
                 <a:solidFill>
                   <a:srgbClr val="525252"/>
                 </a:solidFill>
                 <a:latin typeface="Calibri"/>
               </a:rPr>
-              <a:t>Allocate rank by </a:t>
+              <a:t>Keep no clean subset.  Replace a weight matrix  </a:t>
             </a:r>
             <a:r>
               <a:rPr sz="1300" b="1">
@@ -5450,7 +5401,7 @@
                 </a:solidFill>
                 <a:latin typeface="Calibri"/>
               </a:rPr>
-              <a:t>downstream impact</a:t>
+              <a:t>W ≈ A · B</a:t>
             </a:r>
             <a:r>
               <a:rPr sz="1300" b="0">
@@ -5459,23 +5410,17 @@
                 </a:solidFill>
                 <a:latin typeface="Calibri"/>
               </a:rPr>
-              <a:t>, not local importance:</a:t>
-            </a:r>
-          </a:p>
-          <a:p>
-            <a:pPr algn="l"/>
-            <a:r>
-              <a:rPr sz="700" b="0">
+              <a:t>  with two smaller matrices — keeping a low-dimensional </a:t>
+            </a:r>
+            <a:r>
+              <a:rPr sz="1300" b="1">
                 <a:solidFill>
                   <a:srgbClr val="1A1A1A"/>
                 </a:solidFill>
                 <a:latin typeface="Calibri"/>
               </a:rPr>
-              <a:t/>
-            </a:r>
-          </a:p>
-          <a:p>
-            <a:pPr algn="l"/>
+              <a:t>rotated subspace</a:t>
+            </a:r>
             <a:r>
               <a:rPr sz="1300" b="0">
                 <a:solidFill>
@@ -5483,99 +5428,27 @@
                 </a:solidFill>
                 <a:latin typeface="Calibri"/>
               </a:rPr>
-              <a:t>•  measure each layer's </a:t>
-            </a:r>
-            <a:r>
-              <a:rPr sz="1300" b="1">
-                <a:solidFill>
-                  <a:srgbClr val="2E8B57"/>
-                </a:solidFill>
-                <a:latin typeface="Calibri"/>
-              </a:rPr>
-              <a:t>error amplification</a:t>
-            </a:r>
-            <a:r>
-              <a:rPr sz="1300" b="0">
-                <a:solidFill>
-                  <a:srgbClr val="525252"/>
-                </a:solidFill>
-                <a:latin typeface="Calibri"/>
-              </a:rPr>
-              <a:t> to the output</a:t>
-            </a:r>
-          </a:p>
-          <a:p>
-            <a:pPr algn="l"/>
-            <a:r>
-              <a:rPr sz="1300" b="0">
-                <a:solidFill>
-                  <a:srgbClr val="525252"/>
-                </a:solidFill>
-                <a:latin typeface="Calibri"/>
-              </a:rPr>
-              <a:t>•  account for </a:t>
-            </a:r>
-            <a:r>
-              <a:rPr sz="1300" b="1">
-                <a:solidFill>
-                  <a:srgbClr val="2E8B57"/>
-                </a:solidFill>
-                <a:latin typeface="Calibri"/>
-              </a:rPr>
-              <a:t>cross-layer coupling</a:t>
-            </a:r>
-            <a:r>
-              <a:rPr sz="1300" b="0">
-                <a:solidFill>
-                  <a:srgbClr val="525252"/>
-                </a:solidFill>
-                <a:latin typeface="Calibri"/>
-              </a:rPr>
-              <a:t> — allocate jointly, not greedily</a:t>
-            </a:r>
-          </a:p>
-          <a:p>
-            <a:pPr algn="l"/>
-            <a:r>
-              <a:rPr sz="700" b="0">
-                <a:solidFill>
-                  <a:srgbClr val="1A1A1A"/>
-                </a:solidFill>
-                <a:latin typeface="Calibri"/>
-              </a:rPr>
-              <a:t/>
-            </a:r>
-          </a:p>
-          <a:p>
-            <a:pPr algn="l"/>
-            <a:r>
-              <a:rPr sz="1300" b="1">
-                <a:solidFill>
-                  <a:srgbClr val="1A1A1A"/>
-                </a:solidFill>
-                <a:latin typeface="Calibri"/>
-              </a:rPr>
-              <a:t>Protect layers whose errors blow up;  compress hard where they damp.</a:t>
-            </a:r>
-          </a:p>
-        </p:txBody>
-      </p:sp>
-      <p:sp>
-        <p:nvSpPr>
-          <p:cNvPr id="14" name="Rectangle 13"/>
+              <a:t> (mixtures of neurons).   “Rank” = the inner size.</a:t>
+            </a:r>
+          </a:p>
+        </p:txBody>
+      </p:sp>
+      <p:sp>
+        <p:nvSpPr>
+          <p:cNvPr id="15" name="Rectangle 14"/>
           <p:cNvSpPr/>
           <p:nvPr/>
         </p:nvSpPr>
         <p:spPr>
           <a:xfrm>
-            <a:off x="365760" y="5212080"/>
-            <a:ext cx="11430000" cy="960120"/>
-          </a:xfrm>
-          <a:prstGeom prst="rect">
-            <a:avLst/>
-          </a:prstGeom>
-          <a:solidFill>
-            <a:srgbClr val="DEEBF7"/>
+            <a:off x="365760" y="3364992"/>
+            <a:ext cx="11430000" cy="1207008"/>
+          </a:xfrm>
+          <a:prstGeom prst="rect">
+            <a:avLst/>
+          </a:prstGeom>
+          <a:solidFill>
+            <a:srgbClr val="FCE4D6"/>
           </a:solidFill>
           <a:ln>
             <a:noFill/>
@@ -5606,20 +5479,20 @@
       </p:sp>
       <p:sp>
         <p:nvSpPr>
-          <p:cNvPr id="15" name="Rectangle 14"/>
+          <p:cNvPr id="16" name="Rectangle 15"/>
           <p:cNvSpPr/>
           <p:nvPr/>
         </p:nvSpPr>
         <p:spPr>
           <a:xfrm>
-            <a:off x="365760" y="5212080"/>
-            <a:ext cx="146304" cy="960120"/>
-          </a:xfrm>
-          <a:prstGeom prst="rect">
-            <a:avLst/>
-          </a:prstGeom>
-          <a:solidFill>
-            <a:srgbClr val="0068B5"/>
+            <a:off x="365760" y="3364992"/>
+            <a:ext cx="146304" cy="1207008"/>
+          </a:xfrm>
+          <a:prstGeom prst="rect">
+            <a:avLst/>
+          </a:prstGeom>
+          <a:solidFill>
+            <a:srgbClr val="C0504D"/>
           </a:solidFill>
           <a:ln>
             <a:noFill/>
@@ -5650,14 +5523,14 @@
       </p:sp>
       <p:sp>
         <p:nvSpPr>
-          <p:cNvPr id="16" name="TextBox 15"/>
+          <p:cNvPr id="17" name="TextBox 16"/>
           <p:cNvSpPr txBox="1"/>
           <p:nvPr/>
         </p:nvSpPr>
         <p:spPr>
           <a:xfrm>
-            <a:off x="685800" y="5303520"/>
-            <a:ext cx="10972800" cy="822960"/>
+            <a:off x="685800" y="3456432"/>
+            <a:ext cx="10972800" cy="1078992"/>
           </a:xfrm>
           <a:prstGeom prst="rect">
             <a:avLst/>
@@ -5665,20 +5538,47 @@
           <a:noFill/>
         </p:spPr>
         <p:txBody>
-          <a:bodyPr wrap="square" anchor="ctr" lIns="0" rIns="0" tIns="0" bIns="0">
+          <a:bodyPr wrap="square" anchor="t" lIns="0" rIns="0" tIns="0" bIns="0">
             <a:spAutoFit/>
           </a:bodyPr>
           <a:lstStyle/>
           <a:p>
             <a:pPr algn="l"/>
             <a:r>
+              <a:rPr sz="1400" b="1">
+                <a:solidFill>
+                  <a:srgbClr val="C0504D"/>
+                </a:solidFill>
+                <a:latin typeface="Calibri"/>
+              </a:rPr>
+              <a:t>The weakness both share:  </a:t>
+            </a:r>
+            <a:r>
+              <a:rPr sz="1300" b="0">
+                <a:solidFill>
+                  <a:srgbClr val="1A1A1A"/>
+                </a:solidFill>
+                <a:latin typeface="Calibri"/>
+              </a:rPr>
+              <a:t>either way, the method decides </a:t>
+            </a:r>
+            <a:r>
               <a:rPr sz="1300" b="1">
                 <a:solidFill>
-                  <a:srgbClr val="0068B5"/>
-                </a:solidFill>
-                <a:latin typeface="Calibri"/>
-              </a:rPr>
-              <a:t>Novelty in one line:  </a:t>
+                  <a:srgbClr val="1A1A1A"/>
+                </a:solidFill>
+                <a:latin typeface="Calibri"/>
+              </a:rPr>
+              <a:t>per layer how much to cut</a:t>
+            </a:r>
+            <a:r>
+              <a:rPr sz="1300" b="0">
+                <a:solidFill>
+                  <a:srgbClr val="1A1A1A"/>
+                </a:solidFill>
+                <a:latin typeface="Calibri"/>
+              </a:rPr>
+              <a:t>, from a </a:t>
             </a:r>
             <a:r>
               <a:rPr sz="1300" b="1">
@@ -5687,28 +5587,235 @@
                 </a:solidFill>
                 <a:latin typeface="Calibri"/>
               </a:rPr>
-              <a:t>the first error-propagation-aware, cross-layer-coupled rank allocation for low-rank LLM compression.</a:t>
+              <a:t>LOCAL</a:t>
+            </a:r>
+            <a:r>
+              <a:rPr sz="1300" b="0">
+                <a:solidFill>
+                  <a:srgbClr val="1A1A1A"/>
+                </a:solidFill>
+                <a:latin typeface="Calibri"/>
+              </a:rPr>
+              <a:t> score (importance / reconstruction at that layer alone).</a:t>
             </a:r>
           </a:p>
           <a:p>
             <a:pPr algn="l"/>
             <a:r>
-              <a:rPr sz="1200" b="0">
+              <a:rPr sz="1300" b="0">
                 <a:solidFill>
                   <a:srgbClr val="525252"/>
                 </a:solidFill>
                 <a:latin typeface="Calibri"/>
               </a:rPr>
-              <a:t>Prior work allocates per layer in isolation; we allocate over the propagation graph.   </a:t>
-            </a:r>
-            <a:r>
-              <a:rPr sz="1200" b="0">
+              <a:t>It is blind to how an </a:t>
+            </a:r>
+            <a:r>
+              <a:rPr sz="1300" b="1">
+                <a:solidFill>
+                  <a:srgbClr val="C0504D"/>
+                </a:solidFill>
+                <a:latin typeface="Calibri"/>
+              </a:rPr>
+              <a:t>early layer's error amplifies downstream</a:t>
+            </a:r>
+            <a:r>
+              <a:rPr sz="1300" b="0">
+                <a:solidFill>
+                  <a:srgbClr val="525252"/>
+                </a:solidFill>
+                <a:latin typeface="Calibri"/>
+              </a:rPr>
+              <a:t> (~30× by the output) — the chain is ignored.</a:t>
+            </a:r>
+          </a:p>
+        </p:txBody>
+      </p:sp>
+      <p:sp>
+        <p:nvSpPr>
+          <p:cNvPr id="18" name="Rectangle 17"/>
+          <p:cNvSpPr/>
+          <p:nvPr/>
+        </p:nvSpPr>
+        <p:spPr>
+          <a:xfrm>
+            <a:off x="365760" y="4718304"/>
+            <a:ext cx="11430000" cy="1325880"/>
+          </a:xfrm>
+          <a:prstGeom prst="rect">
+            <a:avLst/>
+          </a:prstGeom>
+          <a:solidFill>
+            <a:srgbClr val="E2F0D9"/>
+          </a:solidFill>
+          <a:ln>
+            <a:noFill/>
+          </a:ln>
+          <a:effectLst/>
+        </p:spPr>
+        <p:style>
+          <a:lnRef idx="1">
+            <a:schemeClr val="accent1"/>
+          </a:lnRef>
+          <a:fillRef idx="3">
+            <a:schemeClr val="accent1"/>
+          </a:fillRef>
+          <a:effectRef idx="2">
+            <a:schemeClr val="accent1"/>
+          </a:effectRef>
+          <a:fontRef idx="minor">
+            <a:schemeClr val="lt1"/>
+          </a:fontRef>
+        </p:style>
+        <p:txBody>
+          <a:bodyPr rtlCol="0" anchor="ctr"/>
+          <a:lstStyle/>
+          <a:p>
+            <a:pPr algn="ctr"/>
+          </a:p>
+        </p:txBody>
+      </p:sp>
+      <p:sp>
+        <p:nvSpPr>
+          <p:cNvPr id="19" name="Rectangle 18"/>
+          <p:cNvSpPr/>
+          <p:nvPr/>
+        </p:nvSpPr>
+        <p:spPr>
+          <a:xfrm>
+            <a:off x="365760" y="4718304"/>
+            <a:ext cx="146304" cy="1325880"/>
+          </a:xfrm>
+          <a:prstGeom prst="rect">
+            <a:avLst/>
+          </a:prstGeom>
+          <a:solidFill>
+            <a:srgbClr val="2E8B57"/>
+          </a:solidFill>
+          <a:ln>
+            <a:noFill/>
+          </a:ln>
+          <a:effectLst/>
+        </p:spPr>
+        <p:style>
+          <a:lnRef idx="1">
+            <a:schemeClr val="accent1"/>
+          </a:lnRef>
+          <a:fillRef idx="3">
+            <a:schemeClr val="accent1"/>
+          </a:fillRef>
+          <a:effectRef idx="2">
+            <a:schemeClr val="accent1"/>
+          </a:effectRef>
+          <a:fontRef idx="minor">
+            <a:schemeClr val="lt1"/>
+          </a:fontRef>
+        </p:style>
+        <p:txBody>
+          <a:bodyPr rtlCol="0" anchor="ctr"/>
+          <a:lstStyle/>
+          <a:p>
+            <a:pPr algn="ctr"/>
+          </a:p>
+        </p:txBody>
+      </p:sp>
+      <p:sp>
+        <p:nvSpPr>
+          <p:cNvPr id="20" name="TextBox 19"/>
+          <p:cNvSpPr txBox="1"/>
+          <p:nvPr/>
+        </p:nvSpPr>
+        <p:spPr>
+          <a:xfrm>
+            <a:off x="685800" y="4809744"/>
+            <a:ext cx="10972800" cy="1188720"/>
+          </a:xfrm>
+          <a:prstGeom prst="rect">
+            <a:avLst/>
+          </a:prstGeom>
+          <a:noFill/>
+        </p:spPr>
+        <p:txBody>
+          <a:bodyPr wrap="square" anchor="t" lIns="0" rIns="0" tIns="0" bIns="0">
+            <a:spAutoFit/>
+          </a:bodyPr>
+          <a:lstStyle/>
+          <a:p>
+            <a:pPr algn="l"/>
+            <a:r>
+              <a:rPr sz="1400" b="1">
                 <a:solidFill>
                   <a:srgbClr val="2E8B57"/>
                 </a:solidFill>
                 <a:latin typeface="Calibri"/>
               </a:rPr>
-              <a:t>(Result next: it beats FLAT-LLM at the same budget.)</a:t>
+              <a:t>Our cure — the novelty:  </a:t>
+            </a:r>
+            <a:r>
+              <a:rPr sz="1300" b="0">
+                <a:solidFill>
+                  <a:srgbClr val="1A1A1A"/>
+                </a:solidFill>
+                <a:latin typeface="Calibri"/>
+              </a:rPr>
+              <a:t>allocate rank by </a:t>
+            </a:r>
+            <a:r>
+              <a:rPr sz="1300" b="1">
+                <a:solidFill>
+                  <a:srgbClr val="2E8B57"/>
+                </a:solidFill>
+                <a:latin typeface="Calibri"/>
+              </a:rPr>
+              <a:t>downstream amplification</a:t>
+            </a:r>
+            <a:r>
+              <a:rPr sz="1300" b="0">
+                <a:solidFill>
+                  <a:srgbClr val="1A1A1A"/>
+                </a:solidFill>
+                <a:latin typeface="Calibri"/>
+              </a:rPr>
+              <a:t> and </a:t>
+            </a:r>
+            <a:r>
+              <a:rPr sz="1300" b="1">
+                <a:solidFill>
+                  <a:srgbClr val="2E8B57"/>
+                </a:solidFill>
+                <a:latin typeface="Calibri"/>
+              </a:rPr>
+              <a:t>cross-layer coupling</a:t>
+            </a:r>
+            <a:r>
+              <a:rPr sz="1300" b="0">
+                <a:solidFill>
+                  <a:srgbClr val="1A1A1A"/>
+                </a:solidFill>
+                <a:latin typeface="Calibri"/>
+              </a:rPr>
+              <a:t>, jointly.</a:t>
+            </a:r>
+          </a:p>
+          <a:p>
+            <a:pPr algn="l"/>
+            <a:r>
+              <a:rPr sz="1300" b="0">
+                <a:solidFill>
+                  <a:srgbClr val="525252"/>
+                </a:solidFill>
+                <a:latin typeface="Calibri"/>
+              </a:rPr>
+              <a:t>Protect layers whose errors blow up; compress hard where they damp.   </a:t>
+            </a:r>
+            <a:r>
+              <a:rPr sz="1300" b="1">
+                <a:solidFill>
+                  <a:srgbClr val="1A1A1A"/>
+                </a:solidFill>
+                <a:latin typeface="Calibri"/>
+              </a:rPr>
+              <a:t>The first error-propagation-aware allocation for low-rank LLM compression.</a:t>
             </a:r>
           </a:p>
         </p:txBody>
@@ -9282,7 +9389,7 @@
                 </a:solidFill>
                 <a:latin typeface="Calibri"/>
               </a:rPr>
-              <a:t>FLAT-LLM's angular BI protects boundary layers (0, 31);</a:t>
+              <a:t>FLAT-LLM's block-influence (how much a layer rotates the residual) favors boundary layers 0 &amp; 31;</a:t>
             </a:r>
           </a:p>
           <a:p>

</xml_diff>

<commit_message>
Soften novelty claim: replace 'first error-propagation-aware allocation' with empirical framing
Literature check found global/loss-aware rank allocation is established (Zero-Sum SVD,
Fisher-based, global rank+sparsity optimization). Removed unsupported 'first/novelty'
wording; slide now states only the verifiable empirical result (beats FLAT-LLM at iso-budget).

Co-Authored-By: Claude Sonnet 4.6 <noreply@anthropic.com>
</commit_message>
<xml_diff>
--- a/hypergraph_slides.pptx
+++ b/hypergraph_slides.pptx
@@ -5749,7 +5749,7 @@
                 </a:solidFill>
                 <a:latin typeface="Calibri"/>
               </a:rPr>
-              <a:t>Our cure — the novelty:  </a:t>
+              <a:t>Our approach:  </a:t>
             </a:r>
             <a:r>
               <a:rPr sz="1300" b="0">
@@ -5794,7 +5794,7 @@
                 </a:solidFill>
                 <a:latin typeface="Calibri"/>
               </a:rPr>
-              <a:t>, jointly.</a:t>
+              <a:t>, not a purely local per-layer score.</a:t>
             </a:r>
           </a:p>
           <a:p>
@@ -5815,7 +5815,7 @@
                 </a:solidFill>
                 <a:latin typeface="Calibri"/>
               </a:rPr>
-              <a:t>The first error-propagation-aware allocation for low-rank LLM compression.</a:t>
+              <a:t>Empirically: beats FLAT-LLM at the same budget (next slide).</a:t>
             </a:r>
           </a:p>
         </p:txBody>

</xml_diff>

<commit_message>
Slide 14 (Finding 3): add plain-language gloss under each bar label
Uniform = every layer same rank; Ours = more rank to high-amplification layers,
jointly; FLAT-LLM = rank by block-influence. Clarifies the allocation methods for
the audience.

Co-Authored-By: Claude Sonnet 4.6 <noreply@anthropic.com>
</commit_message>
<xml_diff>
--- a/hypergraph_slides.pptx
+++ b/hypergraph_slides.pptx
@@ -8509,8 +8509,8 @@
         </p:nvSpPr>
         <p:spPr>
           <a:xfrm>
-            <a:off x="411480" y="1664208"/>
-            <a:ext cx="3611880" cy="457200"/>
+            <a:off x="274320" y="1600200"/>
+            <a:ext cx="4069080" cy="566928"/>
           </a:xfrm>
           <a:prstGeom prst="rect">
             <a:avLst/>
@@ -8534,6 +8534,18 @@
               <a:t>No compression</a:t>
             </a:r>
           </a:p>
+          <a:p>
+            <a:pPr algn="r"/>
+            <a:r>
+              <a:rPr sz="1000" b="0">
+                <a:solidFill>
+                  <a:srgbClr val="525252"/>
+                </a:solidFill>
+                <a:latin typeface="Calibri"/>
+              </a:rPr>
+              <a:t>the full, uncompressed model</a:t>
+            </a:r>
+          </a:p>
         </p:txBody>
       </p:sp>
       <p:sp>
@@ -8544,8 +8556,8 @@
         </p:nvSpPr>
         <p:spPr>
           <a:xfrm>
-            <a:off x="4160520" y="1627632"/>
-            <a:ext cx="2528665" cy="420624"/>
+            <a:off x="4526280" y="1645920"/>
+            <a:ext cx="2384170" cy="420624"/>
           </a:xfrm>
           <a:prstGeom prst="roundRect">
             <a:avLst/>
@@ -8588,7 +8600,7 @@
         </p:nvSpPr>
         <p:spPr>
           <a:xfrm>
-            <a:off x="6798913" y="1655064"/>
+            <a:off x="7020178" y="1682496"/>
             <a:ext cx="1280160" cy="365760"/>
           </a:xfrm>
           <a:prstGeom prst="rect">
@@ -8623,8 +8635,8 @@
         </p:nvSpPr>
         <p:spPr>
           <a:xfrm>
-            <a:off x="411480" y="2304288"/>
-            <a:ext cx="3611880" cy="457200"/>
+            <a:off x="274320" y="2258568"/>
+            <a:ext cx="4069080" cy="566928"/>
           </a:xfrm>
           <a:prstGeom prst="rect">
             <a:avLst/>
@@ -8648,6 +8660,18 @@
               <a:t>Uniform</a:t>
             </a:r>
           </a:p>
+          <a:p>
+            <a:pPr algn="r"/>
+            <a:r>
+              <a:rPr sz="1000" b="0">
+                <a:solidFill>
+                  <a:srgbClr val="525252"/>
+                </a:solidFill>
+                <a:latin typeface="Calibri"/>
+              </a:rPr>
+              <a:t>every layer gets the SAME rank</a:t>
+            </a:r>
+          </a:p>
         </p:txBody>
       </p:sp>
       <p:sp>
@@ -8658,8 +8682,8 @@
         </p:nvSpPr>
         <p:spPr>
           <a:xfrm>
-            <a:off x="4160520" y="2267712"/>
-            <a:ext cx="6400800" cy="420624"/>
+            <a:off x="4526280" y="2304288"/>
+            <a:ext cx="6035040" cy="420624"/>
           </a:xfrm>
           <a:prstGeom prst="roundRect">
             <a:avLst/>
@@ -8702,7 +8726,7 @@
         </p:nvSpPr>
         <p:spPr>
           <a:xfrm>
-            <a:off x="10671048" y="2295144"/>
+            <a:off x="10671048" y="2340864"/>
             <a:ext cx="1280160" cy="365760"/>
           </a:xfrm>
           <a:prstGeom prst="rect">
@@ -8737,8 +8761,8 @@
         </p:nvSpPr>
         <p:spPr>
           <a:xfrm>
-            <a:off x="411480" y="2944368"/>
-            <a:ext cx="3611880" cy="457200"/>
+            <a:off x="274320" y="2916936"/>
+            <a:ext cx="4069080" cy="566928"/>
           </a:xfrm>
           <a:prstGeom prst="rect">
             <a:avLst/>
@@ -8759,7 +8783,19 @@
                 </a:solidFill>
                 <a:latin typeface="Calibri"/>
               </a:rPr>
-              <a:t>FLAT-LLM  (SOTA)</a:t>
+              <a:t>FLAT-LLM (SOTA)</a:t>
+            </a:r>
+          </a:p>
+          <a:p>
+            <a:pPr algn="r"/>
+            <a:r>
+              <a:rPr sz="1000" b="0">
+                <a:solidFill>
+                  <a:srgbClr val="525252"/>
+                </a:solidFill>
+                <a:latin typeface="Calibri"/>
+              </a:rPr>
+              <a:t>rank set by block-influence score</a:t>
             </a:r>
           </a:p>
         </p:txBody>
@@ -8772,8 +8808,8 @@
         </p:nvSpPr>
         <p:spPr>
           <a:xfrm>
-            <a:off x="4160520" y="2907791"/>
-            <a:ext cx="5359151" cy="420624"/>
+            <a:off x="4526280" y="2962656"/>
+            <a:ext cx="5052914" cy="420624"/>
           </a:xfrm>
           <a:prstGeom prst="roundRect">
             <a:avLst/>
@@ -8816,7 +8852,7 @@
         </p:nvSpPr>
         <p:spPr>
           <a:xfrm>
-            <a:off x="9629399" y="2935223"/>
+            <a:off x="9688922" y="2999232"/>
             <a:ext cx="1280160" cy="365760"/>
           </a:xfrm>
           <a:prstGeom prst="rect">
@@ -8851,8 +8887,8 @@
         </p:nvSpPr>
         <p:spPr>
           <a:xfrm>
-            <a:off x="411480" y="3584448"/>
-            <a:ext cx="3611880" cy="457200"/>
+            <a:off x="274320" y="3575304"/>
+            <a:ext cx="4069080" cy="566928"/>
           </a:xfrm>
           <a:prstGeom prst="rect">
             <a:avLst/>
@@ -8873,7 +8909,19 @@
                 </a:solidFill>
                 <a:latin typeface="Calibri"/>
               </a:rPr>
-              <a:t>Ours  (amplification-joint)</a:t>
+              <a:t>Ours</a:t>
+            </a:r>
+          </a:p>
+          <a:p>
+            <a:pPr algn="r"/>
+            <a:r>
+              <a:rPr sz="1000" b="0">
+                <a:solidFill>
+                  <a:srgbClr val="525252"/>
+                </a:solidFill>
+                <a:latin typeface="Calibri"/>
+              </a:rPr>
+              <a:t>more rank to high-amplification layers, jointly</a:t>
             </a:r>
           </a:p>
         </p:txBody>
@@ -8886,8 +8934,8 @@
         </p:nvSpPr>
         <p:spPr>
           <a:xfrm>
-            <a:off x="4160520" y="3547872"/>
-            <a:ext cx="5138307" cy="420624"/>
+            <a:off x="4526280" y="3621024"/>
+            <a:ext cx="4844689" cy="420624"/>
           </a:xfrm>
           <a:prstGeom prst="roundRect">
             <a:avLst/>
@@ -8930,7 +8978,7 @@
         </p:nvSpPr>
         <p:spPr>
           <a:xfrm>
-            <a:off x="9408555" y="3575303"/>
+            <a:off x="9480697" y="3657600"/>
             <a:ext cx="1280160" cy="365760"/>
           </a:xfrm>
           <a:prstGeom prst="rect">
@@ -8965,8 +9013,8 @@
         </p:nvSpPr>
         <p:spPr>
           <a:xfrm>
-            <a:off x="4160520" y="4151376"/>
-            <a:ext cx="6858000" cy="274320"/>
+            <a:off x="4526280" y="4261104"/>
+            <a:ext cx="6400800" cy="274320"/>
           </a:xfrm>
           <a:prstGeom prst="rect">
             <a:avLst/>

</xml_diff>

<commit_message>
Add methods-explainer slide (13) before results: how Uniform/FLAT-LLM/Ours allocate rank
Per-method rule + mini rank-profile sketch (uniform=flat, FLAT-LLM=U-shape protecting
boundary layers, Ours=front-loaded protecting high-amplification early/mid layers).
Deck now 15 slides; Finding-3 results moved to slide 14.

Co-Authored-By: Claude Sonnet 4.6 <noreply@anthropic.com>
</commit_message>
<xml_diff>
--- a/hypergraph_slides.pptx
+++ b/hypergraph_slides.pptx
@@ -19,6 +19,7 @@
     <p:sldId id="267" r:id="rId18"/>
     <p:sldId id="268" r:id="rId19"/>
     <p:sldId id="269" r:id="rId20"/>
+    <p:sldId id="270" r:id="rId21"/>
   </p:sldIdLst>
   <p:sldSz cx="12192000" cy="6858000" type="screen4x3"/>
   <p:notesSz cx="6858000" cy="9144000"/>
@@ -8346,7 +8347,7 @@
                 </a:solidFill>
                 <a:latin typeface="Calibri"/>
               </a:rPr>
-              <a:t>Finding 3:  Amplification-Aware Allocation Beats FLAT-LLM</a:t>
+              <a:t>How the Three Methods Allocate the Rank Budget</a:t>
             </a:r>
           </a:p>
         </p:txBody>
@@ -8426,6 +8427,2842 @@
                 <a:latin typeface="Calibri"/>
               </a:rPr>
               <a:t>13</a:t>
+            </a:r>
+          </a:p>
+        </p:txBody>
+      </p:sp>
+      <p:sp>
+        <p:nvSpPr>
+          <p:cNvPr id="5" name="TextBox 4"/>
+          <p:cNvSpPr txBox="1"/>
+          <p:nvPr/>
+        </p:nvSpPr>
+        <p:spPr>
+          <a:xfrm>
+            <a:off x="365760" y="914400"/>
+            <a:ext cx="11430000" cy="365760"/>
+          </a:xfrm>
+          <a:prstGeom prst="rect">
+            <a:avLst/>
+          </a:prstGeom>
+          <a:noFill/>
+        </p:spPr>
+        <p:txBody>
+          <a:bodyPr wrap="square" anchor="t" lIns="0" rIns="0" tIns="0" bIns="0">
+            <a:spAutoFit/>
+          </a:bodyPr>
+          <a:lstStyle/>
+          <a:p>
+            <a:pPr algn="l"/>
+            <a:r>
+              <a:rPr sz="1400" b="1">
+                <a:solidFill>
+                  <a:srgbClr val="1A1A1A"/>
+                </a:solidFill>
+                <a:latin typeface="Calibri"/>
+              </a:rPr>
+              <a:t>Every method spends the </a:t>
+            </a:r>
+            <a:r>
+              <a:rPr sz="1400" b="1">
+                <a:solidFill>
+                  <a:srgbClr val="2E8B57"/>
+                </a:solidFill>
+                <a:latin typeface="Calibri"/>
+              </a:rPr>
+              <a:t>same total rank</a:t>
+            </a:r>
+            <a:r>
+              <a:rPr sz="1400" b="1">
+                <a:solidFill>
+                  <a:srgbClr val="1A1A1A"/>
+                </a:solidFill>
+                <a:latin typeface="Calibri"/>
+              </a:rPr>
+              <a:t> — they differ only in </a:t>
+            </a:r>
+            <a:r>
+              <a:rPr sz="1400" b="1">
+                <a:solidFill>
+                  <a:srgbClr val="0068B5"/>
+                </a:solidFill>
+                <a:latin typeface="Calibri"/>
+              </a:rPr>
+              <a:t>which layers get more.</a:t>
+            </a:r>
+          </a:p>
+        </p:txBody>
+      </p:sp>
+      <p:sp>
+        <p:nvSpPr>
+          <p:cNvPr id="6" name="Rectangle 5"/>
+          <p:cNvSpPr/>
+          <p:nvPr/>
+        </p:nvSpPr>
+        <p:spPr>
+          <a:xfrm>
+            <a:off x="365760" y="1389888"/>
+            <a:ext cx="3685032" cy="4434840"/>
+          </a:xfrm>
+          <a:prstGeom prst="rect">
+            <a:avLst/>
+          </a:prstGeom>
+          <a:solidFill>
+            <a:srgbClr val="EEEEEE"/>
+          </a:solidFill>
+          <a:ln>
+            <a:noFill/>
+          </a:ln>
+          <a:effectLst/>
+        </p:spPr>
+        <p:style>
+          <a:lnRef idx="1">
+            <a:schemeClr val="accent1"/>
+          </a:lnRef>
+          <a:fillRef idx="3">
+            <a:schemeClr val="accent1"/>
+          </a:fillRef>
+          <a:effectRef idx="2">
+            <a:schemeClr val="accent1"/>
+          </a:effectRef>
+          <a:fontRef idx="minor">
+            <a:schemeClr val="lt1"/>
+          </a:fontRef>
+        </p:style>
+        <p:txBody>
+          <a:bodyPr rtlCol="0" anchor="ctr"/>
+          <a:lstStyle/>
+          <a:p>
+            <a:pPr algn="ctr"/>
+          </a:p>
+        </p:txBody>
+      </p:sp>
+      <p:sp>
+        <p:nvSpPr>
+          <p:cNvPr id="7" name="Rectangle 6"/>
+          <p:cNvSpPr/>
+          <p:nvPr/>
+        </p:nvSpPr>
+        <p:spPr>
+          <a:xfrm>
+            <a:off x="365760" y="1389888"/>
+            <a:ext cx="3685032" cy="91440"/>
+          </a:xfrm>
+          <a:prstGeom prst="rect">
+            <a:avLst/>
+          </a:prstGeom>
+          <a:solidFill>
+            <a:srgbClr val="9E9E9E"/>
+          </a:solidFill>
+          <a:ln>
+            <a:noFill/>
+          </a:ln>
+          <a:effectLst/>
+        </p:spPr>
+        <p:style>
+          <a:lnRef idx="1">
+            <a:schemeClr val="accent1"/>
+          </a:lnRef>
+          <a:fillRef idx="3">
+            <a:schemeClr val="accent1"/>
+          </a:fillRef>
+          <a:effectRef idx="2">
+            <a:schemeClr val="accent1"/>
+          </a:effectRef>
+          <a:fontRef idx="minor">
+            <a:schemeClr val="lt1"/>
+          </a:fontRef>
+        </p:style>
+        <p:txBody>
+          <a:bodyPr rtlCol="0" anchor="ctr"/>
+          <a:lstStyle/>
+          <a:p>
+            <a:pPr algn="ctr"/>
+          </a:p>
+        </p:txBody>
+      </p:sp>
+      <p:sp>
+        <p:nvSpPr>
+          <p:cNvPr id="8" name="TextBox 7"/>
+          <p:cNvSpPr txBox="1"/>
+          <p:nvPr/>
+        </p:nvSpPr>
+        <p:spPr>
+          <a:xfrm>
+            <a:off x="566928" y="1591056"/>
+            <a:ext cx="3282696" cy="365760"/>
+          </a:xfrm>
+          <a:prstGeom prst="rect">
+            <a:avLst/>
+          </a:prstGeom>
+          <a:noFill/>
+        </p:spPr>
+        <p:txBody>
+          <a:bodyPr wrap="square" anchor="t" lIns="0" rIns="0" tIns="0" bIns="0">
+            <a:spAutoFit/>
+          </a:bodyPr>
+          <a:lstStyle/>
+          <a:p>
+            <a:pPr algn="l"/>
+            <a:r>
+              <a:rPr sz="1500" b="1">
+                <a:solidFill>
+                  <a:srgbClr val="9E9E9E"/>
+                </a:solidFill>
+                <a:latin typeface="Calibri"/>
+              </a:rPr>
+              <a:t>Uniform</a:t>
+            </a:r>
+          </a:p>
+        </p:txBody>
+      </p:sp>
+      <p:sp>
+        <p:nvSpPr>
+          <p:cNvPr id="9" name="TextBox 8"/>
+          <p:cNvSpPr txBox="1"/>
+          <p:nvPr/>
+        </p:nvSpPr>
+        <p:spPr>
+          <a:xfrm>
+            <a:off x="566928" y="2048256"/>
+            <a:ext cx="3282696" cy="914400"/>
+          </a:xfrm>
+          <a:prstGeom prst="rect">
+            <a:avLst/>
+          </a:prstGeom>
+          <a:noFill/>
+        </p:spPr>
+        <p:txBody>
+          <a:bodyPr wrap="square" anchor="t" lIns="0" rIns="0" tIns="0" bIns="0">
+            <a:spAutoFit/>
+          </a:bodyPr>
+          <a:lstStyle/>
+          <a:p>
+            <a:pPr algn="l"/>
+            <a:r>
+              <a:rPr sz="1200" b="0">
+                <a:solidFill>
+                  <a:srgbClr val="525252"/>
+                </a:solidFill>
+                <a:latin typeface="Calibri"/>
+              </a:rPr>
+              <a:t>Give every layer the same rank.</a:t>
+            </a:r>
+          </a:p>
+        </p:txBody>
+      </p:sp>
+      <p:sp>
+        <p:nvSpPr>
+          <p:cNvPr id="10" name="Rounded Rectangle 9"/>
+          <p:cNvSpPr/>
+          <p:nvPr/>
+        </p:nvSpPr>
+        <p:spPr>
+          <a:xfrm>
+            <a:off x="640080" y="3858768"/>
+            <a:ext cx="274320" cy="640080"/>
+          </a:xfrm>
+          <a:prstGeom prst="roundRect">
+            <a:avLst/>
+          </a:prstGeom>
+          <a:solidFill>
+            <a:srgbClr val="9E9E9E"/>
+          </a:solidFill>
+          <a:ln>
+            <a:noFill/>
+          </a:ln>
+          <a:effectLst/>
+        </p:spPr>
+        <p:style>
+          <a:lnRef idx="1">
+            <a:schemeClr val="accent1"/>
+          </a:lnRef>
+          <a:fillRef idx="3">
+            <a:schemeClr val="accent1"/>
+          </a:fillRef>
+          <a:effectRef idx="2">
+            <a:schemeClr val="accent1"/>
+          </a:effectRef>
+          <a:fontRef idx="minor">
+            <a:schemeClr val="lt1"/>
+          </a:fontRef>
+        </p:style>
+        <p:txBody>
+          <a:bodyPr rtlCol="0" anchor="ctr"/>
+          <a:lstStyle/>
+          <a:p>
+            <a:pPr algn="ctr"/>
+          </a:p>
+        </p:txBody>
+      </p:sp>
+      <p:sp>
+        <p:nvSpPr>
+          <p:cNvPr id="11" name="TextBox 10"/>
+          <p:cNvSpPr txBox="1"/>
+          <p:nvPr/>
+        </p:nvSpPr>
+        <p:spPr>
+          <a:xfrm>
+            <a:off x="548640" y="4526280"/>
+            <a:ext cx="457200" cy="182880"/>
+          </a:xfrm>
+          <a:prstGeom prst="rect">
+            <a:avLst/>
+          </a:prstGeom>
+          <a:noFill/>
+        </p:spPr>
+        <p:txBody>
+          <a:bodyPr wrap="square" anchor="t" lIns="0" rIns="0" tIns="0" bIns="0">
+            <a:spAutoFit/>
+          </a:bodyPr>
+          <a:lstStyle/>
+          <a:p>
+            <a:pPr algn="ctr"/>
+            <a:r>
+              <a:rPr sz="700" b="0">
+                <a:solidFill>
+                  <a:srgbClr val="525252"/>
+                </a:solidFill>
+                <a:latin typeface="Calibri"/>
+              </a:rPr>
+              <a:t>0</a:t>
+            </a:r>
+          </a:p>
+        </p:txBody>
+      </p:sp>
+      <p:sp>
+        <p:nvSpPr>
+          <p:cNvPr id="12" name="Rounded Rectangle 11"/>
+          <p:cNvSpPr/>
+          <p:nvPr/>
+        </p:nvSpPr>
+        <p:spPr>
+          <a:xfrm>
+            <a:off x="1048947" y="3858768"/>
+            <a:ext cx="274320" cy="640080"/>
+          </a:xfrm>
+          <a:prstGeom prst="roundRect">
+            <a:avLst/>
+          </a:prstGeom>
+          <a:solidFill>
+            <a:srgbClr val="9E9E9E"/>
+          </a:solidFill>
+          <a:ln>
+            <a:noFill/>
+          </a:ln>
+          <a:effectLst/>
+        </p:spPr>
+        <p:style>
+          <a:lnRef idx="1">
+            <a:schemeClr val="accent1"/>
+          </a:lnRef>
+          <a:fillRef idx="3">
+            <a:schemeClr val="accent1"/>
+          </a:fillRef>
+          <a:effectRef idx="2">
+            <a:schemeClr val="accent1"/>
+          </a:effectRef>
+          <a:fontRef idx="minor">
+            <a:schemeClr val="lt1"/>
+          </a:fontRef>
+        </p:style>
+        <p:txBody>
+          <a:bodyPr rtlCol="0" anchor="ctr"/>
+          <a:lstStyle/>
+          <a:p>
+            <a:pPr algn="ctr"/>
+          </a:p>
+        </p:txBody>
+      </p:sp>
+      <p:sp>
+        <p:nvSpPr>
+          <p:cNvPr id="13" name="TextBox 12"/>
+          <p:cNvSpPr txBox="1"/>
+          <p:nvPr/>
+        </p:nvSpPr>
+        <p:spPr>
+          <a:xfrm>
+            <a:off x="957507" y="4526280"/>
+            <a:ext cx="457200" cy="182880"/>
+          </a:xfrm>
+          <a:prstGeom prst="rect">
+            <a:avLst/>
+          </a:prstGeom>
+          <a:noFill/>
+        </p:spPr>
+        <p:txBody>
+          <a:bodyPr wrap="square" anchor="t" lIns="0" rIns="0" tIns="0" bIns="0">
+            <a:spAutoFit/>
+          </a:bodyPr>
+          <a:lstStyle/>
+          <a:p>
+            <a:pPr algn="ctr"/>
+            <a:r>
+              <a:rPr sz="700" b="0">
+                <a:solidFill>
+                  <a:srgbClr val="525252"/>
+                </a:solidFill>
+                <a:latin typeface="Calibri"/>
+              </a:rPr>
+              <a:t>2</a:t>
+            </a:r>
+          </a:p>
+        </p:txBody>
+      </p:sp>
+      <p:sp>
+        <p:nvSpPr>
+          <p:cNvPr id="14" name="Rounded Rectangle 13"/>
+          <p:cNvSpPr/>
+          <p:nvPr/>
+        </p:nvSpPr>
+        <p:spPr>
+          <a:xfrm>
+            <a:off x="1457814" y="3858768"/>
+            <a:ext cx="274320" cy="640080"/>
+          </a:xfrm>
+          <a:prstGeom prst="roundRect">
+            <a:avLst/>
+          </a:prstGeom>
+          <a:solidFill>
+            <a:srgbClr val="9E9E9E"/>
+          </a:solidFill>
+          <a:ln>
+            <a:noFill/>
+          </a:ln>
+          <a:effectLst/>
+        </p:spPr>
+        <p:style>
+          <a:lnRef idx="1">
+            <a:schemeClr val="accent1"/>
+          </a:lnRef>
+          <a:fillRef idx="3">
+            <a:schemeClr val="accent1"/>
+          </a:fillRef>
+          <a:effectRef idx="2">
+            <a:schemeClr val="accent1"/>
+          </a:effectRef>
+          <a:fontRef idx="minor">
+            <a:schemeClr val="lt1"/>
+          </a:fontRef>
+        </p:style>
+        <p:txBody>
+          <a:bodyPr rtlCol="0" anchor="ctr"/>
+          <a:lstStyle/>
+          <a:p>
+            <a:pPr algn="ctr"/>
+          </a:p>
+        </p:txBody>
+      </p:sp>
+      <p:sp>
+        <p:nvSpPr>
+          <p:cNvPr id="15" name="TextBox 14"/>
+          <p:cNvSpPr txBox="1"/>
+          <p:nvPr/>
+        </p:nvSpPr>
+        <p:spPr>
+          <a:xfrm>
+            <a:off x="1366374" y="4526280"/>
+            <a:ext cx="457200" cy="182880"/>
+          </a:xfrm>
+          <a:prstGeom prst="rect">
+            <a:avLst/>
+          </a:prstGeom>
+          <a:noFill/>
+        </p:spPr>
+        <p:txBody>
+          <a:bodyPr wrap="square" anchor="t" lIns="0" rIns="0" tIns="0" bIns="0">
+            <a:spAutoFit/>
+          </a:bodyPr>
+          <a:lstStyle/>
+          <a:p>
+            <a:pPr algn="ctr"/>
+            <a:r>
+              <a:rPr sz="700" b="0">
+                <a:solidFill>
+                  <a:srgbClr val="525252"/>
+                </a:solidFill>
+                <a:latin typeface="Calibri"/>
+              </a:rPr>
+              <a:t>5</a:t>
+            </a:r>
+          </a:p>
+        </p:txBody>
+      </p:sp>
+      <p:sp>
+        <p:nvSpPr>
+          <p:cNvPr id="16" name="Rounded Rectangle 15"/>
+          <p:cNvSpPr/>
+          <p:nvPr/>
+        </p:nvSpPr>
+        <p:spPr>
+          <a:xfrm>
+            <a:off x="1866682" y="3858768"/>
+            <a:ext cx="274320" cy="640080"/>
+          </a:xfrm>
+          <a:prstGeom prst="roundRect">
+            <a:avLst/>
+          </a:prstGeom>
+          <a:solidFill>
+            <a:srgbClr val="9E9E9E"/>
+          </a:solidFill>
+          <a:ln>
+            <a:noFill/>
+          </a:ln>
+          <a:effectLst/>
+        </p:spPr>
+        <p:style>
+          <a:lnRef idx="1">
+            <a:schemeClr val="accent1"/>
+          </a:lnRef>
+          <a:fillRef idx="3">
+            <a:schemeClr val="accent1"/>
+          </a:fillRef>
+          <a:effectRef idx="2">
+            <a:schemeClr val="accent1"/>
+          </a:effectRef>
+          <a:fontRef idx="minor">
+            <a:schemeClr val="lt1"/>
+          </a:fontRef>
+        </p:style>
+        <p:txBody>
+          <a:bodyPr rtlCol="0" anchor="ctr"/>
+          <a:lstStyle/>
+          <a:p>
+            <a:pPr algn="ctr"/>
+          </a:p>
+        </p:txBody>
+      </p:sp>
+      <p:sp>
+        <p:nvSpPr>
+          <p:cNvPr id="17" name="TextBox 16"/>
+          <p:cNvSpPr txBox="1"/>
+          <p:nvPr/>
+        </p:nvSpPr>
+        <p:spPr>
+          <a:xfrm>
+            <a:off x="1775242" y="4526280"/>
+            <a:ext cx="457200" cy="182880"/>
+          </a:xfrm>
+          <a:prstGeom prst="rect">
+            <a:avLst/>
+          </a:prstGeom>
+          <a:noFill/>
+        </p:spPr>
+        <p:txBody>
+          <a:bodyPr wrap="square" anchor="t" lIns="0" rIns="0" tIns="0" bIns="0">
+            <a:spAutoFit/>
+          </a:bodyPr>
+          <a:lstStyle/>
+          <a:p>
+            <a:pPr algn="ctr"/>
+            <a:r>
+              <a:rPr sz="700" b="0">
+                <a:solidFill>
+                  <a:srgbClr val="525252"/>
+                </a:solidFill>
+                <a:latin typeface="Calibri"/>
+              </a:rPr>
+              <a:t>10</a:t>
+            </a:r>
+          </a:p>
+        </p:txBody>
+      </p:sp>
+      <p:sp>
+        <p:nvSpPr>
+          <p:cNvPr id="18" name="Rounded Rectangle 17"/>
+          <p:cNvSpPr/>
+          <p:nvPr/>
+        </p:nvSpPr>
+        <p:spPr>
+          <a:xfrm>
+            <a:off x="2275549" y="3858768"/>
+            <a:ext cx="274320" cy="640080"/>
+          </a:xfrm>
+          <a:prstGeom prst="roundRect">
+            <a:avLst/>
+          </a:prstGeom>
+          <a:solidFill>
+            <a:srgbClr val="9E9E9E"/>
+          </a:solidFill>
+          <a:ln>
+            <a:noFill/>
+          </a:ln>
+          <a:effectLst/>
+        </p:spPr>
+        <p:style>
+          <a:lnRef idx="1">
+            <a:schemeClr val="accent1"/>
+          </a:lnRef>
+          <a:fillRef idx="3">
+            <a:schemeClr val="accent1"/>
+          </a:fillRef>
+          <a:effectRef idx="2">
+            <a:schemeClr val="accent1"/>
+          </a:effectRef>
+          <a:fontRef idx="minor">
+            <a:schemeClr val="lt1"/>
+          </a:fontRef>
+        </p:style>
+        <p:txBody>
+          <a:bodyPr rtlCol="0" anchor="ctr"/>
+          <a:lstStyle/>
+          <a:p>
+            <a:pPr algn="ctr"/>
+          </a:p>
+        </p:txBody>
+      </p:sp>
+      <p:sp>
+        <p:nvSpPr>
+          <p:cNvPr id="19" name="TextBox 18"/>
+          <p:cNvSpPr txBox="1"/>
+          <p:nvPr/>
+        </p:nvSpPr>
+        <p:spPr>
+          <a:xfrm>
+            <a:off x="2184109" y="4526280"/>
+            <a:ext cx="457200" cy="182880"/>
+          </a:xfrm>
+          <a:prstGeom prst="rect">
+            <a:avLst/>
+          </a:prstGeom>
+          <a:noFill/>
+        </p:spPr>
+        <p:txBody>
+          <a:bodyPr wrap="square" anchor="t" lIns="0" rIns="0" tIns="0" bIns="0">
+            <a:spAutoFit/>
+          </a:bodyPr>
+          <a:lstStyle/>
+          <a:p>
+            <a:pPr algn="ctr"/>
+            <a:r>
+              <a:rPr sz="700" b="0">
+                <a:solidFill>
+                  <a:srgbClr val="525252"/>
+                </a:solidFill>
+                <a:latin typeface="Calibri"/>
+              </a:rPr>
+              <a:t>16</a:t>
+            </a:r>
+          </a:p>
+        </p:txBody>
+      </p:sp>
+      <p:sp>
+        <p:nvSpPr>
+          <p:cNvPr id="20" name="Rounded Rectangle 19"/>
+          <p:cNvSpPr/>
+          <p:nvPr/>
+        </p:nvSpPr>
+        <p:spPr>
+          <a:xfrm>
+            <a:off x="2684417" y="3858768"/>
+            <a:ext cx="274320" cy="640080"/>
+          </a:xfrm>
+          <a:prstGeom prst="roundRect">
+            <a:avLst/>
+          </a:prstGeom>
+          <a:solidFill>
+            <a:srgbClr val="9E9E9E"/>
+          </a:solidFill>
+          <a:ln>
+            <a:noFill/>
+          </a:ln>
+          <a:effectLst/>
+        </p:spPr>
+        <p:style>
+          <a:lnRef idx="1">
+            <a:schemeClr val="accent1"/>
+          </a:lnRef>
+          <a:fillRef idx="3">
+            <a:schemeClr val="accent1"/>
+          </a:fillRef>
+          <a:effectRef idx="2">
+            <a:schemeClr val="accent1"/>
+          </a:effectRef>
+          <a:fontRef idx="minor">
+            <a:schemeClr val="lt1"/>
+          </a:fontRef>
+        </p:style>
+        <p:txBody>
+          <a:bodyPr rtlCol="0" anchor="ctr"/>
+          <a:lstStyle/>
+          <a:p>
+            <a:pPr algn="ctr"/>
+          </a:p>
+        </p:txBody>
+      </p:sp>
+      <p:sp>
+        <p:nvSpPr>
+          <p:cNvPr id="21" name="TextBox 20"/>
+          <p:cNvSpPr txBox="1"/>
+          <p:nvPr/>
+        </p:nvSpPr>
+        <p:spPr>
+          <a:xfrm>
+            <a:off x="2592977" y="4526280"/>
+            <a:ext cx="457200" cy="182880"/>
+          </a:xfrm>
+          <a:prstGeom prst="rect">
+            <a:avLst/>
+          </a:prstGeom>
+          <a:noFill/>
+        </p:spPr>
+        <p:txBody>
+          <a:bodyPr wrap="square" anchor="t" lIns="0" rIns="0" tIns="0" bIns="0">
+            <a:spAutoFit/>
+          </a:bodyPr>
+          <a:lstStyle/>
+          <a:p>
+            <a:pPr algn="ctr"/>
+            <a:r>
+              <a:rPr sz="700" b="0">
+                <a:solidFill>
+                  <a:srgbClr val="525252"/>
+                </a:solidFill>
+                <a:latin typeface="Calibri"/>
+              </a:rPr>
+              <a:t>24</a:t>
+            </a:r>
+          </a:p>
+        </p:txBody>
+      </p:sp>
+      <p:sp>
+        <p:nvSpPr>
+          <p:cNvPr id="22" name="Rounded Rectangle 21"/>
+          <p:cNvSpPr/>
+          <p:nvPr/>
+        </p:nvSpPr>
+        <p:spPr>
+          <a:xfrm>
+            <a:off x="3093284" y="3858768"/>
+            <a:ext cx="274320" cy="640080"/>
+          </a:xfrm>
+          <a:prstGeom prst="roundRect">
+            <a:avLst/>
+          </a:prstGeom>
+          <a:solidFill>
+            <a:srgbClr val="9E9E9E"/>
+          </a:solidFill>
+          <a:ln>
+            <a:noFill/>
+          </a:ln>
+          <a:effectLst/>
+        </p:spPr>
+        <p:style>
+          <a:lnRef idx="1">
+            <a:schemeClr val="accent1"/>
+          </a:lnRef>
+          <a:fillRef idx="3">
+            <a:schemeClr val="accent1"/>
+          </a:fillRef>
+          <a:effectRef idx="2">
+            <a:schemeClr val="accent1"/>
+          </a:effectRef>
+          <a:fontRef idx="minor">
+            <a:schemeClr val="lt1"/>
+          </a:fontRef>
+        </p:style>
+        <p:txBody>
+          <a:bodyPr rtlCol="0" anchor="ctr"/>
+          <a:lstStyle/>
+          <a:p>
+            <a:pPr algn="ctr"/>
+          </a:p>
+        </p:txBody>
+      </p:sp>
+      <p:sp>
+        <p:nvSpPr>
+          <p:cNvPr id="23" name="TextBox 22"/>
+          <p:cNvSpPr txBox="1"/>
+          <p:nvPr/>
+        </p:nvSpPr>
+        <p:spPr>
+          <a:xfrm>
+            <a:off x="3001844" y="4526280"/>
+            <a:ext cx="457200" cy="182880"/>
+          </a:xfrm>
+          <a:prstGeom prst="rect">
+            <a:avLst/>
+          </a:prstGeom>
+          <a:noFill/>
+        </p:spPr>
+        <p:txBody>
+          <a:bodyPr wrap="square" anchor="t" lIns="0" rIns="0" tIns="0" bIns="0">
+            <a:spAutoFit/>
+          </a:bodyPr>
+          <a:lstStyle/>
+          <a:p>
+            <a:pPr algn="ctr"/>
+            <a:r>
+              <a:rPr sz="700" b="0">
+                <a:solidFill>
+                  <a:srgbClr val="525252"/>
+                </a:solidFill>
+                <a:latin typeface="Calibri"/>
+              </a:rPr>
+              <a:t>30</a:t>
+            </a:r>
+          </a:p>
+        </p:txBody>
+      </p:sp>
+      <p:sp>
+        <p:nvSpPr>
+          <p:cNvPr id="24" name="Rounded Rectangle 23"/>
+          <p:cNvSpPr/>
+          <p:nvPr/>
+        </p:nvSpPr>
+        <p:spPr>
+          <a:xfrm>
+            <a:off x="3502152" y="3858768"/>
+            <a:ext cx="274320" cy="640080"/>
+          </a:xfrm>
+          <a:prstGeom prst="roundRect">
+            <a:avLst/>
+          </a:prstGeom>
+          <a:solidFill>
+            <a:srgbClr val="9E9E9E"/>
+          </a:solidFill>
+          <a:ln>
+            <a:noFill/>
+          </a:ln>
+          <a:effectLst/>
+        </p:spPr>
+        <p:style>
+          <a:lnRef idx="1">
+            <a:schemeClr val="accent1"/>
+          </a:lnRef>
+          <a:fillRef idx="3">
+            <a:schemeClr val="accent1"/>
+          </a:fillRef>
+          <a:effectRef idx="2">
+            <a:schemeClr val="accent1"/>
+          </a:effectRef>
+          <a:fontRef idx="minor">
+            <a:schemeClr val="lt1"/>
+          </a:fontRef>
+        </p:style>
+        <p:txBody>
+          <a:bodyPr rtlCol="0" anchor="ctr"/>
+          <a:lstStyle/>
+          <a:p>
+            <a:pPr algn="ctr"/>
+          </a:p>
+        </p:txBody>
+      </p:sp>
+      <p:sp>
+        <p:nvSpPr>
+          <p:cNvPr id="25" name="TextBox 24"/>
+          <p:cNvSpPr txBox="1"/>
+          <p:nvPr/>
+        </p:nvSpPr>
+        <p:spPr>
+          <a:xfrm>
+            <a:off x="3410712" y="4526280"/>
+            <a:ext cx="457200" cy="182880"/>
+          </a:xfrm>
+          <a:prstGeom prst="rect">
+            <a:avLst/>
+          </a:prstGeom>
+          <a:noFill/>
+        </p:spPr>
+        <p:txBody>
+          <a:bodyPr wrap="square" anchor="t" lIns="0" rIns="0" tIns="0" bIns="0">
+            <a:spAutoFit/>
+          </a:bodyPr>
+          <a:lstStyle/>
+          <a:p>
+            <a:pPr algn="ctr"/>
+            <a:r>
+              <a:rPr sz="700" b="0">
+                <a:solidFill>
+                  <a:srgbClr val="525252"/>
+                </a:solidFill>
+                <a:latin typeface="Calibri"/>
+              </a:rPr>
+              <a:t>31</a:t>
+            </a:r>
+          </a:p>
+        </p:txBody>
+      </p:sp>
+      <p:sp>
+        <p:nvSpPr>
+          <p:cNvPr id="26" name="TextBox 25"/>
+          <p:cNvSpPr txBox="1"/>
+          <p:nvPr/>
+        </p:nvSpPr>
+        <p:spPr>
+          <a:xfrm>
+            <a:off x="566928" y="4809744"/>
+            <a:ext cx="3282696" cy="274320"/>
+          </a:xfrm>
+          <a:prstGeom prst="rect">
+            <a:avLst/>
+          </a:prstGeom>
+          <a:noFill/>
+        </p:spPr>
+        <p:txBody>
+          <a:bodyPr wrap="square" anchor="t" lIns="0" rIns="0" tIns="0" bIns="0">
+            <a:spAutoFit/>
+          </a:bodyPr>
+          <a:lstStyle/>
+          <a:p>
+            <a:pPr algn="l"/>
+            <a:r>
+              <a:rPr sz="900" b="0">
+                <a:solidFill>
+                  <a:srgbClr val="525252"/>
+                </a:solidFill>
+                <a:latin typeface="Calibri"/>
+              </a:rPr>
+              <a:t>rank per layer  (L0 → L31)</a:t>
+            </a:r>
+          </a:p>
+        </p:txBody>
+      </p:sp>
+      <p:sp>
+        <p:nvSpPr>
+          <p:cNvPr id="27" name="TextBox 26"/>
+          <p:cNvSpPr txBox="1"/>
+          <p:nvPr/>
+        </p:nvSpPr>
+        <p:spPr>
+          <a:xfrm>
+            <a:off x="566928" y="5102352"/>
+            <a:ext cx="3282696" cy="640080"/>
+          </a:xfrm>
+          <a:prstGeom prst="rect">
+            <a:avLst/>
+          </a:prstGeom>
+          <a:noFill/>
+        </p:spPr>
+        <p:txBody>
+          <a:bodyPr wrap="square" anchor="t" lIns="0" rIns="0" tIns="0" bIns="0">
+            <a:spAutoFit/>
+          </a:bodyPr>
+          <a:lstStyle/>
+          <a:p>
+            <a:pPr algn="l"/>
+            <a:r>
+              <a:rPr sz="1100" b="1">
+                <a:solidFill>
+                  <a:srgbClr val="9E9E9E"/>
+                </a:solidFill>
+                <a:latin typeface="Calibri"/>
+              </a:rPr>
+              <a:t>Protects:  </a:t>
+            </a:r>
+            <a:r>
+              <a:rPr sz="1100" b="0">
+                <a:solidFill>
+                  <a:srgbClr val="525252"/>
+                </a:solidFill>
+                <a:latin typeface="Calibri"/>
+              </a:rPr>
+              <a:t>Uses no signal at all — the naive baseline.</a:t>
+            </a:r>
+          </a:p>
+        </p:txBody>
+      </p:sp>
+      <p:sp>
+        <p:nvSpPr>
+          <p:cNvPr id="28" name="Rectangle 27"/>
+          <p:cNvSpPr/>
+          <p:nvPr/>
+        </p:nvSpPr>
+        <p:spPr>
+          <a:xfrm>
+            <a:off x="4238244" y="1389888"/>
+            <a:ext cx="3685032" cy="4434840"/>
+          </a:xfrm>
+          <a:prstGeom prst="rect">
+            <a:avLst/>
+          </a:prstGeom>
+          <a:solidFill>
+            <a:srgbClr val="FFF2CC"/>
+          </a:solidFill>
+          <a:ln>
+            <a:noFill/>
+          </a:ln>
+          <a:effectLst/>
+        </p:spPr>
+        <p:style>
+          <a:lnRef idx="1">
+            <a:schemeClr val="accent1"/>
+          </a:lnRef>
+          <a:fillRef idx="3">
+            <a:schemeClr val="accent1"/>
+          </a:fillRef>
+          <a:effectRef idx="2">
+            <a:schemeClr val="accent1"/>
+          </a:effectRef>
+          <a:fontRef idx="minor">
+            <a:schemeClr val="lt1"/>
+          </a:fontRef>
+        </p:style>
+        <p:txBody>
+          <a:bodyPr rtlCol="0" anchor="ctr"/>
+          <a:lstStyle/>
+          <a:p>
+            <a:pPr algn="ctr"/>
+          </a:p>
+        </p:txBody>
+      </p:sp>
+      <p:sp>
+        <p:nvSpPr>
+          <p:cNvPr id="29" name="Rectangle 28"/>
+          <p:cNvSpPr/>
+          <p:nvPr/>
+        </p:nvSpPr>
+        <p:spPr>
+          <a:xfrm>
+            <a:off x="4238244" y="1389888"/>
+            <a:ext cx="3685032" cy="91440"/>
+          </a:xfrm>
+          <a:prstGeom prst="rect">
+            <a:avLst/>
+          </a:prstGeom>
+          <a:solidFill>
+            <a:srgbClr val="FFA300"/>
+          </a:solidFill>
+          <a:ln>
+            <a:noFill/>
+          </a:ln>
+          <a:effectLst/>
+        </p:spPr>
+        <p:style>
+          <a:lnRef idx="1">
+            <a:schemeClr val="accent1"/>
+          </a:lnRef>
+          <a:fillRef idx="3">
+            <a:schemeClr val="accent1"/>
+          </a:fillRef>
+          <a:effectRef idx="2">
+            <a:schemeClr val="accent1"/>
+          </a:effectRef>
+          <a:fontRef idx="minor">
+            <a:schemeClr val="lt1"/>
+          </a:fontRef>
+        </p:style>
+        <p:txBody>
+          <a:bodyPr rtlCol="0" anchor="ctr"/>
+          <a:lstStyle/>
+          <a:p>
+            <a:pPr algn="ctr"/>
+          </a:p>
+        </p:txBody>
+      </p:sp>
+      <p:sp>
+        <p:nvSpPr>
+          <p:cNvPr id="30" name="TextBox 29"/>
+          <p:cNvSpPr txBox="1"/>
+          <p:nvPr/>
+        </p:nvSpPr>
+        <p:spPr>
+          <a:xfrm>
+            <a:off x="4439412" y="1591056"/>
+            <a:ext cx="3282696" cy="365760"/>
+          </a:xfrm>
+          <a:prstGeom prst="rect">
+            <a:avLst/>
+          </a:prstGeom>
+          <a:noFill/>
+        </p:spPr>
+        <p:txBody>
+          <a:bodyPr wrap="square" anchor="t" lIns="0" rIns="0" tIns="0" bIns="0">
+            <a:spAutoFit/>
+          </a:bodyPr>
+          <a:lstStyle/>
+          <a:p>
+            <a:pPr algn="l"/>
+            <a:r>
+              <a:rPr sz="1500" b="1">
+                <a:solidFill>
+                  <a:srgbClr val="FFA300"/>
+                </a:solidFill>
+                <a:latin typeface="Calibri"/>
+              </a:rPr>
+              <a:t>FLAT-LLM  (SOTA)</a:t>
+            </a:r>
+          </a:p>
+        </p:txBody>
+      </p:sp>
+      <p:sp>
+        <p:nvSpPr>
+          <p:cNvPr id="31" name="TextBox 30"/>
+          <p:cNvSpPr txBox="1"/>
+          <p:nvPr/>
+        </p:nvSpPr>
+        <p:spPr>
+          <a:xfrm>
+            <a:off x="4439412" y="2048256"/>
+            <a:ext cx="3282696" cy="914400"/>
+          </a:xfrm>
+          <a:prstGeom prst="rect">
+            <a:avLst/>
+          </a:prstGeom>
+          <a:noFill/>
+        </p:spPr>
+        <p:txBody>
+          <a:bodyPr wrap="square" anchor="t" lIns="0" rIns="0" tIns="0" bIns="0">
+            <a:spAutoFit/>
+          </a:bodyPr>
+          <a:lstStyle/>
+          <a:p>
+            <a:pPr algn="l"/>
+            <a:r>
+              <a:rPr sz="1200" b="0">
+                <a:solidFill>
+                  <a:srgbClr val="525252"/>
+                </a:solidFill>
+                <a:latin typeface="Calibri"/>
+              </a:rPr>
+              <a:t>Rank set by block-influence (how much a layer rotates the residual).</a:t>
+            </a:r>
+          </a:p>
+        </p:txBody>
+      </p:sp>
+      <p:sp>
+        <p:nvSpPr>
+          <p:cNvPr id="32" name="Rounded Rectangle 31"/>
+          <p:cNvSpPr/>
+          <p:nvPr/>
+        </p:nvSpPr>
+        <p:spPr>
+          <a:xfrm>
+            <a:off x="4512564" y="3218688"/>
+            <a:ext cx="274320" cy="1280160"/>
+          </a:xfrm>
+          <a:prstGeom prst="roundRect">
+            <a:avLst/>
+          </a:prstGeom>
+          <a:solidFill>
+            <a:srgbClr val="FFA300"/>
+          </a:solidFill>
+          <a:ln>
+            <a:noFill/>
+          </a:ln>
+          <a:effectLst/>
+        </p:spPr>
+        <p:style>
+          <a:lnRef idx="1">
+            <a:schemeClr val="accent1"/>
+          </a:lnRef>
+          <a:fillRef idx="3">
+            <a:schemeClr val="accent1"/>
+          </a:fillRef>
+          <a:effectRef idx="2">
+            <a:schemeClr val="accent1"/>
+          </a:effectRef>
+          <a:fontRef idx="minor">
+            <a:schemeClr val="lt1"/>
+          </a:fontRef>
+        </p:style>
+        <p:txBody>
+          <a:bodyPr rtlCol="0" anchor="ctr"/>
+          <a:lstStyle/>
+          <a:p>
+            <a:pPr algn="ctr"/>
+          </a:p>
+        </p:txBody>
+      </p:sp>
+      <p:sp>
+        <p:nvSpPr>
+          <p:cNvPr id="33" name="TextBox 32"/>
+          <p:cNvSpPr txBox="1"/>
+          <p:nvPr/>
+        </p:nvSpPr>
+        <p:spPr>
+          <a:xfrm>
+            <a:off x="4421124" y="4526280"/>
+            <a:ext cx="457200" cy="182880"/>
+          </a:xfrm>
+          <a:prstGeom prst="rect">
+            <a:avLst/>
+          </a:prstGeom>
+          <a:noFill/>
+        </p:spPr>
+        <p:txBody>
+          <a:bodyPr wrap="square" anchor="t" lIns="0" rIns="0" tIns="0" bIns="0">
+            <a:spAutoFit/>
+          </a:bodyPr>
+          <a:lstStyle/>
+          <a:p>
+            <a:pPr algn="ctr"/>
+            <a:r>
+              <a:rPr sz="700" b="0">
+                <a:solidFill>
+                  <a:srgbClr val="525252"/>
+                </a:solidFill>
+                <a:latin typeface="Calibri"/>
+              </a:rPr>
+              <a:t>0</a:t>
+            </a:r>
+          </a:p>
+        </p:txBody>
+      </p:sp>
+      <p:sp>
+        <p:nvSpPr>
+          <p:cNvPr id="34" name="Rounded Rectangle 33"/>
+          <p:cNvSpPr/>
+          <p:nvPr/>
+        </p:nvSpPr>
+        <p:spPr>
+          <a:xfrm>
+            <a:off x="4921431" y="3705148"/>
+            <a:ext cx="274320" cy="793699"/>
+          </a:xfrm>
+          <a:prstGeom prst="roundRect">
+            <a:avLst/>
+          </a:prstGeom>
+          <a:solidFill>
+            <a:srgbClr val="FFA300"/>
+          </a:solidFill>
+          <a:ln>
+            <a:noFill/>
+          </a:ln>
+          <a:effectLst/>
+        </p:spPr>
+        <p:style>
+          <a:lnRef idx="1">
+            <a:schemeClr val="accent1"/>
+          </a:lnRef>
+          <a:fillRef idx="3">
+            <a:schemeClr val="accent1"/>
+          </a:fillRef>
+          <a:effectRef idx="2">
+            <a:schemeClr val="accent1"/>
+          </a:effectRef>
+          <a:fontRef idx="minor">
+            <a:schemeClr val="lt1"/>
+          </a:fontRef>
+        </p:style>
+        <p:txBody>
+          <a:bodyPr rtlCol="0" anchor="ctr"/>
+          <a:lstStyle/>
+          <a:p>
+            <a:pPr algn="ctr"/>
+          </a:p>
+        </p:txBody>
+      </p:sp>
+      <p:sp>
+        <p:nvSpPr>
+          <p:cNvPr id="35" name="TextBox 34"/>
+          <p:cNvSpPr txBox="1"/>
+          <p:nvPr/>
+        </p:nvSpPr>
+        <p:spPr>
+          <a:xfrm>
+            <a:off x="4829991" y="4526280"/>
+            <a:ext cx="457200" cy="182880"/>
+          </a:xfrm>
+          <a:prstGeom prst="rect">
+            <a:avLst/>
+          </a:prstGeom>
+          <a:noFill/>
+        </p:spPr>
+        <p:txBody>
+          <a:bodyPr wrap="square" anchor="t" lIns="0" rIns="0" tIns="0" bIns="0">
+            <a:spAutoFit/>
+          </a:bodyPr>
+          <a:lstStyle/>
+          <a:p>
+            <a:pPr algn="ctr"/>
+            <a:r>
+              <a:rPr sz="700" b="0">
+                <a:solidFill>
+                  <a:srgbClr val="525252"/>
+                </a:solidFill>
+                <a:latin typeface="Calibri"/>
+              </a:rPr>
+              <a:t>2</a:t>
+            </a:r>
+          </a:p>
+        </p:txBody>
+      </p:sp>
+      <p:sp>
+        <p:nvSpPr>
+          <p:cNvPr id="36" name="Rounded Rectangle 35"/>
+          <p:cNvSpPr/>
+          <p:nvPr/>
+        </p:nvSpPr>
+        <p:spPr>
+          <a:xfrm>
+            <a:off x="5330298" y="3705148"/>
+            <a:ext cx="274320" cy="793699"/>
+          </a:xfrm>
+          <a:prstGeom prst="roundRect">
+            <a:avLst/>
+          </a:prstGeom>
+          <a:solidFill>
+            <a:srgbClr val="FFA300"/>
+          </a:solidFill>
+          <a:ln>
+            <a:noFill/>
+          </a:ln>
+          <a:effectLst/>
+        </p:spPr>
+        <p:style>
+          <a:lnRef idx="1">
+            <a:schemeClr val="accent1"/>
+          </a:lnRef>
+          <a:fillRef idx="3">
+            <a:schemeClr val="accent1"/>
+          </a:fillRef>
+          <a:effectRef idx="2">
+            <a:schemeClr val="accent1"/>
+          </a:effectRef>
+          <a:fontRef idx="minor">
+            <a:schemeClr val="lt1"/>
+          </a:fontRef>
+        </p:style>
+        <p:txBody>
+          <a:bodyPr rtlCol="0" anchor="ctr"/>
+          <a:lstStyle/>
+          <a:p>
+            <a:pPr algn="ctr"/>
+          </a:p>
+        </p:txBody>
+      </p:sp>
+      <p:sp>
+        <p:nvSpPr>
+          <p:cNvPr id="37" name="TextBox 36"/>
+          <p:cNvSpPr txBox="1"/>
+          <p:nvPr/>
+        </p:nvSpPr>
+        <p:spPr>
+          <a:xfrm>
+            <a:off x="5238858" y="4526280"/>
+            <a:ext cx="457200" cy="182880"/>
+          </a:xfrm>
+          <a:prstGeom prst="rect">
+            <a:avLst/>
+          </a:prstGeom>
+          <a:noFill/>
+        </p:spPr>
+        <p:txBody>
+          <a:bodyPr wrap="square" anchor="t" lIns="0" rIns="0" tIns="0" bIns="0">
+            <a:spAutoFit/>
+          </a:bodyPr>
+          <a:lstStyle/>
+          <a:p>
+            <a:pPr algn="ctr"/>
+            <a:r>
+              <a:rPr sz="700" b="0">
+                <a:solidFill>
+                  <a:srgbClr val="525252"/>
+                </a:solidFill>
+                <a:latin typeface="Calibri"/>
+              </a:rPr>
+              <a:t>5</a:t>
+            </a:r>
+          </a:p>
+        </p:txBody>
+      </p:sp>
+      <p:sp>
+        <p:nvSpPr>
+          <p:cNvPr id="38" name="Rounded Rectangle 37"/>
+          <p:cNvSpPr/>
+          <p:nvPr/>
+        </p:nvSpPr>
+        <p:spPr>
+          <a:xfrm>
+            <a:off x="5739166" y="3794760"/>
+            <a:ext cx="274320" cy="704088"/>
+          </a:xfrm>
+          <a:prstGeom prst="roundRect">
+            <a:avLst/>
+          </a:prstGeom>
+          <a:solidFill>
+            <a:srgbClr val="FFA300"/>
+          </a:solidFill>
+          <a:ln>
+            <a:noFill/>
+          </a:ln>
+          <a:effectLst/>
+        </p:spPr>
+        <p:style>
+          <a:lnRef idx="1">
+            <a:schemeClr val="accent1"/>
+          </a:lnRef>
+          <a:fillRef idx="3">
+            <a:schemeClr val="accent1"/>
+          </a:fillRef>
+          <a:effectRef idx="2">
+            <a:schemeClr val="accent1"/>
+          </a:effectRef>
+          <a:fontRef idx="minor">
+            <a:schemeClr val="lt1"/>
+          </a:fontRef>
+        </p:style>
+        <p:txBody>
+          <a:bodyPr rtlCol="0" anchor="ctr"/>
+          <a:lstStyle/>
+          <a:p>
+            <a:pPr algn="ctr"/>
+          </a:p>
+        </p:txBody>
+      </p:sp>
+      <p:sp>
+        <p:nvSpPr>
+          <p:cNvPr id="39" name="TextBox 38"/>
+          <p:cNvSpPr txBox="1"/>
+          <p:nvPr/>
+        </p:nvSpPr>
+        <p:spPr>
+          <a:xfrm>
+            <a:off x="5647726" y="4526280"/>
+            <a:ext cx="457200" cy="182880"/>
+          </a:xfrm>
+          <a:prstGeom prst="rect">
+            <a:avLst/>
+          </a:prstGeom>
+          <a:noFill/>
+        </p:spPr>
+        <p:txBody>
+          <a:bodyPr wrap="square" anchor="t" lIns="0" rIns="0" tIns="0" bIns="0">
+            <a:spAutoFit/>
+          </a:bodyPr>
+          <a:lstStyle/>
+          <a:p>
+            <a:pPr algn="ctr"/>
+            <a:r>
+              <a:rPr sz="700" b="0">
+                <a:solidFill>
+                  <a:srgbClr val="525252"/>
+                </a:solidFill>
+                <a:latin typeface="Calibri"/>
+              </a:rPr>
+              <a:t>10</a:t>
+            </a:r>
+          </a:p>
+        </p:txBody>
+      </p:sp>
+      <p:sp>
+        <p:nvSpPr>
+          <p:cNvPr id="40" name="Rounded Rectangle 39"/>
+          <p:cNvSpPr/>
+          <p:nvPr/>
+        </p:nvSpPr>
+        <p:spPr>
+          <a:xfrm>
+            <a:off x="6148033" y="3845966"/>
+            <a:ext cx="274320" cy="652881"/>
+          </a:xfrm>
+          <a:prstGeom prst="roundRect">
+            <a:avLst/>
+          </a:prstGeom>
+          <a:solidFill>
+            <a:srgbClr val="FFA300"/>
+          </a:solidFill>
+          <a:ln>
+            <a:noFill/>
+          </a:ln>
+          <a:effectLst/>
+        </p:spPr>
+        <p:style>
+          <a:lnRef idx="1">
+            <a:schemeClr val="accent1"/>
+          </a:lnRef>
+          <a:fillRef idx="3">
+            <a:schemeClr val="accent1"/>
+          </a:fillRef>
+          <a:effectRef idx="2">
+            <a:schemeClr val="accent1"/>
+          </a:effectRef>
+          <a:fontRef idx="minor">
+            <a:schemeClr val="lt1"/>
+          </a:fontRef>
+        </p:style>
+        <p:txBody>
+          <a:bodyPr rtlCol="0" anchor="ctr"/>
+          <a:lstStyle/>
+          <a:p>
+            <a:pPr algn="ctr"/>
+          </a:p>
+        </p:txBody>
+      </p:sp>
+      <p:sp>
+        <p:nvSpPr>
+          <p:cNvPr id="41" name="TextBox 40"/>
+          <p:cNvSpPr txBox="1"/>
+          <p:nvPr/>
+        </p:nvSpPr>
+        <p:spPr>
+          <a:xfrm>
+            <a:off x="6056593" y="4526280"/>
+            <a:ext cx="457200" cy="182880"/>
+          </a:xfrm>
+          <a:prstGeom prst="rect">
+            <a:avLst/>
+          </a:prstGeom>
+          <a:noFill/>
+        </p:spPr>
+        <p:txBody>
+          <a:bodyPr wrap="square" anchor="t" lIns="0" rIns="0" tIns="0" bIns="0">
+            <a:spAutoFit/>
+          </a:bodyPr>
+          <a:lstStyle/>
+          <a:p>
+            <a:pPr algn="ctr"/>
+            <a:r>
+              <a:rPr sz="700" b="0">
+                <a:solidFill>
+                  <a:srgbClr val="525252"/>
+                </a:solidFill>
+                <a:latin typeface="Calibri"/>
+              </a:rPr>
+              <a:t>16</a:t>
+            </a:r>
+          </a:p>
+        </p:txBody>
+      </p:sp>
+      <p:sp>
+        <p:nvSpPr>
+          <p:cNvPr id="42" name="Rounded Rectangle 41"/>
+          <p:cNvSpPr/>
+          <p:nvPr/>
+        </p:nvSpPr>
+        <p:spPr>
+          <a:xfrm>
+            <a:off x="6556901" y="4127601"/>
+            <a:ext cx="274320" cy="371246"/>
+          </a:xfrm>
+          <a:prstGeom prst="roundRect">
+            <a:avLst/>
+          </a:prstGeom>
+          <a:solidFill>
+            <a:srgbClr val="FFA300"/>
+          </a:solidFill>
+          <a:ln>
+            <a:noFill/>
+          </a:ln>
+          <a:effectLst/>
+        </p:spPr>
+        <p:style>
+          <a:lnRef idx="1">
+            <a:schemeClr val="accent1"/>
+          </a:lnRef>
+          <a:fillRef idx="3">
+            <a:schemeClr val="accent1"/>
+          </a:fillRef>
+          <a:effectRef idx="2">
+            <a:schemeClr val="accent1"/>
+          </a:effectRef>
+          <a:fontRef idx="minor">
+            <a:schemeClr val="lt1"/>
+          </a:fontRef>
+        </p:style>
+        <p:txBody>
+          <a:bodyPr rtlCol="0" anchor="ctr"/>
+          <a:lstStyle/>
+          <a:p>
+            <a:pPr algn="ctr"/>
+          </a:p>
+        </p:txBody>
+      </p:sp>
+      <p:sp>
+        <p:nvSpPr>
+          <p:cNvPr id="43" name="TextBox 42"/>
+          <p:cNvSpPr txBox="1"/>
+          <p:nvPr/>
+        </p:nvSpPr>
+        <p:spPr>
+          <a:xfrm>
+            <a:off x="6465461" y="4526280"/>
+            <a:ext cx="457200" cy="182880"/>
+          </a:xfrm>
+          <a:prstGeom prst="rect">
+            <a:avLst/>
+          </a:prstGeom>
+          <a:noFill/>
+        </p:spPr>
+        <p:txBody>
+          <a:bodyPr wrap="square" anchor="t" lIns="0" rIns="0" tIns="0" bIns="0">
+            <a:spAutoFit/>
+          </a:bodyPr>
+          <a:lstStyle/>
+          <a:p>
+            <a:pPr algn="ctr"/>
+            <a:r>
+              <a:rPr sz="700" b="0">
+                <a:solidFill>
+                  <a:srgbClr val="525252"/>
+                </a:solidFill>
+                <a:latin typeface="Calibri"/>
+              </a:rPr>
+              <a:t>24</a:t>
+            </a:r>
+          </a:p>
+        </p:txBody>
+      </p:sp>
+      <p:sp>
+        <p:nvSpPr>
+          <p:cNvPr id="44" name="Rounded Rectangle 43"/>
+          <p:cNvSpPr/>
+          <p:nvPr/>
+        </p:nvSpPr>
+        <p:spPr>
+          <a:xfrm>
+            <a:off x="6965768" y="3999585"/>
+            <a:ext cx="274320" cy="499262"/>
+          </a:xfrm>
+          <a:prstGeom prst="roundRect">
+            <a:avLst/>
+          </a:prstGeom>
+          <a:solidFill>
+            <a:srgbClr val="FFA300"/>
+          </a:solidFill>
+          <a:ln>
+            <a:noFill/>
+          </a:ln>
+          <a:effectLst/>
+        </p:spPr>
+        <p:style>
+          <a:lnRef idx="1">
+            <a:schemeClr val="accent1"/>
+          </a:lnRef>
+          <a:fillRef idx="3">
+            <a:schemeClr val="accent1"/>
+          </a:fillRef>
+          <a:effectRef idx="2">
+            <a:schemeClr val="accent1"/>
+          </a:effectRef>
+          <a:fontRef idx="minor">
+            <a:schemeClr val="lt1"/>
+          </a:fontRef>
+        </p:style>
+        <p:txBody>
+          <a:bodyPr rtlCol="0" anchor="ctr"/>
+          <a:lstStyle/>
+          <a:p>
+            <a:pPr algn="ctr"/>
+          </a:p>
+        </p:txBody>
+      </p:sp>
+      <p:sp>
+        <p:nvSpPr>
+          <p:cNvPr id="45" name="TextBox 44"/>
+          <p:cNvSpPr txBox="1"/>
+          <p:nvPr/>
+        </p:nvSpPr>
+        <p:spPr>
+          <a:xfrm>
+            <a:off x="6874328" y="4526280"/>
+            <a:ext cx="457200" cy="182880"/>
+          </a:xfrm>
+          <a:prstGeom prst="rect">
+            <a:avLst/>
+          </a:prstGeom>
+          <a:noFill/>
+        </p:spPr>
+        <p:txBody>
+          <a:bodyPr wrap="square" anchor="t" lIns="0" rIns="0" tIns="0" bIns="0">
+            <a:spAutoFit/>
+          </a:bodyPr>
+          <a:lstStyle/>
+          <a:p>
+            <a:pPr algn="ctr"/>
+            <a:r>
+              <a:rPr sz="700" b="0">
+                <a:solidFill>
+                  <a:srgbClr val="525252"/>
+                </a:solidFill>
+                <a:latin typeface="Calibri"/>
+              </a:rPr>
+              <a:t>30</a:t>
+            </a:r>
+          </a:p>
+        </p:txBody>
+      </p:sp>
+      <p:sp>
+        <p:nvSpPr>
+          <p:cNvPr id="46" name="Rounded Rectangle 45"/>
+          <p:cNvSpPr/>
+          <p:nvPr/>
+        </p:nvSpPr>
+        <p:spPr>
+          <a:xfrm>
+            <a:off x="7374636" y="3308299"/>
+            <a:ext cx="274320" cy="1190548"/>
+          </a:xfrm>
+          <a:prstGeom prst="roundRect">
+            <a:avLst/>
+          </a:prstGeom>
+          <a:solidFill>
+            <a:srgbClr val="FFA300"/>
+          </a:solidFill>
+          <a:ln>
+            <a:noFill/>
+          </a:ln>
+          <a:effectLst/>
+        </p:spPr>
+        <p:style>
+          <a:lnRef idx="1">
+            <a:schemeClr val="accent1"/>
+          </a:lnRef>
+          <a:fillRef idx="3">
+            <a:schemeClr val="accent1"/>
+          </a:fillRef>
+          <a:effectRef idx="2">
+            <a:schemeClr val="accent1"/>
+          </a:effectRef>
+          <a:fontRef idx="minor">
+            <a:schemeClr val="lt1"/>
+          </a:fontRef>
+        </p:style>
+        <p:txBody>
+          <a:bodyPr rtlCol="0" anchor="ctr"/>
+          <a:lstStyle/>
+          <a:p>
+            <a:pPr algn="ctr"/>
+          </a:p>
+        </p:txBody>
+      </p:sp>
+      <p:sp>
+        <p:nvSpPr>
+          <p:cNvPr id="47" name="TextBox 46"/>
+          <p:cNvSpPr txBox="1"/>
+          <p:nvPr/>
+        </p:nvSpPr>
+        <p:spPr>
+          <a:xfrm>
+            <a:off x="7283196" y="4526280"/>
+            <a:ext cx="457200" cy="182880"/>
+          </a:xfrm>
+          <a:prstGeom prst="rect">
+            <a:avLst/>
+          </a:prstGeom>
+          <a:noFill/>
+        </p:spPr>
+        <p:txBody>
+          <a:bodyPr wrap="square" anchor="t" lIns="0" rIns="0" tIns="0" bIns="0">
+            <a:spAutoFit/>
+          </a:bodyPr>
+          <a:lstStyle/>
+          <a:p>
+            <a:pPr algn="ctr"/>
+            <a:r>
+              <a:rPr sz="700" b="0">
+                <a:solidFill>
+                  <a:srgbClr val="525252"/>
+                </a:solidFill>
+                <a:latin typeface="Calibri"/>
+              </a:rPr>
+              <a:t>31</a:t>
+            </a:r>
+          </a:p>
+        </p:txBody>
+      </p:sp>
+      <p:sp>
+        <p:nvSpPr>
+          <p:cNvPr id="48" name="TextBox 47"/>
+          <p:cNvSpPr txBox="1"/>
+          <p:nvPr/>
+        </p:nvSpPr>
+        <p:spPr>
+          <a:xfrm>
+            <a:off x="4439412" y="4809744"/>
+            <a:ext cx="3282696" cy="274320"/>
+          </a:xfrm>
+          <a:prstGeom prst="rect">
+            <a:avLst/>
+          </a:prstGeom>
+          <a:noFill/>
+        </p:spPr>
+        <p:txBody>
+          <a:bodyPr wrap="square" anchor="t" lIns="0" rIns="0" tIns="0" bIns="0">
+            <a:spAutoFit/>
+          </a:bodyPr>
+          <a:lstStyle/>
+          <a:p>
+            <a:pPr algn="l"/>
+            <a:r>
+              <a:rPr sz="900" b="0">
+                <a:solidFill>
+                  <a:srgbClr val="525252"/>
+                </a:solidFill>
+                <a:latin typeface="Calibri"/>
+              </a:rPr>
+              <a:t>rank per layer  (L0 → L31)</a:t>
+            </a:r>
+          </a:p>
+        </p:txBody>
+      </p:sp>
+      <p:sp>
+        <p:nvSpPr>
+          <p:cNvPr id="49" name="TextBox 48"/>
+          <p:cNvSpPr txBox="1"/>
+          <p:nvPr/>
+        </p:nvSpPr>
+        <p:spPr>
+          <a:xfrm>
+            <a:off x="4439412" y="5102352"/>
+            <a:ext cx="3282696" cy="640080"/>
+          </a:xfrm>
+          <a:prstGeom prst="rect">
+            <a:avLst/>
+          </a:prstGeom>
+          <a:noFill/>
+        </p:spPr>
+        <p:txBody>
+          <a:bodyPr wrap="square" anchor="t" lIns="0" rIns="0" tIns="0" bIns="0">
+            <a:spAutoFit/>
+          </a:bodyPr>
+          <a:lstStyle/>
+          <a:p>
+            <a:pPr algn="l"/>
+            <a:r>
+              <a:rPr sz="1100" b="1">
+                <a:solidFill>
+                  <a:srgbClr val="FFA300"/>
+                </a:solidFill>
+                <a:latin typeface="Calibri"/>
+              </a:rPr>
+              <a:t>Protects:  </a:t>
+            </a:r>
+            <a:r>
+              <a:rPr sz="1100" b="0">
+                <a:solidFill>
+                  <a:srgbClr val="525252"/>
+                </a:solidFill>
+                <a:latin typeface="Calibri"/>
+              </a:rPr>
+              <a:t>Protects boundary layers (0 &amp; 31); compresses the middle.</a:t>
+            </a:r>
+          </a:p>
+        </p:txBody>
+      </p:sp>
+      <p:sp>
+        <p:nvSpPr>
+          <p:cNvPr id="50" name="Rectangle 49"/>
+          <p:cNvSpPr/>
+          <p:nvPr/>
+        </p:nvSpPr>
+        <p:spPr>
+          <a:xfrm>
+            <a:off x="8110728" y="1389888"/>
+            <a:ext cx="3685032" cy="4434840"/>
+          </a:xfrm>
+          <a:prstGeom prst="rect">
+            <a:avLst/>
+          </a:prstGeom>
+          <a:solidFill>
+            <a:srgbClr val="E2F0D9"/>
+          </a:solidFill>
+          <a:ln>
+            <a:noFill/>
+          </a:ln>
+          <a:effectLst/>
+        </p:spPr>
+        <p:style>
+          <a:lnRef idx="1">
+            <a:schemeClr val="accent1"/>
+          </a:lnRef>
+          <a:fillRef idx="3">
+            <a:schemeClr val="accent1"/>
+          </a:fillRef>
+          <a:effectRef idx="2">
+            <a:schemeClr val="accent1"/>
+          </a:effectRef>
+          <a:fontRef idx="minor">
+            <a:schemeClr val="lt1"/>
+          </a:fontRef>
+        </p:style>
+        <p:txBody>
+          <a:bodyPr rtlCol="0" anchor="ctr"/>
+          <a:lstStyle/>
+          <a:p>
+            <a:pPr algn="ctr"/>
+          </a:p>
+        </p:txBody>
+      </p:sp>
+      <p:sp>
+        <p:nvSpPr>
+          <p:cNvPr id="51" name="Rectangle 50"/>
+          <p:cNvSpPr/>
+          <p:nvPr/>
+        </p:nvSpPr>
+        <p:spPr>
+          <a:xfrm>
+            <a:off x="8110728" y="1389888"/>
+            <a:ext cx="3685032" cy="91440"/>
+          </a:xfrm>
+          <a:prstGeom prst="rect">
+            <a:avLst/>
+          </a:prstGeom>
+          <a:solidFill>
+            <a:srgbClr val="2E8B57"/>
+          </a:solidFill>
+          <a:ln>
+            <a:noFill/>
+          </a:ln>
+          <a:effectLst/>
+        </p:spPr>
+        <p:style>
+          <a:lnRef idx="1">
+            <a:schemeClr val="accent1"/>
+          </a:lnRef>
+          <a:fillRef idx="3">
+            <a:schemeClr val="accent1"/>
+          </a:fillRef>
+          <a:effectRef idx="2">
+            <a:schemeClr val="accent1"/>
+          </a:effectRef>
+          <a:fontRef idx="minor">
+            <a:schemeClr val="lt1"/>
+          </a:fontRef>
+        </p:style>
+        <p:txBody>
+          <a:bodyPr rtlCol="0" anchor="ctr"/>
+          <a:lstStyle/>
+          <a:p>
+            <a:pPr algn="ctr"/>
+          </a:p>
+        </p:txBody>
+      </p:sp>
+      <p:sp>
+        <p:nvSpPr>
+          <p:cNvPr id="52" name="TextBox 51"/>
+          <p:cNvSpPr txBox="1"/>
+          <p:nvPr/>
+        </p:nvSpPr>
+        <p:spPr>
+          <a:xfrm>
+            <a:off x="8311896" y="1591056"/>
+            <a:ext cx="3282696" cy="365760"/>
+          </a:xfrm>
+          <a:prstGeom prst="rect">
+            <a:avLst/>
+          </a:prstGeom>
+          <a:noFill/>
+        </p:spPr>
+        <p:txBody>
+          <a:bodyPr wrap="square" anchor="t" lIns="0" rIns="0" tIns="0" bIns="0">
+            <a:spAutoFit/>
+          </a:bodyPr>
+          <a:lstStyle/>
+          <a:p>
+            <a:pPr algn="l"/>
+            <a:r>
+              <a:rPr sz="1500" b="1">
+                <a:solidFill>
+                  <a:srgbClr val="2E8B57"/>
+                </a:solidFill>
+                <a:latin typeface="Calibri"/>
+              </a:rPr>
+              <a:t>Ours — amplification-joint</a:t>
+            </a:r>
+          </a:p>
+        </p:txBody>
+      </p:sp>
+      <p:sp>
+        <p:nvSpPr>
+          <p:cNvPr id="53" name="TextBox 52"/>
+          <p:cNvSpPr txBox="1"/>
+          <p:nvPr/>
+        </p:nvSpPr>
+        <p:spPr>
+          <a:xfrm>
+            <a:off x="8311896" y="2048256"/>
+            <a:ext cx="3282696" cy="914400"/>
+          </a:xfrm>
+          <a:prstGeom prst="rect">
+            <a:avLst/>
+          </a:prstGeom>
+          <a:noFill/>
+        </p:spPr>
+        <p:txBody>
+          <a:bodyPr wrap="square" anchor="t" lIns="0" rIns="0" tIns="0" bIns="0">
+            <a:spAutoFit/>
+          </a:bodyPr>
+          <a:lstStyle/>
+          <a:p>
+            <a:pPr algn="l"/>
+            <a:r>
+              <a:rPr sz="1200" b="0">
+                <a:solidFill>
+                  <a:srgbClr val="525252"/>
+                </a:solidFill>
+                <a:latin typeface="Calibri"/>
+              </a:rPr>
+              <a:t>Rank set by measured downstream amplification, allocated jointly across coupled layers.</a:t>
+            </a:r>
+          </a:p>
+        </p:txBody>
+      </p:sp>
+      <p:sp>
+        <p:nvSpPr>
+          <p:cNvPr id="54" name="Rounded Rectangle 53"/>
+          <p:cNvSpPr/>
+          <p:nvPr/>
+        </p:nvSpPr>
+        <p:spPr>
+          <a:xfrm>
+            <a:off x="8385048" y="3769156"/>
+            <a:ext cx="274320" cy="729691"/>
+          </a:xfrm>
+          <a:prstGeom prst="roundRect">
+            <a:avLst/>
+          </a:prstGeom>
+          <a:solidFill>
+            <a:srgbClr val="2E8B57"/>
+          </a:solidFill>
+          <a:ln>
+            <a:noFill/>
+          </a:ln>
+          <a:effectLst/>
+        </p:spPr>
+        <p:style>
+          <a:lnRef idx="1">
+            <a:schemeClr val="accent1"/>
+          </a:lnRef>
+          <a:fillRef idx="3">
+            <a:schemeClr val="accent1"/>
+          </a:fillRef>
+          <a:effectRef idx="2">
+            <a:schemeClr val="accent1"/>
+          </a:effectRef>
+          <a:fontRef idx="minor">
+            <a:schemeClr val="lt1"/>
+          </a:fontRef>
+        </p:style>
+        <p:txBody>
+          <a:bodyPr rtlCol="0" anchor="ctr"/>
+          <a:lstStyle/>
+          <a:p>
+            <a:pPr algn="ctr"/>
+          </a:p>
+        </p:txBody>
+      </p:sp>
+      <p:sp>
+        <p:nvSpPr>
+          <p:cNvPr id="55" name="TextBox 54"/>
+          <p:cNvSpPr txBox="1"/>
+          <p:nvPr/>
+        </p:nvSpPr>
+        <p:spPr>
+          <a:xfrm>
+            <a:off x="8293608" y="4526280"/>
+            <a:ext cx="457200" cy="182880"/>
+          </a:xfrm>
+          <a:prstGeom prst="rect">
+            <a:avLst/>
+          </a:prstGeom>
+          <a:noFill/>
+        </p:spPr>
+        <p:txBody>
+          <a:bodyPr wrap="square" anchor="t" lIns="0" rIns="0" tIns="0" bIns="0">
+            <a:spAutoFit/>
+          </a:bodyPr>
+          <a:lstStyle/>
+          <a:p>
+            <a:pPr algn="ctr"/>
+            <a:r>
+              <a:rPr sz="700" b="0">
+                <a:solidFill>
+                  <a:srgbClr val="525252"/>
+                </a:solidFill>
+                <a:latin typeface="Calibri"/>
+              </a:rPr>
+              <a:t>0</a:t>
+            </a:r>
+          </a:p>
+        </p:txBody>
+      </p:sp>
+      <p:sp>
+        <p:nvSpPr>
+          <p:cNvPr id="56" name="Rounded Rectangle 55"/>
+          <p:cNvSpPr/>
+          <p:nvPr/>
+        </p:nvSpPr>
+        <p:spPr>
+          <a:xfrm>
+            <a:off x="8793915" y="3346704"/>
+            <a:ext cx="274320" cy="1152144"/>
+          </a:xfrm>
+          <a:prstGeom prst="roundRect">
+            <a:avLst/>
+          </a:prstGeom>
+          <a:solidFill>
+            <a:srgbClr val="2E8B57"/>
+          </a:solidFill>
+          <a:ln>
+            <a:noFill/>
+          </a:ln>
+          <a:effectLst/>
+        </p:spPr>
+        <p:style>
+          <a:lnRef idx="1">
+            <a:schemeClr val="accent1"/>
+          </a:lnRef>
+          <a:fillRef idx="3">
+            <a:schemeClr val="accent1"/>
+          </a:fillRef>
+          <a:effectRef idx="2">
+            <a:schemeClr val="accent1"/>
+          </a:effectRef>
+          <a:fontRef idx="minor">
+            <a:schemeClr val="lt1"/>
+          </a:fontRef>
+        </p:style>
+        <p:txBody>
+          <a:bodyPr rtlCol="0" anchor="ctr"/>
+          <a:lstStyle/>
+          <a:p>
+            <a:pPr algn="ctr"/>
+          </a:p>
+        </p:txBody>
+      </p:sp>
+      <p:sp>
+        <p:nvSpPr>
+          <p:cNvPr id="57" name="TextBox 56"/>
+          <p:cNvSpPr txBox="1"/>
+          <p:nvPr/>
+        </p:nvSpPr>
+        <p:spPr>
+          <a:xfrm>
+            <a:off x="8702475" y="4526280"/>
+            <a:ext cx="457200" cy="182880"/>
+          </a:xfrm>
+          <a:prstGeom prst="rect">
+            <a:avLst/>
+          </a:prstGeom>
+          <a:noFill/>
+        </p:spPr>
+        <p:txBody>
+          <a:bodyPr wrap="square" anchor="t" lIns="0" rIns="0" tIns="0" bIns="0">
+            <a:spAutoFit/>
+          </a:bodyPr>
+          <a:lstStyle/>
+          <a:p>
+            <a:pPr algn="ctr"/>
+            <a:r>
+              <a:rPr sz="700" b="0">
+                <a:solidFill>
+                  <a:srgbClr val="525252"/>
+                </a:solidFill>
+                <a:latin typeface="Calibri"/>
+              </a:rPr>
+              <a:t>2</a:t>
+            </a:r>
+          </a:p>
+        </p:txBody>
+      </p:sp>
+      <p:sp>
+        <p:nvSpPr>
+          <p:cNvPr id="58" name="Rounded Rectangle 57"/>
+          <p:cNvSpPr/>
+          <p:nvPr/>
+        </p:nvSpPr>
+        <p:spPr>
+          <a:xfrm>
+            <a:off x="9202782" y="3346704"/>
+            <a:ext cx="274320" cy="1152144"/>
+          </a:xfrm>
+          <a:prstGeom prst="roundRect">
+            <a:avLst/>
+          </a:prstGeom>
+          <a:solidFill>
+            <a:srgbClr val="2E8B57"/>
+          </a:solidFill>
+          <a:ln>
+            <a:noFill/>
+          </a:ln>
+          <a:effectLst/>
+        </p:spPr>
+        <p:style>
+          <a:lnRef idx="1">
+            <a:schemeClr val="accent1"/>
+          </a:lnRef>
+          <a:fillRef idx="3">
+            <a:schemeClr val="accent1"/>
+          </a:fillRef>
+          <a:effectRef idx="2">
+            <a:schemeClr val="accent1"/>
+          </a:effectRef>
+          <a:fontRef idx="minor">
+            <a:schemeClr val="lt1"/>
+          </a:fontRef>
+        </p:style>
+        <p:txBody>
+          <a:bodyPr rtlCol="0" anchor="ctr"/>
+          <a:lstStyle/>
+          <a:p>
+            <a:pPr algn="ctr"/>
+          </a:p>
+        </p:txBody>
+      </p:sp>
+      <p:sp>
+        <p:nvSpPr>
+          <p:cNvPr id="59" name="TextBox 58"/>
+          <p:cNvSpPr txBox="1"/>
+          <p:nvPr/>
+        </p:nvSpPr>
+        <p:spPr>
+          <a:xfrm>
+            <a:off x="9111342" y="4526280"/>
+            <a:ext cx="457200" cy="182880"/>
+          </a:xfrm>
+          <a:prstGeom prst="rect">
+            <a:avLst/>
+          </a:prstGeom>
+          <a:noFill/>
+        </p:spPr>
+        <p:txBody>
+          <a:bodyPr wrap="square" anchor="t" lIns="0" rIns="0" tIns="0" bIns="0">
+            <a:spAutoFit/>
+          </a:bodyPr>
+          <a:lstStyle/>
+          <a:p>
+            <a:pPr algn="ctr"/>
+            <a:r>
+              <a:rPr sz="700" b="0">
+                <a:solidFill>
+                  <a:srgbClr val="525252"/>
+                </a:solidFill>
+                <a:latin typeface="Calibri"/>
+              </a:rPr>
+              <a:t>5</a:t>
+            </a:r>
+          </a:p>
+        </p:txBody>
+      </p:sp>
+      <p:sp>
+        <p:nvSpPr>
+          <p:cNvPr id="60" name="Rounded Rectangle 59"/>
+          <p:cNvSpPr/>
+          <p:nvPr/>
+        </p:nvSpPr>
+        <p:spPr>
+          <a:xfrm>
+            <a:off x="9611650" y="3833164"/>
+            <a:ext cx="274320" cy="665683"/>
+          </a:xfrm>
+          <a:prstGeom prst="roundRect">
+            <a:avLst/>
+          </a:prstGeom>
+          <a:solidFill>
+            <a:srgbClr val="2E8B57"/>
+          </a:solidFill>
+          <a:ln>
+            <a:noFill/>
+          </a:ln>
+          <a:effectLst/>
+        </p:spPr>
+        <p:style>
+          <a:lnRef idx="1">
+            <a:schemeClr val="accent1"/>
+          </a:lnRef>
+          <a:fillRef idx="3">
+            <a:schemeClr val="accent1"/>
+          </a:fillRef>
+          <a:effectRef idx="2">
+            <a:schemeClr val="accent1"/>
+          </a:effectRef>
+          <a:fontRef idx="minor">
+            <a:schemeClr val="lt1"/>
+          </a:fontRef>
+        </p:style>
+        <p:txBody>
+          <a:bodyPr rtlCol="0" anchor="ctr"/>
+          <a:lstStyle/>
+          <a:p>
+            <a:pPr algn="ctr"/>
+          </a:p>
+        </p:txBody>
+      </p:sp>
+      <p:sp>
+        <p:nvSpPr>
+          <p:cNvPr id="61" name="TextBox 60"/>
+          <p:cNvSpPr txBox="1"/>
+          <p:nvPr/>
+        </p:nvSpPr>
+        <p:spPr>
+          <a:xfrm>
+            <a:off x="9520210" y="4526280"/>
+            <a:ext cx="457200" cy="182880"/>
+          </a:xfrm>
+          <a:prstGeom prst="rect">
+            <a:avLst/>
+          </a:prstGeom>
+          <a:noFill/>
+        </p:spPr>
+        <p:txBody>
+          <a:bodyPr wrap="square" anchor="t" lIns="0" rIns="0" tIns="0" bIns="0">
+            <a:spAutoFit/>
+          </a:bodyPr>
+          <a:lstStyle/>
+          <a:p>
+            <a:pPr algn="ctr"/>
+            <a:r>
+              <a:rPr sz="700" b="0">
+                <a:solidFill>
+                  <a:srgbClr val="525252"/>
+                </a:solidFill>
+                <a:latin typeface="Calibri"/>
+              </a:rPr>
+              <a:t>10</a:t>
+            </a:r>
+          </a:p>
+        </p:txBody>
+      </p:sp>
+      <p:sp>
+        <p:nvSpPr>
+          <p:cNvPr id="62" name="Rounded Rectangle 61"/>
+          <p:cNvSpPr/>
+          <p:nvPr/>
+        </p:nvSpPr>
+        <p:spPr>
+          <a:xfrm>
+            <a:off x="10020517" y="3922776"/>
+            <a:ext cx="274320" cy="576072"/>
+          </a:xfrm>
+          <a:prstGeom prst="roundRect">
+            <a:avLst/>
+          </a:prstGeom>
+          <a:solidFill>
+            <a:srgbClr val="2E8B57"/>
+          </a:solidFill>
+          <a:ln>
+            <a:noFill/>
+          </a:ln>
+          <a:effectLst/>
+        </p:spPr>
+        <p:style>
+          <a:lnRef idx="1">
+            <a:schemeClr val="accent1"/>
+          </a:lnRef>
+          <a:fillRef idx="3">
+            <a:schemeClr val="accent1"/>
+          </a:fillRef>
+          <a:effectRef idx="2">
+            <a:schemeClr val="accent1"/>
+          </a:effectRef>
+          <a:fontRef idx="minor">
+            <a:schemeClr val="lt1"/>
+          </a:fontRef>
+        </p:style>
+        <p:txBody>
+          <a:bodyPr rtlCol="0" anchor="ctr"/>
+          <a:lstStyle/>
+          <a:p>
+            <a:pPr algn="ctr"/>
+          </a:p>
+        </p:txBody>
+      </p:sp>
+      <p:sp>
+        <p:nvSpPr>
+          <p:cNvPr id="63" name="TextBox 62"/>
+          <p:cNvSpPr txBox="1"/>
+          <p:nvPr/>
+        </p:nvSpPr>
+        <p:spPr>
+          <a:xfrm>
+            <a:off x="9929077" y="4526280"/>
+            <a:ext cx="457200" cy="182880"/>
+          </a:xfrm>
+          <a:prstGeom prst="rect">
+            <a:avLst/>
+          </a:prstGeom>
+          <a:noFill/>
+        </p:spPr>
+        <p:txBody>
+          <a:bodyPr wrap="square" anchor="t" lIns="0" rIns="0" tIns="0" bIns="0">
+            <a:spAutoFit/>
+          </a:bodyPr>
+          <a:lstStyle/>
+          <a:p>
+            <a:pPr algn="ctr"/>
+            <a:r>
+              <a:rPr sz="700" b="0">
+                <a:solidFill>
+                  <a:srgbClr val="525252"/>
+                </a:solidFill>
+                <a:latin typeface="Calibri"/>
+              </a:rPr>
+              <a:t>16</a:t>
+            </a:r>
+          </a:p>
+        </p:txBody>
+      </p:sp>
+      <p:sp>
+        <p:nvSpPr>
+          <p:cNvPr id="64" name="Rounded Rectangle 63"/>
+          <p:cNvSpPr/>
+          <p:nvPr/>
+        </p:nvSpPr>
+        <p:spPr>
+          <a:xfrm>
+            <a:off x="10429385" y="3986784"/>
+            <a:ext cx="274320" cy="512063"/>
+          </a:xfrm>
+          <a:prstGeom prst="roundRect">
+            <a:avLst/>
+          </a:prstGeom>
+          <a:solidFill>
+            <a:srgbClr val="2E8B57"/>
+          </a:solidFill>
+          <a:ln>
+            <a:noFill/>
+          </a:ln>
+          <a:effectLst/>
+        </p:spPr>
+        <p:style>
+          <a:lnRef idx="1">
+            <a:schemeClr val="accent1"/>
+          </a:lnRef>
+          <a:fillRef idx="3">
+            <a:schemeClr val="accent1"/>
+          </a:fillRef>
+          <a:effectRef idx="2">
+            <a:schemeClr val="accent1"/>
+          </a:effectRef>
+          <a:fontRef idx="minor">
+            <a:schemeClr val="lt1"/>
+          </a:fontRef>
+        </p:style>
+        <p:txBody>
+          <a:bodyPr rtlCol="0" anchor="ctr"/>
+          <a:lstStyle/>
+          <a:p>
+            <a:pPr algn="ctr"/>
+          </a:p>
+        </p:txBody>
+      </p:sp>
+      <p:sp>
+        <p:nvSpPr>
+          <p:cNvPr id="65" name="TextBox 64"/>
+          <p:cNvSpPr txBox="1"/>
+          <p:nvPr/>
+        </p:nvSpPr>
+        <p:spPr>
+          <a:xfrm>
+            <a:off x="10337945" y="4526280"/>
+            <a:ext cx="457200" cy="182880"/>
+          </a:xfrm>
+          <a:prstGeom prst="rect">
+            <a:avLst/>
+          </a:prstGeom>
+          <a:noFill/>
+        </p:spPr>
+        <p:txBody>
+          <a:bodyPr wrap="square" anchor="t" lIns="0" rIns="0" tIns="0" bIns="0">
+            <a:spAutoFit/>
+          </a:bodyPr>
+          <a:lstStyle/>
+          <a:p>
+            <a:pPr algn="ctr"/>
+            <a:r>
+              <a:rPr sz="700" b="0">
+                <a:solidFill>
+                  <a:srgbClr val="525252"/>
+                </a:solidFill>
+                <a:latin typeface="Calibri"/>
+              </a:rPr>
+              <a:t>24</a:t>
+            </a:r>
+          </a:p>
+        </p:txBody>
+      </p:sp>
+      <p:sp>
+        <p:nvSpPr>
+          <p:cNvPr id="66" name="Rounded Rectangle 65"/>
+          <p:cNvSpPr/>
+          <p:nvPr/>
+        </p:nvSpPr>
+        <p:spPr>
+          <a:xfrm>
+            <a:off x="10838252" y="4025188"/>
+            <a:ext cx="274320" cy="473659"/>
+          </a:xfrm>
+          <a:prstGeom prst="roundRect">
+            <a:avLst/>
+          </a:prstGeom>
+          <a:solidFill>
+            <a:srgbClr val="2E8B57"/>
+          </a:solidFill>
+          <a:ln>
+            <a:noFill/>
+          </a:ln>
+          <a:effectLst/>
+        </p:spPr>
+        <p:style>
+          <a:lnRef idx="1">
+            <a:schemeClr val="accent1"/>
+          </a:lnRef>
+          <a:fillRef idx="3">
+            <a:schemeClr val="accent1"/>
+          </a:fillRef>
+          <a:effectRef idx="2">
+            <a:schemeClr val="accent1"/>
+          </a:effectRef>
+          <a:fontRef idx="minor">
+            <a:schemeClr val="lt1"/>
+          </a:fontRef>
+        </p:style>
+        <p:txBody>
+          <a:bodyPr rtlCol="0" anchor="ctr"/>
+          <a:lstStyle/>
+          <a:p>
+            <a:pPr algn="ctr"/>
+          </a:p>
+        </p:txBody>
+      </p:sp>
+      <p:sp>
+        <p:nvSpPr>
+          <p:cNvPr id="67" name="TextBox 66"/>
+          <p:cNvSpPr txBox="1"/>
+          <p:nvPr/>
+        </p:nvSpPr>
+        <p:spPr>
+          <a:xfrm>
+            <a:off x="10746812" y="4526280"/>
+            <a:ext cx="457200" cy="182880"/>
+          </a:xfrm>
+          <a:prstGeom prst="rect">
+            <a:avLst/>
+          </a:prstGeom>
+          <a:noFill/>
+        </p:spPr>
+        <p:txBody>
+          <a:bodyPr wrap="square" anchor="t" lIns="0" rIns="0" tIns="0" bIns="0">
+            <a:spAutoFit/>
+          </a:bodyPr>
+          <a:lstStyle/>
+          <a:p>
+            <a:pPr algn="ctr"/>
+            <a:r>
+              <a:rPr sz="700" b="0">
+                <a:solidFill>
+                  <a:srgbClr val="525252"/>
+                </a:solidFill>
+                <a:latin typeface="Calibri"/>
+              </a:rPr>
+              <a:t>30</a:t>
+            </a:r>
+          </a:p>
+        </p:txBody>
+      </p:sp>
+      <p:sp>
+        <p:nvSpPr>
+          <p:cNvPr id="68" name="Rounded Rectangle 67"/>
+          <p:cNvSpPr/>
+          <p:nvPr/>
+        </p:nvSpPr>
+        <p:spPr>
+          <a:xfrm>
+            <a:off x="11247120" y="4025188"/>
+            <a:ext cx="274320" cy="473659"/>
+          </a:xfrm>
+          <a:prstGeom prst="roundRect">
+            <a:avLst/>
+          </a:prstGeom>
+          <a:solidFill>
+            <a:srgbClr val="2E8B57"/>
+          </a:solidFill>
+          <a:ln>
+            <a:noFill/>
+          </a:ln>
+          <a:effectLst/>
+        </p:spPr>
+        <p:style>
+          <a:lnRef idx="1">
+            <a:schemeClr val="accent1"/>
+          </a:lnRef>
+          <a:fillRef idx="3">
+            <a:schemeClr val="accent1"/>
+          </a:fillRef>
+          <a:effectRef idx="2">
+            <a:schemeClr val="accent1"/>
+          </a:effectRef>
+          <a:fontRef idx="minor">
+            <a:schemeClr val="lt1"/>
+          </a:fontRef>
+        </p:style>
+        <p:txBody>
+          <a:bodyPr rtlCol="0" anchor="ctr"/>
+          <a:lstStyle/>
+          <a:p>
+            <a:pPr algn="ctr"/>
+          </a:p>
+        </p:txBody>
+      </p:sp>
+      <p:sp>
+        <p:nvSpPr>
+          <p:cNvPr id="69" name="TextBox 68"/>
+          <p:cNvSpPr txBox="1"/>
+          <p:nvPr/>
+        </p:nvSpPr>
+        <p:spPr>
+          <a:xfrm>
+            <a:off x="11155680" y="4526280"/>
+            <a:ext cx="457200" cy="182880"/>
+          </a:xfrm>
+          <a:prstGeom prst="rect">
+            <a:avLst/>
+          </a:prstGeom>
+          <a:noFill/>
+        </p:spPr>
+        <p:txBody>
+          <a:bodyPr wrap="square" anchor="t" lIns="0" rIns="0" tIns="0" bIns="0">
+            <a:spAutoFit/>
+          </a:bodyPr>
+          <a:lstStyle/>
+          <a:p>
+            <a:pPr algn="ctr"/>
+            <a:r>
+              <a:rPr sz="700" b="0">
+                <a:solidFill>
+                  <a:srgbClr val="525252"/>
+                </a:solidFill>
+                <a:latin typeface="Calibri"/>
+              </a:rPr>
+              <a:t>31</a:t>
+            </a:r>
+          </a:p>
+        </p:txBody>
+      </p:sp>
+      <p:sp>
+        <p:nvSpPr>
+          <p:cNvPr id="70" name="TextBox 69"/>
+          <p:cNvSpPr txBox="1"/>
+          <p:nvPr/>
+        </p:nvSpPr>
+        <p:spPr>
+          <a:xfrm>
+            <a:off x="8311896" y="4809744"/>
+            <a:ext cx="3282696" cy="274320"/>
+          </a:xfrm>
+          <a:prstGeom prst="rect">
+            <a:avLst/>
+          </a:prstGeom>
+          <a:noFill/>
+        </p:spPr>
+        <p:txBody>
+          <a:bodyPr wrap="square" anchor="t" lIns="0" rIns="0" tIns="0" bIns="0">
+            <a:spAutoFit/>
+          </a:bodyPr>
+          <a:lstStyle/>
+          <a:p>
+            <a:pPr algn="l"/>
+            <a:r>
+              <a:rPr sz="900" b="0">
+                <a:solidFill>
+                  <a:srgbClr val="525252"/>
+                </a:solidFill>
+                <a:latin typeface="Calibri"/>
+              </a:rPr>
+              <a:t>rank per layer  (L0 → L31)</a:t>
+            </a:r>
+          </a:p>
+        </p:txBody>
+      </p:sp>
+      <p:sp>
+        <p:nvSpPr>
+          <p:cNvPr id="71" name="TextBox 70"/>
+          <p:cNvSpPr txBox="1"/>
+          <p:nvPr/>
+        </p:nvSpPr>
+        <p:spPr>
+          <a:xfrm>
+            <a:off x="8311896" y="5102352"/>
+            <a:ext cx="3282696" cy="640080"/>
+          </a:xfrm>
+          <a:prstGeom prst="rect">
+            <a:avLst/>
+          </a:prstGeom>
+          <a:noFill/>
+        </p:spPr>
+        <p:txBody>
+          <a:bodyPr wrap="square" anchor="t" lIns="0" rIns="0" tIns="0" bIns="0">
+            <a:spAutoFit/>
+          </a:bodyPr>
+          <a:lstStyle/>
+          <a:p>
+            <a:pPr algn="l"/>
+            <a:r>
+              <a:rPr sz="1100" b="1">
+                <a:solidFill>
+                  <a:srgbClr val="2E8B57"/>
+                </a:solidFill>
+                <a:latin typeface="Calibri"/>
+              </a:rPr>
+              <a:t>Protects:  </a:t>
+            </a:r>
+            <a:r>
+              <a:rPr sz="1100" b="0">
+                <a:solidFill>
+                  <a:srgbClr val="525252"/>
+                </a:solidFill>
+                <a:latin typeface="Calibri"/>
+              </a:rPr>
+              <a:t>Protects high-impact early / mid layers (2–5); drains the damping tail.</a:t>
+            </a:r>
+          </a:p>
+        </p:txBody>
+      </p:sp>
+      <p:sp>
+        <p:nvSpPr>
+          <p:cNvPr id="72" name="TextBox 71"/>
+          <p:cNvSpPr txBox="1"/>
+          <p:nvPr/>
+        </p:nvSpPr>
+        <p:spPr>
+          <a:xfrm>
+            <a:off x="365760" y="5989320"/>
+            <a:ext cx="11430000" cy="320040"/>
+          </a:xfrm>
+          <a:prstGeom prst="rect">
+            <a:avLst/>
+          </a:prstGeom>
+          <a:noFill/>
+        </p:spPr>
+        <p:txBody>
+          <a:bodyPr wrap="square" anchor="t" lIns="0" rIns="0" tIns="0" bIns="0">
+            <a:spAutoFit/>
+          </a:bodyPr>
+          <a:lstStyle/>
+          <a:p>
+            <a:pPr algn="ctr"/>
+            <a:r>
+              <a:rPr sz="1200" b="1">
+                <a:solidFill>
+                  <a:srgbClr val="1A1A1A"/>
+                </a:solidFill>
+                <a:latin typeface="Calibri"/>
+              </a:rPr>
+              <a:t>Same budget, different shape — next slide: which shape gives the lowest perplexity.</a:t>
+            </a:r>
+          </a:p>
+        </p:txBody>
+      </p:sp>
+    </p:spTree>
+  </p:cSld>
+  <p:clrMapOvr>
+    <a:masterClrMapping/>
+  </p:clrMapOvr>
+</p:sld>
+</file>
+
+<file path=ppt/slides/slide15.xml><?xml version="1.0" encoding="utf-8"?>
+<p:sld xmlns:a="http://schemas.openxmlformats.org/drawingml/2006/main" xmlns:p="http://schemas.openxmlformats.org/presentationml/2006/main" xmlns:r="http://schemas.openxmlformats.org/officeDocument/2006/relationships">
+  <p:cSld>
+    <p:spTree>
+      <p:nvGrpSpPr>
+        <p:cNvPr id="1" name=""/>
+        <p:cNvGrpSpPr/>
+        <p:nvPr/>
+      </p:nvGrpSpPr>
+      <p:grpSpPr/>
+      <p:sp>
+        <p:nvSpPr>
+          <p:cNvPr id="2" name="TextBox 1"/>
+          <p:cNvSpPr txBox="1"/>
+          <p:nvPr/>
+        </p:nvSpPr>
+        <p:spPr>
+          <a:xfrm>
+            <a:off x="365760" y="228600"/>
+            <a:ext cx="11430000" cy="548640"/>
+          </a:xfrm>
+          <a:prstGeom prst="rect">
+            <a:avLst/>
+          </a:prstGeom>
+          <a:noFill/>
+        </p:spPr>
+        <p:txBody>
+          <a:bodyPr wrap="square" anchor="t" lIns="0" rIns="0" tIns="0" bIns="0">
+            <a:spAutoFit/>
+          </a:bodyPr>
+          <a:lstStyle/>
+          <a:p>
+            <a:pPr algn="l"/>
+            <a:r>
+              <a:rPr sz="2600" b="1">
+                <a:solidFill>
+                  <a:srgbClr val="1A1A1A"/>
+                </a:solidFill>
+                <a:latin typeface="Calibri"/>
+              </a:rPr>
+              <a:t>Finding 3:  Amplification-Aware Allocation Beats FLAT-LLM</a:t>
+            </a:r>
+          </a:p>
+        </p:txBody>
+      </p:sp>
+      <p:sp>
+        <p:nvSpPr>
+          <p:cNvPr id="3" name="Rectangle 2"/>
+          <p:cNvSpPr/>
+          <p:nvPr/>
+        </p:nvSpPr>
+        <p:spPr>
+          <a:xfrm>
+            <a:off x="365760" y="795528"/>
+            <a:ext cx="11457432" cy="27432"/>
+          </a:xfrm>
+          <a:prstGeom prst="rect">
+            <a:avLst/>
+          </a:prstGeom>
+          <a:solidFill>
+            <a:srgbClr val="0068B5"/>
+          </a:solidFill>
+          <a:ln>
+            <a:noFill/>
+          </a:ln>
+          <a:effectLst/>
+        </p:spPr>
+        <p:style>
+          <a:lnRef idx="1">
+            <a:schemeClr val="accent1"/>
+          </a:lnRef>
+          <a:fillRef idx="3">
+            <a:schemeClr val="accent1"/>
+          </a:fillRef>
+          <a:effectRef idx="2">
+            <a:schemeClr val="accent1"/>
+          </a:effectRef>
+          <a:fontRef idx="minor">
+            <a:schemeClr val="lt1"/>
+          </a:fontRef>
+        </p:style>
+        <p:txBody>
+          <a:bodyPr rtlCol="0" anchor="ctr"/>
+          <a:lstStyle/>
+          <a:p>
+            <a:pPr algn="ctr"/>
+          </a:p>
+        </p:txBody>
+      </p:sp>
+      <p:sp>
+        <p:nvSpPr>
+          <p:cNvPr id="4" name="TextBox 3"/>
+          <p:cNvSpPr txBox="1"/>
+          <p:nvPr/>
+        </p:nvSpPr>
+        <p:spPr>
+          <a:xfrm>
+            <a:off x="11430000" y="6492240"/>
+            <a:ext cx="640080" cy="274320"/>
+          </a:xfrm>
+          <a:prstGeom prst="rect">
+            <a:avLst/>
+          </a:prstGeom>
+          <a:noFill/>
+        </p:spPr>
+        <p:txBody>
+          <a:bodyPr wrap="square" anchor="t" lIns="0" rIns="0" tIns="0" bIns="0">
+            <a:spAutoFit/>
+          </a:bodyPr>
+          <a:lstStyle/>
+          <a:p>
+            <a:pPr algn="r"/>
+            <a:r>
+              <a:rPr sz="1000" b="0">
+                <a:solidFill>
+                  <a:srgbClr val="AAAAAA"/>
+                </a:solidFill>
+                <a:latin typeface="Calibri"/>
+              </a:rPr>
+              <a:t>14</a:t>
             </a:r>
           </a:p>
         </p:txBody>

</xml_diff>

<commit_message>
Add signal-explainer slide (15): block-influence vs downstream amplification
Side-by-side: formula, intuition, local-vs-global+joint, and captures/misses for each
importance signal. Deck now 16 slides.

Co-Authored-By: Claude Sonnet 4.6 <noreply@anthropic.com>
</commit_message>
<xml_diff>
--- a/hypergraph_slides.pptx
+++ b/hypergraph_slides.pptx
@@ -20,6 +20,7 @@
     <p:sldId id="268" r:id="rId19"/>
     <p:sldId id="269" r:id="rId20"/>
     <p:sldId id="270" r:id="rId21"/>
+    <p:sldId id="271" r:id="rId22"/>
   </p:sldIdLst>
   <p:sldSz cx="12192000" cy="6858000" type="screen4x3"/>
   <p:notesSz cx="6858000" cy="9144000"/>
@@ -12296,6 +12297,910 @@
                 <a:latin typeface="Calibri"/>
               </a:rPr>
               <a:t>Amp captures sensitivity BI misses.</a:t>
+            </a:r>
+          </a:p>
+        </p:txBody>
+      </p:sp>
+    </p:spTree>
+  </p:cSld>
+  <p:clrMapOvr>
+    <a:masterClrMapping/>
+  </p:clrMapOvr>
+</p:sld>
+</file>
+
+<file path=ppt/slides/slide16.xml><?xml version="1.0" encoding="utf-8"?>
+<p:sld xmlns:a="http://schemas.openxmlformats.org/drawingml/2006/main" xmlns:p="http://schemas.openxmlformats.org/presentationml/2006/main" xmlns:r="http://schemas.openxmlformats.org/officeDocument/2006/relationships">
+  <p:cSld>
+    <p:spTree>
+      <p:nvGrpSpPr>
+        <p:cNvPr id="1" name=""/>
+        <p:cNvGrpSpPr/>
+        <p:nvPr/>
+      </p:nvGrpSpPr>
+      <p:grpSpPr/>
+      <p:sp>
+        <p:nvSpPr>
+          <p:cNvPr id="2" name="TextBox 1"/>
+          <p:cNvSpPr txBox="1"/>
+          <p:nvPr/>
+        </p:nvSpPr>
+        <p:spPr>
+          <a:xfrm>
+            <a:off x="365760" y="228600"/>
+            <a:ext cx="11430000" cy="548640"/>
+          </a:xfrm>
+          <a:prstGeom prst="rect">
+            <a:avLst/>
+          </a:prstGeom>
+          <a:noFill/>
+        </p:spPr>
+        <p:txBody>
+          <a:bodyPr wrap="square" anchor="t" lIns="0" rIns="0" tIns="0" bIns="0">
+            <a:spAutoFit/>
+          </a:bodyPr>
+          <a:lstStyle/>
+          <a:p>
+            <a:pPr algn="l"/>
+            <a:r>
+              <a:rPr sz="2600" b="1">
+                <a:solidFill>
+                  <a:srgbClr val="1A1A1A"/>
+                </a:solidFill>
+                <a:latin typeface="Calibri"/>
+              </a:rPr>
+              <a:t>The Two Importance Signals, Up Close</a:t>
+            </a:r>
+          </a:p>
+        </p:txBody>
+      </p:sp>
+      <p:sp>
+        <p:nvSpPr>
+          <p:cNvPr id="3" name="Rectangle 2"/>
+          <p:cNvSpPr/>
+          <p:nvPr/>
+        </p:nvSpPr>
+        <p:spPr>
+          <a:xfrm>
+            <a:off x="365760" y="795528"/>
+            <a:ext cx="11457432" cy="27432"/>
+          </a:xfrm>
+          <a:prstGeom prst="rect">
+            <a:avLst/>
+          </a:prstGeom>
+          <a:solidFill>
+            <a:srgbClr val="0068B5"/>
+          </a:solidFill>
+          <a:ln>
+            <a:noFill/>
+          </a:ln>
+          <a:effectLst/>
+        </p:spPr>
+        <p:style>
+          <a:lnRef idx="1">
+            <a:schemeClr val="accent1"/>
+          </a:lnRef>
+          <a:fillRef idx="3">
+            <a:schemeClr val="accent1"/>
+          </a:fillRef>
+          <a:effectRef idx="2">
+            <a:schemeClr val="accent1"/>
+          </a:effectRef>
+          <a:fontRef idx="minor">
+            <a:schemeClr val="lt1"/>
+          </a:fontRef>
+        </p:style>
+        <p:txBody>
+          <a:bodyPr rtlCol="0" anchor="ctr"/>
+          <a:lstStyle/>
+          <a:p>
+            <a:pPr algn="ctr"/>
+          </a:p>
+        </p:txBody>
+      </p:sp>
+      <p:sp>
+        <p:nvSpPr>
+          <p:cNvPr id="4" name="TextBox 3"/>
+          <p:cNvSpPr txBox="1"/>
+          <p:nvPr/>
+        </p:nvSpPr>
+        <p:spPr>
+          <a:xfrm>
+            <a:off x="11430000" y="6492240"/>
+            <a:ext cx="640080" cy="274320"/>
+          </a:xfrm>
+          <a:prstGeom prst="rect">
+            <a:avLst/>
+          </a:prstGeom>
+          <a:noFill/>
+        </p:spPr>
+        <p:txBody>
+          <a:bodyPr wrap="square" anchor="t" lIns="0" rIns="0" tIns="0" bIns="0">
+            <a:spAutoFit/>
+          </a:bodyPr>
+          <a:lstStyle/>
+          <a:p>
+            <a:pPr algn="r"/>
+            <a:r>
+              <a:rPr sz="1000" b="0">
+                <a:solidFill>
+                  <a:srgbClr val="AAAAAA"/>
+                </a:solidFill>
+                <a:latin typeface="Calibri"/>
+              </a:rPr>
+              <a:t>15</a:t>
+            </a:r>
+          </a:p>
+        </p:txBody>
+      </p:sp>
+      <p:sp>
+        <p:nvSpPr>
+          <p:cNvPr id="5" name="TextBox 4"/>
+          <p:cNvSpPr txBox="1"/>
+          <p:nvPr/>
+        </p:nvSpPr>
+        <p:spPr>
+          <a:xfrm>
+            <a:off x="365760" y="914400"/>
+            <a:ext cx="11430000" cy="365760"/>
+          </a:xfrm>
+          <a:prstGeom prst="rect">
+            <a:avLst/>
+          </a:prstGeom>
+          <a:noFill/>
+        </p:spPr>
+        <p:txBody>
+          <a:bodyPr wrap="square" anchor="t" lIns="0" rIns="0" tIns="0" bIns="0">
+            <a:spAutoFit/>
+          </a:bodyPr>
+          <a:lstStyle/>
+          <a:p>
+            <a:pPr algn="l"/>
+            <a:r>
+              <a:rPr sz="1400" b="1">
+                <a:solidFill>
+                  <a:srgbClr val="1A1A1A"/>
+                </a:solidFill>
+                <a:latin typeface="Calibri"/>
+              </a:rPr>
+              <a:t>Both pick which layers keep the most rank — but they measure </a:t>
+            </a:r>
+            <a:r>
+              <a:rPr sz="1400" b="1">
+                <a:solidFill>
+                  <a:srgbClr val="0068B5"/>
+                </a:solidFill>
+                <a:latin typeface="Calibri"/>
+              </a:rPr>
+              <a:t>very different things.</a:t>
+            </a:r>
+          </a:p>
+        </p:txBody>
+      </p:sp>
+      <p:sp>
+        <p:nvSpPr>
+          <p:cNvPr id="6" name="Rectangle 5"/>
+          <p:cNvSpPr/>
+          <p:nvPr/>
+        </p:nvSpPr>
+        <p:spPr>
+          <a:xfrm>
+            <a:off x="365760" y="1371600"/>
+            <a:ext cx="5623560" cy="4736592"/>
+          </a:xfrm>
+          <a:prstGeom prst="rect">
+            <a:avLst/>
+          </a:prstGeom>
+          <a:solidFill>
+            <a:srgbClr val="FFF2CC"/>
+          </a:solidFill>
+          <a:ln>
+            <a:noFill/>
+          </a:ln>
+          <a:effectLst/>
+        </p:spPr>
+        <p:style>
+          <a:lnRef idx="1">
+            <a:schemeClr val="accent1"/>
+          </a:lnRef>
+          <a:fillRef idx="3">
+            <a:schemeClr val="accent1"/>
+          </a:fillRef>
+          <a:effectRef idx="2">
+            <a:schemeClr val="accent1"/>
+          </a:effectRef>
+          <a:fontRef idx="minor">
+            <a:schemeClr val="lt1"/>
+          </a:fontRef>
+        </p:style>
+        <p:txBody>
+          <a:bodyPr rtlCol="0" anchor="ctr"/>
+          <a:lstStyle/>
+          <a:p>
+            <a:pPr algn="ctr"/>
+          </a:p>
+        </p:txBody>
+      </p:sp>
+      <p:sp>
+        <p:nvSpPr>
+          <p:cNvPr id="7" name="Rectangle 6"/>
+          <p:cNvSpPr/>
+          <p:nvPr/>
+        </p:nvSpPr>
+        <p:spPr>
+          <a:xfrm>
+            <a:off x="365760" y="1371600"/>
+            <a:ext cx="146304" cy="4736592"/>
+          </a:xfrm>
+          <a:prstGeom prst="rect">
+            <a:avLst/>
+          </a:prstGeom>
+          <a:solidFill>
+            <a:srgbClr val="FFA300"/>
+          </a:solidFill>
+          <a:ln>
+            <a:noFill/>
+          </a:ln>
+          <a:effectLst/>
+        </p:spPr>
+        <p:style>
+          <a:lnRef idx="1">
+            <a:schemeClr val="accent1"/>
+          </a:lnRef>
+          <a:fillRef idx="3">
+            <a:schemeClr val="accent1"/>
+          </a:fillRef>
+          <a:effectRef idx="2">
+            <a:schemeClr val="accent1"/>
+          </a:effectRef>
+          <a:fontRef idx="minor">
+            <a:schemeClr val="lt1"/>
+          </a:fontRef>
+        </p:style>
+        <p:txBody>
+          <a:bodyPr rtlCol="0" anchor="ctr"/>
+          <a:lstStyle/>
+          <a:p>
+            <a:pPr algn="ctr"/>
+          </a:p>
+        </p:txBody>
+      </p:sp>
+      <p:sp>
+        <p:nvSpPr>
+          <p:cNvPr id="8" name="TextBox 7"/>
+          <p:cNvSpPr txBox="1"/>
+          <p:nvPr/>
+        </p:nvSpPr>
+        <p:spPr>
+          <a:xfrm>
+            <a:off x="685800" y="1499616"/>
+            <a:ext cx="5120640" cy="411480"/>
+          </a:xfrm>
+          <a:prstGeom prst="rect">
+            <a:avLst/>
+          </a:prstGeom>
+          <a:noFill/>
+        </p:spPr>
+        <p:txBody>
+          <a:bodyPr wrap="square" anchor="t" lIns="0" rIns="0" tIns="0" bIns="0">
+            <a:spAutoFit/>
+          </a:bodyPr>
+          <a:lstStyle/>
+          <a:p>
+            <a:pPr algn="l"/>
+            <a:r>
+              <a:rPr sz="1700" b="1">
+                <a:solidFill>
+                  <a:srgbClr val="FFA300"/>
+                </a:solidFill>
+                <a:latin typeface="Calibri"/>
+              </a:rPr>
+              <a:t>Block-influence   (FLAT-LLM)</a:t>
+            </a:r>
+          </a:p>
+        </p:txBody>
+      </p:sp>
+      <p:sp>
+        <p:nvSpPr>
+          <p:cNvPr id="9" name="Rounded Rectangle 8"/>
+          <p:cNvSpPr/>
+          <p:nvPr/>
+        </p:nvSpPr>
+        <p:spPr>
+          <a:xfrm>
+            <a:off x="685800" y="1975104"/>
+            <a:ext cx="4983480" cy="658368"/>
+          </a:xfrm>
+          <a:prstGeom prst="roundRect">
+            <a:avLst/>
+          </a:prstGeom>
+          <a:solidFill>
+            <a:srgbClr val="FFFFFF"/>
+          </a:solidFill>
+          <a:ln>
+            <a:noFill/>
+          </a:ln>
+          <a:effectLst/>
+        </p:spPr>
+        <p:style>
+          <a:lnRef idx="1">
+            <a:schemeClr val="accent1"/>
+          </a:lnRef>
+          <a:fillRef idx="3">
+            <a:schemeClr val="accent1"/>
+          </a:fillRef>
+          <a:effectRef idx="2">
+            <a:schemeClr val="accent1"/>
+          </a:effectRef>
+          <a:fontRef idx="minor">
+            <a:schemeClr val="lt1"/>
+          </a:fontRef>
+        </p:style>
+        <p:txBody>
+          <a:bodyPr rtlCol="0" anchor="ctr"/>
+          <a:lstStyle/>
+          <a:p>
+            <a:pPr algn="ctr"/>
+          </a:p>
+        </p:txBody>
+      </p:sp>
+      <p:sp>
+        <p:nvSpPr>
+          <p:cNvPr id="10" name="TextBox 9"/>
+          <p:cNvSpPr txBox="1"/>
+          <p:nvPr/>
+        </p:nvSpPr>
+        <p:spPr>
+          <a:xfrm>
+            <a:off x="777240" y="2066543"/>
+            <a:ext cx="4800600" cy="502920"/>
+          </a:xfrm>
+          <a:prstGeom prst="rect">
+            <a:avLst/>
+          </a:prstGeom>
+          <a:noFill/>
+        </p:spPr>
+        <p:txBody>
+          <a:bodyPr wrap="square" anchor="ctr" lIns="0" rIns="0" tIns="0" bIns="0">
+            <a:spAutoFit/>
+          </a:bodyPr>
+          <a:lstStyle/>
+          <a:p>
+            <a:pPr algn="ctr"/>
+            <a:r>
+              <a:rPr sz="1300" b="1">
+                <a:solidFill>
+                  <a:srgbClr val="1A1A1A"/>
+                </a:solidFill>
+                <a:latin typeface="Calibri"/>
+              </a:rPr>
+              <a:t>angle( h_in , h_out )  =  arccos( cos )</a:t>
+            </a:r>
+          </a:p>
+        </p:txBody>
+      </p:sp>
+      <p:sp>
+        <p:nvSpPr>
+          <p:cNvPr id="11" name="TextBox 10"/>
+          <p:cNvSpPr txBox="1"/>
+          <p:nvPr/>
+        </p:nvSpPr>
+        <p:spPr>
+          <a:xfrm>
+            <a:off x="685800" y="2779776"/>
+            <a:ext cx="5120640" cy="1143000"/>
+          </a:xfrm>
+          <a:prstGeom prst="rect">
+            <a:avLst/>
+          </a:prstGeom>
+          <a:noFill/>
+        </p:spPr>
+        <p:txBody>
+          <a:bodyPr wrap="square" anchor="t" lIns="0" rIns="0" tIns="0" bIns="0">
+            <a:spAutoFit/>
+          </a:bodyPr>
+          <a:lstStyle/>
+          <a:p>
+            <a:pPr algn="l"/>
+            <a:r>
+              <a:rPr sz="1300" b="0">
+                <a:solidFill>
+                  <a:srgbClr val="525252"/>
+                </a:solidFill>
+                <a:latin typeface="Calibri"/>
+              </a:rPr>
+              <a:t>How much does the layer </a:t>
+            </a:r>
+            <a:r>
+              <a:rPr sz="1300" b="1">
+                <a:solidFill>
+                  <a:srgbClr val="1A1A1A"/>
+                </a:solidFill>
+                <a:latin typeface="Calibri"/>
+              </a:rPr>
+              <a:t>rotate the residual</a:t>
+            </a:r>
+            <a:r>
+              <a:rPr sz="1300" b="0">
+                <a:solidFill>
+                  <a:srgbClr val="525252"/>
+                </a:solidFill>
+                <a:latin typeface="Calibri"/>
+              </a:rPr>
+              <a:t>?  A big turn ⇒ it transforms the representation a lot ⇒ treat it as important, keep more rank.</a:t>
+            </a:r>
+          </a:p>
+        </p:txBody>
+      </p:sp>
+      <p:sp>
+        <p:nvSpPr>
+          <p:cNvPr id="12" name="TextBox 11"/>
+          <p:cNvSpPr txBox="1"/>
+          <p:nvPr/>
+        </p:nvSpPr>
+        <p:spPr>
+          <a:xfrm>
+            <a:off x="685800" y="4023360"/>
+            <a:ext cx="5120640" cy="457200"/>
+          </a:xfrm>
+          <a:prstGeom prst="rect">
+            <a:avLst/>
+          </a:prstGeom>
+          <a:noFill/>
+        </p:spPr>
+        <p:txBody>
+          <a:bodyPr wrap="square" anchor="t" lIns="0" rIns="0" tIns="0" bIns="0">
+            <a:spAutoFit/>
+          </a:bodyPr>
+          <a:lstStyle/>
+          <a:p>
+            <a:pPr algn="l"/>
+            <a:r>
+              <a:rPr sz="1300" b="1">
+                <a:solidFill>
+                  <a:srgbClr val="FFA300"/>
+                </a:solidFill>
+                <a:latin typeface="Calibri"/>
+              </a:rPr>
+              <a:t>Local</a:t>
+            </a:r>
+            <a:r>
+              <a:rPr sz="1300" b="0">
+                <a:solidFill>
+                  <a:srgbClr val="525252"/>
+                </a:solidFill>
+                <a:latin typeface="Calibri"/>
+              </a:rPr>
+              <a:t> — from one layer's own input vs. output.</a:t>
+            </a:r>
+          </a:p>
+        </p:txBody>
+      </p:sp>
+      <p:sp>
+        <p:nvSpPr>
+          <p:cNvPr id="13" name="TextBox 12"/>
+          <p:cNvSpPr txBox="1"/>
+          <p:nvPr/>
+        </p:nvSpPr>
+        <p:spPr>
+          <a:xfrm>
+            <a:off x="685800" y="4681728"/>
+            <a:ext cx="5120640" cy="1280160"/>
+          </a:xfrm>
+          <a:prstGeom prst="rect">
+            <a:avLst/>
+          </a:prstGeom>
+          <a:noFill/>
+        </p:spPr>
+        <p:txBody>
+          <a:bodyPr wrap="square" anchor="t" lIns="0" rIns="0" tIns="0" bIns="0">
+            <a:spAutoFit/>
+          </a:bodyPr>
+          <a:lstStyle/>
+          <a:p>
+            <a:pPr algn="l"/>
+            <a:r>
+              <a:rPr sz="1200" b="1">
+                <a:solidFill>
+                  <a:srgbClr val="1A1A1A"/>
+                </a:solidFill>
+                <a:latin typeface="Calibri"/>
+              </a:rPr>
+              <a:t>Captures:  </a:t>
+            </a:r>
+            <a:r>
+              <a:rPr sz="1200" b="0">
+                <a:solidFill>
+                  <a:srgbClr val="525252"/>
+                </a:solidFill>
+                <a:latin typeface="Calibri"/>
+              </a:rPr>
+              <a:t>how active a layer is.</a:t>
+            </a:r>
+          </a:p>
+          <a:p>
+            <a:pPr algn="l"/>
+            <a:r>
+              <a:rPr sz="1200" b="1">
+                <a:solidFill>
+                  <a:srgbClr val="C0504D"/>
+                </a:solidFill>
+                <a:latin typeface="Calibri"/>
+              </a:rPr>
+              <a:t>Misses:  </a:t>
+            </a:r>
+            <a:r>
+              <a:rPr sz="1200" b="0">
+                <a:solidFill>
+                  <a:srgbClr val="525252"/>
+                </a:solidFill>
+                <a:latin typeface="Calibri"/>
+              </a:rPr>
+              <a:t>whether that layer's error actually reaches the output.</a:t>
+            </a:r>
+          </a:p>
+        </p:txBody>
+      </p:sp>
+      <p:sp>
+        <p:nvSpPr>
+          <p:cNvPr id="14" name="Rectangle 13"/>
+          <p:cNvSpPr/>
+          <p:nvPr/>
+        </p:nvSpPr>
+        <p:spPr>
+          <a:xfrm>
+            <a:off x="6172200" y="1371600"/>
+            <a:ext cx="5623560" cy="4736592"/>
+          </a:xfrm>
+          <a:prstGeom prst="rect">
+            <a:avLst/>
+          </a:prstGeom>
+          <a:solidFill>
+            <a:srgbClr val="E2F0D9"/>
+          </a:solidFill>
+          <a:ln>
+            <a:noFill/>
+          </a:ln>
+          <a:effectLst/>
+        </p:spPr>
+        <p:style>
+          <a:lnRef idx="1">
+            <a:schemeClr val="accent1"/>
+          </a:lnRef>
+          <a:fillRef idx="3">
+            <a:schemeClr val="accent1"/>
+          </a:fillRef>
+          <a:effectRef idx="2">
+            <a:schemeClr val="accent1"/>
+          </a:effectRef>
+          <a:fontRef idx="minor">
+            <a:schemeClr val="lt1"/>
+          </a:fontRef>
+        </p:style>
+        <p:txBody>
+          <a:bodyPr rtlCol="0" anchor="ctr"/>
+          <a:lstStyle/>
+          <a:p>
+            <a:pPr algn="ctr"/>
+          </a:p>
+        </p:txBody>
+      </p:sp>
+      <p:sp>
+        <p:nvSpPr>
+          <p:cNvPr id="15" name="Rectangle 14"/>
+          <p:cNvSpPr/>
+          <p:nvPr/>
+        </p:nvSpPr>
+        <p:spPr>
+          <a:xfrm>
+            <a:off x="6172200" y="1371600"/>
+            <a:ext cx="146304" cy="4736592"/>
+          </a:xfrm>
+          <a:prstGeom prst="rect">
+            <a:avLst/>
+          </a:prstGeom>
+          <a:solidFill>
+            <a:srgbClr val="2E8B57"/>
+          </a:solidFill>
+          <a:ln>
+            <a:noFill/>
+          </a:ln>
+          <a:effectLst/>
+        </p:spPr>
+        <p:style>
+          <a:lnRef idx="1">
+            <a:schemeClr val="accent1"/>
+          </a:lnRef>
+          <a:fillRef idx="3">
+            <a:schemeClr val="accent1"/>
+          </a:fillRef>
+          <a:effectRef idx="2">
+            <a:schemeClr val="accent1"/>
+          </a:effectRef>
+          <a:fontRef idx="minor">
+            <a:schemeClr val="lt1"/>
+          </a:fontRef>
+        </p:style>
+        <p:txBody>
+          <a:bodyPr rtlCol="0" anchor="ctr"/>
+          <a:lstStyle/>
+          <a:p>
+            <a:pPr algn="ctr"/>
+          </a:p>
+        </p:txBody>
+      </p:sp>
+      <p:sp>
+        <p:nvSpPr>
+          <p:cNvPr id="16" name="TextBox 15"/>
+          <p:cNvSpPr txBox="1"/>
+          <p:nvPr/>
+        </p:nvSpPr>
+        <p:spPr>
+          <a:xfrm>
+            <a:off x="6492240" y="1499616"/>
+            <a:ext cx="5120640" cy="411480"/>
+          </a:xfrm>
+          <a:prstGeom prst="rect">
+            <a:avLst/>
+          </a:prstGeom>
+          <a:noFill/>
+        </p:spPr>
+        <p:txBody>
+          <a:bodyPr wrap="square" anchor="t" lIns="0" rIns="0" tIns="0" bIns="0">
+            <a:spAutoFit/>
+          </a:bodyPr>
+          <a:lstStyle/>
+          <a:p>
+            <a:pPr algn="l"/>
+            <a:r>
+              <a:rPr sz="1700" b="1">
+                <a:solidFill>
+                  <a:srgbClr val="2E8B57"/>
+                </a:solidFill>
+                <a:latin typeface="Calibri"/>
+              </a:rPr>
+              <a:t>Downstream amplification   (ours)</a:t>
+            </a:r>
+          </a:p>
+        </p:txBody>
+      </p:sp>
+      <p:sp>
+        <p:nvSpPr>
+          <p:cNvPr id="17" name="Rounded Rectangle 16"/>
+          <p:cNvSpPr/>
+          <p:nvPr/>
+        </p:nvSpPr>
+        <p:spPr>
+          <a:xfrm>
+            <a:off x="6492240" y="1975104"/>
+            <a:ext cx="4983480" cy="658368"/>
+          </a:xfrm>
+          <a:prstGeom prst="roundRect">
+            <a:avLst/>
+          </a:prstGeom>
+          <a:solidFill>
+            <a:srgbClr val="FFFFFF"/>
+          </a:solidFill>
+          <a:ln>
+            <a:noFill/>
+          </a:ln>
+          <a:effectLst/>
+        </p:spPr>
+        <p:style>
+          <a:lnRef idx="1">
+            <a:schemeClr val="accent1"/>
+          </a:lnRef>
+          <a:fillRef idx="3">
+            <a:schemeClr val="accent1"/>
+          </a:fillRef>
+          <a:effectRef idx="2">
+            <a:schemeClr val="accent1"/>
+          </a:effectRef>
+          <a:fontRef idx="minor">
+            <a:schemeClr val="lt1"/>
+          </a:fontRef>
+        </p:style>
+        <p:txBody>
+          <a:bodyPr rtlCol="0" anchor="ctr"/>
+          <a:lstStyle/>
+          <a:p>
+            <a:pPr algn="ctr"/>
+          </a:p>
+        </p:txBody>
+      </p:sp>
+      <p:sp>
+        <p:nvSpPr>
+          <p:cNvPr id="18" name="TextBox 17"/>
+          <p:cNvSpPr txBox="1"/>
+          <p:nvPr/>
+        </p:nvSpPr>
+        <p:spPr>
+          <a:xfrm>
+            <a:off x="6583680" y="2066543"/>
+            <a:ext cx="4800600" cy="502920"/>
+          </a:xfrm>
+          <a:prstGeom prst="rect">
+            <a:avLst/>
+          </a:prstGeom>
+          <a:noFill/>
+        </p:spPr>
+        <p:txBody>
+          <a:bodyPr wrap="square" anchor="ctr" lIns="0" rIns="0" tIns="0" bIns="0">
+            <a:spAutoFit/>
+          </a:bodyPr>
+          <a:lstStyle/>
+          <a:p>
+            <a:pPr algn="ctr"/>
+            <a:r>
+              <a:rPr sz="1300" b="1">
+                <a:solidFill>
+                  <a:srgbClr val="1A1A1A"/>
+                </a:solidFill>
+                <a:latin typeface="Calibri"/>
+              </a:rPr>
+              <a:t>Δ final output  ÷  Δ this layer's output</a:t>
+            </a:r>
+          </a:p>
+        </p:txBody>
+      </p:sp>
+      <p:sp>
+        <p:nvSpPr>
+          <p:cNvPr id="19" name="TextBox 18"/>
+          <p:cNvSpPr txBox="1"/>
+          <p:nvPr/>
+        </p:nvSpPr>
+        <p:spPr>
+          <a:xfrm>
+            <a:off x="6492240" y="2779776"/>
+            <a:ext cx="5120640" cy="1143000"/>
+          </a:xfrm>
+          <a:prstGeom prst="rect">
+            <a:avLst/>
+          </a:prstGeom>
+          <a:noFill/>
+        </p:spPr>
+        <p:txBody>
+          <a:bodyPr wrap="square" anchor="t" lIns="0" rIns="0" tIns="0" bIns="0">
+            <a:spAutoFit/>
+          </a:bodyPr>
+          <a:lstStyle/>
+          <a:p>
+            <a:pPr algn="l"/>
+            <a:r>
+              <a:rPr sz="1300" b="0">
+                <a:solidFill>
+                  <a:srgbClr val="525252"/>
+                </a:solidFill>
+                <a:latin typeface="Calibri"/>
+              </a:rPr>
+              <a:t>How much does the layer's compression error </a:t>
+            </a:r>
+            <a:r>
+              <a:rPr sz="1300" b="1">
+                <a:solidFill>
+                  <a:srgbClr val="1A1A1A"/>
+                </a:solidFill>
+                <a:latin typeface="Calibri"/>
+              </a:rPr>
+              <a:t>grow</a:t>
+            </a:r>
+            <a:r>
+              <a:rPr sz="1300" b="0">
+                <a:solidFill>
+                  <a:srgbClr val="525252"/>
+                </a:solidFill>
+                <a:latin typeface="Calibri"/>
+              </a:rPr>
+              <a:t> by the time it reaches the logits?  Big ⇒ protect it;  small ⇒ safe to compress.</a:t>
+            </a:r>
+          </a:p>
+        </p:txBody>
+      </p:sp>
+      <p:sp>
+        <p:nvSpPr>
+          <p:cNvPr id="20" name="TextBox 19"/>
+          <p:cNvSpPr txBox="1"/>
+          <p:nvPr/>
+        </p:nvSpPr>
+        <p:spPr>
+          <a:xfrm>
+            <a:off x="6492240" y="4023360"/>
+            <a:ext cx="5120640" cy="548640"/>
+          </a:xfrm>
+          <a:prstGeom prst="rect">
+            <a:avLst/>
+          </a:prstGeom>
+          <a:noFill/>
+        </p:spPr>
+        <p:txBody>
+          <a:bodyPr wrap="square" anchor="t" lIns="0" rIns="0" tIns="0" bIns="0">
+            <a:spAutoFit/>
+          </a:bodyPr>
+          <a:lstStyle/>
+          <a:p>
+            <a:pPr algn="l"/>
+            <a:r>
+              <a:rPr sz="1300" b="1">
+                <a:solidFill>
+                  <a:srgbClr val="2E8B57"/>
+                </a:solidFill>
+                <a:latin typeface="Calibri"/>
+              </a:rPr>
+              <a:t>Global + joint</a:t>
+            </a:r>
+            <a:r>
+              <a:rPr sz="1300" b="0">
+                <a:solidFill>
+                  <a:srgbClr val="525252"/>
+                </a:solidFill>
+                <a:latin typeface="Calibri"/>
+              </a:rPr>
+              <a:t> — layers' errors interact (banded), so ranks are set together, not greedily.</a:t>
+            </a:r>
+          </a:p>
+        </p:txBody>
+      </p:sp>
+      <p:sp>
+        <p:nvSpPr>
+          <p:cNvPr id="21" name="TextBox 20"/>
+          <p:cNvSpPr txBox="1"/>
+          <p:nvPr/>
+        </p:nvSpPr>
+        <p:spPr>
+          <a:xfrm>
+            <a:off x="6492240" y="4754880"/>
+            <a:ext cx="5120640" cy="1280160"/>
+          </a:xfrm>
+          <a:prstGeom prst="rect">
+            <a:avLst/>
+          </a:prstGeom>
+          <a:noFill/>
+        </p:spPr>
+        <p:txBody>
+          <a:bodyPr wrap="square" anchor="t" lIns="0" rIns="0" tIns="0" bIns="0">
+            <a:spAutoFit/>
+          </a:bodyPr>
+          <a:lstStyle/>
+          <a:p>
+            <a:pPr algn="l"/>
+            <a:r>
+              <a:rPr sz="1200" b="1">
+                <a:solidFill>
+                  <a:srgbClr val="1A1A1A"/>
+                </a:solidFill>
+                <a:latin typeface="Calibri"/>
+              </a:rPr>
+              <a:t>Captures:  </a:t>
+            </a:r>
+            <a:r>
+              <a:rPr sz="1200" b="0">
+                <a:solidFill>
+                  <a:srgbClr val="525252"/>
+                </a:solidFill>
+                <a:latin typeface="Calibri"/>
+              </a:rPr>
+              <a:t>the true end-to-end cost.</a:t>
+            </a:r>
+          </a:p>
+          <a:p>
+            <a:pPr algn="l"/>
+            <a:r>
+              <a:rPr sz="1200" b="1">
+                <a:solidFill>
+                  <a:srgbClr val="2E8B57"/>
+                </a:solidFill>
+                <a:latin typeface="Calibri"/>
+              </a:rPr>
+              <a:t>Range:  </a:t>
+            </a:r>
+            <a:r>
+              <a:rPr sz="1200" b="0">
+                <a:solidFill>
+                  <a:srgbClr val="525252"/>
+                </a:solidFill>
+                <a:latin typeface="Calibri"/>
+              </a:rPr>
+              <a:t>~30× at early layers, &lt;1× at the tail.</a:t>
             </a:r>
           </a:p>
         </p:txBody>

</xml_diff>